<commit_message>
Update Ontology presentation and presenter companion for §1.2 gyan alignment.
Refresh deck PDF/PPTX and Presenters Companion with reader comments and saturation/verb-discipline revisions matching the study update.

Co-authored-by: Cursor <cursoragent@cursor.com>
</commit_message>
<xml_diff>
--- a/Studies/The-Ontology-of-Coexistence/The-Ontology-of-Existence-Madhyasth-Darshan.pptx
+++ b/Studies/The-Ontology-of-Coexistence/The-Ontology-of-Existence-Madhyasth-Darshan.pptx
@@ -19,9 +19,10 @@
     <p:sldId id="267" r:id="rId13"/>
     <p:sldId id="268" r:id="rId14"/>
     <p:sldId id="269" r:id="rId15"/>
+    <p:sldId id="271" r:id="rId17"/>
     <p:sldId id="270" r:id="rId16"/>
-    <p:sldId id="271" r:id="rId17"/>
     <p:sldId id="272" r:id="rId18"/>
+    <p:sldId id="274" r:id="rId25"/>
     <p:sldId id="273" r:id="rId19"/>
   </p:sldIdLst>
   <p:notesMasterIdLst>
@@ -607,7 +608,7 @@
           <a:p>
             <a:r>
               <a:rPr lang="en-US" dirty="0"/>
-              <a:t>T1 deserves its own slide because it is the sentience threshold - and it is constitutional, not neural complexity, molecular size, or position on the order chain. Molecules exhibit characteristics of development but not actual development. Mechanism: particle incorporation through hungry and overfull complementarity within a conducive environment; when the required particles integrate, the constitution closes. The bondage shift is the textual evidence (MVD p. 91): molecular-bondage and weight-bondage are released; hope-bondage defines the sentient mode. After T1: no change in particle count - qualitative change without quantitative change. Close with latency: the complete atom acts as a mediating reflector configuration - sentience is what was ever-present in satta, actualised - which becomes important in the comparison deck against emergence objections.</a:t>
+              <a:t>T1 deserves its own slide because it is the sentience threshold - and it is constitutional, not neural complexity, molecular size, or position on the order chain. Molecules exhibit characteristics of development but not actual development. Mechanism: particle incorporation through hungry and overfull complementarity within a conducive environment; when the required particles integrate, the constitution closes. The bondage shift is the textual evidence (MVD p. 91): molecular-bondage and weight-bondage are released; hope-bondage defines the sentient mode. After T1: no change in particle count - qualitative change without quantitative change. Close with latency: the complete atom acts as a mediating reflector configuration - sentience is what was ever-present in satta, actualised - which becomes important in the comparison deck against emergence objections. NEW: T1 changes the drive's mode, not its direction - hope-bondage carries the same orientation. Epistemic upgrade: taste-recognition, impossible in insentient nature, first manifests in sentient nature (SB pp. 80-81) - recognition acquires the inner circuit of strengths and powers, the condition for knowing-believing-recognising-fulfilling at the knowledge order.</a:t>
             </a:r>
             <a:endParaRPr lang="en-US" dirty="0"/>
           </a:p>
@@ -695,7 +696,7 @@
           <a:p>
             <a:r>
               <a:rPr lang="en-US" dirty="0"/>
-              <a:t>Jeevan's structure: atma is the nucleus; buddhi, chitta, vritti, mun are particles in the first through fourth orbits - this is MVD p. 78, and the study insists it is structural, not metaphor. Each faculty works through projection (paravartan) and reflection (pratyavartan) - walk one or two rows of the table, e.g. mun selects and tastes; buddhi resolves and is enlightened; atma authenticates and realises. Two cautions: this five-fold (faculties) must NOT be conflated with the kosha five-fold (developmental sheaths) - they do not align column-to-column. And the delusion structure: on the delusional plane atma is 'I' and the orbital four are 'mine'; awakening is the four coming into accordance with atma. Mistaking the body for the self is the root confusion.</a:t>
+              <a:t>Jeevan's structure: atma is the nucleus; buddhi, chitta, vritti, mun are particles in the first through fourth orbits - this is MVD p. 78, and the study insists it is structural, not metaphor. Each faculty works through projection (paravartan) and reflection (pratyavartan) - walk one or two rows of the table, e.g. mun selects and tastes; buddhi resolves and is enlightened; atma authenticates and realises. Two cautions: this five-fold (faculties) must NOT be conflated with the kosha five-fold (developmental sheaths) - they do not align column-to-column. And the delusion structure: on the delusional plane atma is 'I' and the orbital four are 'mine'; awakening is the four coming into accordance with atma. Mistaking the body for the self is the root confusion. NEW: directional reading of the table - reflection (pratyavartan) is the knowing direction, the study circuit ratiocination in mun, deliberation in vritti, direct recognition in chitta, enlightenment in buddhi (MVD p. 126), terminating in anubhav in satta (MVD pp. 286-287); projection (paravartan) is the evidencing direction, the cascade from anubhav to pramanikta (MVD pp. 99-100). Delusional inversion: circuit driven body-upward, only 4.5 of ten activities effective, believing severed from knowing (JV pp. 73-74). Awakening staged by three statuses of buddhi: chitta-driven, buddhi-driven, atma-disciplined (MVD pp. 278-279).</a:t>
             </a:r>
             <a:endParaRPr lang="en-US" dirty="0"/>
           </a:p>
@@ -1047,7 +1048,7 @@
           <a:p>
             <a:r>
               <a:rPr lang="en-US" dirty="0"/>
-              <a:t>This is the disambiguation slide - the study calls conflating these four senses the main source of misreading. Realisation Knowledge: orderliness already present in every saturated unit - the ontological given. Gyan as satta: the ground's intelligibility - Space as knowledge - a condition of intelligibility, NOT a knowing subject. Realisation in coexistence: the telos - relationships fulfilled and evident - not a new state of the ground. Gyan udghatan: the unfolding of knowledge in thought and conduct - exclusive to awakened jeevan, through the human body as interface; the knower is always jeevan, never the brain. Two failure modes to name: collapse them one way and you get a pan-knowing Omnipresence; the other way, a world with no inherent intelligibility to unfold.</a:t>
+              <a:t>This is the telos slide - where the completeness drive terminates. The paper's 1.13 is Realisation in coexistence; the former four-senses taxonomy has been removed from the study - the vocabulary discipline now lives in Editorial Notes and the glossary (gyan names intelligibility in satta, the saturation bond - not a mind that knows; Realisation Knowledge for orderliness in every unit, 1.1; gyan udghatan for unfolding through awakened jeevan, 1.7; gyan-avastha for the fourth order, 1.5). Walk the slide: intro states the termination - not satta becoming a knower, but awakened jeevan enacting what was latent in the bond; realisation itself is the form of awakening, and recognition and fulfilment then constitute authenticity (SB p. 81). Card 1: realisation is anand - verity chain, MVD pp. 14-15 - and knowledge itself, since what is realised is the ground the unit was always saturated in. Cards 2-4: the AVD p. 217 identity - knowledge in projection (authenticity: gyan-vivek-vigyan, unfolding as gyan udghatan), knower in reflection (jeevan full of realisation; buddhi's reflection toward atma yields atma-bodh and realisation in coexistence together, MVD pp. 286-287), knowable as existence (nature saturated in Omnipotence). Guardrail: uniformity of knowledge, knower, and knowable in coexistence names coordinated roles in one bond - NOT merger into a universal knower; the knower remains distinct jeevan. This is the hinge against the Advaita chit reading (paper 5.6).</a:t>
             </a:r>
             <a:endParaRPr lang="en-US" dirty="0"/>
           </a:p>
@@ -1223,7 +1224,7 @@
           <a:p>
             <a:r>
               <a:rPr lang="en-US" dirty="0"/>
-              <a:t>Two distinct conservation claims - keep them separate. Coexistence conservation: nothing arises from non-being (abhava), nothing is annihilated; only configurations change - jagat satat, the world is perpetual. Jeevan persistence: a further claim resting on constitutional completeness and immunity to decomposition. At the human scale the completeness drive becomes four societal goals: resolution, prosperity, fearlessness, coexistence - JV p. 61 links them to the internal values: resolution IS happiness realised, prosperity in family is peace, orderly living in society is contentment, evidencing understanding is bliss. Note the contrast: animal collectivity arises primarily from fear; human sociality builds on resolution and trust. These compose upward to undivided society and universal orderliness across five dimensions - education-character, justice-preservation, health-restraint, production-work, exchange-storage.</a:t>
+              <a:t>Two distinct conservation claims - keep them separate. Coexistence conservation: nothing arises from non-being (abhava), nothing is annihilated; only configurations change - jagat satat, the world is perpetual. Jeevan persistence: a further claim resting on constitutional completeness and immunity to decomposition. At the human scale the completeness drive becomes four societal goals: resolution, prosperity, fearlessness, coexistence - JV p. 61 links them to the internal values: resolution IS happiness realised, prosperity in family is peace, orderly living in society is contentment, evidencing understanding is bliss. Note the contrast: animal collectivity arises primarily from fear; human sociality builds on resolution and trust. These compose upward to undivided society and universal orderliness across five dimensions - education-character, justice-preservation, health-restraint, production-work, exchange-storage. NEW: close on continuity - the five dimensions sustained across generations as humane tradition (manav parampara), the continuity in which the drive's societal evidence goes on.</a:t>
             </a:r>
             <a:endParaRPr lang="en-US" dirty="0"/>
           </a:p>
@@ -1353,6 +1354,94 @@
 </p:notes>
 </file>
 
+<file path=ppt/notesSlides/notesSlide19.xml><?xml version="1.0" encoding="utf-8"?>
+<p:notes xmlns:a="http://schemas.openxmlformats.org/drawingml/2006/main" xmlns:r="http://schemas.openxmlformats.org/officeDocument/2006/relationships" xmlns:p="http://schemas.openxmlformats.org/presentationml/2006/main">
+  <p:cSld>
+    <p:spTree>
+      <p:nvGrpSpPr>
+        <p:cNvPr id="1" name=""/>
+        <p:cNvGrpSpPr/>
+        <p:nvPr/>
+      </p:nvGrpSpPr>
+      <p:grpSpPr>
+        <a:xfrm>
+          <a:off x="0" y="0"/>
+          <a:ext cx="0" cy="0"/>
+          <a:chOff x="0" y="0"/>
+          <a:chExt cx="0" cy="0"/>
+        </a:xfrm>
+      </p:grpSpPr>
+      <p:sp>
+        <p:nvSpPr>
+          <p:cNvPr id="2" name="Slide Image Placeholder 1"/>
+          <p:cNvSpPr>
+            <a:spLocks noGrp="1" noRot="1" noChangeAspect="1"/>
+          </p:cNvSpPr>
+          <p:nvPr>
+            <p:ph type="sldImg"/>
+          </p:nvPr>
+        </p:nvSpPr>
+        <p:spPr/>
+      </p:sp>
+      <p:sp>
+        <p:nvSpPr>
+          <p:cNvPr id="3" name="Notes Placeholder 2"/>
+          <p:cNvSpPr>
+            <a:spLocks noGrp="1"/>
+          </p:cNvSpPr>
+          <p:nvPr>
+            <p:ph type="body" idx="1"/>
+          </p:nvPr>
+        </p:nvSpPr>
+        <p:spPr/>
+        <p:txBody>
+          <a:bodyPr/>
+          <a:lstStyle/>
+          <a:p>
+            <a:r>
+              <a:rPr lang="en-US" dirty="0"/>
+              <a:t>The culmination slide - give it time and let it land. The drive that opened on slide 8 in every atom ends here, in people. Effort settled in realisation is T2 (restfulness of effort, anubhav); understanding proven in daily conduct is T3 (pramanikta). The four goals land at their four levels: resolution in every person (samadhan), prosperity in every family (samriddhi), fearlessness and trust in society (abhay), coexistence with all of nature (sah-astitva). An undivided society (akhand samaj) in universal orderliness is their composed form. Tradition: each generation raised into the same understanding through education-sanskar - the humane tradition (manav parampara) that carries on. Highlight the design point: this is not an ideal bolted onto matter - the ontology is such that the progression is designed to arrive here. Development is definite, laws inherent to being (MVD p. 5); the three completenesses are designed stages toward which units are meant (SB pp. 50-52); the drive is built into the design of existence (paper 1.6); nature saturated in satta is bound for development until realisation in satta (SB pp. 51, 91). An awakened human tradition is what existence's own progression delivers. Close the arc: what is saturated in the ground has come to realise the ground, and the whole of nature stands fulfilled and evident in coexistence (SB pp. 51, 81; JV p. 61; MVD pp. 14-15).</a:t>
+            </a:r>
+            <a:endParaRPr lang="en-US" dirty="0"/>
+          </a:p>
+        </p:txBody>
+      </p:sp>
+      <p:sp>
+        <p:nvSpPr>
+          <p:cNvPr id="4" name="Slide Number Placeholder 3"/>
+          <p:cNvSpPr>
+            <a:spLocks noGrp="1"/>
+          </p:cNvSpPr>
+          <p:nvPr>
+            <p:ph type="sldNum" sz="quarter" idx="10"/>
+          </p:nvPr>
+        </p:nvSpPr>
+        <p:spPr/>
+        <p:txBody>
+          <a:bodyPr/>
+          <a:lstStyle/>
+          <a:p>
+            <a:fld id="{F7021451-1387-4CA6-816F-3879F97B5CBC}" type="slidenum">
+              <a:rPr lang="en-US"/>
+              <a:t>18</a:t>
+            </a:fld>
+            <a:endParaRPr lang="en-US"/>
+          </a:p>
+        </p:txBody>
+      </p:sp>
+    </p:spTree>
+    <p:extLst>
+      <p:ext uri="{BB962C8B-B14F-4D97-AF65-F5344CB8AC3E}">
+        <p14:creationId xmlns:p14="http://schemas.microsoft.com/office/powerpoint/2010/main" val="1024086991"/>
+      </p:ext>
+    </p:extLst>
+  </p:cSld>
+  <p:clrMapOvr>
+    <a:masterClrMapping/>
+  </p:clrMapOvr>
+</p:notes>
+</file>
+
 <file path=ppt/notesSlides/notesSlide2.xml><?xml version="1.0" encoding="utf-8"?>
 <p:notes xmlns:a="http://schemas.openxmlformats.org/drawingml/2006/main" xmlns:r="http://schemas.openxmlformats.org/officeDocument/2006/relationships" xmlns:p="http://schemas.openxmlformats.org/presentationml/2006/main">
   <p:cSld>
@@ -1399,7 +1488,7 @@
           <a:p>
             <a:r>
               <a:rPr lang="en-US" dirty="0"/>
-              <a:t>Set up the stakes before the answers. The first five questions are the classic ontological battleground - shared with Advaita Vedanta, Western philosophy, and modern science. The sixth is the epistemic question the study also frames: how can what exists be known, and at what scope? Emphasise that Madhyasth Darshan does not answer these piecemeal: one picture (coexistence) answers all six. The epistemic question gets its payoff mid-deck - the four senses of knowledge, then the epistemic ladder (what must be understood, from the unit alone up to the whole, to know form, gun, svabhav, and dharma) - and the closing slide answers it with the staged method: study, experiment and practice, realisation with conduct-evidence. Flag that we will close the loop at the end.</a:t>
+              <a:t>Set up the stakes before the answers. The first five questions are the classic ontological battleground - shared with Advaita Vedanta, Western philosophy, and modern science. The sixth is the epistemic question the study also frames: how can what exists be known, and at what scope? Emphasise that Madhyasth Darshan does not answer these piecemeal: one picture (coexistence) answers all six. The epistemic question gets its payoff mid-deck - the epistemic ladder (what must be understood, from the unit alone up to the whole, to know form, gun, svabhav, and dharma), then realisation in coexistence as where the drive terminates - and the closing slide answers it with the staged method: study, experiment and practice, realisation with conduct-evidence. Flag that we will close the loop at the end.</a:t>
             </a:r>
             <a:endParaRPr lang="en-US" dirty="0"/>
           </a:p>
@@ -1575,7 +1664,7 @@
           <a:p>
             <a:r>
               <a:rPr lang="en-US" dirty="0"/>
-              <a:t>Saturation (samprikt) is the ever-present bond - soaked, submerged, surrounded. The sponge-in-water and cell-in-nutrient images are illustrative, not identities. Stress that satta does not push units: it is not an efficient cause. Three endowments follow from the bond: recognition capability (complementarity is given, not created - capacity, ability, receptivity), activeness (inherent energy plus basic impulsion; quote 'Unit + Energy fullness = Activeness'), and inherent regulation (order comes from within, not from a cosmic command). Also worth saying aloud: manifestation is mutually dependent - without basic impulsion energy stays unmanifest; without energy no impulsion. Neither pole creates the other's existence, only its manifestation.</a:t>
+              <a:t>Saturation (samprikt) is the ever-present bond - soaked, submerged, surrounded. The sponge-in-water and cell-in-nutrient images are illustrative, not identities. Stress that satta does not push units: it is not an efficient cause. Three endowments follow from the bond: recognition capability (complementarity is given, not created - capacity, ability, receptivity), activeness (inherent energy plus basic impulsion; quote 'Unit + Energy fullness = Activeness'), and inherent regulation (order comes from within, not from a cosmic command). Also worth saying aloud: manifestation is mutually dependent - without basic impulsion energy stays unmanifest; without energy no impulsion. Neither pole creates the other's existence, only its manifestation. NEW: the saturation bond itself is knowledge - samprikt, coexistence, and gyan name one fact (MVD pp. 32-33); the three endowments are how gyan is present on the unit side. Attribute mapping: permeative satta provisions activeness (JV p. 150); transparency in mutuality provisions recognition (SB p. 50); mediativeness provisions regulation (MVD p. 26). INTERPRETATION (settled): in MVD pp. 32-33 the referent of 'yahi... yahi gyan hai' is the saturated STATE - nature submerged, soaked, surrounded in satta, which the text names coexistence - not a reified 'bond' as a third item. The slide uses the texts' evidence language ('is evident as' - MVD: law and regulation are evident in coexistence only; JV p. 150: the endowments are the testimony of permeative satta). Avoid 'projects' for the ground - satta is actionless, and projection (paravartan) is jeevan's outward activity on slides 11 and 16; avoid predicating reflection of the ground too - the reflector model has the ATOM reflecting satta (slide 10). the identity claim itself - saturated coexistence IS knowledge, MVD pp. 32-33 - stays as presenter background and in the paper 1.2. If pressed, avoid 'the bond itself is knowledge'. It is an identity claim about the state, plus a separate consequence: from it, every unit has the three endowments. The knowledge identity holds for insentient AND sentient nature (MVD pp. 32-33) - insentient units abide in gyan as the three endowments (law and regulation evident, without knowing); the sentient atom ALONE additionally reflects the ground as active sentience - the capacity to know (the reflector model, slide 10; permeative gyan latent in satta actualised as chaitanya at T1). Careful wording: satta does not project - it is actionless; the unit reflects what is ever-present in the ground. What is exclusive to the sentient atom is the reflection of gyan as sentience, not the ground itself - every atom is saturated in and sustained by satta.</a:t>
             </a:r>
             <a:endParaRPr lang="en-US" dirty="0"/>
           </a:p>
@@ -1927,7 +2016,7 @@
           <a:p>
             <a:r>
               <a:rPr lang="en-US" dirty="0"/>
-              <a:t>The completeness drive is built into the design of existence, not an ethic bolted onto matter. Every activity is one inseparable triad - effort, motion, result are three joint aspects, not three sequential steps. Example from SB: sodium and chlorine ions approaching is effort and motion together; the stable salt crystal is the result. Read SB p. 62's compressed chain aloud if time allows - saturation itself is forcefulness, forcefulness is basic impulsion, impulsion is activity, activity is effort-motion-result, and that is development. Each triad term has a teleological goal (restfulness, destination, immortality), and the two atomic paths on the right set up the next slide: the insentient path completes result at T1; the sentient path continues to T2 and T3.</a:t>
+              <a:t>The completeness drive is built into the design of existence, not an ethic bolted onto matter. Every activity is one inseparable triad - effort, motion, result are three joint aspects, not three sequential steps. Example from SB: sodium and chlorine ions approaching is effort and motion together; the stable salt crystal is the result. Read SB p. 62's compressed chain aloud if time allows - saturation itself is forcefulness, forcefulness is basic impulsion, impulsion is activity, activity is effort-motion-result, and that is development. Each triad term has a teleological goal (restfulness, destination, immortality), and the two atomic paths on the right set up the next slide: the insentient path completes result at T1; the sentient path continues to T2 and T3. NEW: state the drive's span with SB p. 51 - nature is oriented for development and awakening UNTIL realisation in Omnipotence; SB p. 91 calls this bound an existential truth. Role differentiation: development pervades all of nature, awakening occurs in the sentient - insentient units participate by composing bodies and environments without individually completing the drive.</a:t>
             </a:r>
             <a:endParaRPr lang="en-US" dirty="0"/>
           </a:p>
@@ -2015,7 +2104,7 @@
           <a:p>
             <a:r>
               <a:rPr lang="en-US" dirty="0"/>
-              <a:t>The three transitions are developmental milestones mapped to plane shifts. T1: constitutional completeness - immortality of result - sentient jeevan appears; physicochemical to delusional. T2: activity completeness - restfulness of effort - internal cognitive seeking resolves into direct realisation and absolute resolution (samadhan); delusional to deific. T3: conduct completeness - destination of motion - authentic conduct with living proof (pramanikta); deific to divine. Two cautions from the study: 'delusional' names a developmental stage, not psychiatric illness; and T2's vishram (settlement of internal effort) must not be conflated with the insentient natural-state ease from the unit slide, nor T3 collapsed into T2 - one is internal settlement, the other external destination.</a:t>
+              <a:t>The three transitions are developmental milestones mapped to plane shifts. T1: constitutional completeness - immortality of result - sentient jeevan appears; physicochemical to delusional. T2: activity completeness - restfulness of effort - internal cognitive seeking resolves into direct realisation and absolute resolution (samadhan); delusional to deific. T3: conduct completeness - destination of motion - authentic conduct with living proof (pramanikta); deific to divine. Two cautions from the study: 'delusional' names a developmental stage, not psychiatric illness; and T2's vishram (settlement of internal effort) must not be conflated with the insentient natural-state ease from the unit slide, nor T3 collapsed into T2 - one is internal settlement, the other external destination. NEW: T3 Hindi term corrected to acharanpurnata (both MVD and SB use aacharan purnata; vyavahar purnata appears in neither). Close with the drive statement: the saturated realising the ground it is saturated in - that is the completeness drive.</a:t>
             </a:r>
             <a:endParaRPr lang="en-US" dirty="0"/>
           </a:p>
@@ -2730,7 +2819,7 @@
                 <a:ea typeface="Calibri" pitchFamily="34" charset="-122"/>
                 <a:cs typeface="Calibri" pitchFamily="34" charset="-120"/>
               </a:rPr>
-              <a:t>Based on §1 of </a:t>
+              <a:t xml:space="preserve">Based on §1 of </a:t>
             </a:r>
             <a:pPr indent="0" marL="0">
               <a:buNone/>
@@ -2758,7 +2847,7 @@
                 <a:ea typeface="Calibri" pitchFamily="34" charset="-122"/>
                 <a:cs typeface="Calibri" pitchFamily="34" charset="-120"/>
               </a:rPr>
-              <a:t> (AnalyticMadhyasthDarshan.org)</a:t>
+              <a:t xml:space="preserve"> (AnalyticMadhyasthDarshan.org)</a:t>
             </a:r>
             <a:endParaRPr lang="en-US" sz="1150" dirty="0"/>
           </a:p>
@@ -3010,7 +3099,7 @@
                 <a:ea typeface="Calibri" pitchFamily="34" charset="-122"/>
                 <a:cs typeface="Calibri" pitchFamily="34" charset="-120"/>
               </a:rPr>
-              <a:t>Constitutional completeness at the atomic level, </a:t>
+              <a:t xml:space="preserve">Constitutional completeness at the atomic level, </a:t>
             </a:r>
             <a:pPr indent="0" marL="0">
               <a:buNone/>
@@ -3276,7 +3365,7 @@
                 <a:ea typeface="Calibri" pitchFamily="34" charset="-122"/>
                 <a:cs typeface="Calibri" pitchFamily="34" charset="-120"/>
               </a:rPr>
-              <a:t>Liberated from molecular- and weight-bondage; hope-bondage defines the sentient mode</a:t>
+              <a:t>Liberated from molecular- and weight-bondage; hope-bondage carries the drive — a new mode, not a new direction</a:t>
             </a:r>
             <a:endParaRPr lang="en-US" sz="1050" dirty="0"/>
           </a:p>
@@ -3390,7 +3479,7 @@
                 <a:ea typeface="Calibri" pitchFamily="34" charset="-122"/>
                 <a:cs typeface="Calibri" pitchFamily="34" charset="-120"/>
               </a:rPr>
-              <a:t>T1 is irreversible at the atomic level: the jeevan atom is immune to decomposition — the ontological basis for jeevan’s persistence.</a:t>
+              <a:t>T1 is irreversible at the atomic level: the jeevan atom is immune to decomposition — the ontological basis for jeevan’s persistence. Taste-recognition, impossible in insentient nature, first manifests here — recognition gains its inner circuit.</a:t>
             </a:r>
             <a:endParaRPr lang="en-US" sz="1200" dirty="0"/>
           </a:p>
@@ -3429,7 +3518,7 @@
                 <a:ea typeface="Calibri" pitchFamily="34" charset="-122"/>
                 <a:cs typeface="Calibri" pitchFamily="34" charset="-120"/>
               </a:rPr>
-              <a:t>SB pp. 52, 55, 59, 92  ·  MVD pp. 8, 91, 117</a:t>
+              <a:t>SB pp. 52, 55, 59, 80–81, 92  ·  MVD pp. 8, 91, 117</a:t>
             </a:r>
             <a:endParaRPr lang="en-US" sz="950" dirty="0"/>
           </a:p>
@@ -5259,7 +5348,7 @@
                 <a:ea typeface="Calibri" pitchFamily="34" charset="-122"/>
                 <a:cs typeface="Calibri" pitchFamily="34" charset="-120"/>
               </a:rPr>
-              <a:t>Five inseparable aspects operating through projection and reflection. </a:t>
+              <a:t xml:space="preserve">Reflection is the knowing direction — ascent of understanding toward anubhav; projection is the evidencing direction — descent from realisation to conduct. </a:t>
             </a:r>
             <a:pPr indent="0" marL="0">
               <a:buNone/>
@@ -5273,7 +5362,7 @@
                 <a:ea typeface="Calibri" pitchFamily="34" charset="-122"/>
                 <a:cs typeface="Calibri" pitchFamily="34" charset="-120"/>
               </a:rPr>
-              <a:t>On the delusional plane, atma is “I” and the orbital four are “mine”; awakening is the four coming into accordance with atma.</a:t>
+              <a:t>On the delusional plane, atma is “I” and the orbital four are “mine”; awakening — staged as three statuses of buddhi — is the four coming into accordance with atma.</a:t>
             </a:r>
             <a:endParaRPr lang="en-US" sz="1050" dirty="0"/>
           </a:p>
@@ -5312,7 +5401,7 @@
                 <a:ea typeface="Calibri" pitchFamily="34" charset="-122"/>
                 <a:cs typeface="Calibri" pitchFamily="34" charset="-120"/>
               </a:rPr>
-              <a:t>MVD pp. 13, 78  ·  JV p. 92  ·  koshas (developmental sheaths) are a distinct five-fold structure — MVD pp. 49–50</a:t>
+              <a:t>MVD pp. 13, 78, 126, 278–279, 286–287  ·  JV p. 92  ·  koshas (developmental sheaths) are a distinct five-fold structure — MVD pp. 49–50</a:t>
             </a:r>
             <a:endParaRPr lang="en-US" sz="950" dirty="0"/>
           </a:p>
@@ -6209,7 +6298,7 @@
                 <a:ea typeface="Calibri" pitchFamily="34" charset="-122"/>
                 <a:cs typeface="Calibri" pitchFamily="34" charset="-120"/>
               </a:rPr>
-              <a:t>Awakening is felt harmony: </a:t>
+              <a:t xml:space="preserve">Awakening is felt harmony: </a:t>
             </a:r>
             <a:pPr indent="0" marL="0">
               <a:buNone/>
@@ -6658,7 +6747,7 @@
                 <a:ea typeface="Calibri" pitchFamily="34" charset="-122"/>
                 <a:cs typeface="Calibri" pitchFamily="34" charset="-120"/>
               </a:rPr>
-              <a:t>Niyati-kram — </a:t>
+              <a:t xml:space="preserve">Niyati-kram — </a:t>
             </a:r>
             <a:pPr indent="0" marL="0">
               <a:buNone/>
@@ -6770,7 +6859,7 @@
                 <a:ea typeface="Calibri" pitchFamily="34" charset="-122"/>
                 <a:cs typeface="Calibri" pitchFamily="34" charset="-120"/>
               </a:rPr>
-              <a:t>Niyati-vidhi — </a:t>
+              <a:t xml:space="preserve">Niyati-vidhi — </a:t>
             </a:r>
             <a:pPr indent="0" marL="0">
               <a:buNone/>
@@ -6882,7 +6971,7 @@
                 <a:ea typeface="Calibri" pitchFamily="34" charset="-122"/>
                 <a:cs typeface="Calibri" pitchFamily="34" charset="-120"/>
               </a:rPr>
-              <a:t>Vikas-kram — </a:t>
+              <a:t xml:space="preserve">Vikas-kram — </a:t>
             </a:r>
             <a:pPr indent="0" marL="0">
               <a:buNone/>
@@ -6994,7 +7083,7 @@
                 <a:ea typeface="Calibri" pitchFamily="34" charset="-122"/>
                 <a:cs typeface="Calibri" pitchFamily="34" charset="-120"/>
               </a:rPr>
-              <a:t>Jagriti-kram — </a:t>
+              <a:t xml:space="preserve">Jagriti-kram — </a:t>
             </a:r>
             <a:pPr indent="0" marL="0">
               <a:buNone/>
@@ -8097,7 +8186,7 @@
                 <a:ea typeface="Calibri" pitchFamily="34" charset="-122"/>
                 <a:cs typeface="Calibri" pitchFamily="34" charset="-120"/>
               </a:rPr>
-              <a:t>Orderliness is self-regulation, inherent in saturated units — not dispensed by a cosmic governor. </a:t>
+              <a:t xml:space="preserve">Orderliness is self-regulation, inherent in saturated units — not dispensed by a cosmic governor. </a:t>
             </a:r>
             <a:pPr indent="0" marL="0">
               <a:buNone/>
@@ -9233,7 +9322,7 @@
                 <a:ea typeface="Calibri" pitchFamily="34" charset="-122"/>
                 <a:cs typeface="Calibri" pitchFamily="34" charset="-120"/>
               </a:rPr>
-              <a:t>Justice (nyaya) </a:t>
+              <a:t xml:space="preserve">Justice (nyaya) </a:t>
             </a:r>
             <a:pPr indent="0" marL="0">
               <a:buNone/>
@@ -9421,7 +9510,7 @@
                 <a:ea typeface="Calibri" pitchFamily="34" charset="-122"/>
                 <a:cs typeface="Calibri" pitchFamily="34" charset="-120"/>
               </a:rPr>
-              <a:t>§1.13</a:t>
+              <a:t>§1.13 · WHERE THE DRIVE TERMINATES</a:t>
             </a:r>
             <a:endParaRPr lang="en-US" sz="1050" dirty="0"/>
           </a:p>
@@ -9460,7 +9549,7 @@
                 <a:ea typeface="Cambria" pitchFamily="34" charset="-122"/>
                 <a:cs typeface="Cambria" pitchFamily="34" charset="-120"/>
               </a:rPr>
-              <a:t>Four Senses of Knowledge (Gyan)</a:t>
+              <a:t>Realisation in Coexistence</a:t>
             </a:r>
             <a:endParaRPr lang="en-US" sz="3000" dirty="0"/>
           </a:p>
@@ -9499,7 +9588,7 @@
                 <a:ea typeface="Calibri" pitchFamily="34" charset="-122"/>
                 <a:cs typeface="Calibri" pitchFamily="34" charset="-120"/>
               </a:rPr>
-              <a:t>The texts use gyan at four distinct senses; conflating them yields either a pan-knowing Omnipresence or a world with no inherent intelligibility.</a:t>
+              <a:t>The drive comes to rest when relationships across nature are fulfilled and made evident in coexistence — not because satta becomes a knower, but because awakened jeevan lives out what was always latent in the bond. Realisation itself is awakening; recognising and fulfilling then become its living proof.</a:t>
             </a:r>
             <a:endParaRPr lang="en-US" sz="1250" dirty="0"/>
           </a:p>
@@ -9567,7 +9656,7 @@
                 <a:ea typeface="Cambria" pitchFamily="34" charset="-122"/>
                 <a:cs typeface="Cambria" pitchFamily="34" charset="-120"/>
               </a:rPr>
-              <a:t>Realisation Knowledge (anubhav jnan)</a:t>
+              <a:t>Realisation is bliss (anand)</a:t>
             </a:r>
             <a:endParaRPr lang="en-US" sz="1250" dirty="0"/>
           </a:p>
@@ -9606,7 +9695,7 @@
                 <a:ea typeface="Calibri" pitchFamily="34" charset="-122"/>
                 <a:cs typeface="Calibri" pitchFamily="34" charset="-120"/>
               </a:rPr>
-              <a:t>Orderliness already present in every saturated unit — the ontological given: what exists to be known.</a:t>
+              <a:t>“Truth itself is abundance (coexistence), realisation of abundance itself is bliss, bliss itself is jeevan.” And it is knowledge itself: what is realised is the ground the unit was always soaked in.</a:t>
             </a:r>
             <a:endParaRPr lang="en-US" sz="1030" dirty="0"/>
           </a:p>
@@ -9674,7 +9763,7 @@
                 <a:ea typeface="Cambria" pitchFamily="34" charset="-122"/>
                 <a:cs typeface="Cambria" pitchFamily="34" charset="-120"/>
               </a:rPr>
-              <a:t>Gyan as satta</a:t>
+              <a:t>Knowledge — in projection</a:t>
             </a:r>
             <a:endParaRPr lang="en-US" sz="1250" dirty="0"/>
           </a:p>
@@ -9713,7 +9802,7 @@
                 <a:ea typeface="Calibri" pitchFamily="34" charset="-122"/>
                 <a:cs typeface="Calibri" pitchFamily="34" charset="-120"/>
               </a:rPr>
-              <a:t>The ground’s state-complete intelligibility — Space as knowledge; a condition of intelligibility, not a knowing subject.</a:t>
+              <a:t>Realisation projected outward is authenticity — knowledge, wisdom, and science (gyan–vivek–vigyan) unfolding into conduct (gyan udghatan).</a:t>
             </a:r>
             <a:endParaRPr lang="en-US" sz="1030" dirty="0"/>
           </a:p>
@@ -9781,7 +9870,7 @@
                 <a:ea typeface="Cambria" pitchFamily="34" charset="-122"/>
                 <a:cs typeface="Cambria" pitchFamily="34" charset="-120"/>
               </a:rPr>
-              <a:t>Realisation in coexistence</a:t>
+              <a:t>Knower — in reflection</a:t>
             </a:r>
             <a:endParaRPr lang="en-US" sz="1250" dirty="0"/>
           </a:p>
@@ -9820,7 +9909,7 @@
                 <a:ea typeface="Calibri" pitchFamily="34" charset="-122"/>
                 <a:cs typeface="Calibri" pitchFamily="34" charset="-120"/>
               </a:rPr>
-              <a:t>Relationships fulfilled and made evident across nature — the telos of complete knowing, not a new state of the ground.</a:t>
+              <a:t>The knower is jeevan filled with realisation. When buddhi reflects toward atma, self-knowledge (atma-bodh) and realisation in coexistence arrive together.</a:t>
             </a:r>
             <a:endParaRPr lang="en-US" sz="1030" dirty="0"/>
           </a:p>
@@ -9888,7 +9977,7 @@
                 <a:ea typeface="Cambria" pitchFamily="34" charset="-122"/>
                 <a:cs typeface="Cambria" pitchFamily="34" charset="-120"/>
               </a:rPr>
-              <a:t>Gyan udghatan</a:t>
+              <a:t>Knowable — and no merger</a:t>
             </a:r>
             <a:endParaRPr lang="en-US" sz="1250" dirty="0"/>
           </a:p>
@@ -9927,7 +10016,7 @@
                 <a:ea typeface="Calibri" pitchFamily="34" charset="-122"/>
                 <a:cs typeface="Calibri" pitchFamily="34" charset="-120"/>
               </a:rPr>
-              <a:t>The unfolding of knowledge in thought and conduct — exclusive activity of awakened jeevan through the human body.</a:t>
+              <a:t>What is known is existence itself — nature saturated in satta. Knowledge, knower, and known become uniform as roles in one bond — not a merger: the knower remains a distinct jeevan.</a:t>
             </a:r>
             <a:endParaRPr lang="en-US" sz="1030" dirty="0"/>
           </a:p>
@@ -9966,7 +10055,7 @@
                 <a:ea typeface="Calibri" pitchFamily="34" charset="-122"/>
                 <a:cs typeface="Calibri" pitchFamily="34" charset="-120"/>
               </a:rPr>
-              <a:t>The knower is always sentient jeevan; the brain is a physical interface — MVD pp. 11, 35, 115–116, 289; SB p. 51</a:t>
+              <a:t>“In the state of realisation in existence, uniformity in knowledge, knowable &amp; knower has been observed to be in the form of coexistence” — AVD p. 217 · SB p. 81 · MVD pp. 14–15</a:t>
             </a:r>
             <a:endParaRPr lang="en-US" sz="950" dirty="0"/>
           </a:p>
@@ -10597,7 +10686,7 @@
                 <a:ea typeface="Calibri" pitchFamily="34" charset="-122"/>
                 <a:cs typeface="Calibri" pitchFamily="34" charset="-120"/>
               </a:rPr>
-              <a:t>Atma   </a:t>
+              <a:t xml:space="preserve">Atma   </a:t>
             </a:r>
             <a:pPr indent="0" marL="0">
               <a:buNone/>
@@ -10679,7 +10768,7 @@
                 <a:ea typeface="Calibri" pitchFamily="34" charset="-122"/>
                 <a:cs typeface="Calibri" pitchFamily="34" charset="-120"/>
               </a:rPr>
-              <a:t>Buddhi   </a:t>
+              <a:t xml:space="preserve">Buddhi   </a:t>
             </a:r>
             <a:pPr indent="0" marL="0">
               <a:buNone/>
@@ -10761,7 +10850,7 @@
                 <a:ea typeface="Calibri" pitchFamily="34" charset="-122"/>
                 <a:cs typeface="Calibri" pitchFamily="34" charset="-120"/>
               </a:rPr>
-              <a:t>Chitta   </a:t>
+              <a:t xml:space="preserve">Chitta   </a:t>
             </a:r>
             <a:pPr indent="0" marL="0">
               <a:buNone/>
@@ -10843,7 +10932,7 @@
                 <a:ea typeface="Calibri" pitchFamily="34" charset="-122"/>
                 <a:cs typeface="Calibri" pitchFamily="34" charset="-120"/>
               </a:rPr>
-              <a:t>Vritti   </a:t>
+              <a:t xml:space="preserve">Vritti   </a:t>
             </a:r>
             <a:pPr indent="0" marL="0">
               <a:buNone/>
@@ -10925,7 +11014,7 @@
                 <a:ea typeface="Calibri" pitchFamily="34" charset="-122"/>
                 <a:cs typeface="Calibri" pitchFamily="34" charset="-120"/>
               </a:rPr>
-              <a:t>Mun   </a:t>
+              <a:t xml:space="preserve">Mun   </a:t>
             </a:r>
             <a:pPr indent="0" marL="0">
               <a:buNone/>
@@ -11531,7 +11620,7 @@
                 <a:ea typeface="Calibri" pitchFamily="34" charset="-122"/>
                 <a:cs typeface="Calibri" pitchFamily="34" charset="-120"/>
               </a:rPr>
-              <a:t>At the human scale, the completeness drive manifests as four goals — composing upward from family to undivided society (akhand samaj) and universal orderliness (sarvabhaum vyavastha):</a:t>
+              <a:t>At the human scale, the drive shows itself as four goals — rising from the person, through the family, to an undivided society (akhand samaj) in universal orderliness (sarvabhaum vyavastha):</a:t>
             </a:r>
             <a:endParaRPr lang="en-US" sz="1200" dirty="0"/>
           </a:p>
@@ -11638,7 +11727,7 @@
                 <a:ea typeface="Calibri" pitchFamily="34" charset="-122"/>
                 <a:cs typeface="Calibri" pitchFamily="34" charset="-120"/>
               </a:rPr>
-              <a:t>samadhan — clarity without residue</a:t>
+              <a:t>samadhan — understanding settled, nothing left unresolved</a:t>
             </a:r>
             <a:endParaRPr lang="en-US" sz="930" dirty="0"/>
           </a:p>
@@ -11998,7 +12087,7 @@
                 <a:ea typeface="Calibri" pitchFamily="34" charset="-122"/>
                 <a:cs typeface="Calibri" pitchFamily="34" charset="-120"/>
               </a:rPr>
-              <a:t>“Resolution = Happiness…” — JV p. 61  ·  MVD p. 13  ·  five dimensions of universal orderliness, §1.15</a:t>
+              <a:t>“Resolution = Happiness…” — JV p. 61  ·  MVD p. 13  ·  five dimensions of universal orderliness, sustained as humane tradition (manav parampara), §1.15</a:t>
             </a:r>
             <a:endParaRPr lang="en-US" sz="950" dirty="0"/>
           </a:p>
@@ -13221,6 +13310,453 @@
 </p:sld>
 </file>
 
+<file path=ppt/slides/slide19.xml><?xml version="1.0" encoding="utf-8"?>
+<p:sld xmlns:a="http://schemas.openxmlformats.org/drawingml/2006/main" xmlns:r="http://schemas.openxmlformats.org/officeDocument/2006/relationships" xmlns:p="http://schemas.openxmlformats.org/presentationml/2006/main">
+  <p:cSld name="Slide 1">
+    <p:bg>
+      <p:bgPr>
+        <a:solidFill>
+          <a:srgbClr val="1E2447"/>
+        </a:solidFill>
+      </p:bgPr>
+    </p:bg>
+    <p:spTree>
+      <p:nvGrpSpPr>
+        <p:cNvPr id="1" name=""/>
+        <p:cNvGrpSpPr/>
+        <p:nvPr/>
+      </p:nvGrpSpPr>
+      <p:grpSpPr>
+        <a:xfrm>
+          <a:off x="0" y="0"/>
+          <a:ext cx="0" cy="0"/>
+          <a:chOff x="0" y="0"/>
+          <a:chExt cx="0" cy="0"/>
+        </a:xfrm>
+      </p:grpSpPr>
+      <p:sp>
+        <p:nvSpPr>
+          <p:cNvPr id="3" name="Shape 0"/>
+          <p:cNvSpPr/>
+          <p:nvPr/>
+        </p:nvSpPr>
+        <p:spPr>
+          <a:xfrm>
+            <a:off x="5852160" y="822960"/>
+            <a:ext cx="3291840" cy="3291840"/>
+          </a:xfrm>
+          <a:prstGeom prst="ellipse">
+            <a:avLst/>
+          </a:prstGeom>
+          <a:ln w="15875">
+            <a:solidFill>
+              <a:srgbClr val="44507E"/>
+            </a:solidFill>
+            <a:prstDash val="solid"/>
+          </a:ln>
+        </p:spPr>
+      </p:sp>
+      <p:sp>
+        <p:nvSpPr>
+          <p:cNvPr id="4" name="Shape 1"/>
+          <p:cNvSpPr/>
+          <p:nvPr/>
+        </p:nvSpPr>
+        <p:spPr>
+          <a:xfrm>
+            <a:off x="6510528" y="1481328"/>
+            <a:ext cx="1975104" cy="1975104"/>
+          </a:xfrm>
+          <a:prstGeom prst="ellipse">
+            <a:avLst/>
+          </a:prstGeom>
+          <a:ln w="15875">
+            <a:solidFill>
+              <a:srgbClr val="44507E"/>
+            </a:solidFill>
+            <a:prstDash val="solid"/>
+          </a:ln>
+        </p:spPr>
+      </p:sp>
+      <p:sp>
+        <p:nvSpPr>
+          <p:cNvPr id="5" name="Shape 2"/>
+          <p:cNvSpPr/>
+          <p:nvPr/>
+        </p:nvSpPr>
+        <p:spPr>
+          <a:xfrm>
+            <a:off x="7070141" y="2040941"/>
+            <a:ext cx="855878" cy="855878"/>
+          </a:xfrm>
+          <a:prstGeom prst="ellipse">
+            <a:avLst/>
+          </a:prstGeom>
+          <a:solidFill>
+            <a:srgbClr val="C9821E"/>
+          </a:solidFill>
+          <a:ln/>
+        </p:spPr>
+      </p:sp>
+      <p:sp>
+        <p:nvSpPr>
+          <p:cNvPr id="6" name="Shape 3"/>
+          <p:cNvSpPr/>
+          <p:nvPr/>
+        </p:nvSpPr>
+        <p:spPr>
+          <a:xfrm>
+            <a:off x="5394960" y="3566160"/>
+            <a:ext cx="1097280" cy="1097280"/>
+          </a:xfrm>
+          <a:prstGeom prst="ellipse">
+            <a:avLst/>
+          </a:prstGeom>
+          <a:ln w="15875">
+            <a:solidFill>
+              <a:srgbClr val="44507E"/>
+            </a:solidFill>
+            <a:prstDash val="solid"/>
+          </a:ln>
+        </p:spPr>
+      </p:sp>
+      <p:sp>
+        <p:nvSpPr>
+          <p:cNvPr id="7" name="Shape 4"/>
+          <p:cNvSpPr/>
+          <p:nvPr/>
+        </p:nvSpPr>
+        <p:spPr>
+          <a:xfrm>
+            <a:off x="5614416" y="3785616"/>
+            <a:ext cx="658368" cy="658368"/>
+          </a:xfrm>
+          <a:prstGeom prst="ellipse">
+            <a:avLst/>
+          </a:prstGeom>
+          <a:ln w="15875">
+            <a:solidFill>
+              <a:srgbClr val="44507E"/>
+            </a:solidFill>
+            <a:prstDash val="solid"/>
+          </a:ln>
+        </p:spPr>
+      </p:sp>
+      <p:sp>
+        <p:nvSpPr>
+          <p:cNvPr id="8" name="Shape 5"/>
+          <p:cNvSpPr/>
+          <p:nvPr/>
+        </p:nvSpPr>
+        <p:spPr>
+          <a:xfrm>
+            <a:off x="5800954" y="3972154"/>
+            <a:ext cx="285293" cy="285293"/>
+          </a:xfrm>
+          <a:prstGeom prst="ellipse">
+            <a:avLst/>
+          </a:prstGeom>
+          <a:solidFill>
+            <a:srgbClr val="C9D4EF"/>
+          </a:solidFill>
+          <a:ln/>
+        </p:spPr>
+      </p:sp>
+      <p:sp>
+        <p:nvSpPr>
+          <p:cNvPr id="9" name="Shape 6"/>
+          <p:cNvSpPr/>
+          <p:nvPr/>
+        </p:nvSpPr>
+        <p:spPr>
+          <a:xfrm>
+            <a:off x="8138160" y="4023360"/>
+            <a:ext cx="731520" cy="731520"/>
+          </a:xfrm>
+          <a:prstGeom prst="ellipse">
+            <a:avLst/>
+          </a:prstGeom>
+          <a:ln w="15875">
+            <a:solidFill>
+              <a:srgbClr val="44507E"/>
+            </a:solidFill>
+            <a:prstDash val="solid"/>
+          </a:ln>
+        </p:spPr>
+      </p:sp>
+      <p:sp>
+        <p:nvSpPr>
+          <p:cNvPr id="10" name="Shape 7"/>
+          <p:cNvSpPr/>
+          <p:nvPr/>
+        </p:nvSpPr>
+        <p:spPr>
+          <a:xfrm>
+            <a:off x="8284464" y="4169664"/>
+            <a:ext cx="438912" cy="438912"/>
+          </a:xfrm>
+          <a:prstGeom prst="ellipse">
+            <a:avLst/>
+          </a:prstGeom>
+          <a:ln w="15875">
+            <a:solidFill>
+              <a:srgbClr val="44507E"/>
+            </a:solidFill>
+            <a:prstDash val="solid"/>
+          </a:ln>
+        </p:spPr>
+      </p:sp>
+      <p:sp>
+        <p:nvSpPr>
+          <p:cNvPr id="11" name="Shape 8"/>
+          <p:cNvSpPr/>
+          <p:nvPr/>
+        </p:nvSpPr>
+        <p:spPr>
+          <a:xfrm>
+            <a:off x="8408822" y="4294022"/>
+            <a:ext cx="190195" cy="190195"/>
+          </a:xfrm>
+          <a:prstGeom prst="ellipse">
+            <a:avLst/>
+          </a:prstGeom>
+          <a:solidFill>
+            <a:srgbClr val="C9D4EF"/>
+          </a:solidFill>
+          <a:ln/>
+        </p:spPr>
+      </p:sp>
+      <p:sp>
+        <p:nvSpPr>
+          <p:cNvPr id="12" name="Text 9"/>
+          <p:cNvSpPr/>
+          <p:nvPr/>
+        </p:nvSpPr>
+        <p:spPr>
+          <a:xfrm>
+            <a:off x="640080" y="1234440"/>
+            <a:ext cx="5852160" cy="274320"/>
+          </a:xfrm>
+          <a:prstGeom prst="rect">
+            <a:avLst/>
+          </a:prstGeom>
+          <a:noFill/>
+          <a:ln/>
+        </p:spPr>
+        <p:txBody>
+          <a:bodyPr wrap="square" lIns="0" tIns="0" rIns="0" bIns="0" rtlCol="0" anchor="ctr"/>
+          <a:lstStyle/>
+          <a:p>
+            <a:pPr indent="0" marL="0">
+              <a:buNone/>
+            </a:pPr>
+            <a:r>
+              <a:rPr lang="en-US" sz="1200" b="1" spc="400" kern="0" dirty="0">
+                <a:solidFill>
+                  <a:srgbClr val="C9821E"/>
+                </a:solidFill>
+                <a:latin typeface="Calibri" pitchFamily="34" charset="0"/>
+                <a:ea typeface="Calibri" pitchFamily="34" charset="-122"/>
+                <a:cs typeface="Calibri" pitchFamily="34" charset="-120"/>
+              </a:rPr>
+              <a:t>THE CULMINATION  ·  BUILT INTO THE DESIGN</a:t>
+            </a:r>
+            <a:endParaRPr lang="en-US" sz="1200" dirty="0"/>
+          </a:p>
+        </p:txBody>
+      </p:sp>
+      <p:sp>
+        <p:nvSpPr>
+          <p:cNvPr id="13" name="Text 10"/>
+          <p:cNvSpPr/>
+          <p:nvPr/>
+        </p:nvSpPr>
+        <p:spPr>
+          <a:xfrm>
+            <a:off x="640080" y="1572768"/>
+            <a:ext cx="5577840" cy="1371600"/>
+          </a:xfrm>
+          <a:prstGeom prst="rect">
+            <a:avLst/>
+          </a:prstGeom>
+          <a:noFill/>
+          <a:ln/>
+        </p:spPr>
+        <p:txBody>
+          <a:bodyPr wrap="square" lIns="0" tIns="0" rIns="0" bIns="0" rtlCol="0" anchor="ctr"/>
+          <a:lstStyle/>
+          <a:p>
+            <a:pPr indent="0" marL="0">
+              <a:buNone/>
+            </a:pPr>
+            <a:r>
+              <a:rPr lang="en-US" sz="4400" b="1" dirty="0">
+                <a:solidFill>
+                  <a:srgbClr val="FFFFFF"/>
+                </a:solidFill>
+                <a:latin typeface="Cambria" pitchFamily="34" charset="0"/>
+                <a:ea typeface="Cambria" pitchFamily="34" charset="-122"/>
+                <a:cs typeface="Cambria" pitchFamily="34" charset="-120"/>
+              </a:rPr>
+              <a:t>An Awakened Human Tradition</a:t>
+            </a:r>
+            <a:endParaRPr lang="en-US" sz="4400" dirty="0"/>
+          </a:p>
+        </p:txBody>
+      </p:sp>
+      <p:sp>
+        <p:nvSpPr>
+          <p:cNvPr id="14" name="Text 11"/>
+          <p:cNvSpPr/>
+          <p:nvPr/>
+        </p:nvSpPr>
+        <p:spPr>
+          <a:xfrm>
+            <a:off x="640080" y="3050000"/>
+            <a:ext cx="4846320" cy="685800"/>
+          </a:xfrm>
+          <a:prstGeom prst="rect">
+            <a:avLst/>
+          </a:prstGeom>
+          <a:noFill/>
+          <a:ln/>
+        </p:spPr>
+        <p:txBody>
+          <a:bodyPr wrap="square" lIns="0" tIns="0" rIns="0" bIns="0" rtlCol="0" anchor="ctr"/>
+          <a:lstStyle/>
+          <a:p>
+            <a:pPr indent="0" marL="0">
+              <a:buNone/>
+            </a:pPr>
+            <a:r>
+              <a:rPr lang="en-US" sz="1600" i="1" dirty="0">
+                <a:solidFill>
+                  <a:srgbClr val="C9D4EF"/>
+                </a:solidFill>
+                <a:latin typeface="Calibri" pitchFamily="34" charset="0"/>
+                <a:ea typeface="Calibri" pitchFamily="34" charset="-122"/>
+                <a:cs typeface="Calibri" pitchFamily="34" charset="-120"/>
+              </a:rPr>
+              <a:t>The drive that began in every atom comes to rest in awakened human beings — effort settled in realisation, understanding proven in daily conduct. The progression was always headed here.</a:t>
+            </a:r>
+            <a:endParaRPr lang="en-US" sz="1600" dirty="0"/>
+          </a:p>
+        </p:txBody>
+      </p:sp>
+      <p:sp>
+        <p:nvSpPr>
+          <p:cNvPr id="15" name="Text 12"/>
+          <p:cNvSpPr/>
+          <p:nvPr/>
+        </p:nvSpPr>
+        <p:spPr>
+          <a:xfrm>
+            <a:off x="640080" y="4160520"/>
+            <a:ext cx="5303520" cy="548640"/>
+          </a:xfrm>
+          <a:prstGeom prst="rect">
+            <a:avLst/>
+          </a:prstGeom>
+          <a:noFill/>
+          <a:ln/>
+        </p:spPr>
+        <p:txBody>
+          <a:bodyPr wrap="square" lIns="0" tIns="0" rIns="0" bIns="0" rtlCol="0" anchor="ctr"/>
+          <a:lstStyle/>
+          <a:p>
+            <a:pPr indent="0" marL="0">
+              <a:buNone/>
+            </a:pPr>
+            <a:r>
+              <a:rPr lang="en-US" sz="1150" dirty="0">
+                <a:solidFill>
+                  <a:srgbClr val="8E9BC4"/>
+                </a:solidFill>
+                <a:latin typeface="Calibri" pitchFamily="34" charset="0"/>
+                <a:ea typeface="Calibri" pitchFamily="34" charset="-122"/>
+                <a:cs typeface="Calibri" pitchFamily="34" charset="-120"/>
+              </a:rPr>
+              <a:t xml:space="preserve">They live as one undivided society — </a:t>
+            </a:r>
+            <a:pPr indent="0" marL="0">
+              <a:buNone/>
+            </a:pPr>
+            <a:r>
+              <a:rPr lang="en-US" sz="1150" i="1" dirty="0">
+                <a:solidFill>
+                  <a:srgbClr val="8E9BC4"/>
+                </a:solidFill>
+                <a:latin typeface="Calibri" pitchFamily="34" charset="0"/>
+                <a:ea typeface="Calibri" pitchFamily="34" charset="-122"/>
+                <a:cs typeface="Calibri" pitchFamily="34" charset="-120"/>
+              </a:rPr>
+              <a:t>resolution in every person, prosperity in every family, fearlessness and trust in society, coexistence with all of nature</a:t>
+            </a:r>
+            <a:pPr indent="0" marL="0">
+              <a:buNone/>
+            </a:pPr>
+            <a:r>
+              <a:rPr lang="en-US" sz="1150" dirty="0">
+                <a:solidFill>
+                  <a:srgbClr val="8E9BC4"/>
+                </a:solidFill>
+                <a:latin typeface="Calibri" pitchFamily="34" charset="0"/>
+                <a:ea typeface="Calibri" pitchFamily="34" charset="-122"/>
+                <a:cs typeface="Calibri" pitchFamily="34" charset="-120"/>
+              </a:rPr>
+              <a:t>.</a:t>
+            </a:r>
+            <a:endParaRPr lang="en-US" sz="1150" dirty="0"/>
+          </a:p>
+        </p:txBody>
+      </p:sp>
+      <p:sp>
+        <p:nvSpPr>
+          <p:cNvPr id="16" name="Text 13"/>
+          <p:cNvSpPr/>
+          <p:nvPr/>
+        </p:nvSpPr>
+        <p:spPr>
+          <a:xfrm>
+            <a:off x="640080" y="4650000"/>
+            <a:ext cx="5303520" cy="548640"/>
+          </a:xfrm>
+          <a:prstGeom prst="rect">
+            <a:avLst/>
+          </a:prstGeom>
+          <a:noFill/>
+          <a:ln/>
+        </p:spPr>
+        <p:txBody>
+          <a:bodyPr wrap="square" lIns="0" tIns="0" rIns="0" bIns="0" rtlCol="0" anchor="ctr"/>
+          <a:lstStyle/>
+          <a:p>
+            <a:pPr indent="0" marL="0">
+              <a:buNone/>
+            </a:pPr>
+            <a:r>
+              <a:rPr lang="en-US" sz="1150" dirty="0">
+                <a:solidFill>
+                  <a:srgbClr val="8E9BC4"/>
+                </a:solidFill>
+                <a:latin typeface="Calibri" pitchFamily="34" charset="0"/>
+                <a:ea typeface="Calibri" pitchFamily="34" charset="-122"/>
+                <a:cs typeface="Calibri" pitchFamily="34" charset="-120"/>
+              </a:rPr>
+              <a:t>A humane tradition: each generation raised into the same understanding, carried on.</a:t>
+            </a:r>
+            <a:endParaRPr lang="en-US" sz="1150" dirty="0"/>
+          </a:p>
+        </p:txBody>
+      </p:sp>
+    </p:spTree>
+  </p:cSld>
+  <p:clrMapOvr>
+    <a:masterClrMapping/>
+  </p:clrMapOvr>
+</p:sld>
+</file>
+
 <file path=ppt/slides/slide2.xml><?xml version="1.0" encoding="utf-8"?>
 <p:sld xmlns:a="http://schemas.openxmlformats.org/drawingml/2006/main" xmlns:r="http://schemas.openxmlformats.org/officeDocument/2006/relationships" xmlns:p="http://schemas.openxmlformats.org/presentationml/2006/main">
   <p:cSld name="Slide 2">
@@ -13409,7 +13945,7 @@
       </p:sp>
       <p:pic>
         <p:nvPicPr>
-          <p:cNvPr id="9" name="Image 0" descr="preencoded.png">    </p:cNvPr>
+          <p:cNvPr id="9" name="Image 0" descr="preencoded.png"/>
           <p:cNvPicPr>
             <a:picLocks noChangeAspect="1"/>
           </p:cNvPicPr>
@@ -13464,7 +14000,7 @@
                 <a:ea typeface="Calibri" pitchFamily="34" charset="-122"/>
                 <a:cs typeface="Calibri" pitchFamily="34" charset="-120"/>
               </a:rPr>
-              <a:t>What is Existence?  —  </a:t>
+              <a:t xml:space="preserve">What is Existence?  —  </a:t>
             </a:r>
             <a:pPr indent="0" marL="0">
               <a:buNone/>
@@ -13506,7 +14042,7 @@
       </p:sp>
       <p:pic>
         <p:nvPicPr>
-          <p:cNvPr id="12" name="Image 1" descr="preencoded.png">    </p:cNvPr>
+          <p:cNvPr id="12" name="Image 1" descr="preencoded.png"/>
           <p:cNvPicPr>
             <a:picLocks noChangeAspect="1"/>
           </p:cNvPicPr>
@@ -13561,7 +14097,7 @@
                 <a:ea typeface="Calibri" pitchFamily="34" charset="-122"/>
                 <a:cs typeface="Calibri" pitchFamily="34" charset="-120"/>
               </a:rPr>
-              <a:t>What exists?  —  </a:t>
+              <a:t xml:space="preserve">What exists?  —  </a:t>
             </a:r>
             <a:pPr indent="0" marL="0">
               <a:buNone/>
@@ -13603,7 +14139,7 @@
       </p:sp>
       <p:pic>
         <p:nvPicPr>
-          <p:cNvPr id="15" name="Image 2" descr="preencoded.png">    </p:cNvPr>
+          <p:cNvPr id="15" name="Image 2" descr="preencoded.png"/>
           <p:cNvPicPr>
             <a:picLocks noChangeAspect="1"/>
           </p:cNvPicPr>
@@ -13658,7 +14194,7 @@
                 <a:ea typeface="Calibri" pitchFamily="34" charset="-122"/>
                 <a:cs typeface="Calibri" pitchFamily="34" charset="-120"/>
               </a:rPr>
-              <a:t>Does what exists begin?  —  </a:t>
+              <a:t xml:space="preserve">Does what exists begin?  —  </a:t>
             </a:r>
             <a:pPr indent="0" marL="0">
               <a:buNone/>
@@ -13700,7 +14236,7 @@
       </p:sp>
       <p:pic>
         <p:nvPicPr>
-          <p:cNvPr id="18" name="Image 3" descr="preencoded.png">    </p:cNvPr>
+          <p:cNvPr id="18" name="Image 3" descr="preencoded.png"/>
           <p:cNvPicPr>
             <a:picLocks noChangeAspect="1"/>
           </p:cNvPicPr>
@@ -13755,7 +14291,7 @@
                 <a:ea typeface="Calibri" pitchFamily="34" charset="-122"/>
                 <a:cs typeface="Calibri" pitchFamily="34" charset="-120"/>
               </a:rPr>
-              <a:t>Does the self begin or end with the body?  —  </a:t>
+              <a:t xml:space="preserve">Does the self begin or end with the body?  —  </a:t>
             </a:r>
             <a:pPr indent="0" marL="0">
               <a:buNone/>
@@ -13797,7 +14333,7 @@
       </p:sp>
       <p:pic>
         <p:nvPicPr>
-          <p:cNvPr id="21" name="Image 4" descr="preencoded.png">    </p:cNvPr>
+          <p:cNvPr id="21" name="Image 4" descr="preencoded.png"/>
           <p:cNvPicPr>
             <a:picLocks noChangeAspect="1"/>
           </p:cNvPicPr>
@@ -13852,7 +14388,7 @@
                 <a:ea typeface="Calibri" pitchFamily="34" charset="-122"/>
                 <a:cs typeface="Calibri" pitchFamily="34" charset="-120"/>
               </a:rPr>
-              <a:t>Is the world finally real?  —  </a:t>
+              <a:t xml:space="preserve">Is the world finally real?  —  </a:t>
             </a:r>
             <a:pPr indent="0" marL="0">
               <a:buNone/>
@@ -13894,7 +14430,7 @@
       </p:sp>
       <p:pic>
         <p:nvPicPr>
-          <p:cNvPr id="24" name="Image 5" descr="preencoded.png">    </p:cNvPr>
+          <p:cNvPr id="24" name="Image 5" descr="preencoded.png"/>
           <p:cNvPicPr>
             <a:picLocks noChangeAspect="1"/>
           </p:cNvPicPr>
@@ -13949,7 +14485,7 @@
                 <a:ea typeface="Calibri" pitchFamily="34" charset="-122"/>
                 <a:cs typeface="Calibri" pitchFamily="34" charset="-120"/>
               </a:rPr>
-              <a:t>How can what exists be known?  —  </a:t>
+              <a:t xml:space="preserve">How can what exists be known?  —  </a:t>
             </a:r>
             <a:pPr indent="0" marL="0">
               <a:buNone/>
@@ -14985,7 +15521,7 @@
                 <a:ea typeface="Calibri" pitchFamily="34" charset="-122"/>
                 <a:cs typeface="Calibri" pitchFamily="34" charset="-120"/>
               </a:rPr>
-              <a:t>Every formful unit is soaked, submerged, and surrounded in Omnipresence — like a sponge in water or a cell in a nutrient medium. The ground does not push units; through the bond itself, three endowments are present in every unit.</a:t>
+              <a:t>Every formful unit is soaked, submerged, and surrounded in Omnipresence — like a sponge in water, never pushed by it. This saturated coexistence is evident in the sentient atom as gyan, and in every unit as the three endowments.</a:t>
             </a:r>
             <a:endParaRPr lang="en-US" sz="1300" dirty="0"/>
           </a:p>
@@ -15042,7 +15578,7 @@
       </p:sp>
       <p:pic>
         <p:nvPicPr>
-          <p:cNvPr id="11" name="Image 0" descr="preencoded.png">    </p:cNvPr>
+          <p:cNvPr id="11" name="Image 0" descr="preencoded.png"/>
           <p:cNvPicPr>
             <a:picLocks noChangeAspect="1"/>
           </p:cNvPicPr>
@@ -15193,7 +15729,7 @@
       </p:sp>
       <p:pic>
         <p:nvPicPr>
-          <p:cNvPr id="16" name="Image 1" descr="preencoded.png">    </p:cNvPr>
+          <p:cNvPr id="16" name="Image 1" descr="preencoded.png"/>
           <p:cNvPicPr>
             <a:picLocks noChangeAspect="1"/>
           </p:cNvPicPr>
@@ -15344,7 +15880,7 @@
       </p:sp>
       <p:pic>
         <p:nvPicPr>
-          <p:cNvPr id="21" name="Image 2" descr="preencoded.png">    </p:cNvPr>
+          <p:cNvPr id="21" name="Image 2" descr="preencoded.png"/>
           <p:cNvPicPr>
             <a:picLocks noChangeAspect="1"/>
           </p:cNvPicPr>
@@ -15477,7 +16013,7 @@
                 <a:ea typeface="Calibri" pitchFamily="34" charset="-122"/>
                 <a:cs typeface="Calibri" pitchFamily="34" charset="-120"/>
               </a:rPr>
-              <a:t>Together these ground the completeness drive of every unit — SB pp. 49–62, 69; MVD pp. 40, 62</a:t>
+              <a:t>Together these ground the completeness drive — permeative satta provisions activeness · transparent in mutuality, recognition · mediative, regulation — SB pp. 49–62, 69; MVD pp. 26, 32–33, 40; JV p. 150</a:t>
             </a:r>
             <a:endParaRPr lang="en-US" sz="950" dirty="0"/>
           </a:p>
@@ -16410,7 +16946,7 @@
                 <a:ea typeface="Calibri" pitchFamily="34" charset="-122"/>
                 <a:cs typeface="Calibri" pitchFamily="34" charset="-120"/>
               </a:rPr>
-              <a:t>  (fulfilment aligned with innateness)      </a:t>
+              <a:t xml:space="preserve">  (fulfilment aligned with innateness)      </a:t>
             </a:r>
             <a:pPr indent="0" marL="0">
               <a:buNone/>
@@ -16438,7 +16974,7 @@
                 <a:ea typeface="Calibri" pitchFamily="34" charset="-122"/>
                 <a:cs typeface="Calibri" pitchFamily="34" charset="-120"/>
               </a:rPr>
-              <a:t>  — each unit is a whole along with its environment, orderliness with its ness.</a:t>
+              <a:t xml:space="preserve">  — each unit is a whole along with its environment, orderliness with its ness.</a:t>
             </a:r>
             <a:endParaRPr lang="en-US" sz="1200" dirty="0"/>
           </a:p>
@@ -16943,7 +17479,7 @@
                 <a:ea typeface="Calibri" pitchFamily="34" charset="-122"/>
                 <a:cs typeface="Calibri" pitchFamily="34" charset="-120"/>
               </a:rPr>
-              <a:t>Essentiality is value (mulya).  </a:t>
+              <a:t xml:space="preserve">Essentiality is value (mulya).  </a:t>
             </a:r>
             <a:pPr indent="0" marL="0">
               <a:buNone/>
@@ -19033,7 +19569,7 @@
                 <a:ea typeface="Calibri" pitchFamily="34" charset="-122"/>
                 <a:cs typeface="Calibri" pitchFamily="34" charset="-120"/>
               </a:rPr>
-              <a:t>The sentience boundary lies between pran and jeev:  </a:t>
+              <a:t xml:space="preserve">The sentience boundary lies between pran and jeev:  </a:t>
             </a:r>
             <a:pPr indent="0" marL="0">
               <a:buNone/>
@@ -19299,7 +19835,7 @@
                 <a:ea typeface="Calibri" pitchFamily="34" charset="-122"/>
                 <a:cs typeface="Calibri" pitchFamily="34" charset="-120"/>
               </a:rPr>
-              <a:t>The three endowments of saturation ground each unit’s completeness drive — built into the design of existence, not an ethic added to matter. All change is unit-activity, and every activity is the inseparable triad shram–gati–parinam: three joint aspects of one activity, not three sequential steps.</a:t>
+              <a:t>Every unit, saturated in satta, carries a drive toward completeness — built into existence itself, not an ethic added to matter. The drive does not stop until what is soaked in satta comes to realise satta. All of nature develops; awakening happens in the sentient. And every activity is one inseparable triad — effort, motion, and result together, not three steps in a row.</a:t>
             </a:r>
             <a:endParaRPr lang="en-US" sz="1250" dirty="0"/>
           </a:p>
@@ -19857,7 +20393,7 @@
                 <a:ea typeface="Calibri" pitchFamily="34" charset="-122"/>
                 <a:cs typeface="Calibri" pitchFamily="34" charset="-120"/>
               </a:rPr>
-              <a:t>“Saturation … itself is forcefulness … basic impulsion … activity … effort-motion-result … development” — SB p. 62; also SB pp. 53, 58, 71; MVD p. 104</a:t>
+              <a:t>“Saturation … itself is forcefulness … basic impulsion … activity … effort-motion-result … development” — SB p. 62; also SB pp. 51, 53, 58, 71, 91; MVD p. 104</a:t>
             </a:r>
             <a:endParaRPr lang="en-US" sz="950" dirty="0"/>
           </a:p>
@@ -20930,7 +21466,7 @@
                 <a:ea typeface="Calibri" pitchFamily="34" charset="-122"/>
                 <a:cs typeface="Calibri" pitchFamily="34" charset="-120"/>
               </a:rPr>
-              <a:t>Conduct completeness (vyavaharpurnata) — destination of motion; authentic conduct, living proof (pramanikta)</a:t>
+              <a:t>Conduct completeness (acharanpurnata) — destination of motion; authentic conduct, living proof (pramanikta)</a:t>
             </a:r>
             <a:endParaRPr lang="en-US" sz="1200" dirty="0"/>
           </a:p>
@@ -20969,7 +21505,7 @@
                 <a:ea typeface="Calibri" pitchFamily="34" charset="-122"/>
                 <a:cs typeface="Calibri" pitchFamily="34" charset="-120"/>
               </a:rPr>
-              <a:t>T1 belongs to the insentient path and completes result; T2 and T3 belong to the sentient path — internal cognitive settlement (T2) and external behavioural destination (T3) must not be conflated.</a:t>
+              <a:t>T1 completes the insentient path; T2 and T3 belong to the sentient path — inner settling (T2) and outer destination (T3) are different completions. What is saturated in the ground comes to realise the ground: that is the completeness drive.</a:t>
             </a:r>
             <a:endParaRPr lang="en-US" sz="1050" dirty="0"/>
           </a:p>

</xml_diff>

<commit_message>
Add scaling footnote to Justice/Dharma/Satya slide and regenerate deck PDF
Keeps the individual-relationship framing (Justice/Dharma/Satya as three
widening perspectives) as the primary slide content, per feedback, and
adds a short footnote noting the same principle scales up across wider
social levels per MVD (individual order -> between nations -> cosmic
scale), rather than replacing the base framing with it.

Also regenerates the companion PDF from the updated pptx via LibreOffice,
since the deck has changed across several recent commits.
</commit_message>
<xml_diff>
--- a/Studies/The-Ontology-of-Coexistence/The-Ontology-of-Existence-Madhyasth-Darshan.pptx
+++ b/Studies/The-Ontology-of-Coexistence/The-Ontology-of-Existence-Madhyasth-Darshan.pptx
@@ -26428,6 +26428,69 @@
               <a:t>— KD p. 13</a:t>
             </a:r>
             <a:endParaRPr sz="1000" b="0" i="0" u="none" strike="noStrike" cap="none">
+              <a:solidFill>
+                <a:schemeClr val="dk1"/>
+              </a:solidFill>
+              <a:latin typeface="Calibri"/>
+              <a:ea typeface="Calibri"/>
+              <a:cs typeface="Calibri"/>
+              <a:sym typeface="Calibri"/>
+            </a:endParaRPr>
+          </a:p>
+        </p:txBody>
+      </p:sp>
+      <p:sp>
+        <p:nvSpPr>
+          <p:cNvPr id="230" name="Google Shape;230;p10"/>
+          <p:cNvSpPr/>
+          <p:nvPr/>
+        </p:nvSpPr>
+        <p:spPr>
+          <a:xfrm>
+            <a:off x="502920" y="4560000"/>
+            <a:ext cx="8138160" cy="230000"/>
+          </a:xfrm>
+          <a:prstGeom prst="rect">
+            <a:avLst/>
+          </a:prstGeom>
+          <a:noFill/>
+          <a:ln>
+            <a:noFill/>
+          </a:ln>
+        </p:spPr>
+        <p:txBody>
+          <a:bodyPr spcFirstLastPara="1" wrap="square" lIns="0" tIns="0" rIns="0" bIns="0" anchor="ctr" anchorCtr="0">
+            <a:noAutofit/>
+          </a:bodyPr>
+          <a:lstStyle/>
+          <a:p>
+            <a:pPr marL="0" marR="0" lvl="0" indent="0" algn="l" rtl="0">
+              <a:spcBef>
+                <a:spcPts val="0"/>
+              </a:spcBef>
+              <a:spcAft>
+                <a:spcPts val="0"/>
+              </a:spcAft>
+              <a:buClr>
+                <a:srgbClr val="9A6414"/>
+              </a:buClr>
+              <a:buSzPts val="900"/>
+              <a:buFont typeface="Calibri"/>
+              <a:buNone/>
+            </a:pPr>
+            <a:r>
+              <a:rPr lang="en-US" sz="900" b="0" i="1" u="none" strike="noStrike" cap="none">
+                <a:solidFill>
+                  <a:srgbClr val="9A6414"/>
+                </a:solidFill>
+                <a:latin typeface="Calibri"/>
+                <a:ea typeface="Calibri"/>
+                <a:cs typeface="Calibri"/>
+                <a:sym typeface="Calibri"/>
+              </a:rPr>
+              <a:t>Footnote: the same principle scales up — MVD names it justice within one order, dharma between nations, truth at cosmic scale (p. 161–162).</a:t>
+            </a:r>
+            <a:endParaRPr sz="900" b="0" i="0" u="none" strike="noStrike" cap="none">
               <a:solidFill>
                 <a:schemeClr val="dk1"/>
               </a:solidFill>

</xml_diff>

<commit_message>
Revise ontology around definite mutuality
</commit_message>
<xml_diff>
--- a/Studies/The-Ontology-of-Coexistence/The-Ontology-of-Existence-Madhyasth-Darshan.pptx
+++ b/Studies/The-Ontology-of-Coexistence/The-Ontology-of-Existence-Madhyasth-Darshan.pptx
@@ -2,36 +2,36 @@
 <file path=ppt/presentation.xml><?xml version="1.0" encoding="utf-8"?>
 <p:presentation xmlns:p="http://schemas.openxmlformats.org/presentationml/2006/main">
   <p:sldMasterIdLst>
-    <p:sldMasterId xmlns:r="http://schemas.openxmlformats.org/officeDocument/2006/relationships" id="2147483648" r:id="Rb91ecd57c18f44fa"/>
+    <p:sldMasterId xmlns:r="http://schemas.openxmlformats.org/officeDocument/2006/relationships" id="2147483648" r:id="R2ab47f0255ab46b2"/>
   </p:sldMasterIdLst>
   <p:notesMasterIdLst>
-    <p:notesMasterId xmlns:r="http://schemas.openxmlformats.org/officeDocument/2006/relationships" r:id="R7fa3bd495e0b49eb"/>
+    <p:notesMasterId xmlns:r="http://schemas.openxmlformats.org/officeDocument/2006/relationships" r:id="R976a1b4e4ae74717"/>
   </p:notesMasterIdLst>
   <p:sldIdLst>
-    <p:sldId xmlns:r="http://schemas.openxmlformats.org/officeDocument/2006/relationships" id="256" r:id="R1dc00366768b4809"/>
-    <p:sldId xmlns:r="http://schemas.openxmlformats.org/officeDocument/2006/relationships" id="257" r:id="R77df621d77b94771"/>
-    <p:sldId xmlns:r="http://schemas.openxmlformats.org/officeDocument/2006/relationships" id="258" r:id="Rf440affb8eaa4a18"/>
-    <p:sldId xmlns:r="http://schemas.openxmlformats.org/officeDocument/2006/relationships" id="259" r:id="R3bbdeeb259bb4268"/>
-    <p:sldId xmlns:r="http://schemas.openxmlformats.org/officeDocument/2006/relationships" id="260" r:id="R306efc7cb72847cb"/>
-    <p:sldId xmlns:r="http://schemas.openxmlformats.org/officeDocument/2006/relationships" id="261" r:id="R1d0bb72d446a49e1"/>
-    <p:sldId xmlns:r="http://schemas.openxmlformats.org/officeDocument/2006/relationships" id="262" r:id="Rdf891aebe67c4d4d"/>
-    <p:sldId xmlns:r="http://schemas.openxmlformats.org/officeDocument/2006/relationships" id="263" r:id="Rdd0fb09cfe164f19"/>
-    <p:sldId xmlns:r="http://schemas.openxmlformats.org/officeDocument/2006/relationships" id="264" r:id="Rb8697e9b048b4a67"/>
-    <p:sldId xmlns:r="http://schemas.openxmlformats.org/officeDocument/2006/relationships" id="265" r:id="R2bf4fb0c86f249b4"/>
-    <p:sldId xmlns:r="http://schemas.openxmlformats.org/officeDocument/2006/relationships" id="266" r:id="Rb4d0528c6db14641"/>
-    <p:sldId xmlns:r="http://schemas.openxmlformats.org/officeDocument/2006/relationships" id="267" r:id="R08aaa8dc16d5497f"/>
-    <p:sldId xmlns:r="http://schemas.openxmlformats.org/officeDocument/2006/relationships" id="268" r:id="Rca32c4b905ef4506"/>
-    <p:sldId xmlns:r="http://schemas.openxmlformats.org/officeDocument/2006/relationships" id="269" r:id="Rb5a08fa31f8d4984"/>
-    <p:sldId xmlns:r="http://schemas.openxmlformats.org/officeDocument/2006/relationships" id="270" r:id="R8bf8b992a4c24db6"/>
-    <p:sldId xmlns:r="http://schemas.openxmlformats.org/officeDocument/2006/relationships" id="271" r:id="Rb8a883a0bd2640b3"/>
-    <p:sldId xmlns:r="http://schemas.openxmlformats.org/officeDocument/2006/relationships" id="272" r:id="Rbb534527a15f4244"/>
-    <p:sldId xmlns:r="http://schemas.openxmlformats.org/officeDocument/2006/relationships" id="273" r:id="R74d7e2e50b934347"/>
-    <p:sldId xmlns:r="http://schemas.openxmlformats.org/officeDocument/2006/relationships" id="274" r:id="Rbaa4f3b2243a472a"/>
-    <p:sldId xmlns:r="http://schemas.openxmlformats.org/officeDocument/2006/relationships" id="275" r:id="R01988b2c2ecd4636"/>
-    <p:sldId xmlns:r="http://schemas.openxmlformats.org/officeDocument/2006/relationships" id="276" r:id="R9d272711c7014ad9"/>
-    <p:sldId xmlns:r="http://schemas.openxmlformats.org/officeDocument/2006/relationships" id="277" r:id="R40549c780f104e00"/>
-    <p:sldId xmlns:r="http://schemas.openxmlformats.org/officeDocument/2006/relationships" id="278" r:id="Re9f304428ede4039"/>
-    <p:sldId xmlns:r="http://schemas.openxmlformats.org/officeDocument/2006/relationships" id="279" r:id="Rd1ebb91feb724730"/>
+    <p:sldId xmlns:r="http://schemas.openxmlformats.org/officeDocument/2006/relationships" id="256" r:id="Re8bfde844f044856"/>
+    <p:sldId xmlns:r="http://schemas.openxmlformats.org/officeDocument/2006/relationships" id="257" r:id="Ra28ee0df49904aac"/>
+    <p:sldId xmlns:r="http://schemas.openxmlformats.org/officeDocument/2006/relationships" id="258" r:id="R0ca0f2b5af7246f4"/>
+    <p:sldId xmlns:r="http://schemas.openxmlformats.org/officeDocument/2006/relationships" id="259" r:id="R1fd9b78b07984908"/>
+    <p:sldId xmlns:r="http://schemas.openxmlformats.org/officeDocument/2006/relationships" id="260" r:id="R0b9001fd56fc46ef"/>
+    <p:sldId xmlns:r="http://schemas.openxmlformats.org/officeDocument/2006/relationships" id="261" r:id="R5d07bbbb88094736"/>
+    <p:sldId xmlns:r="http://schemas.openxmlformats.org/officeDocument/2006/relationships" id="262" r:id="R247c549a66384e79"/>
+    <p:sldId xmlns:r="http://schemas.openxmlformats.org/officeDocument/2006/relationships" id="263" r:id="R30ce2ef1e7784e43"/>
+    <p:sldId xmlns:r="http://schemas.openxmlformats.org/officeDocument/2006/relationships" id="264" r:id="R1d8509b144664017"/>
+    <p:sldId xmlns:r="http://schemas.openxmlformats.org/officeDocument/2006/relationships" id="265" r:id="Re9b0aa974928436c"/>
+    <p:sldId xmlns:r="http://schemas.openxmlformats.org/officeDocument/2006/relationships" id="266" r:id="Rda6bbb92ca14444e"/>
+    <p:sldId xmlns:r="http://schemas.openxmlformats.org/officeDocument/2006/relationships" id="267" r:id="Rab9c2b11f81b4d01"/>
+    <p:sldId xmlns:r="http://schemas.openxmlformats.org/officeDocument/2006/relationships" id="268" r:id="R751246d742774347"/>
+    <p:sldId xmlns:r="http://schemas.openxmlformats.org/officeDocument/2006/relationships" id="269" r:id="R53b0454050cb44bd"/>
+    <p:sldId xmlns:r="http://schemas.openxmlformats.org/officeDocument/2006/relationships" id="270" r:id="R0976fab93b7b42a7"/>
+    <p:sldId xmlns:r="http://schemas.openxmlformats.org/officeDocument/2006/relationships" id="271" r:id="Rf7702542b0164297"/>
+    <p:sldId xmlns:r="http://schemas.openxmlformats.org/officeDocument/2006/relationships" id="272" r:id="R75bf481cf7654716"/>
+    <p:sldId xmlns:r="http://schemas.openxmlformats.org/officeDocument/2006/relationships" id="273" r:id="R9b51ef5a889346b3"/>
+    <p:sldId xmlns:r="http://schemas.openxmlformats.org/officeDocument/2006/relationships" id="274" r:id="Ra7cd1ce75483407a"/>
+    <p:sldId xmlns:r="http://schemas.openxmlformats.org/officeDocument/2006/relationships" id="275" r:id="R1304c41ce313407f"/>
+    <p:sldId xmlns:r="http://schemas.openxmlformats.org/officeDocument/2006/relationships" id="276" r:id="R3758d5e80db04e63"/>
+    <p:sldId xmlns:r="http://schemas.openxmlformats.org/officeDocument/2006/relationships" id="277" r:id="R43bc4679298842e4"/>
+    <p:sldId xmlns:r="http://schemas.openxmlformats.org/officeDocument/2006/relationships" id="278" r:id="R12471cdb83a74544"/>
+    <p:sldId xmlns:r="http://schemas.openxmlformats.org/officeDocument/2006/relationships" id="279" r:id="Rddf26886c0f74a7e"/>
   </p:sldIdLst>
   <p:sldSz cx="9144000" cy="5143500"/>
   <p:notesSz cx="6858000" cy="9144000"/>
@@ -908,7 +908,7 @@
               <a:buNone/>
             </a:pPr>
             <a:r>
-              <a:t>This slide closes a conceptual gap that can otherwise make the four orders look like a single emergence chain. The body is a pranic composition with organs and brain; jeevan is the constitutionally complete sentient atom. In animal and human living they operate as one joint form. Jeevan knows, decides, experiences, and acts through the bodily instrument. When the joint form ends, the body decomposes while jeevan continues.</a:t>
+              <a:t>The body is a pranic composition and the expression medium; jeevan is the constitutionally complete sentient atom and bearer of all five faculties and ten activities. Animal bodily and brain development constrains expression. The human bodily medium can support the full range, while delusion can still make jeevan identify as the body. The body does not produce sentience, and bodily limitation is not the same as human mis-evaluation.</a:t>
             </a:r>
           </a:p>
         </p:txBody>
@@ -987,7 +987,7 @@
               <a:buNone/>
             </a:pPr>
             <a:r>
-              <a:t>Jeevan's structure: atma is the nucleus; buddhi, chitta, vritti, mun are particles in the first through fourth orbits - this is MVD p. 78, and the study insists it is structural, not metaphor. Each faculty works through projection (outward) and reflection (inward) - walk one or two rows of the table, e.g. mun selects and tastes; buddhi resolves and is enlightened; atma authenticates and realises. Two cautions: this five-fold (faculties) must NOT be conflated with the kosha five-fold (developmental sheaths) - they do not align column-to-column. And the delusion structure: on the delusional plane atma is 'I' and the orbital four are 'mine'; awakening is the four coming into accordance with atma. Mistaking the body for the self is the root confusion. NEW: directional reading of the table - reflection (inward) is the knowing direction, the study circuit ratiocination in mun, deliberation in vritti, direct recognition in chitta, enlightenment in buddhi (MVD p. 126), terminating in anubhav in Omnipotence (MVD pp. 286-287); projection (outward) is the evidencing direction, the cascade from anubhav to pramanikta (MVD pp. 99-100). Delusional inversion: circuit driven body-upward, only 4.5 of ten activities effective, believing severed from knowing (JV pp. 73-74). Awakening staged by three statuses of buddhi: chitta-driven, buddhi-driven, atma-disciplined (MVD pp. 278-279).</a:t>
+              <a:t>All five faculties and all ten activities belong to jeevan. Their presence must be distinguished from their expression and effective organisation. Animal bodies limit expression through the bodily and neural medium. Humans possess the bodily medium for the full range, but body-delusion leaves only four and a half effectively organised before awakening. Study provides understanding; practice tests, evidences, and stabilises that understanding. Practice does not manufacture dormant or missing faculties.</a:t>
             </a:r>
           </a:p>
         </p:txBody>
@@ -1274,7 +1274,7 @@
               <a:buNone/>
             </a:pPr>
             <a:r>
-              <a:t>This slide explains the darshan's name. Orderliness is self-regulation - swatah-saspurt - inherent in saturated units, not dispensed by a cosmic governor; MVD p. 26: Omnipotence is mediative, therefore nature saturated in it is regulated and conserved; the nucleus in every atom is the mediative activity. Regulation manifests as law through order-specific conformance modes - definite for the first three orders, achieved for humans through the knowing-believing-recognising-fulfilling chain. Justice enters only where evaluation and error are possible: it is the closure of the full relational cycle - recognise, fulfil values, evaluate, mutual satisfaction (MVD p. 311). Awakened evaluation reorganises refuge under justice, dharma and truth; the lower triad (pleasant, healthy, profitable) stays legitimate in its domain but is subordinated, not abandoned.</a:t>
+              <a:t>Orderliness is self-regulation in saturated units, not an external command. Material, bio, and animal recognition and fulfilment are definite; an animal body's expressive limits do not introduce ontological indeterminacy or evaluative error. Justice becomes necessary in human living because jeevan can mis-evaluate under delusion. Awakening aligns its existing evaluative capacity with justice, dharma, truth, and coexistence.</a:t>
             </a:r>
           </a:p>
         </p:txBody>
@@ -1485,7 +1485,7 @@
               <a:buNone/>
             </a:pPr>
             <a:r>
-              <a:t>Two ladders on this slide, and they meet. LEFT - the scope ladder: what must be understood to know each aspect of a unit. Read bottom-up: form is graspable from the unit alone; properties (gun) need mutuality (they are defined as effects units have on one another); essential nature (svabhav) needs the unit's order; dharma needs the whole - JV: dharma is understood on the basis of orderliness, and the ultimate dharma (indestructibility) follows from a whole-level fact, that existence is coexistence. Note the design choice if anyone compares with the jeevan atom diagram: there, inward means deeper (atma at the nucleus); here, HIGHER means wider context needed - dharma on the top rung is not far from the unit, it is the aspect whose understanding demands the widest horizon. RIGHT - how that knowing actually happens, within jeevan, ascending the faculties by reflection (inward): mun tastes and selects the proposal; vritti deliberates - in humane consciousness, in the refuge of justice, dharma, and truth (JV pp. 138-139); chitta contemplates and visualises - revelation, sakshatkar (JV p. 61); buddhi has enlightenment  - understanding is enlightenment of existence, jeevan, and humane conduct in buddhi (JV p. 120) - and resolve; atma realises - anubhav - and realisation takes place only through truth (MVD p. 137). Then the return arrow: realisation projects back down (outward) as authenticity - pramanikta - evidenced in conduct; MVD p. 101 describes the effects of atma realised in truth registering on the lower faculties. Where the ladders meet: the widest scopes - dharma and truth - are understood as bodh in buddhi and realised as anubhav in atma. The wider the scope of reality to be known, the deeper within jeevan the knowing must go.</a:t>
+              <a:t>Read the left ladder as widening mutual context, not a progression from an isolated unit. Form is real bounded structure and is encountered through definite reflection in mutual facing. Guna is evident as effects in mutuality. Svabhav requires state, motion, plane, and order. Dharma is evidenced through whole-order fulfilment. The right ladder shows how jeevan understands and evidences these scopes. Human error belongs to deluded evaluation, not to indeterminacy in the reality reflected.</a:t>
             </a:r>
           </a:p>
         </p:txBody>
@@ -1788,7 +1788,7 @@
               <a:buNone/>
             </a:pPr>
             <a:r>
-              <a:t>Close the loop on the opening questions. Existence is the eternal coexistence of Omnipotence and units; what exists is Omnipotence plus countable units; nothing existent begins - only configurations; jeevan is constitutionally immortal and does not end with the body; the world is real and perpetual; and it is known through staged study, experiment and practice, and realisation with conduct-evidence - with the epistemic ladder adding the scope answer: form known from the unit alone, properties in mutuality, essential nature in its order, dharma against the whole, truth on the basis of existence itself. Land the final line: the darshan's ultimate test is not intellectual assent but pramanikta - lived evidence in humane conduct. If continuing to the companion deck: the next session compares this ontology with Advaita Vedanta, modern philosophy, and modern science - including where each alliance falls and what remains open.</a:t>
+              <a:t>Close the loop: existence is eternal coexistence; definite bounded units are real bearers whose form, guna, svabhav, and dharma become evident through mutuality. Material reflection and fulfilment are definite. Jeevan is not produced by the body: animal bodily development limits expression, while human mis-evaluation arises from body-identification. Study and self-examination bring understanding; practice tests, evidences, and stabilises it in conduct rather than creating jeevan's faculties.</a:t>
             </a:r>
           </a:p>
         </p:txBody>
@@ -2104,7 +2104,7 @@
               <a:buNone/>
             </a:pPr>
             <a:r>
-              <a:t>Saturation (samprikt) is the ever-present bond - soaked, submerged, surrounded. The sponge-in-water and cell-in-nutrient images are illustrative, not identities. Stress that Omnipotence does not push units: it is not an efficient cause. Three endowments follow from the bond: recognition capability (complementarity is given, not created - capacity, ability, receptivity), activeness (inherent energy plus basic impulsion; quote 'Unit + Energy fullness = Activeness'), and inherent regulation (order comes from within, not from a cosmic command). Also worth saying aloud: manifestation is mutually dependent - without basic impulsion energy stays unmanifest; without energy no impulsion. Neither pole creates the other's existence, only its manifestation. NEW: the saturation bond itself is knowledge - samprikt, coexistence, and gyan name one fact (MVD pp. 32-33); the three endowments are how gyan is present on the unit side. Attribute mapping: permeative Omnipotence provisions activeness (JV p. 150); transparency in mutuality provisions recognition (SB p. 50); mediativeness provisions regulation (MVD p. 26). INTERPRETATION (settled): in MVD pp. 32-33 the referent of 'yahi... yahi gyan hai' is the saturated STATE - nature submerged, soaked, surrounded in Omnipotence, which the text names coexistence - not a reified 'bond' as a third item. The slide uses the texts' evidence language ('is evident as' - MVD: law and regulation are evident in coexistence only; JV p. 150: the endowments are the testimony of permeative Omnipotence). Avoid 'projects' for the ground - Omnipotence is actionless, and projection (outward) is jeevan's outward activity on slides 11 and 16; avoid predicating reflection of the ground too - the reflector model has the ATOM reflecting Omnipotence (slide 10). the identity claim itself - saturated coexistence IS knowledge, MVD pp. 32-33 - stays as presenter background and in the paper 1.2. If pressed, avoid 'the bond itself is knowledge'. It is an identity claim about the state, plus a separate consequence: from it, every unit has the three endowments. The knowledge identity holds for insentient AND sentient nature (MVD pp. 32-33) - insentient units abide in gyan as the three endowments (law and regulation evident, without knowing); the sentient atom ALONE additionally reflects the ground as active sentience - the capacity to know (the reflector model, slide 10; permeative gyan latent in Omnipotence actualised as chaitanya at T1). Careful wording: Omnipotence does not project - it is actionless; the unit reflects what is ever-present in the ground. What is exclusive to the sentient atom is the reflection of gyan as sentience, not the ground itself - every atom is saturated in and sustained by Omnipotence.</a:t>
+              <a:t>Saturation (samprikt) is the ever-present state of nature soaked, submerged, and surrounded in Omnipotence. Omnipotence does not push or act on units. Recognition capability, activeness, and inherent regulation are evident on the unit side. In insentient nature, mutual reflection, recognition, evaluation, and fulfilment are definite; they do not require a human observer. The sentient atom additionally knows and can evidence this coexistence consciously.</a:t>
             </a:r>
           </a:p>
         </p:txBody>
@@ -2183,7 +2183,7 @@
               <a:buNone/>
             </a:pPr>
             <a:r>
-              <a:t>Every unit at every order carries the same four-aspect signature. Walk the grid: form individuates; properties are effects in mutuality (generative, degenerative, mediative); essential nature is how usefulness participates in the unit's order; dharma is what a unit cannot be separated from - and since existence is coexistence, indestructibility is the ultimate dharma. Introduce 'ness' - what makes a unit the kind of unit it is. The state band matters for everything later: natural state moves to development, excited state to decline. Concrete anchor if useful: JV's peepal tree, whose fruits, seeds and leaves all exhibit peepal's properties, intrinsic nature and dharma - definite conduct. Context ladder worth noting: form is graspable from the unit alone; gun needs mutuality; svabhav needs the unit's order; dharma needs the whole - JV: 'dharma is understood on the basis of orderliness' (pp. 120-121), and the ultimate dharma follows from existence being coexistence.</a:t>
+              <a:t>Do not present roop, guna, svabhav, and dharma as a static four-field signature. The bearer is definite: a bounded unit with constitution, state, order, and capacities. Form is real, while what another unit encounters is its definite reflection in mutual facing. Guna is the inseparable relative power or effect of the guni. Svabhav is the usefulness or essentiality of that effect according to state, motion, plane, order, and context. Dharma is inseparable innateness and fulfilment, evidenced in participation. In insentient nature these are definite. Mis-evaluation arises only in human living when jeevan, under delusion, takes the body to be the self.</a:t>
             </a:r>
           </a:p>
         </p:txBody>
@@ -2262,7 +2262,7 @@
               <a:buNone/>
             </a:pPr>
             <a:r>
-              <a:t>'Nothing is isolated - that is the principle.' Relationships are where complementarity is actualised as value. Draw the contrast carefully: a relationship  has expectations predetermined toward completeness (parent-child); a contact has voluntary expectations (neighbours sharing a wall). Translation note if asked: the published rendering of sampark is 'association'; the translator (Rakesh Gupta) has revised it to 'contact', which the slide uses - cite against either printing accordingly. The neighbours-sharing-a-wall example is the study's illustrative gloss, not primary text. Value  is differentiated: object values (utility and art) operate at every order; jeevan harmonies, human values, relationship values and expression values presuppose the knowledge order. The chain at the bottom is the crucial asymmetry: below the knowledge order, fulfilment is definite (structural, seed, species conformance); humans must ACHIEVE it through knowing, believing, recognising, fulfilling - which is why evaluation and error enter only at our order.</a:t>
+              <a:t>Complementarity is actualised as value in mutuality. In material, bio, and animal orders recognition and fulfilment are definite. At the human order evaluation and error enter because jeevan can organise its faculties around body-identification. Awakening does not create new faculties; it aligns knowing, believing, recognising, and fulfilling with coexistence.</a:t>
             </a:r>
           </a:p>
         </p:txBody>
@@ -2341,7 +2341,7 @@
               <a:buNone/>
             </a:pPr>
             <a:r>
-              <a:t>Four stable orders - stress these are plateaus in development, not a human typology. Read the dharma column cumulatively: each higher order includes the dharmas below and adds one. The pivotal line is the boundary between pran and jeev: hope to live  is where sentience enters - hope is the defining activity of the sentient unit, expressed through mun. Material and pranic orders are insentient; jeevan first appears at the animal order. The knowledge order's six svabhav qualities (fortitude through compassion) are developed as human values. If asked about how orders emerge: that is existential progression, covered on the progressions slide.</a:t>
+              <a:t>The four orders are stable modes of participation. Jeevan is present in animal and human joint forms. In animals, species-specific bodily and brain development limits which of jeevan's activities can be expressed through the body. In humans, the bodily medium supports the full range; the distinct problem is delusion and body-identification, which misdirect evaluation. Do not collapse either condition into material emergence of sentience.</a:t>
             </a:r>
           </a:p>
         </p:txBody>
@@ -2416,7 +2416,7 @@
   </p:cSld>
   <p:clrMap bg1="lt1" tx1="dk1" bg2="dk2" tx2="lt2" accent1="accent1" accent2="accent2" accent3="accent3" accent4="accent4" accent5="accent5" accent6="accent6" hlink="hlink" folHlink="folHlink"/>
   <p:sldLayoutIdLst>
-    <p:sldLayoutId xmlns:r="http://schemas.openxmlformats.org/officeDocument/2006/relationships" id="2147483649" r:id="Rc146bc67c4fa4dd1"/>
+    <p:sldLayoutId xmlns:r="http://schemas.openxmlformats.org/officeDocument/2006/relationships" id="2147483649" r:id="R0233ba452ac04100"/>
   </p:sldLayoutIdLst>
   <p:hf sldNum="0" hdr="0" ftr="0" dt="0"/>
   <p:txStyles>
@@ -8171,7 +8171,7 @@
                 <a:ea typeface="Calibri"/>
                 <a:cs typeface="Calibri"/>
               </a:rPr>
-              <a:t>§1.7 · THE HUMAN JOINT FORM</a:t>
+              <a:t>§ 1.7 · THE HUMAN JOINT FORM</a:t>
             </a:r>
           </a:p>
         </p:txBody>
@@ -8283,7 +8283,7 @@
                 <a:ea typeface="Calibri"/>
                 <a:cs typeface="Calibri"/>
               </a:rPr>
-              <a:t>Animal and human living is a joint form. The body belongs to compositional progression; jeevan belongs to development in the atom. Their coordinated operation does not make the two processes identical, and bodily complexity alone does not produce sentience.</a:t>
+              <a:t>Animal and human living is a joint form. Jeevan brings all ten activities; the body supplies the species-specific medium. Animal bodily and brain development limits their expression. The human medium supports the full range, while body-identification can still misdirect evaluation.</a:t>
             </a:r>
           </a:p>
         </p:txBody>
@@ -8501,7 +8501,7 @@
                   <a:srgbClr val="5F6B82"/>
                 </a:solidFill>
               </a:rPr>
-              <a:t>Species-conformant and decomposable</a:t>
+              <a:t>Animal: limited · Human: full medium; decomposable</a:t>
             </a:r>
           </a:p>
         </p:txBody>
@@ -8695,7 +8695,7 @@
                   <a:srgbClr val="5F6B82"/>
                 </a:solidFill>
               </a:rPr>
-              <a:t>Hope, thought, desire, and resolve</a:t>
+              <a:t>All five faculties and ten activities inherent</a:t>
             </a:r>
           </a:p>
           <a:p xmlns:a="http://schemas.openxmlformats.org/drawingml/2006/main">
@@ -8831,7 +8831,7 @@
                 <a:ea typeface="Calibri"/>
                 <a:cs typeface="Calibri"/>
               </a:rPr>
-              <a:t>The body supplies the instrument; jeevan is seer–doer–enjoyer through it. Their coordinated operation is the human joint form.</a:t>
+              <a:t>The body gates expression; jeevan is seer–doer–enjoyer through it. Animal limitation belongs to the medium; human mis-evaluation belongs to body-delusion.</a:t>
             </a:r>
           </a:p>
         </p:txBody>
@@ -8887,7 +8887,18 @@
                 <a:ea typeface="Calibri"/>
                 <a:cs typeface="Calibri"/>
               </a:rPr>
-              <a:t>MVD pp. 13, 115, 288–289 · SB pp. 91–92 · JV pp. 20, 54</a:t>
+              <a:t>Sources: MVD pp. 13, 115, 288–289</a:t>
+            </a:r>
+            <a:r>
+              <a:rPr sz="950" b="0" i="1" u="none" cap="none">
+                <a:solidFill>
+                  <a:srgbClr val="5A6377"/>
+                </a:solidFill>
+                <a:latin typeface="Calibri"/>
+                <a:ea typeface="Calibri"/>
+                <a:cs typeface="Calibri"/>
+              </a:rPr>
+              <a:t> · SB pp. 91–92 · JV pp. 20, 54</a:t>
             </a:r>
           </a:p>
         </p:txBody>
@@ -10777,7 +10788,7 @@
                 <a:ea typeface="Calibri"/>
                 <a:cs typeface="Calibri"/>
               </a:rPr>
-              <a:t>Jeevan is a constitutionally complete sentient atom. Its five faculties — mun, vritti, chitta, buddhi, and atma — carry ten activities through reflection (knowing) and projection (evidencing). Before awakening, four and a half activities are effective; awakening brings the faculties into accordance with atma and opens full activity.</a:t>
+              <a:t>Jeevan is a constitutionally complete sentient atom. All five faculties and all ten activities belong to it. Animal bodies limit their expression. The human body can express the full range, yet delusion can leave only four and a half effectively organised. Study brings understanding; practice evidences and stabilises it — it does not create missing faculties.</a:t>
             </a:r>
           </a:p>
         </p:txBody>
@@ -14608,7 +14619,7 @@
                 <a:ea typeface="Calibri"/>
                 <a:cs typeface="Calibri"/>
               </a:rPr>
-              <a:t>Components combine in definite proportion and present a genuinely new unit, with its own form, properties, essential nature, and dharma.</a:t>
+              <a:t>Definite proportion yields a new bounded unit. Its real form and its guna, svabhav, and dharma are evidenced in the new unit's mutuality.</a:t>
             </a:r>
           </a:p>
         </p:txBody>
@@ -14664,18 +14675,7 @@
                 <a:ea typeface="Calibri"/>
                 <a:cs typeface="Calibri"/>
               </a:rPr>
-              <a:t>Composition is not development.  </a:t>
-            </a:r>
-            <a:r>
-              <a:rPr sz="1200" b="0" i="0" u="none" cap="none">
-                <a:solidFill>
-                  <a:srgbClr val="5A6377"/>
-                </a:solidFill>
-                <a:latin typeface="Calibri"/>
-                <a:ea typeface="Calibri"/>
-                <a:cs typeface="Calibri"/>
-              </a:rPr>
-              <a:t>The developmental threshold is crossed only when an atom reaches constitutional completeness (T1); assemblies persist while relationships are fulfilled and decline when they are not.</a:t>
+              <a:t>Composition is not development. T1 occurs only when an atom reaches constitutional completeness. Insentient assemblies persist or decline definitely according to whether constituent relationships are fulfilled.</a:t>
             </a:r>
           </a:p>
         </p:txBody>
@@ -15607,7 +15607,7 @@
                 <a:ea typeface="Calibri"/>
                 <a:cs typeface="Calibri"/>
               </a:rPr>
-              <a:t>§1.11 · THE THIRD ENDOWMENT</a:t>
+              <a:t>§ 1.11 · THE THIRD ENDOWMENT</a:t>
             </a:r>
           </a:p>
         </p:txBody>
@@ -15876,7 +15876,7 @@
                           <a:ea typeface="Calibri"/>
                           <a:cs typeface="Calibri"/>
                         </a:rPr>
-                        <a:t>Definite or achieved</a:t>
+                        <a:t>Mode of fulfilment</a:t>
                       </a:r>
                     </a:p>
                   </a:txBody>
@@ -16341,7 +16341,7 @@
                           <a:ea typeface="Calibri"/>
                           <a:cs typeface="Calibri"/>
                         </a:rPr>
-                        <a:t>definite</a:t>
+                        <a:t>definite; bodily expression limited</a:t>
                       </a:r>
                     </a:p>
                   </a:txBody>
@@ -16445,7 +16445,7 @@
                           <a:ea typeface="Calibri"/>
                           <a:cs typeface="Calibri"/>
                         </a:rPr>
-                        <a:t>learned conformance (character, upbringing)</a:t>
+                        <a:t>learned conformance through understanding</a:t>
                       </a:r>
                     </a:p>
                   </a:txBody>
@@ -16496,7 +16496,7 @@
                           <a:ea typeface="Calibri"/>
                           <a:cs typeface="Calibri"/>
                         </a:rPr>
-                        <a:t>achieved: knowing → believing → recognising → fulfilling</a:t>
+                        <a:t>evaluation may err; alignment achieved</a:t>
                       </a:r>
                     </a:p>
                   </a:txBody>
@@ -16635,18 +16635,7 @@
                 <a:ea typeface="Calibri"/>
                 <a:cs typeface="Calibri"/>
               </a:rPr>
-              <a:t>The regulation endowment </a:t>
-            </a:r>
-            <a:r>
-              <a:rPr sz="1100" b="0" i="0" u="none" cap="none">
-                <a:solidFill>
-                  <a:srgbClr val="5A6377"/>
-                </a:solidFill>
-                <a:latin typeface="Calibri"/>
-                <a:ea typeface="Calibri"/>
-                <a:cs typeface="Calibri"/>
-              </a:rPr>
-              <a:t>is each jeevan’s own capacity to evaluate and fulfil relationships — not granted from outside. At family and society scale, this same regulation becomes visible as law. But statutory codification is not automatically justice: conduct can satisfy legality while still diverging from it.</a:t>
+              <a:t>Material, bio, and animal regulation is definite; animal bodily development limits expression but does not introduce mis-evaluation. In human living, jeevan can judge wrongly when delusion mistakes the body for the self. Awakening aligns evaluation and fulfilment with coexistence.</a:t>
             </a:r>
           </a:p>
         </p:txBody>
@@ -18340,7 +18329,7 @@
                 <a:ea typeface="Calibri"/>
                 <a:cs typeface="Calibri"/>
               </a:rPr>
-              <a:t>What is real, and how it is ordered  —  coexistence is the bond of an all-pervasive ground and countable units; each unit has form, properties, essential nature, and dharma, and nature appears in four orders.</a:t>
+              <a:t>What is real, and how it is ordered  —  coexistence is the bond of an all-pervasive ground and countable units; each definite unit bears form, guna, svabhav, and dharma, whose expression becomes evident in mutuality across four orders.</a:t>
             </a:r>
           </a:p>
         </p:txBody>
@@ -18968,7 +18957,7 @@
                 <a:ea typeface="Cambria"/>
                 <a:cs typeface="Cambria"/>
               </a:rPr>
-              <a:t>What must be understood — scope</a:t>
+              <a:t>What must be understood — widening mutual context</a:t>
             </a:r>
           </a:p>
         </p:txBody>
@@ -19310,7 +19299,7 @@
                 <a:ea typeface="Calibri"/>
                 <a:cs typeface="Calibri"/>
               </a:rPr>
-              <a:t>dharma  ·  needs the whole</a:t>
+              <a:t>dharma  ·  innateness evidenced in whole-order fulfilment</a:t>
             </a:r>
           </a:p>
         </p:txBody>
@@ -19422,7 +19411,7 @@
                 <a:ea typeface="Calibri"/>
                 <a:cs typeface="Calibri"/>
               </a:rPr>
-              <a:t>essential nature  ·  needs its order</a:t>
+              <a:t>svabhav  ·  usefulness within state, plane &amp; order</a:t>
             </a:r>
           </a:p>
         </p:txBody>
@@ -19534,7 +19523,7 @@
                 <a:ea typeface="Calibri"/>
                 <a:cs typeface="Calibri"/>
               </a:rPr>
-              <a:t>properties  ·  need mutuality</a:t>
+              <a:t>guna  ·  effects evident in definite mutuality</a:t>
             </a:r>
           </a:p>
         </p:txBody>
@@ -19646,7 +19635,7 @@
                 <a:ea typeface="Calibri"/>
                 <a:cs typeface="Calibri"/>
               </a:rPr>
-              <a:t>form  ·  the unit alone</a:t>
+              <a:t>form  ·  real structure reflected in mutual facing</a:t>
             </a:r>
           </a:p>
         </p:txBody>
@@ -19702,29 +19691,7 @@
                 <a:ea typeface="Calibri"/>
                 <a:cs typeface="Calibri"/>
               </a:rPr>
-              <a:t>each higher rung needs a wider context to understand the aspect; the top rung is a different kind of knowing — coexistence </a:t>
-            </a:r>
-            <a:r>
-              <a:rPr sz="950" b="0" i="1" u="none" cap="none">
-                <a:solidFill>
-                  <a:srgbClr val="5A6377"/>
-                </a:solidFill>
-                <a:latin typeface="Calibri"/>
-                <a:ea typeface="Calibri"/>
-                <a:cs typeface="Calibri"/>
-              </a:rPr>
-              <a:t>realised</a:t>
-            </a:r>
-            <a:r>
-              <a:rPr sz="950" b="0" i="1" u="none" cap="none">
-                <a:solidFill>
-                  <a:srgbClr val="5A6377"/>
-                </a:solidFill>
-                <a:latin typeface="Calibri"/>
-                <a:ea typeface="Calibri"/>
-                <a:cs typeface="Calibri"/>
-              </a:rPr>
-              <a:t>, not just a wider unit-aspect</a:t>
+              <a:t>each rung widens the mutual context in which a real unit is understood; the top is a different kind of knowing — coexistence realised, not merely another observed aspect</a:t>
             </a:r>
           </a:p>
         </p:txBody>
@@ -20626,7 +20593,7 @@
       </p:sp>
       <p:cxnSp>
         <p:nvCxnSpPr>
-          <p:cNvPr id="529" name="Google Shape;445;p18"/>
+          <p:cNvPr id="603" name="Google Shape;445;p18"/>
           <p:cNvCxnSpPr/>
           <p:nvPr/>
         </p:nvCxnSpPr>
@@ -20707,7 +20674,7 @@
       </p:sp>
       <p:cxnSp>
         <p:nvCxnSpPr>
-          <p:cNvPr id="531" name="Google Shape;447;p18"/>
+          <p:cNvPr id="605" name="Google Shape;447;p18"/>
           <p:cNvCxnSpPr/>
           <p:nvPr/>
         </p:nvCxnSpPr>
@@ -21069,7 +21036,18 @@
                 <a:ea typeface="Calibri"/>
                 <a:cs typeface="Calibri"/>
               </a:rPr>
-              <a:t>§§1.7–1.8, 1.10, 1.12, 1.15 · WHERE THE LADDER COMPLETES — OR STALLS</a:t>
+              <a:t>§§ 1.7–1.8, 1.10, 1.12, 1.15</a:t>
+            </a:r>
+            <a:r>
+              <a:rPr sz="1050" b="1" i="0" u="none" cap="none">
+                <a:solidFill>
+                  <a:srgbClr val="9A6414"/>
+                </a:solidFill>
+                <a:latin typeface="Calibri"/>
+                <a:ea typeface="Calibri"/>
+                <a:cs typeface="Calibri"/>
+              </a:rPr>
+              <a:t> · WHERE THE LADDER COMPLETES — OR STALLS</a:t>
             </a:r>
           </a:p>
         </p:txBody>
@@ -21181,29 +21159,7 @@
                 <a:ea typeface="Calibri"/>
                 <a:cs typeface="Calibri"/>
               </a:rPr>
-              <a:t>Every </a:t>
-            </a:r>
-            <a:r>
-              <a:rPr sz="1300" b="0" i="0" u="none" cap="none">
-                <a:solidFill>
-                  <a:srgbClr val="5A6377"/>
-                </a:solidFill>
-                <a:latin typeface="Calibri"/>
-                <a:ea typeface="Calibri"/>
-                <a:cs typeface="Calibri"/>
-              </a:rPr>
-              <a:t>jeevan</a:t>
-            </a:r>
-            <a:r>
-              <a:rPr sz="1300" b="0" i="0" u="none" cap="none">
-                <a:solidFill>
-                  <a:srgbClr val="5A6377"/>
-                </a:solidFill>
-                <a:latin typeface="Calibri"/>
-                <a:ea typeface="Calibri"/>
-                <a:cs typeface="Calibri"/>
-              </a:rPr>
-              <a:t>, knowingly or not, is asking one question: what makes me happy? Its faculties — resolve, desire, thought, and hope — answer that question by pointing either toward the body or toward coexistence.</a:t>
+              <a:t>Every jeevan bears the same five faculties and ten activities. In human living they answer one question — what makes me happy? — by organising either around body-identification or around coexistence.</a:t>
             </a:r>
           </a:p>
         </p:txBody>
@@ -21371,7 +21327,7 @@
                 <a:ea typeface="Calibri"/>
                 <a:cs typeface="Calibri"/>
               </a:rPr>
-              <a:t>jeevan identifies as the body — resolve, desire, thought, and hope pull toward the body — accumulation, comfort, and safety</a:t>
+              <a:t>jeevan mistakes the body for the self — its present faculties organise around accumulation, comfort, and safety; mis-evaluation follows</a:t>
             </a:r>
           </a:p>
         </p:txBody>
@@ -21595,18 +21551,7 @@
                 <a:ea typeface="Calibri"/>
                 <a:cs typeface="Calibri"/>
               </a:rPr>
-              <a:t>Same faculties, opposite direction.  </a:t>
-            </a:r>
-            <a:r>
-              <a:rPr sz="1200" b="0" i="0" u="none" cap="none">
-                <a:solidFill>
-                  <a:srgbClr val="5A6377"/>
-                </a:solidFill>
-                <a:latin typeface="Calibri"/>
-                <a:ea typeface="Calibri"/>
-                <a:cs typeface="Calibri"/>
-              </a:rPr>
-              <a:t>The drive that builds the epistemic ladder (§1.7) runs toward the body in delusion and toward coexistence in awakening — the same faculties, run two ways.</a:t>
+              <a:t>No faculty is absent. Delusion directs evaluation toward the body; awakening aligns it with coexistence. Study supplies understanding; practice evidences and stabilises that alignment.</a:t>
             </a:r>
           </a:p>
         </p:txBody>
@@ -25306,7 +25251,7 @@
                           <a:ea typeface="Calibri"/>
                           <a:cs typeface="Calibri"/>
                         </a:rPr>
-                        <a:t>Formless Omnipotence and countless formful units, irreducibly together.</a:t>
+                        <a:t>Formless Omnipotence and definite bounded units whose aspects are evidenced in mutuality.</a:t>
                       </a:r>
                     </a:p>
                   </a:txBody>
@@ -25618,7 +25563,7 @@
                           <a:ea typeface="Calibri"/>
                           <a:cs typeface="Calibri"/>
                         </a:rPr>
-                        <a:t>Yes. Units and their relationships are real within perpetual coexistence.</a:t>
+                        <a:t>Yes. Units, mutual relationships, and definite material fulfilment are real within perpetual coexistence.</a:t>
                       </a:r>
                     </a:p>
                   </a:txBody>
@@ -25722,7 +25667,7 @@
                           <a:ea typeface="Calibri"/>
                           <a:cs typeface="Calibri"/>
                         </a:rPr>
-                        <a:t>Through study, self-examination, practice, realisation, and evidence in conduct.</a:t>
+                        <a:t>Through study and self-examination; practice tests, evidences, and stabilises understanding in conduct.</a:t>
                       </a:r>
                     </a:p>
                   </a:txBody>
@@ -26161,7 +26106,7 @@
           <p:nvPr/>
         </p:nvPicPr>
         <p:blipFill rotWithShape="1">
-          <a:blip xmlns:r="http://schemas.openxmlformats.org/officeDocument/2006/relationships" xmlns:a="http://schemas.openxmlformats.org/drawingml/2006/main" r:embed="Rddb9d766f3714bac">
+          <a:blip xmlns:r="http://schemas.openxmlformats.org/officeDocument/2006/relationships" xmlns:a="http://schemas.openxmlformats.org/drawingml/2006/main" r:embed="Rb61586ef2efe4ed2">
             <a:alphaModFix/>
           </a:blip>
           <a:srcRect xmlns:a="http://schemas.openxmlformats.org/drawingml/2006/main" l="0" t="0" r="0" b="0"/>
@@ -26303,7 +26248,7 @@
           <p:nvPr/>
         </p:nvPicPr>
         <p:blipFill rotWithShape="1">
-          <a:blip xmlns:r="http://schemas.openxmlformats.org/officeDocument/2006/relationships" xmlns:a="http://schemas.openxmlformats.org/drawingml/2006/main" r:embed="Rddb9d766f3714bac">
+          <a:blip xmlns:r="http://schemas.openxmlformats.org/officeDocument/2006/relationships" xmlns:a="http://schemas.openxmlformats.org/drawingml/2006/main" r:embed="Rb61586ef2efe4ed2">
             <a:alphaModFix/>
           </a:blip>
           <a:srcRect xmlns:a="http://schemas.openxmlformats.org/drawingml/2006/main" l="0" t="0" r="0" b="0"/>
@@ -26445,7 +26390,7 @@
           <p:nvPr/>
         </p:nvPicPr>
         <p:blipFill rotWithShape="1">
-          <a:blip xmlns:r="http://schemas.openxmlformats.org/officeDocument/2006/relationships" xmlns:a="http://schemas.openxmlformats.org/drawingml/2006/main" r:embed="Rddb9d766f3714bac">
+          <a:blip xmlns:r="http://schemas.openxmlformats.org/officeDocument/2006/relationships" xmlns:a="http://schemas.openxmlformats.org/drawingml/2006/main" r:embed="Rb61586ef2efe4ed2">
             <a:alphaModFix/>
           </a:blip>
           <a:srcRect xmlns:a="http://schemas.openxmlformats.org/drawingml/2006/main" l="0" t="0" r="0" b="0"/>
@@ -26587,7 +26532,7 @@
           <p:nvPr/>
         </p:nvPicPr>
         <p:blipFill rotWithShape="1">
-          <a:blip xmlns:r="http://schemas.openxmlformats.org/officeDocument/2006/relationships" xmlns:a="http://schemas.openxmlformats.org/drawingml/2006/main" r:embed="Rddb9d766f3714bac">
+          <a:blip xmlns:r="http://schemas.openxmlformats.org/officeDocument/2006/relationships" xmlns:a="http://schemas.openxmlformats.org/drawingml/2006/main" r:embed="Rb61586ef2efe4ed2">
             <a:alphaModFix/>
           </a:blip>
           <a:srcRect xmlns:a="http://schemas.openxmlformats.org/drawingml/2006/main" l="0" t="0" r="0" b="0"/>
@@ -26729,7 +26674,7 @@
           <p:nvPr/>
         </p:nvPicPr>
         <p:blipFill rotWithShape="1">
-          <a:blip xmlns:r="http://schemas.openxmlformats.org/officeDocument/2006/relationships" xmlns:a="http://schemas.openxmlformats.org/drawingml/2006/main" r:embed="Rddb9d766f3714bac">
+          <a:blip xmlns:r="http://schemas.openxmlformats.org/officeDocument/2006/relationships" xmlns:a="http://schemas.openxmlformats.org/drawingml/2006/main" r:embed="Rb61586ef2efe4ed2">
             <a:alphaModFix/>
           </a:blip>
           <a:srcRect xmlns:a="http://schemas.openxmlformats.org/drawingml/2006/main" l="0" t="0" r="0" b="0"/>
@@ -26871,7 +26816,7 @@
           <p:nvPr/>
         </p:nvPicPr>
         <p:blipFill rotWithShape="1">
-          <a:blip xmlns:r="http://schemas.openxmlformats.org/officeDocument/2006/relationships" xmlns:a="http://schemas.openxmlformats.org/drawingml/2006/main" r:embed="Rddb9d766f3714bac">
+          <a:blip xmlns:r="http://schemas.openxmlformats.org/officeDocument/2006/relationships" xmlns:a="http://schemas.openxmlformats.org/drawingml/2006/main" r:embed="Rb61586ef2efe4ed2">
             <a:alphaModFix/>
           </a:blip>
           <a:srcRect xmlns:a="http://schemas.openxmlformats.org/drawingml/2006/main" l="0" t="0" r="0" b="0"/>
@@ -27422,7 +27367,7 @@
           <p:nvPr/>
         </p:nvPicPr>
         <p:blipFill>
-          <a:blip xmlns:r="http://schemas.openxmlformats.org/officeDocument/2006/relationships" xmlns:a="http://schemas.openxmlformats.org/drawingml/2006/main" r:embed="R61b7c944b53e42ef"/>
+          <a:blip xmlns:r="http://schemas.openxmlformats.org/officeDocument/2006/relationships" xmlns:a="http://schemas.openxmlformats.org/drawingml/2006/main" r:embed="Rf62b9a5120084ac0"/>
           <a:stretch xmlns:a="http://schemas.openxmlformats.org/drawingml/2006/main"/>
         </p:blipFill>
         <p:spPr>
@@ -27840,7 +27785,29 @@
                 <a:ea typeface="Calibri"/>
                 <a:cs typeface="Calibri"/>
               </a:rPr>
-              <a:t>Formful, active, countable entities — each bounded from six directions, and each soaked, submerged, and surrounded in Omnipotence, with form, properties, essential nature, and dharma. At the smallest scale, every unit is built from the same basic building block: an atom — a core with parts orbiting it.</a:t>
+              <a:t>Formful, active, countable entities — </a:t>
+            </a:r>
+            <a:r>
+              <a:rPr sz="1250" b="0" i="0" u="none" cap="none">
+                <a:solidFill>
+                  <a:srgbClr val="5A6377"/>
+                </a:solidFill>
+                <a:latin typeface="Calibri"/>
+                <a:ea typeface="Calibri"/>
+                <a:cs typeface="Calibri"/>
+              </a:rPr>
+              <a:t>each bounded from six directions and saturated in Omnipotence, bearing form, guna, svabhav, and dharma, whose expression is evident in definite mutuality.</a:t>
+            </a:r>
+            <a:r>
+              <a:rPr sz="1250" b="0" i="0" u="none" cap="none">
+                <a:solidFill>
+                  <a:srgbClr val="5A6377"/>
+                </a:solidFill>
+                <a:latin typeface="Calibri"/>
+                <a:ea typeface="Calibri"/>
+                <a:cs typeface="Calibri"/>
+              </a:rPr>
+              <a:t> At the smallest scale, every unit is built from the same basic building block: an atom — a core with parts orbiting it.</a:t>
             </a:r>
           </a:p>
           <a:p xmlns:a="http://schemas.openxmlformats.org/drawingml/2006/main">
@@ -28787,7 +28754,7 @@
                 <a:ea typeface="Calibri"/>
                 <a:cs typeface="Calibri"/>
               </a:rPr>
-              <a:t>bounded units, each saturated in the ground; even the distance between units is held in Omnipotence as Space</a:t>
+              <a:t>bounded units in definite mutual facing; form is reflected, while effects, essentiality, and fulfilment are evidenced in coexistence</a:t>
             </a:r>
           </a:p>
         </p:txBody>
@@ -29304,7 +29271,7 @@
           <p:nvPr/>
         </p:nvPicPr>
         <p:blipFill rotWithShape="1">
-          <a:blip xmlns:r="http://schemas.openxmlformats.org/officeDocument/2006/relationships" xmlns:a="http://schemas.openxmlformats.org/drawingml/2006/main" r:embed="Rd154b8aa4131482a">
+          <a:blip xmlns:r="http://schemas.openxmlformats.org/officeDocument/2006/relationships" xmlns:a="http://schemas.openxmlformats.org/drawingml/2006/main" r:embed="Rca6f2c87ac2d49fd">
             <a:alphaModFix/>
           </a:blip>
           <a:srcRect xmlns:a="http://schemas.openxmlformats.org/drawingml/2006/main" l="0" t="0" r="0" b="0"/>
@@ -29430,7 +29397,7 @@
                 <a:ea typeface="Calibri"/>
                 <a:cs typeface="Calibri"/>
               </a:rPr>
-              <a:t>Complementarity is given in coexistence, not created. Bounded units standing together in the ground are able to recognise one another through capacity, ability, and receptivity.</a:t>
+              <a:t>Complementarity is given in coexistence, not created. In insentient nature, reflection, recognition, and fulfilment occur definitely through the unit's capacity, ability, and receptivity.</a:t>
             </a:r>
           </a:p>
         </p:txBody>
@@ -29547,7 +29514,7 @@
           <p:nvPr/>
         </p:nvPicPr>
         <p:blipFill rotWithShape="1">
-          <a:blip xmlns:r="http://schemas.openxmlformats.org/officeDocument/2006/relationships" xmlns:a="http://schemas.openxmlformats.org/drawingml/2006/main" r:embed="Rc5eb85f55fd6457a">
+          <a:blip xmlns:r="http://schemas.openxmlformats.org/officeDocument/2006/relationships" xmlns:a="http://schemas.openxmlformats.org/drawingml/2006/main" r:embed="R5d0e756c21794690">
             <a:alphaModFix/>
           </a:blip>
           <a:srcRect xmlns:a="http://schemas.openxmlformats.org/drawingml/2006/main" l="0" t="0" r="0" b="0"/>
@@ -29790,7 +29757,7 @@
           <p:nvPr/>
         </p:nvPicPr>
         <p:blipFill rotWithShape="1">
-          <a:blip xmlns:r="http://schemas.openxmlformats.org/officeDocument/2006/relationships" xmlns:a="http://schemas.openxmlformats.org/drawingml/2006/main" r:embed="R84f61d41cc954bd3">
+          <a:blip xmlns:r="http://schemas.openxmlformats.org/officeDocument/2006/relationships" xmlns:a="http://schemas.openxmlformats.org/drawingml/2006/main" r:embed="Rdcce4f10cee847d4">
             <a:alphaModFix/>
           </a:blip>
           <a:srcRect xmlns:a="http://schemas.openxmlformats.org/drawingml/2006/main" l="0" t="0" r="0" b="0"/>
@@ -30260,7 +30227,7 @@
                 <a:ea typeface="Cambria"/>
                 <a:cs typeface="Cambria"/>
               </a:rPr>
-              <a:t>What Every Unit Is: Four Inseparable Aspects</a:t>
+              <a:t>The Unit and Its Four Aspects in Mutuality</a:t>
             </a:r>
           </a:p>
         </p:txBody>
@@ -30575,7 +30542,7 @@
                 <a:ea typeface="Calibri"/>
                 <a:cs typeface="Calibri"/>
               </a:rPr>
-              <a:t>Shape, volume, and density — by which a bounded unit is individuated. Shared across all orders.</a:t>
+              <a:t>Real shape, volume, and density. In mutual facing, another unit encounters their definite reflection; observation does not create form.</a:t>
             </a:r>
           </a:p>
         </p:txBody>
@@ -30890,7 +30857,7 @@
                 <a:ea typeface="Calibri"/>
                 <a:cs typeface="Calibri"/>
               </a:rPr>
-              <a:t>Effects units have on one another in mutuality — generative, degenerative, and mediative (assisting creation, dissolution, sustainment).</a:t>
+              <a:t>Guna: inseparable relative powers or effects, manifested with partners and conditions as generative, degenerative, or mediative.</a:t>
             </a:r>
           </a:p>
         </p:txBody>
@@ -31205,7 +31172,7 @@
                 <a:ea typeface="Calibri"/>
                 <a:cs typeface="Calibri"/>
               </a:rPr>
-              <a:t>How the usefulness of a unit’s properties participates in its order — its distinctive way of being (its “ness”).</a:t>
+              <a:t>Svabhav: the usefulness or essentiality of those effects according to the unit's state, motion, plane, order, and context.</a:t>
             </a:r>
           </a:p>
         </p:txBody>
@@ -31520,7 +31487,7 @@
                 <a:ea typeface="Calibri"/>
                 <a:cs typeface="Calibri"/>
               </a:rPr>
-              <a:t>What a unit cannot be separated from — its innateness and fulfilment. Since existence is coexistence, indestructibility is the ultimate dharma.</a:t>
+              <a:t>Inseparable innateness and fulfilment, evidenced as the unit participates in its order. Dharma is not an observer-assigned label.</a:t>
             </a:r>
           </a:p>
         </p:txBody>
@@ -31625,40 +31592,7 @@
                 <a:ea typeface="Calibri"/>
                 <a:cs typeface="Calibri"/>
               </a:rPr>
-              <a:t>Natural state → development</a:t>
-            </a:r>
-            <a:r>
-              <a:rPr sz="1200" b="0" i="0" u="none" cap="none">
-                <a:solidFill>
-                  <a:srgbClr val="5A6377"/>
-                </a:solidFill>
-                <a:latin typeface="Calibri"/>
-                <a:ea typeface="Calibri"/>
-                <a:cs typeface="Calibri"/>
-              </a:rPr>
-              <a:t>  (fulfilment aligned with innateness)      </a:t>
-            </a:r>
-            <a:r>
-              <a:rPr sz="1200" b="1" i="0" u="none" cap="none">
-                <a:solidFill>
-                  <a:srgbClr val="9A6414"/>
-                </a:solidFill>
-                <a:latin typeface="Calibri"/>
-                <a:ea typeface="Calibri"/>
-                <a:cs typeface="Calibri"/>
-              </a:rPr>
-              <a:t>Excited state → decline</a:t>
-            </a:r>
-            <a:r>
-              <a:rPr sz="1200" b="0" i="0" u="none" cap="none">
-                <a:solidFill>
-                  <a:srgbClr val="5A6377"/>
-                </a:solidFill>
-                <a:latin typeface="Calibri"/>
-                <a:ea typeface="Calibri"/>
-                <a:cs typeface="Calibri"/>
-              </a:rPr>
-              <a:t>  — each unit is a whole along with its environment; when all relationships are fulfilled, it is at ease.</a:t>
+              <a:t>In insentient nature, reflection, recognition, evaluation, and fulfilment are definite. Human mis-evaluation enters only when jeevan, under delusion, takes the body to be the self.</a:t>
             </a:r>
           </a:p>
         </p:txBody>
@@ -32058,7 +31992,7 @@
                 <a:ea typeface="Calibri"/>
                 <a:cs typeface="Calibri"/>
               </a:rPr>
-              <a:t>“Nothing is isolated — that is the principle” (JV p. 43). Complementarity is actualised as value in mutuality; the unit’s main drive is to recognise and fulfil its relationships.</a:t>
+              <a:t>“Nothing is isolated — that is the principle” (JV p. 43). Complementarity is actualised as value in mutuality. Its expression is definite in material, bio, and animal orders; human evaluation may err under body-identification.</a:t>
             </a:r>
           </a:p>
         </p:txBody>
@@ -32226,7 +32160,7 @@
                 <a:ea typeface="Calibri"/>
                 <a:cs typeface="Calibri"/>
               </a:rPr>
-              <a:t>Mutuality where expectations are predetermined in the sense of completeness — e.g. parent and child.</a:t>
+              <a:t>Mutuality whose expectations and fulfilment are definite in the relation's completeness — e.g. parent and child.</a:t>
             </a:r>
           </a:p>
         </p:txBody>
@@ -32450,18 +32384,7 @@
                 <a:ea typeface="Calibri"/>
                 <a:cs typeface="Calibri"/>
               </a:rPr>
-              <a:t>Essentiality is value.  </a:t>
-            </a:r>
-            <a:r>
-              <a:rPr sz="1200" b="0" i="0" u="none" cap="none">
-                <a:solidFill>
-                  <a:srgbClr val="5A6377"/>
-                </a:solidFill>
-                <a:latin typeface="Calibri"/>
-                <a:ea typeface="Calibri"/>
-                <a:cs typeface="Calibri"/>
-              </a:rPr>
-              <a:t>Object values — utility and art — operate at every order; jeevan values, human values, relationship values, and expression values presuppose the knowledge order.</a:t>
+              <a:t>Essentiality is value as expressed in mutuality. Object values — utility and art — operate at every order; jeevan, human, relationship, and expression values presuppose the knowledge order.</a:t>
             </a:r>
           </a:p>
         </p:txBody>
@@ -33105,7 +33028,7 @@
                 <a:ea typeface="Calibri"/>
                 <a:cs typeface="Calibri"/>
               </a:rPr>
-              <a:t>Below the knowledge order fulfilment is definite; at the human order it must be achieved through this chain.</a:t>
+              <a:t>Material, bio, and animal fulfilment is definite. Human living can mis-evaluate this chain under body-delusion; understanding restores alignment.</a:t>
             </a:r>
           </a:p>
         </p:txBody>
@@ -33545,7 +33468,7 @@
                           <a:ea typeface="Calibri"/>
                           <a:cs typeface="Calibri"/>
                         </a:rPr>
-                        <a:t>Essential nature</a:t>
+                        <a:t>Svabhav in mutuality</a:t>
                       </a:r>
                     </a:p>
                   </a:txBody>
@@ -33853,7 +33776,7 @@
                           <a:ea typeface="Calibri"/>
                           <a:cs typeface="Calibri"/>
                         </a:rPr>
-                        <a:t>insentient</a:t>
+                        <a:t>insentient · definite</a:t>
                       </a:r>
                     </a:p>
                   </a:txBody>
@@ -34059,7 +33982,7 @@
                           <a:ea typeface="Calibri"/>
                           <a:cs typeface="Calibri"/>
                         </a:rPr>
-                        <a:t>insentient</a:t>
+                        <a:t>insentient · definite</a:t>
                       </a:r>
                     </a:p>
                   </a:txBody>
@@ -34265,7 +34188,7 @@
                           <a:ea typeface="Calibri"/>
                           <a:cs typeface="Calibri"/>
                         </a:rPr>
-                        <a:t>sentient — jeevan appears</a:t>
+                        <a:t>sentient · bodily expression limited</a:t>
                       </a:r>
                     </a:p>
                   </a:txBody>
@@ -34471,7 +34394,7 @@
                           <a:ea typeface="Calibri"/>
                           <a:cs typeface="Calibri"/>
                         </a:rPr>
-                        <a:t>sentient — awakening possible</a:t>
+                        <a:t>sentient · full bodily medium; awakening possible</a:t>
                       </a:r>
                     </a:p>
                   </a:txBody>
@@ -34610,7 +34533,7 @@
                 <a:ea typeface="Calibri"/>
                 <a:cs typeface="Calibri"/>
               </a:rPr>
-              <a:t>The sentience boundary lies between the bio and animal orders. The body develops along the compositional line; jeevan arises through development in an atom. They meet as a joint form in animal and human living — not by the body becoming sentient through complexity.</a:t>
+              <a:t>Jeevan is present in animal and human joint forms. In animals, bodily and brain development limits how its faculties can be expressed. In humans, the bodily medium supports the full range, but delusion can misdirect evaluation. Neither body produces sentience.</a:t>
             </a:r>
           </a:p>
         </p:txBody>

</xml_diff>

<commit_message>
Clarify how structure and mutuality express four aspects
</commit_message>
<xml_diff>
--- a/Studies/The-Ontology-of-Coexistence/The-Ontology-of-Existence-Madhyasth-Darshan.pptx
+++ b/Studies/The-Ontology-of-Coexistence/The-Ontology-of-Existence-Madhyasth-Darshan.pptx
@@ -2,36 +2,36 @@
 <file path=ppt/presentation.xml><?xml version="1.0" encoding="utf-8"?>
 <p:presentation xmlns:p="http://schemas.openxmlformats.org/presentationml/2006/main">
   <p:sldMasterIdLst>
-    <p:sldMasterId xmlns:r="http://schemas.openxmlformats.org/officeDocument/2006/relationships" id="2147483648" r:id="R2ab47f0255ab46b2"/>
+    <p:sldMasterId xmlns:r="http://schemas.openxmlformats.org/officeDocument/2006/relationships" id="2147483648" r:id="R92f624f45424452f"/>
   </p:sldMasterIdLst>
   <p:notesMasterIdLst>
-    <p:notesMasterId xmlns:r="http://schemas.openxmlformats.org/officeDocument/2006/relationships" r:id="R976a1b4e4ae74717"/>
+    <p:notesMasterId xmlns:r="http://schemas.openxmlformats.org/officeDocument/2006/relationships" r:id="Ra55e71b4c2f14f47"/>
   </p:notesMasterIdLst>
   <p:sldIdLst>
-    <p:sldId xmlns:r="http://schemas.openxmlformats.org/officeDocument/2006/relationships" id="256" r:id="Re8bfde844f044856"/>
-    <p:sldId xmlns:r="http://schemas.openxmlformats.org/officeDocument/2006/relationships" id="257" r:id="Ra28ee0df49904aac"/>
-    <p:sldId xmlns:r="http://schemas.openxmlformats.org/officeDocument/2006/relationships" id="258" r:id="R0ca0f2b5af7246f4"/>
-    <p:sldId xmlns:r="http://schemas.openxmlformats.org/officeDocument/2006/relationships" id="259" r:id="R1fd9b78b07984908"/>
-    <p:sldId xmlns:r="http://schemas.openxmlformats.org/officeDocument/2006/relationships" id="260" r:id="R0b9001fd56fc46ef"/>
-    <p:sldId xmlns:r="http://schemas.openxmlformats.org/officeDocument/2006/relationships" id="261" r:id="R5d07bbbb88094736"/>
-    <p:sldId xmlns:r="http://schemas.openxmlformats.org/officeDocument/2006/relationships" id="262" r:id="R247c549a66384e79"/>
-    <p:sldId xmlns:r="http://schemas.openxmlformats.org/officeDocument/2006/relationships" id="263" r:id="R30ce2ef1e7784e43"/>
-    <p:sldId xmlns:r="http://schemas.openxmlformats.org/officeDocument/2006/relationships" id="264" r:id="R1d8509b144664017"/>
-    <p:sldId xmlns:r="http://schemas.openxmlformats.org/officeDocument/2006/relationships" id="265" r:id="Re9b0aa974928436c"/>
-    <p:sldId xmlns:r="http://schemas.openxmlformats.org/officeDocument/2006/relationships" id="266" r:id="Rda6bbb92ca14444e"/>
-    <p:sldId xmlns:r="http://schemas.openxmlformats.org/officeDocument/2006/relationships" id="267" r:id="Rab9c2b11f81b4d01"/>
-    <p:sldId xmlns:r="http://schemas.openxmlformats.org/officeDocument/2006/relationships" id="268" r:id="R751246d742774347"/>
-    <p:sldId xmlns:r="http://schemas.openxmlformats.org/officeDocument/2006/relationships" id="269" r:id="R53b0454050cb44bd"/>
-    <p:sldId xmlns:r="http://schemas.openxmlformats.org/officeDocument/2006/relationships" id="270" r:id="R0976fab93b7b42a7"/>
-    <p:sldId xmlns:r="http://schemas.openxmlformats.org/officeDocument/2006/relationships" id="271" r:id="Rf7702542b0164297"/>
-    <p:sldId xmlns:r="http://schemas.openxmlformats.org/officeDocument/2006/relationships" id="272" r:id="R75bf481cf7654716"/>
-    <p:sldId xmlns:r="http://schemas.openxmlformats.org/officeDocument/2006/relationships" id="273" r:id="R9b51ef5a889346b3"/>
-    <p:sldId xmlns:r="http://schemas.openxmlformats.org/officeDocument/2006/relationships" id="274" r:id="Ra7cd1ce75483407a"/>
-    <p:sldId xmlns:r="http://schemas.openxmlformats.org/officeDocument/2006/relationships" id="275" r:id="R1304c41ce313407f"/>
-    <p:sldId xmlns:r="http://schemas.openxmlformats.org/officeDocument/2006/relationships" id="276" r:id="R3758d5e80db04e63"/>
-    <p:sldId xmlns:r="http://schemas.openxmlformats.org/officeDocument/2006/relationships" id="277" r:id="R43bc4679298842e4"/>
-    <p:sldId xmlns:r="http://schemas.openxmlformats.org/officeDocument/2006/relationships" id="278" r:id="R12471cdb83a74544"/>
-    <p:sldId xmlns:r="http://schemas.openxmlformats.org/officeDocument/2006/relationships" id="279" r:id="Rddf26886c0f74a7e"/>
+    <p:sldId xmlns:r="http://schemas.openxmlformats.org/officeDocument/2006/relationships" id="256" r:id="Ra2e6dabf48f642ea"/>
+    <p:sldId xmlns:r="http://schemas.openxmlformats.org/officeDocument/2006/relationships" id="257" r:id="R19d8713f9d374dc3"/>
+    <p:sldId xmlns:r="http://schemas.openxmlformats.org/officeDocument/2006/relationships" id="258" r:id="Ra49c29211e6f48a8"/>
+    <p:sldId xmlns:r="http://schemas.openxmlformats.org/officeDocument/2006/relationships" id="259" r:id="Rd78a744b89c8415f"/>
+    <p:sldId xmlns:r="http://schemas.openxmlformats.org/officeDocument/2006/relationships" id="260" r:id="R3c27c3444d3847e0"/>
+    <p:sldId xmlns:r="http://schemas.openxmlformats.org/officeDocument/2006/relationships" id="261" r:id="R9906e6ec7b7b4bd8"/>
+    <p:sldId xmlns:r="http://schemas.openxmlformats.org/officeDocument/2006/relationships" id="262" r:id="R50171322ed794da5"/>
+    <p:sldId xmlns:r="http://schemas.openxmlformats.org/officeDocument/2006/relationships" id="263" r:id="Rece21e36fdf04601"/>
+    <p:sldId xmlns:r="http://schemas.openxmlformats.org/officeDocument/2006/relationships" id="264" r:id="Rb729523048bd455a"/>
+    <p:sldId xmlns:r="http://schemas.openxmlformats.org/officeDocument/2006/relationships" id="265" r:id="Rfeb7c5fbf04a4d87"/>
+    <p:sldId xmlns:r="http://schemas.openxmlformats.org/officeDocument/2006/relationships" id="266" r:id="R3b9e20babf2946aa"/>
+    <p:sldId xmlns:r="http://schemas.openxmlformats.org/officeDocument/2006/relationships" id="267" r:id="R398181487b044f79"/>
+    <p:sldId xmlns:r="http://schemas.openxmlformats.org/officeDocument/2006/relationships" id="268" r:id="Rd56a65fc53f74b04"/>
+    <p:sldId xmlns:r="http://schemas.openxmlformats.org/officeDocument/2006/relationships" id="269" r:id="R7d5a111654224ab9"/>
+    <p:sldId xmlns:r="http://schemas.openxmlformats.org/officeDocument/2006/relationships" id="270" r:id="R8c35ab92e88e4319"/>
+    <p:sldId xmlns:r="http://schemas.openxmlformats.org/officeDocument/2006/relationships" id="271" r:id="Re53dc5a33fb54879"/>
+    <p:sldId xmlns:r="http://schemas.openxmlformats.org/officeDocument/2006/relationships" id="272" r:id="Re8c19a19911545da"/>
+    <p:sldId xmlns:r="http://schemas.openxmlformats.org/officeDocument/2006/relationships" id="273" r:id="R947e84c9630b45b1"/>
+    <p:sldId xmlns:r="http://schemas.openxmlformats.org/officeDocument/2006/relationships" id="274" r:id="Rf9b727d3c63d4e25"/>
+    <p:sldId xmlns:r="http://schemas.openxmlformats.org/officeDocument/2006/relationships" id="275" r:id="Rf0b268f4cca549bc"/>
+    <p:sldId xmlns:r="http://schemas.openxmlformats.org/officeDocument/2006/relationships" id="276" r:id="R3ce4251260ef49f7"/>
+    <p:sldId xmlns:r="http://schemas.openxmlformats.org/officeDocument/2006/relationships" id="277" r:id="R81396cf7f81140a9"/>
+    <p:sldId xmlns:r="http://schemas.openxmlformats.org/officeDocument/2006/relationships" id="278" r:id="Ref593b4592284e45"/>
+    <p:sldId xmlns:r="http://schemas.openxmlformats.org/officeDocument/2006/relationships" id="279" r:id="Rc2ed281b01244d1e"/>
   </p:sldIdLst>
   <p:sldSz cx="9144000" cy="5143500"/>
   <p:notesSz cx="6858000" cy="9144000"/>
@@ -2416,7 +2416,7 @@
   </p:cSld>
   <p:clrMap bg1="lt1" tx1="dk1" bg2="dk2" tx2="lt2" accent1="accent1" accent2="accent2" accent3="accent3" accent4="accent4" accent5="accent5" accent6="accent6" hlink="hlink" folHlink="folHlink"/>
   <p:sldLayoutIdLst>
-    <p:sldLayoutId xmlns:r="http://schemas.openxmlformats.org/officeDocument/2006/relationships" id="2147483649" r:id="R0233ba452ac04100"/>
+    <p:sldLayoutId xmlns:r="http://schemas.openxmlformats.org/officeDocument/2006/relationships" id="2147483649" r:id="R18d84c5e869a473e"/>
   </p:sldLayoutIdLst>
   <p:hf sldNum="0" hdr="0" ftr="0" dt="0"/>
   <p:txStyles>
@@ -5469,7 +5469,7 @@
                 <a:ea typeface="Cambria"/>
                 <a:cs typeface="Cambria"/>
               </a:rPr>
-              <a:t>Three Completeness Transitions: T1, T2, T3</a:t>
+              <a:t>Three Transitions: T1, T2, T3</a:t>
             </a:r>
           </a:p>
         </p:txBody>
@@ -20593,7 +20593,7 @@
       </p:sp>
       <p:cxnSp>
         <p:nvCxnSpPr>
-          <p:cNvPr id="603" name="Google Shape;445;p18"/>
+          <p:cNvPr id="677" name="Google Shape;445;p18"/>
           <p:cNvCxnSpPr/>
           <p:nvPr/>
         </p:nvCxnSpPr>
@@ -20674,7 +20674,7 @@
       </p:sp>
       <p:cxnSp>
         <p:nvCxnSpPr>
-          <p:cNvPr id="605" name="Google Shape;447;p18"/>
+          <p:cNvPr id="679" name="Google Shape;447;p18"/>
           <p:cNvCxnSpPr/>
           <p:nvPr/>
         </p:nvCxnSpPr>
@@ -21103,7 +21103,7 @@
                 <a:ea typeface="Cambria"/>
                 <a:cs typeface="Cambria"/>
               </a:rPr>
-              <a:t>The Fork: What Makes Me Happy?</a:t>
+              <a:t>What Makes Me Happy?</a:t>
             </a:r>
           </a:p>
         </p:txBody>
@@ -26045,7 +26045,7 @@
                 <a:ea typeface="Cambria"/>
                 <a:cs typeface="Cambria"/>
               </a:rPr>
-              <a:t>The Questions Ontology Must Answer</a:t>
+              <a:t>Questions Ontology Must Answer</a:t>
             </a:r>
           </a:p>
         </p:txBody>
@@ -26106,7 +26106,7 @@
           <p:nvPr/>
         </p:nvPicPr>
         <p:blipFill rotWithShape="1">
-          <a:blip xmlns:r="http://schemas.openxmlformats.org/officeDocument/2006/relationships" xmlns:a="http://schemas.openxmlformats.org/drawingml/2006/main" r:embed="Rb61586ef2efe4ed2">
+          <a:blip xmlns:r="http://schemas.openxmlformats.org/officeDocument/2006/relationships" xmlns:a="http://schemas.openxmlformats.org/drawingml/2006/main" r:embed="R60eabc6028aa480b">
             <a:alphaModFix/>
           </a:blip>
           <a:srcRect xmlns:a="http://schemas.openxmlformats.org/drawingml/2006/main" l="0" t="0" r="0" b="0"/>
@@ -26248,7 +26248,7 @@
           <p:nvPr/>
         </p:nvPicPr>
         <p:blipFill rotWithShape="1">
-          <a:blip xmlns:r="http://schemas.openxmlformats.org/officeDocument/2006/relationships" xmlns:a="http://schemas.openxmlformats.org/drawingml/2006/main" r:embed="Rb61586ef2efe4ed2">
+          <a:blip xmlns:r="http://schemas.openxmlformats.org/officeDocument/2006/relationships" xmlns:a="http://schemas.openxmlformats.org/drawingml/2006/main" r:embed="R60eabc6028aa480b">
             <a:alphaModFix/>
           </a:blip>
           <a:srcRect xmlns:a="http://schemas.openxmlformats.org/drawingml/2006/main" l="0" t="0" r="0" b="0"/>
@@ -26390,7 +26390,7 @@
           <p:nvPr/>
         </p:nvPicPr>
         <p:blipFill rotWithShape="1">
-          <a:blip xmlns:r="http://schemas.openxmlformats.org/officeDocument/2006/relationships" xmlns:a="http://schemas.openxmlformats.org/drawingml/2006/main" r:embed="Rb61586ef2efe4ed2">
+          <a:blip xmlns:r="http://schemas.openxmlformats.org/officeDocument/2006/relationships" xmlns:a="http://schemas.openxmlformats.org/drawingml/2006/main" r:embed="R60eabc6028aa480b">
             <a:alphaModFix/>
           </a:blip>
           <a:srcRect xmlns:a="http://schemas.openxmlformats.org/drawingml/2006/main" l="0" t="0" r="0" b="0"/>
@@ -26532,7 +26532,7 @@
           <p:nvPr/>
         </p:nvPicPr>
         <p:blipFill rotWithShape="1">
-          <a:blip xmlns:r="http://schemas.openxmlformats.org/officeDocument/2006/relationships" xmlns:a="http://schemas.openxmlformats.org/drawingml/2006/main" r:embed="Rb61586ef2efe4ed2">
+          <a:blip xmlns:r="http://schemas.openxmlformats.org/officeDocument/2006/relationships" xmlns:a="http://schemas.openxmlformats.org/drawingml/2006/main" r:embed="R60eabc6028aa480b">
             <a:alphaModFix/>
           </a:blip>
           <a:srcRect xmlns:a="http://schemas.openxmlformats.org/drawingml/2006/main" l="0" t="0" r="0" b="0"/>
@@ -26674,7 +26674,7 @@
           <p:nvPr/>
         </p:nvPicPr>
         <p:blipFill rotWithShape="1">
-          <a:blip xmlns:r="http://schemas.openxmlformats.org/officeDocument/2006/relationships" xmlns:a="http://schemas.openxmlformats.org/drawingml/2006/main" r:embed="Rb61586ef2efe4ed2">
+          <a:blip xmlns:r="http://schemas.openxmlformats.org/officeDocument/2006/relationships" xmlns:a="http://schemas.openxmlformats.org/drawingml/2006/main" r:embed="R60eabc6028aa480b">
             <a:alphaModFix/>
           </a:blip>
           <a:srcRect xmlns:a="http://schemas.openxmlformats.org/drawingml/2006/main" l="0" t="0" r="0" b="0"/>
@@ -26816,7 +26816,7 @@
           <p:nvPr/>
         </p:nvPicPr>
         <p:blipFill rotWithShape="1">
-          <a:blip xmlns:r="http://schemas.openxmlformats.org/officeDocument/2006/relationships" xmlns:a="http://schemas.openxmlformats.org/drawingml/2006/main" r:embed="Rb61586ef2efe4ed2">
+          <a:blip xmlns:r="http://schemas.openxmlformats.org/officeDocument/2006/relationships" xmlns:a="http://schemas.openxmlformats.org/drawingml/2006/main" r:embed="R60eabc6028aa480b">
             <a:alphaModFix/>
           </a:blip>
           <a:srcRect xmlns:a="http://schemas.openxmlformats.org/drawingml/2006/main" l="0" t="0" r="0" b="0"/>
@@ -27367,7 +27367,7 @@
           <p:nvPr/>
         </p:nvPicPr>
         <p:blipFill>
-          <a:blip xmlns:r="http://schemas.openxmlformats.org/officeDocument/2006/relationships" xmlns:a="http://schemas.openxmlformats.org/drawingml/2006/main" r:embed="Rf62b9a5120084ac0"/>
+          <a:blip xmlns:r="http://schemas.openxmlformats.org/officeDocument/2006/relationships" xmlns:a="http://schemas.openxmlformats.org/drawingml/2006/main" r:embed="R19e19323847949a2"/>
           <a:stretch xmlns:a="http://schemas.openxmlformats.org/drawingml/2006/main"/>
         </p:blipFill>
         <p:spPr>
@@ -29271,7 +29271,7 @@
           <p:nvPr/>
         </p:nvPicPr>
         <p:blipFill rotWithShape="1">
-          <a:blip xmlns:r="http://schemas.openxmlformats.org/officeDocument/2006/relationships" xmlns:a="http://schemas.openxmlformats.org/drawingml/2006/main" r:embed="Rca6f2c87ac2d49fd">
+          <a:blip xmlns:r="http://schemas.openxmlformats.org/officeDocument/2006/relationships" xmlns:a="http://schemas.openxmlformats.org/drawingml/2006/main" r:embed="R42c2e34c59974a9e">
             <a:alphaModFix/>
           </a:blip>
           <a:srcRect xmlns:a="http://schemas.openxmlformats.org/drawingml/2006/main" l="0" t="0" r="0" b="0"/>
@@ -29514,7 +29514,7 @@
           <p:nvPr/>
         </p:nvPicPr>
         <p:blipFill rotWithShape="1">
-          <a:blip xmlns:r="http://schemas.openxmlformats.org/officeDocument/2006/relationships" xmlns:a="http://schemas.openxmlformats.org/drawingml/2006/main" r:embed="R5d0e756c21794690">
+          <a:blip xmlns:r="http://schemas.openxmlformats.org/officeDocument/2006/relationships" xmlns:a="http://schemas.openxmlformats.org/drawingml/2006/main" r:embed="R9af2e785855e4fe5">
             <a:alphaModFix/>
           </a:blip>
           <a:srcRect xmlns:a="http://schemas.openxmlformats.org/drawingml/2006/main" l="0" t="0" r="0" b="0"/>
@@ -29757,7 +29757,7 @@
           <p:nvPr/>
         </p:nvPicPr>
         <p:blipFill rotWithShape="1">
-          <a:blip xmlns:r="http://schemas.openxmlformats.org/officeDocument/2006/relationships" xmlns:a="http://schemas.openxmlformats.org/drawingml/2006/main" r:embed="Rdcce4f10cee847d4">
+          <a:blip xmlns:r="http://schemas.openxmlformats.org/officeDocument/2006/relationships" xmlns:a="http://schemas.openxmlformats.org/drawingml/2006/main" r:embed="R095125ef378c4d21">
             <a:alphaModFix/>
           </a:blip>
           <a:srcRect xmlns:a="http://schemas.openxmlformats.org/drawingml/2006/main" l="0" t="0" r="0" b="0"/>
@@ -30227,7 +30227,7 @@
                 <a:ea typeface="Cambria"/>
                 <a:cs typeface="Cambria"/>
               </a:rPr>
-              <a:t>The Unit and Its Four Aspects in Mutuality</a:t>
+              <a:t>Structure Constrains; Mutuality Makes Evident</a:t>
             </a:r>
           </a:p>
         </p:txBody>
@@ -30542,7 +30542,7 @@
                 <a:ea typeface="Calibri"/>
                 <a:cs typeface="Calibri"/>
               </a:rPr>
-              <a:t>Real shape, volume, and density. In mutual facing, another unit encounters their definite reflection; observation does not create form.</a:t>
+              <a:t>Real boundary and configuration. Atomic constitution and motion-path differentiate material form; mutual facing presents its definite reflection.</a:t>
             </a:r>
           </a:p>
         </p:txBody>
@@ -30857,7 +30857,7 @@
                 <a:ea typeface="Calibri"/>
                 <a:cs typeface="Calibri"/>
               </a:rPr>
-              <a:t>Guna: inseparable relative powers or effects, manifested with partners and conditions as generative, degenerative, or mediative.</a:t>
+              <a:t>The bearer has definite capacity. Guna is the relative effect that becomes active when units meet under definite conditions.</a:t>
             </a:r>
           </a:p>
         </p:txBody>
@@ -31172,7 +31172,7 @@
                 <a:ea typeface="Calibri"/>
                 <a:cs typeface="Calibri"/>
               </a:rPr>
-              <a:t>Svabhav: the usefulness or essentiality of those effects according to the unit's state, motion, plane, order, and context.</a:t>
+              <a:t>Svabhav is the usefulness of the manifested effect according to state, motion, plane, order, and mutual context.</a:t>
             </a:r>
           </a:p>
         </p:txBody>
@@ -31487,7 +31487,7 @@
                 <a:ea typeface="Calibri"/>
                 <a:cs typeface="Calibri"/>
               </a:rPr>
-              <a:t>Inseparable innateness and fulfilment, evidenced as the unit participates in its order. Dharma is not an observer-assigned label.</a:t>
+              <a:t>Unit innateness and order-specific fulfilment. Existence is universal; growth, hope to live, and happiness are cumulative.</a:t>
             </a:r>
           </a:p>
         </p:txBody>
@@ -31592,7 +31592,7 @@
                 <a:ea typeface="Calibri"/>
                 <a:cs typeface="Calibri"/>
               </a:rPr>
-              <a:t>In insentient nature, reflection, recognition, evaluation, and fulfilment are definite. Human mis-evaluation enters only when jeevan, under delusion, takes the body to be the self.</a:t>
+              <a:t>Not a particle-count reduction: constitution differentiates possible expression; mutuality manifests guna and svabhav; higher-order dharma remains taught ontological content.</a:t>
             </a:r>
           </a:p>
         </p:txBody>
@@ -31648,7 +31648,7 @@
                 <a:ea typeface="Calibri"/>
                 <a:cs typeface="Calibri"/>
               </a:rPr>
-              <a:t>MVD pp. 50–51, 112  ·  SB pp. 13–15, 50–54  ·  JV p. 113 (the peepal tree’s definite conduct)</a:t>
+              <a:t>MVD pp. 11, 42, 47, 50–51  ·  SB pp. 55, 71, 86</a:t>
             </a:r>
           </a:p>
         </p:txBody>

</xml_diff>

<commit_message>
Refine coexistence architecture across study and deck
</commit_message>
<xml_diff>
--- a/Studies/The-Ontology-of-Coexistence/The-Ontology-of-Existence-Madhyasth-Darshan.pptx
+++ b/Studies/The-Ontology-of-Coexistence/The-Ontology-of-Existence-Madhyasth-Darshan.pptx
@@ -2,38 +2,38 @@
 <file path=ppt/presentation.xml><?xml version="1.0" encoding="utf-8"?>
 <p:presentation xmlns:p="http://schemas.openxmlformats.org/presentationml/2006/main">
   <p:sldMasterIdLst>
-    <p:sldMasterId xmlns:r="http://schemas.openxmlformats.org/officeDocument/2006/relationships" id="2147483648" r:id="R2a0ef68f0f0541a7"/>
+    <p:sldMasterId xmlns:r="http://schemas.openxmlformats.org/officeDocument/2006/relationships" id="2147483648" r:id="R6055c6fd07ce4201"/>
   </p:sldMasterIdLst>
   <p:notesMasterIdLst>
-    <p:notesMasterId xmlns:r="http://schemas.openxmlformats.org/officeDocument/2006/relationships" r:id="R74a6bbf5abf64823"/>
+    <p:notesMasterId xmlns:r="http://schemas.openxmlformats.org/officeDocument/2006/relationships" r:id="Rf8d867df9cf24b24"/>
   </p:notesMasterIdLst>
   <p:sldIdLst>
-    <p:sldId xmlns:r="http://schemas.openxmlformats.org/officeDocument/2006/relationships" id="256" r:id="R9c533cfa73c04dd2"/>
-    <p:sldId xmlns:r="http://schemas.openxmlformats.org/officeDocument/2006/relationships" id="257" r:id="Rb2a2087c9bb44616"/>
-    <p:sldId xmlns:r="http://schemas.openxmlformats.org/officeDocument/2006/relationships" id="258" r:id="R8fd0fda216454365"/>
-    <p:sldId xmlns:r="http://schemas.openxmlformats.org/officeDocument/2006/relationships" id="259" r:id="Rb780e261156446ad"/>
-    <p:sldId xmlns:r="http://schemas.openxmlformats.org/officeDocument/2006/relationships" id="260" r:id="Rb951d57b77164375"/>
-    <p:sldId xmlns:r="http://schemas.openxmlformats.org/officeDocument/2006/relationships" id="261" r:id="R58eaf07ae1aa4e9c"/>
-    <p:sldId xmlns:r="http://schemas.openxmlformats.org/officeDocument/2006/relationships" id="262" r:id="R143d7333070d41fb"/>
-    <p:sldId xmlns:r="http://schemas.openxmlformats.org/officeDocument/2006/relationships" id="263" r:id="R70dcf6cad9fa478f"/>
-    <p:sldId xmlns:r="http://schemas.openxmlformats.org/officeDocument/2006/relationships" id="264" r:id="R9e18e1c55c1f435b"/>
-    <p:sldId xmlns:r="http://schemas.openxmlformats.org/officeDocument/2006/relationships" id="265" r:id="R927238c614014eaa"/>
-    <p:sldId xmlns:r="http://schemas.openxmlformats.org/officeDocument/2006/relationships" id="266" r:id="R7ed81ea42cd846d3"/>
-    <p:sldId xmlns:r="http://schemas.openxmlformats.org/officeDocument/2006/relationships" id="267" r:id="Rdf612538c1bf4edc"/>
-    <p:sldId xmlns:r="http://schemas.openxmlformats.org/officeDocument/2006/relationships" id="268" r:id="Rf9a679d87ca74255"/>
-    <p:sldId xmlns:r="http://schemas.openxmlformats.org/officeDocument/2006/relationships" id="269" r:id="R7312656ed1d34a2b"/>
-    <p:sldId xmlns:r="http://schemas.openxmlformats.org/officeDocument/2006/relationships" id="270" r:id="Rd3053a1830a648bd"/>
-    <p:sldId xmlns:r="http://schemas.openxmlformats.org/officeDocument/2006/relationships" id="271" r:id="Rd4e990cca9494eac"/>
-    <p:sldId xmlns:r="http://schemas.openxmlformats.org/officeDocument/2006/relationships" id="272" r:id="Rdbfc2da6e5af4763"/>
-    <p:sldId xmlns:r="http://schemas.openxmlformats.org/officeDocument/2006/relationships" id="273" r:id="R64047738b35b41ac"/>
-    <p:sldId xmlns:r="http://schemas.openxmlformats.org/officeDocument/2006/relationships" id="274" r:id="Rc33c8ed9d36f454f"/>
-    <p:sldId xmlns:r="http://schemas.openxmlformats.org/officeDocument/2006/relationships" id="275" r:id="Ra9c1b438caf64dc1"/>
-    <p:sldId xmlns:r="http://schemas.openxmlformats.org/officeDocument/2006/relationships" id="276" r:id="R762bffa5b6124c26"/>
-    <p:sldId xmlns:r="http://schemas.openxmlformats.org/officeDocument/2006/relationships" id="277" r:id="Rf2c6b44dc3d84c32"/>
-    <p:sldId xmlns:r="http://schemas.openxmlformats.org/officeDocument/2006/relationships" id="278" r:id="Rb644de25fdce4412"/>
-    <p:sldId xmlns:r="http://schemas.openxmlformats.org/officeDocument/2006/relationships" id="279" r:id="Rd236f8c378754511"/>
-    <p:sldId xmlns:r="http://schemas.openxmlformats.org/officeDocument/2006/relationships" id="280" r:id="R701d17ade7124769"/>
-    <p:sldId xmlns:r="http://schemas.openxmlformats.org/officeDocument/2006/relationships" id="281" r:id="R1b0e0d3fd3d144fb"/>
+    <p:sldId xmlns:r="http://schemas.openxmlformats.org/officeDocument/2006/relationships" id="256" r:id="Rf62651482fd64891"/>
+    <p:sldId xmlns:r="http://schemas.openxmlformats.org/officeDocument/2006/relationships" id="257" r:id="R316883c49d8b4fdc"/>
+    <p:sldId xmlns:r="http://schemas.openxmlformats.org/officeDocument/2006/relationships" id="258" r:id="R5fbeae8ec6824505"/>
+    <p:sldId xmlns:r="http://schemas.openxmlformats.org/officeDocument/2006/relationships" id="259" r:id="Rf441cd0d05c74aa6"/>
+    <p:sldId xmlns:r="http://schemas.openxmlformats.org/officeDocument/2006/relationships" id="260" r:id="R1d66dbfa2b234950"/>
+    <p:sldId xmlns:r="http://schemas.openxmlformats.org/officeDocument/2006/relationships" id="261" r:id="R81e34653592e49ba"/>
+    <p:sldId xmlns:r="http://schemas.openxmlformats.org/officeDocument/2006/relationships" id="262" r:id="R6e786645449842b5"/>
+    <p:sldId xmlns:r="http://schemas.openxmlformats.org/officeDocument/2006/relationships" id="263" r:id="R8707da54cd414837"/>
+    <p:sldId xmlns:r="http://schemas.openxmlformats.org/officeDocument/2006/relationships" id="264" r:id="R039492544497463a"/>
+    <p:sldId xmlns:r="http://schemas.openxmlformats.org/officeDocument/2006/relationships" id="265" r:id="R2afd297358264062"/>
+    <p:sldId xmlns:r="http://schemas.openxmlformats.org/officeDocument/2006/relationships" id="266" r:id="Rbcbe54a1f28048e5"/>
+    <p:sldId xmlns:r="http://schemas.openxmlformats.org/officeDocument/2006/relationships" id="267" r:id="R9f458f915492474b"/>
+    <p:sldId xmlns:r="http://schemas.openxmlformats.org/officeDocument/2006/relationships" id="268" r:id="R6fddbb211d6648aa"/>
+    <p:sldId xmlns:r="http://schemas.openxmlformats.org/officeDocument/2006/relationships" id="269" r:id="R6b223340a783449f"/>
+    <p:sldId xmlns:r="http://schemas.openxmlformats.org/officeDocument/2006/relationships" id="270" r:id="Rfcd7ef0cec004985"/>
+    <p:sldId xmlns:r="http://schemas.openxmlformats.org/officeDocument/2006/relationships" id="271" r:id="Rf4ee074f5688498d"/>
+    <p:sldId xmlns:r="http://schemas.openxmlformats.org/officeDocument/2006/relationships" id="272" r:id="Rdd7049f1fd6b4a31"/>
+    <p:sldId xmlns:r="http://schemas.openxmlformats.org/officeDocument/2006/relationships" id="273" r:id="R8702ce0324a04c86"/>
+    <p:sldId xmlns:r="http://schemas.openxmlformats.org/officeDocument/2006/relationships" id="274" r:id="R57ba474117454c34"/>
+    <p:sldId xmlns:r="http://schemas.openxmlformats.org/officeDocument/2006/relationships" id="275" r:id="Re6ed68ad8bf84ca2"/>
+    <p:sldId xmlns:r="http://schemas.openxmlformats.org/officeDocument/2006/relationships" id="276" r:id="Rb41d28aa159a4776"/>
+    <p:sldId xmlns:r="http://schemas.openxmlformats.org/officeDocument/2006/relationships" id="277" r:id="Re50e980df4794685"/>
+    <p:sldId xmlns:r="http://schemas.openxmlformats.org/officeDocument/2006/relationships" id="278" r:id="R2e1414a4e2c24104"/>
+    <p:sldId xmlns:r="http://schemas.openxmlformats.org/officeDocument/2006/relationships" id="279" r:id="R9a0d295377ec45d3"/>
+    <p:sldId xmlns:r="http://schemas.openxmlformats.org/officeDocument/2006/relationships" id="280" r:id="R1fef91ff18154784"/>
+    <p:sldId xmlns:r="http://schemas.openxmlformats.org/officeDocument/2006/relationships" id="281" r:id="R85af59f95ed9426e"/>
   </p:sldIdLst>
   <p:sldSz cx="9144000" cy="5143500"/>
   <p:notesSz cx="6858000" cy="9144000"/>
@@ -2576,7 +2576,7 @@
   </p:cSld>
   <p:clrMap bg1="lt1" tx1="dk1" bg2="dk2" tx2="lt2" accent1="accent1" accent2="accent2" accent3="accent3" accent4="accent4" accent5="accent5" accent6="accent6" hlink="hlink" folHlink="folHlink"/>
   <p:sldLayoutIdLst>
-    <p:sldLayoutId xmlns:r="http://schemas.openxmlformats.org/officeDocument/2006/relationships" id="2147483649" r:id="R2f864dbeaed44cb9"/>
+    <p:sldLayoutId xmlns:r="http://schemas.openxmlformats.org/officeDocument/2006/relationships" id="2147483649" r:id="R930dbeaa02974b77"/>
   </p:sldLayoutIdLst>
   <p:hf sldNum="0" hdr="0" ftr="0" dt="0"/>
   <p:txStyles>
@@ -22302,7 +22302,7 @@
       </p:sp>
       <p:cxnSp>
         <p:nvCxnSpPr>
-          <p:cNvPr id="751" name="Google Shape;445;p18"/>
+          <p:cNvPr id="825" name="Google Shape;445;p18"/>
           <p:cNvCxnSpPr/>
           <p:nvPr/>
         </p:nvCxnSpPr>
@@ -22383,7 +22383,7 @@
       </p:sp>
       <p:cxnSp>
         <p:nvCxnSpPr>
-          <p:cNvPr id="753" name="Google Shape;447;p18"/>
+          <p:cNvPr id="827" name="Google Shape;447;p18"/>
           <p:cNvCxnSpPr/>
           <p:nvPr/>
         </p:nvCxnSpPr>
@@ -29120,7 +29120,7 @@
           <p:nvPr/>
         </p:nvPicPr>
         <p:blipFill rotWithShape="1">
-          <a:blip xmlns:r="http://schemas.openxmlformats.org/officeDocument/2006/relationships" xmlns:a="http://schemas.openxmlformats.org/drawingml/2006/main" r:embed="R0b3a6baffb9b49e0">
+          <a:blip xmlns:r="http://schemas.openxmlformats.org/officeDocument/2006/relationships" xmlns:a="http://schemas.openxmlformats.org/drawingml/2006/main" r:embed="R0664648e943b4a52">
             <a:alphaModFix/>
           </a:blip>
           <a:srcRect xmlns:a="http://schemas.openxmlformats.org/drawingml/2006/main" l="0" t="0" r="0" b="0"/>
@@ -29262,7 +29262,7 @@
           <p:nvPr/>
         </p:nvPicPr>
         <p:blipFill rotWithShape="1">
-          <a:blip xmlns:r="http://schemas.openxmlformats.org/officeDocument/2006/relationships" xmlns:a="http://schemas.openxmlformats.org/drawingml/2006/main" r:embed="R0b3a6baffb9b49e0">
+          <a:blip xmlns:r="http://schemas.openxmlformats.org/officeDocument/2006/relationships" xmlns:a="http://schemas.openxmlformats.org/drawingml/2006/main" r:embed="R0664648e943b4a52">
             <a:alphaModFix/>
           </a:blip>
           <a:srcRect xmlns:a="http://schemas.openxmlformats.org/drawingml/2006/main" l="0" t="0" r="0" b="0"/>
@@ -29404,7 +29404,7 @@
           <p:nvPr/>
         </p:nvPicPr>
         <p:blipFill rotWithShape="1">
-          <a:blip xmlns:r="http://schemas.openxmlformats.org/officeDocument/2006/relationships" xmlns:a="http://schemas.openxmlformats.org/drawingml/2006/main" r:embed="R0b3a6baffb9b49e0">
+          <a:blip xmlns:r="http://schemas.openxmlformats.org/officeDocument/2006/relationships" xmlns:a="http://schemas.openxmlformats.org/drawingml/2006/main" r:embed="R0664648e943b4a52">
             <a:alphaModFix/>
           </a:blip>
           <a:srcRect xmlns:a="http://schemas.openxmlformats.org/drawingml/2006/main" l="0" t="0" r="0" b="0"/>
@@ -29546,7 +29546,7 @@
           <p:nvPr/>
         </p:nvPicPr>
         <p:blipFill rotWithShape="1">
-          <a:blip xmlns:r="http://schemas.openxmlformats.org/officeDocument/2006/relationships" xmlns:a="http://schemas.openxmlformats.org/drawingml/2006/main" r:embed="R0b3a6baffb9b49e0">
+          <a:blip xmlns:r="http://schemas.openxmlformats.org/officeDocument/2006/relationships" xmlns:a="http://schemas.openxmlformats.org/drawingml/2006/main" r:embed="R0664648e943b4a52">
             <a:alphaModFix/>
           </a:blip>
           <a:srcRect xmlns:a="http://schemas.openxmlformats.org/drawingml/2006/main" l="0" t="0" r="0" b="0"/>
@@ -29688,7 +29688,7 @@
           <p:nvPr/>
         </p:nvPicPr>
         <p:blipFill rotWithShape="1">
-          <a:blip xmlns:r="http://schemas.openxmlformats.org/officeDocument/2006/relationships" xmlns:a="http://schemas.openxmlformats.org/drawingml/2006/main" r:embed="R0b3a6baffb9b49e0">
+          <a:blip xmlns:r="http://schemas.openxmlformats.org/officeDocument/2006/relationships" xmlns:a="http://schemas.openxmlformats.org/drawingml/2006/main" r:embed="R0664648e943b4a52">
             <a:alphaModFix/>
           </a:blip>
           <a:srcRect xmlns:a="http://schemas.openxmlformats.org/drawingml/2006/main" l="0" t="0" r="0" b="0"/>
@@ -29830,7 +29830,7 @@
           <p:nvPr/>
         </p:nvPicPr>
         <p:blipFill rotWithShape="1">
-          <a:blip xmlns:r="http://schemas.openxmlformats.org/officeDocument/2006/relationships" xmlns:a="http://schemas.openxmlformats.org/drawingml/2006/main" r:embed="R0b3a6baffb9b49e0">
+          <a:blip xmlns:r="http://schemas.openxmlformats.org/officeDocument/2006/relationships" xmlns:a="http://schemas.openxmlformats.org/drawingml/2006/main" r:embed="R0664648e943b4a52">
             <a:alphaModFix/>
           </a:blip>
           <a:srcRect xmlns:a="http://schemas.openxmlformats.org/drawingml/2006/main" l="0" t="0" r="0" b="0"/>
@@ -30381,7 +30381,7 @@
           <p:nvPr/>
         </p:nvPicPr>
         <p:blipFill>
-          <a:blip xmlns:r="http://schemas.openxmlformats.org/officeDocument/2006/relationships" xmlns:a="http://schemas.openxmlformats.org/drawingml/2006/main" r:embed="Raf2dd1461d934041"/>
+          <a:blip xmlns:r="http://schemas.openxmlformats.org/officeDocument/2006/relationships" xmlns:a="http://schemas.openxmlformats.org/drawingml/2006/main" r:embed="R3b6e4667f9df4a21"/>
           <a:stretch xmlns:a="http://schemas.openxmlformats.org/drawingml/2006/main"/>
         </p:blipFill>
         <p:spPr>
@@ -32296,7 +32296,7 @@
           <p:nvPr/>
         </p:nvPicPr>
         <p:blipFill rotWithShape="1">
-          <a:blip xmlns:r="http://schemas.openxmlformats.org/officeDocument/2006/relationships" xmlns:a="http://schemas.openxmlformats.org/drawingml/2006/main" r:embed="Rac6eb5231a8d4969">
+          <a:blip xmlns:r="http://schemas.openxmlformats.org/officeDocument/2006/relationships" xmlns:a="http://schemas.openxmlformats.org/drawingml/2006/main" r:embed="R978d0a1f843049c3">
             <a:alphaModFix/>
           </a:blip>
           <a:srcRect xmlns:a="http://schemas.openxmlformats.org/drawingml/2006/main" l="0" t="0" r="0" b="0"/>
@@ -32539,7 +32539,7 @@
           <p:nvPr/>
         </p:nvPicPr>
         <p:blipFill rotWithShape="1">
-          <a:blip xmlns:r="http://schemas.openxmlformats.org/officeDocument/2006/relationships" xmlns:a="http://schemas.openxmlformats.org/drawingml/2006/main" r:embed="Re81859561c924876">
+          <a:blip xmlns:r="http://schemas.openxmlformats.org/officeDocument/2006/relationships" xmlns:a="http://schemas.openxmlformats.org/drawingml/2006/main" r:embed="R265feef7dd2849ea">
             <a:alphaModFix/>
           </a:blip>
           <a:srcRect xmlns:a="http://schemas.openxmlformats.org/drawingml/2006/main" l="0" t="0" r="0" b="0"/>
@@ -32782,7 +32782,7 @@
           <p:nvPr/>
         </p:nvPicPr>
         <p:blipFill rotWithShape="1">
-          <a:blip xmlns:r="http://schemas.openxmlformats.org/officeDocument/2006/relationships" xmlns:a="http://schemas.openxmlformats.org/drawingml/2006/main" r:embed="Re872714097a14f61">
+          <a:blip xmlns:r="http://schemas.openxmlformats.org/officeDocument/2006/relationships" xmlns:a="http://schemas.openxmlformats.org/drawingml/2006/main" r:embed="Rdb12d5633aaf4e80">
             <a:alphaModFix/>
           </a:blip>
           <a:srcRect xmlns:a="http://schemas.openxmlformats.org/drawingml/2006/main" l="0" t="0" r="0" b="0"/>

</xml_diff>

<commit_message>
Sync Ontology presenter's companion to the 26-slide deck with read-aloud notes.
Add reusable companion build/sync scripts and an update-presenters-companion skill so delivery scripts stay aligned with the teaching deck.

Co-authored-by: Cursor <cursoragent@cursor.com>
</commit_message>
<xml_diff>
--- a/Studies/The-Ontology-of-Coexistence/The-Ontology-of-Existence-Madhyasth-Darshan.pptx
+++ b/Studies/The-Ontology-of-Coexistence/The-Ontology-of-Existence-Madhyasth-Darshan.pptx
@@ -594,7 +594,27 @@
               <a:buNone/>
             </a:pPr>
             <a:r>
-              <a:t>Welcome. This deck presents the ontology of existence as stated in Madhyasth Darshan, following Section 1 of the study The Ontology of Coexistence. The study is written from a scientist-technologist standpoint, but the darshan is stated on its own terms first. Core claim to land up front: existence is not matter alone, and not one undifferentiated absolute - it is the ever-present togetherness of Omnipotence and countless real units of nature, each saturated in that ground. Everything else in the deck unfolds from this one picture.</a:t>
+              <a:t>Welcome, and thank you for joining this session.</a:t>
+            </a:r>
+          </a:p>
+          <a:p xmlns:a="http://schemas.openxmlformats.org/drawingml/2006/main">
+            <a:r>
+              <a:t>Today we will study the ontology of existence as stated in Madhyasth Darshan, also called Co-existentialism, propounded by Shri A. Nagraj. The name itself carries a thesis: madhyasth means mediative. The darshan holds that reality is regulated and conserved through an inherent, mediative orderliness, not by an external governor.</a:t>
+            </a:r>
+          </a:p>
+          <a:p xmlns:a="http://schemas.openxmlformats.org/drawingml/2006/main">
+            <a:r>
+              <a:t>This presentation follows Section 1 of the study The Ontology of Coexistence. It states the darshan’s ontology on its own terms, grounded in the primary texts — Madhyasth Darshan, Manav Karm Darshan, Samadhanatmak Bhautikvad, and Jeevan Vidya.</a:t>
+            </a:r>
+          </a:p>
+          <a:p xmlns:a="http://schemas.openxmlformats.org/drawingml/2006/main">
+            <a:r>
+              <a:t>Here is the core claim I want you to hold for the whole session: existence is coexistence. It is the ever-present togetherness of a formless, all-pervasive ground — satta — and countless real, bounded units of nature, each saturated in that ground. You will see the slides use the translation’s word Omnipotence for that ground; in spoken explanation I will often say Omnipresence. Both names point to the same reality.</a:t>
+            </a:r>
+          </a:p>
+          <a:p xmlns:a="http://schemas.openxmlformats.org/drawingml/2006/main">
+            <a:r>
+              <a:t>Everything that follows — sentience, values, justice, and humane society — unfolds from this one picture. The study is written from a scientist-technologist standpoint. Our aim is rigorous understanding: testing definitions and internal consistency — not persuasion, and not devotion.</a:t>
             </a:r>
           </a:p>
         </p:txBody>
@@ -673,7 +693,27 @@
               <a:buNone/>
             </a:pPr>
             <a:r>
-              <a:t>The completeness drive is built into the design of existence, not an ethic bolted onto matter. Every activity is one inseparable triad - effort, motion, result are three joint aspects, not three sequential steps. Example from SB: sodium and chlorine ions approaching is effort and motion together; the stable salt crystal is the result. Read SB p. 62's compressed chain aloud if time allows - saturation itself is forcefulness, forcefulness is basic impulsion, impulsion is activity, activity is effort-motion-result, and that is development. Each triad term has a teleological goal (restfulness, destination, immortality), and the two atomic paths on the right set up the next slide: the insentient path completes result at T1; the sentient path continues to T2 and T3. NEW: state the drive's span with SB p. 51 - nature is oriented for development and awakening UNTIL realisation in Omnipotence; SB p. 91 calls this bound an existential truth. Role differentiation: development pervades all of nature, awakening occurs in the sentient - insentient units participate by composing bodies and environments without individually completing the drive.</a:t>
+              <a:t>Madhyasth Darshan distinguishes two developments that must not be collapsed.</a:t>
+            </a:r>
+          </a:p>
+          <a:p xmlns:a="http://schemas.openxmlformats.org/drawingml/2006/main">
+            <a:r>
+              <a:t>Compositional progression joins particles, atoms, molecules, cells, and bodies into larger configurations. Development in an atom can reach constitutional completeness as jeevan. These lines meet in living joint forms, but they remain distinct.</a:t>
+            </a:r>
+          </a:p>
+          <a:p xmlns:a="http://schemas.openxmlformats.org/drawingml/2006/main">
+            <a:r>
+              <a:t>Across both, activity is one inseparable triad: effort, motion, and result. These are three joint aspects of one activity, not three steps in a sequence. When sodium and chlorine approach one another, the approach is effort and motion together; the stable salt crystal is the result.</a:t>
+            </a:r>
+          </a:p>
+          <a:p xmlns:a="http://schemas.openxmlformats.org/drawingml/2006/main">
+            <a:r>
+              <a:t>The texts compress the engine of development this way: saturation itself is forcefulness; forcefulness is basic impulsion; impulsion is activity; activity is effort-motion-result; and that is development and its continuity.</a:t>
+            </a:r>
+          </a:p>
+          <a:p xmlns:a="http://schemas.openxmlformats.org/drawingml/2006/main">
+            <a:r>
+              <a:t>Each term has a goal: restfulness of effort, destination of motion, immortality of result. Nature saturated in the ground is oriented for development and awakening until realisation. That bound is called an existential truth. Development pervades nature; awakening occurs in the sentient. Insentient units participate by composing bodies and environments without each individually completing the drive.</a:t>
             </a:r>
           </a:p>
         </p:txBody>
@@ -752,7 +792,32 @@
               <a:buNone/>
             </a:pPr>
             <a:r>
-              <a:t>The three transitions are developmental milestones mapped to plane shifts. T1: constitutional completeness - immortality of result - sentient jeevan appears; physicochemical to delusional. T2: activity completeness - restfulness of effort - internal cognitive seeking resolves into direct realisation and absolute resolution; delusional to deific. T3: conduct completeness - destination of motion - authentic conduct with living proof; deific to divine. Two cautions from the study: 'delusional' names a developmental stage, not psychiatric illness; and T2's vishram (settlement of internal effort) must not be conflated with the insentient natural-state ease from the unit slide, nor T3 collapsed into T2 - one is internal settlement, the other external destination. NEW: T3 Hindi term corrected to acharanpurnata (both MVD and SB use aacharan purnata; vyavahar purnata appears in neither). Close with the drive statement: the saturated realising the ground it is saturated in - that is the completeness drive.</a:t>
+              <a:t>The three transitions are developmental milestones.</a:t>
+            </a:r>
+          </a:p>
+          <a:p xmlns:a="http://schemas.openxmlformats.org/drawingml/2006/main">
+            <a:r>
+              <a:t>T1 is constitutional completeness — gathanpurnata: immortality of result. A developing atom becomes sentient jeevan. The plane shifts from physicochemical to delusional — meaning the body is mistaken for the self, not psychiatric illness.</a:t>
+            </a:r>
+          </a:p>
+          <a:p xmlns:a="http://schemas.openxmlformats.org/drawingml/2006/main">
+            <a:r>
+              <a:t>T2 is activity completeness — kriyapurnata: restfulness of effort. Internal seeking resolves into direct realisation and absolute resolution. The plane shifts from delusional to deific.</a:t>
+            </a:r>
+          </a:p>
+          <a:p xmlns:a="http://schemas.openxmlformats.org/drawingml/2006/main">
+            <a:r>
+              <a:t>T3 is conduct completeness — acharanpurnata: destination of motion. Authentic conduct becomes living proof. The plane shifts from deific to divine.</a:t>
+            </a:r>
+          </a:p>
+          <a:p xmlns:a="http://schemas.openxmlformats.org/drawingml/2006/main">
+            <a:r>
+              <a:t>Keep T2 and T3 apart. T2 is internal settlement of effort. T3 is external destination in conduct. And do not confuse T2’s restfulness with the ease of insentient natural-state complementarity.</a:t>
+            </a:r>
+          </a:p>
+          <a:p xmlns:a="http://schemas.openxmlformats.org/drawingml/2006/main">
+            <a:r>
+              <a:t>T1 is constitutional completeness of an atom. T2 and T3 are not further material stages; they name completeness of activity and conduct in awakened jeevan. In one line: the saturated realises the ground it is saturated in. That is the completeness drive.</a:t>
             </a:r>
           </a:p>
         </p:txBody>
@@ -831,7 +896,32 @@
               <a:buNone/>
             </a:pPr>
             <a:r>
-              <a:t>The four orders are stable modes of participation. Jeevan is present in animal and human joint forms. In animals, species-specific bodily and brain development limits which of jeevan's activities can be expressed through the body. In humans, the bodily medium supports the full range; the distinct problem is delusion and body-identification, which misdirect evaluation. Do not collapse either condition into material emergence of sentience.</a:t>
+              <a:t>This slide is a confusion-preventer. Madhyasth Darshan uses several classifications that overlap without being interchangeable. Each answers a different question.</a:t>
+            </a:r>
+          </a:p>
+          <a:p xmlns:a="http://schemas.openxmlformats.org/drawingml/2006/main">
+            <a:r>
+              <a:t>Orders — material, bio, animal, knowledge — classify organisation, svabhav, and dharma. Do not confuse orders with planes.</a:t>
+            </a:r>
+          </a:p>
+          <a:p xmlns:a="http://schemas.openxmlformats.org/drawingml/2006/main">
+            <a:r>
+              <a:t>Progressions — physicochemical, delusional, deific, divine — track status across T1, T2, and T3. Do not confuse them with orders or planes.</a:t>
+            </a:r>
+          </a:p>
+          <a:p xmlns:a="http://schemas.openxmlformats.org/drawingml/2006/main">
+            <a:r>
+              <a:t>Planes name scope of knowing and experience. They are not simply material stages.</a:t>
+            </a:r>
+          </a:p>
+          <a:p xmlns:a="http://schemas.openxmlformats.org/drawingml/2006/main">
+            <a:r>
+              <a:t>Human types — animal, demon, human, divine, transcendental — mark orientation of human living. Do not confuse them with value families.</a:t>
+            </a:r>
+          </a:p>
+          <a:p xmlns:a="http://schemas.openxmlformats.org/drawingml/2006/main">
+            <a:r>
+              <a:t>T1 separates the physicochemical from the sentient. T2 and T3 concern awakening and conduct. So if someone asks whether the human order is the same as the divine plane, the answer is no. One human order can span multiple planes.</a:t>
             </a:r>
           </a:p>
         </p:txBody>
@@ -910,7 +1000,32 @@
               <a:buNone/>
             </a:pPr>
             <a:r>
-              <a:t>T1 is the sentience threshold, and it is constitutional rather than neural, molecular, or a position higher on the order chain. The texts describe particle incorporation through hungry and overfull complementarity in a conducive environment; when the required constitution closes, particle count no longer increases or decreases. MVD describes a shift from molecular- and weight-bondage to hope-bondage. The point to retain is textual: the constitutionally complete atom is jeevan, has a finer mode of recognition, and does not decompose with the body.</a:t>
+              <a:t>T1 is the hinge of the ontology: where sentience enters.</a:t>
+            </a:r>
+          </a:p>
+          <a:p xmlns:a="http://schemas.openxmlformats.org/drawingml/2006/main">
+            <a:r>
+              <a:t>It is constitutional completeness at the atomic level — not neural complexity, not molecular size, and not mere elevation along the order chain.</a:t>
+            </a:r>
+          </a:p>
+          <a:p xmlns:a="http://schemas.openxmlformats.org/drawingml/2006/main">
+            <a:r>
+              <a:t>The texts describe a constitution-oriented developing atom that takes in particles — hungry and overfull atoms completing each other — within a suitable environment. When the required constitution closes, the particle count no longer increases or decreases.</a:t>
+            </a:r>
+          </a:p>
+          <a:p xmlns:a="http://schemas.openxmlformats.org/drawingml/2006/main">
+            <a:r>
+              <a:t>Before T1, the evolving atom is still bound by molecular weight and structure; particle count is still changing; it exhibits radiance and projection as an insentient unit. After T1, it is released from molecular and weight bondage and carried by hope. Sentient jeevan shows a finer mode of recognition.</a:t>
+            </a:r>
+          </a:p>
+          <a:p xmlns:a="http://schemas.openxmlformats.org/drawingml/2006/main">
+            <a:r>
+              <a:t>T1 is irreversible because the completed constitution no longer decomposes. That completed constitution grounds jeevan’s continuity beyond the body.</a:t>
+            </a:r>
+          </a:p>
+          <a:p xmlns:a="http://schemas.openxmlformats.org/drawingml/2006/main">
+            <a:r>
+              <a:t>I want to be plain: this is an ontological account. No accepted empirical procedure currently identifies the threshold. We will return to that honesty when we discuss method and evidence.</a:t>
             </a:r>
           </a:p>
         </p:txBody>
@@ -989,7 +1104,22 @@
               <a:buNone/>
             </a:pPr>
             <a:r>
-              <a:t>The body is a pranic composition and the expression medium; jeevan is the constitutionally complete sentient atom and bearer of all five faculties and ten activities. Animal bodily and brain development constrains expression. The human bodily medium can support the full range, while delusion can still make jeevan identify as the body. The body does not produce sentience, and bodily limitation is not the same as human mis-evaluation.</a:t>
+              <a:t>Animal and human living is a joint form.</a:t>
+            </a:r>
+          </a:p>
+          <a:p xmlns:a="http://schemas.openxmlformats.org/drawingml/2006/main">
+            <a:r>
+              <a:t>Jeevan brings all ten activities. The body supplies the species-specific medium. Animal bodily and brain development limits their expression. The human medium supports the full range, while body-identification can still misdirect evaluation.</a:t>
+            </a:r>
+          </a:p>
+          <a:p xmlns:a="http://schemas.openxmlformats.org/drawingml/2006/main">
+            <a:r>
+              <a:t>On one side is the body: a pranic composition — sense organs, brain, and physical expression; decomposable. On the other side is jeevan: the constitutionally complete sentient atom; five faculties and ten activities inherent; continuing when the joint form ends.</a:t>
+            </a:r>
+          </a:p>
+          <a:p xmlns:a="http://schemas.openxmlformats.org/drawingml/2006/main">
+            <a:r>
+              <a:t>The body gates expression. Jeevan is seer, doer, and enjoyer through the body. Animal limitation belongs to the medium. Human mis-evaluation belongs to body-delusion. The body does not produce sentience, and those two problems are not the same problem.</a:t>
             </a:r>
           </a:p>
         </p:txBody>
@@ -1068,7 +1198,27 @@
               <a:buNone/>
             </a:pPr>
             <a:r>
-              <a:t>All five faculties and all ten activities belong to jeevan. Their presence must be distinguished from their expression and effective organisation. Animal bodies limit expression through the bodily and neural medium. Humans possess the bodily medium for the full range, but body-delusion leaves only four and a half effectively organised before awakening. Study provides understanding; practice tests, evidences, and stabilises that understanding. Practice does not manufacture dormant or missing faculties.</a:t>
+              <a:t>Jeevan is a constitutionally complete sentient atom.</a:t>
+            </a:r>
+          </a:p>
+          <a:p xmlns:a="http://schemas.openxmlformats.org/drawingml/2006/main">
+            <a:r>
+              <a:t>Structurally, the nucleus is atma, the core self. The rings around it are buddhi, chitta, vritti, and mun — resolve, desire, thought, and hope.</a:t>
+            </a:r>
+          </a:p>
+          <a:p xmlns:a="http://schemas.openxmlformats.org/drawingml/2006/main">
+            <a:r>
+              <a:t>Each faculty works outward in projection and inward in reflection. Hope selects outward and tastes inward. Thought analyses and deliberates. Desire visualises and contemplates. Resolve resolves and receives enlightenment. The core self authenticates and realises.</a:t>
+            </a:r>
+          </a:p>
+          <a:p xmlns:a="http://schemas.openxmlformats.org/drawingml/2006/main">
+            <a:r>
+              <a:t>All five faculties and all ten activities belong to jeevan. Presence must be distinguished from expression and from effective organisation. Animal bodies limit expression through the medium. Humans have the bodily medium for the full range, yet under body-delusion only four and a half activities may be effectively organised.</a:t>
+            </a:r>
+          </a:p>
+          <a:p xmlns:a="http://schemas.openxmlformats.org/drawingml/2006/main">
+            <a:r>
+              <a:t>Study brings understanding. Practice evidences and stabilises it. Practice does not manufacture faculties that were missing.</a:t>
             </a:r>
           </a:p>
         </p:txBody>
@@ -1136,7 +1286,31 @@
         <p:txBody>
           <a:bodyPr xmlns:a="http://schemas.openxmlformats.org/drawingml/2006/main"/>
           <a:lstStyle xmlns:a="http://schemas.openxmlformats.org/drawingml/2006/main"/>
-          <a:p xmlns:a="http://schemas.openxmlformats.org/drawingml/2006/main"/>
+          <a:p xmlns:a="http://schemas.openxmlformats.org/drawingml/2006/main">
+            <a:r>
+              <a:t>From Manav Karm Darshan, Chapter 1: the structure of karma.</a:t>
+            </a:r>
+          </a:p>
+          <a:p xmlns:a="http://schemas.openxmlformats.org/drawingml/2006/main">
+            <a:r>
+              <a:t>Every karma — every activity done with desire — carries five limbs: doer, cause, objective, result, and effect. Effect names the act’s reach or consequence. The text does not add a separate cosmic reward-and-punishment ledger on this slide.</a:t>
+            </a:r>
+          </a:p>
+          <a:p xmlns:a="http://schemas.openxmlformats.org/drawingml/2006/main">
+            <a:r>
+              <a:t>Desire is the aspiration. Karma is the doing — activity together with aspiration. Result is the fruit. Desire, karma, and result must balance for the desire to be truly accomplished.</a:t>
+            </a:r>
+          </a:p>
+          <a:p xmlns:a="http://schemas.openxmlformats.org/drawingml/2006/main">
+            <a:r>
+              <a:t>Understanding alone changes nothing. It is the doing that yields the fruit. Book knowledge is only half the work.</a:t>
+            </a:r>
+          </a:p>
+          <a:p xmlns:a="http://schemas.openxmlformats.org/drawingml/2006/main">
+            <a:r>
+              <a:t>Hold this beside the earlier triad of effort, motion, and result. Karma is the desire-laden framing of activity in sentient living. Later we will see how desire and doing are reorganised under justice, dharma, and truth.</a:t>
+            </a:r>
+          </a:p>
         </p:txBody>
       </p:sp>
       <p:sp>
@@ -1202,7 +1376,26 @@
         <p:txBody>
           <a:bodyPr xmlns:a="http://schemas.openxmlformats.org/drawingml/2006/main"/>
           <a:lstStyle xmlns:a="http://schemas.openxmlformats.org/drawingml/2006/main"/>
-          <a:p xmlns:a="http://schemas.openxmlformats.org/drawingml/2006/main"/>
+          <a:p xmlns:a="http://schemas.openxmlformats.org/drawingml/2006/main">
+            <a:r>
+              <a:t>Happiness, peace, contentment, and bliss are not passing moods, and they are not a fourth sequence after T1, T2, and T3.</a:t>
+            </a:r>
+          </a:p>
+          <a:p xmlns:a="http://schemas.openxmlformats.org/drawingml/2006/main">
+            <a:r>
+              <a:t>They name harmonies within jeevan. Happiness is harmony of mun and vritti — hope and thought. Peace is harmony of vritti and chitta — thought and desire. Contentment is harmony of chitta and buddhi — desire and resolve. Bliss is harmony of buddhi and atma — resolve and the core self.</a:t>
+            </a:r>
+          </a:p>
+          <a:p xmlns:a="http://schemas.openxmlformats.org/drawingml/2006/main">
+            <a:r>
+              <a:t>Evidenced outwardly, these harmonies support resolution, prosperity, fearlessness, and coexistence in human living.</a:t>
+            </a:r>
+          </a:p>
+          <a:p xmlns:a="http://schemas.openxmlformats.org/drawingml/2006/main">
+            <a:r>
+              <a:t>Karm Darshan puts the living cycle this way: reflection feeds projection, and projection feeds deeper reflection — this alone is what living means. Continuous happiness is harmony evidenced in resolved living, not a sensory spike.</a:t>
+            </a:r>
+          </a:p>
         </p:txBody>
       </p:sp>
       <p:sp>
@@ -1278,6 +1471,24 @@
               </a:spcAft>
               <a:buNone/>
             </a:pPr>
+            <a:r>
+              <a:t>Composition is not the same as development.</a:t>
+            </a:r>
+          </a:p>
+          <a:p xmlns:a="http://schemas.openxmlformats.org/drawingml/2006/main">
+            <a:r>
+              <a:t>Physicochemical units compose into mixtures, compounds, cells, and bodies through definite constituent relations. Human families and societies arise differently: through recognised relationships, evaluation, and mutual satisfaction.</a:t>
+            </a:r>
+          </a:p>
+          <a:p xmlns:a="http://schemas.openxmlformats.org/drawingml/2006/main">
+            <a:r>
+              <a:t>In a mixture, components stay side by side and each maintains its own conduct — no new unit is formed. In a compound, definite proportion yields a new bounded unit, and its form, guna, svabhav, and dharma are evidenced in that new unit’s mutuality.</a:t>
+            </a:r>
+          </a:p>
+          <a:p xmlns:a="http://schemas.openxmlformats.org/drawingml/2006/main">
+            <a:r>
+              <a:t>Particles to molecules to cells and bodies is composition. Humane assemblies are relational achievements, not a further chemical tier. T1 occurs only when an atom reaches constitutional completeness. Insentient assemblies persist or decline according to whether constituent relationships are fulfilled.</a:t>
+            </a:r>
           </a:p>
         </p:txBody>
       </p:sp>
@@ -1355,7 +1566,22 @@
               <a:buNone/>
             </a:pPr>
             <a:r>
-              <a:t>Orderliness is self-regulation in saturated units, not an external command. Material, bio, and animal recognition and fulfilment are definite; an animal body's expressive limits do not introduce ontological indeterminacy or evaluative error. Justice becomes necessary in human living because jeevan can mis-evaluate under delusion. Awakening aligns its existing evaluative capacity with justice, dharma, truth, and coexistence.</a:t>
+              <a:t>This slide explains the darshan’s name.</a:t>
+            </a:r>
+          </a:p>
+          <a:p xmlns:a="http://schemas.openxmlformats.org/drawingml/2006/main">
+            <a:r>
+              <a:t>Orderliness is self-regulation, inherent in saturated units — not dispensed by a cosmic governor. This mediative — madhyasth — regulation, which regulates and conserves every unit, gives Madhyasth Darshan its name.</a:t>
+            </a:r>
+          </a:p>
+          <a:p xmlns:a="http://schemas.openxmlformats.org/drawingml/2006/main">
+            <a:r>
+              <a:t>Conformance has order-specific modes. Material: result or structural conformance. Bio: seed-conformance. Animal: species-conformance, inherited from gestation. Human: learned conformance through understanding.</a:t>
+            </a:r>
+          </a:p>
+          <a:p xmlns:a="http://schemas.openxmlformats.org/drawingml/2006/main">
+            <a:r>
+              <a:t>Material, bio, and animal regulation is definite. An animal body’s expressive limits do not introduce mis-evaluation. In human living, jeevan can judge wrongly when delusion mistakes the body for the self. Awakening aligns evaluation and fulfilment with coexistence. That is why justice becomes necessary at the knowledge order.</a:t>
             </a:r>
           </a:p>
         </p:txBody>
@@ -1423,7 +1649,36 @@
         <p:txBody>
           <a:bodyPr xmlns:a="http://schemas.openxmlformats.org/drawingml/2006/main"/>
           <a:lstStyle xmlns:a="http://schemas.openxmlformats.org/drawingml/2006/main"/>
-          <a:p xmlns:a="http://schemas.openxmlformats.org/drawingml/2006/main"/>
+          <a:p xmlns:a="http://schemas.openxmlformats.org/drawingml/2006/main">
+            <a:r>
+              <a:t>Before we enter the details, here is the map of the argument.</a:t>
+            </a:r>
+          </a:p>
+          <a:p xmlns:a="http://schemas.openxmlformats.org/drawingml/2006/main">
+            <a:r>
+              <a:t>One claim — existence is coexistence — will be carried through three movements.</a:t>
+            </a:r>
+          </a:p>
+          <a:p xmlns:a="http://schemas.openxmlformats.org/drawingml/2006/main">
+            <a:r>
+              <a:t>First: what is real, and how it is ordered. Coexistence is the bond of an all-pervasive ground and countable units. Each definite unit bears form, properties or guna, essential nature or svabhav, and dharma. Their expression becomes evident in mutuality across four orders of nature.</a:t>
+            </a:r>
+          </a:p>
+          <a:p xmlns:a="http://schemas.openxmlformats.org/drawingml/2006/main">
+            <a:r>
+              <a:t>Second: how two developmental lines proceed. One line is compositional: particles, atoms, molecules, cells, and bodies form larger configurations. The other is development in an atom, which can reach constitutional completeness as sentient jeevan. Across both lines, every activity is effort, motion, and result together.</a:t>
+            </a:r>
+          </a:p>
+          <a:p xmlns:a="http://schemas.openxmlformats.org/drawingml/2006/main">
+            <a:r>
+              <a:t>Third: how sentient living becomes awakened conduct — the human joint form of body and jeevan, the faculties and activities of jeevan, the four harmonies, evaluation, realisation, and participation in humane order.</a:t>
+            </a:r>
+          </a:p>
+          <a:p xmlns:a="http://schemas.openxmlformats.org/drawingml/2006/main">
+            <a:r>
+              <a:t>Please keep this distinction early: the body’s compositional line and jeevan’s atomic line meet in animal and human living, but they do not become the same process. That prevents the most common confusion — treating the body as the producer of sentience.</a:t>
+            </a:r>
+          </a:p>
         </p:txBody>
       </p:sp>
       <p:sp>
@@ -1489,7 +1744,31 @@
         <p:txBody>
           <a:bodyPr xmlns:a="http://schemas.openxmlformats.org/drawingml/2006/main"/>
           <a:lstStyle xmlns:a="http://schemas.openxmlformats.org/drawingml/2006/main"/>
-          <a:p xmlns:a="http://schemas.openxmlformats.org/drawingml/2006/main"/>
+          <a:p xmlns:a="http://schemas.openxmlformats.org/drawingml/2006/main">
+            <a:r>
+              <a:t>Karm Darshan names six evaluative perspectives: pleasant, healthy, profit, justice, dharma, and truth. They widen from sensation, body, and gain to relationship, orderliness, and coexistence.</a:t>
+            </a:r>
+          </a:p>
+          <a:p xmlns:a="http://schemas.openxmlformats.org/drawingml/2006/main">
+            <a:r>
+              <a:t>Justice has a dual role: it is one of the six, and it is the principle of fulfilled relationship. Dharma here as an evaluative perspective means fitting the wider pattern — discipline in thought, not only in outer conduct. Truth means alignment with the whole, grounded in realisation, not in liking or gain.</a:t>
+            </a:r>
+          </a:p>
+          <a:p xmlns:a="http://schemas.openxmlformats.org/drawingml/2006/main">
+            <a:r>
+              <a:t>The graduated chain is: rule itself is justice; justice itself is dharma; dharma itself is truth; truth itself is coexistence.</a:t>
+            </a:r>
+          </a:p>
+          <a:p xmlns:a="http://schemas.openxmlformats.org/drawingml/2006/main">
+            <a:r>
+              <a:t>Pleasure, health, and profit are not condemned. They remain legitimate in their domain. Awakening changes the organising refuge: they are subordinated under justice, dharma, and truth, not abandoned.</a:t>
+            </a:r>
+          </a:p>
+          <a:p xmlns:a="http://schemas.openxmlformats.org/drawingml/2006/main">
+            <a:r>
+              <a:t>Keep this distinct from unit-dharma on the earlier slide. Unit-dharma is innateness. The dharma–adharma perspective is an evaluative lens on thought and resolution.</a:t>
+            </a:r>
+          </a:p>
         </p:txBody>
       </p:sp>
       <p:sp>
@@ -1566,7 +1845,22 @@
               <a:buNone/>
             </a:pPr>
             <a:r>
-              <a:t>Read the left ladder as widening mutual context, not a progression from an isolated unit. Form is real bounded structure and is encountered through definite reflection in mutual facing. Guna is evident as effects in mutuality. Svabhav requires state, motion, plane, and order. Dharma is evidenced through whole-order fulfilment. The right ladder shows how jeevan understands and evidences these scopes. Human error belongs to deluded evaluation, not to indeterminacy in the reality reflected.</a:t>
+              <a:t>Here are two ladders that meet.</a:t>
+            </a:r>
+          </a:p>
+          <a:p xmlns:a="http://schemas.openxmlformats.org/drawingml/2006/main">
+            <a:r>
+              <a:t>On the left: what must be understood, as mutual context widens. Form is real structure reflected in mutual facing. Guna is effects evident in definite mutuality. Svabhav is usefulness within state, plane, and order. Dharma is innateness evidenced in whole-order fulfilment. Relationships are shared expectations weighed by justice, dharma, and truth. At the top is coexistence itself — the telos of knowing. This is not a climb away from the unit; it is a widening of the context in which a real unit is understood.</a:t>
+            </a:r>
+          </a:p>
+          <a:p xmlns:a="http://schemas.openxmlformats.org/drawingml/2006/main">
+            <a:r>
+              <a:t>On the right: how knowing happens within jeevan. Hope tastes and selects. Thought deliberates and analyses. Desire contemplates and visualises. Resolve receives enlightenment and resolves. The core self realises — and realisation takes place through truth. When each level is acted in alignment, it is felt as happiness, peace, contentment, and bliss.</a:t>
+            </a:r>
+          </a:p>
+          <a:p xmlns:a="http://schemas.openxmlformats.org/drawingml/2006/main">
+            <a:r>
+              <a:t>The ladders meet at the top: coexistence known and acted in the core self is felt as bliss. Human error belongs to deluded evaluation, not to indeterminacy in the reality reflected.</a:t>
             </a:r>
           </a:p>
         </p:txBody>
@@ -1645,7 +1939,32 @@
               <a:buNone/>
             </a:pPr>
             <a:r>
-              <a:t>Orderliness is self-regulation in saturated units, not an external command. Material, bio, and animal recognition and fulfilment are definite; an animal body's expressive limits do not introduce ontological indeterminacy or evaluative error. Justice becomes necessary in human living because jeevan can mis-evaluate under delusion. Awakening aligns its existing evaluative capacity with justice, dharma, truth, and coexistence.</a:t>
+              <a:t>Madhyasth Darshan uses several modes of warrant. They can support one another, but they do not establish the same thing.</a:t>
+            </a:r>
+          </a:p>
+          <a:p xmlns:a="http://schemas.openxmlformats.org/drawingml/2006/main">
+            <a:r>
+              <a:t>Logical exposition can establish internal coherence and entailment. It cannot by itself establish empirical truth.</a:t>
+            </a:r>
+          </a:p>
+          <a:p xmlns:a="http://schemas.openxmlformats.org/drawingml/2006/main">
+            <a:r>
+              <a:t>Study and self-examination can establish intelligibility and first-person recognition. They cannot by themselves physically identify jeevan.</a:t>
+            </a:r>
+          </a:p>
+          <a:p xmlns:a="http://schemas.openxmlformats.org/drawingml/2006/main">
+            <a:r>
+              <a:t>Experiment, practice, and conduct-evidence can establish effects in work, behaviour, and mutual satisfaction. They cannot by themselves measure T1 or the jeevan–body interface.</a:t>
+            </a:r>
+          </a:p>
+          <a:p xmlns:a="http://schemas.openxmlformats.org/drawingml/2006/main">
+            <a:r>
+              <a:t>Realisation is the darshan’s claimed completion of knowing. It does not force agreement from other methods.</a:t>
+            </a:r>
+          </a:p>
+          <a:p xmlns:a="http://schemas.openxmlformats.org/drawingml/2006/main">
+            <a:r>
+              <a:t>Publicly measurable physical claims remain answerable to instrument-based scientific inquiry. No accepted measurement procedure currently identifies T1, the jeevan–body interface, or post-body reassociation. Stating that plainly is part of responsible presentation.</a:t>
             </a:r>
           </a:p>
         </p:txBody>
@@ -1713,7 +2032,31 @@
         <p:txBody>
           <a:bodyPr xmlns:a="http://schemas.openxmlformats.org/drawingml/2006/main"/>
           <a:lstStyle xmlns:a="http://schemas.openxmlformats.org/drawingml/2006/main"/>
-          <a:p xmlns:a="http://schemas.openxmlformats.org/drawingml/2006/main"/>
+          <a:p xmlns:a="http://schemas.openxmlformats.org/drawingml/2006/main">
+            <a:r>
+              <a:t>Every jeevan bears the same five faculties and ten activities. In human living they answer one question — what makes me happy? — by organising in one of two ways.</a:t>
+            </a:r>
+          </a:p>
+          <a:p xmlns:a="http://schemas.openxmlformats.org/drawingml/2006/main">
+            <a:r>
+              <a:t>Under delusion, jeevan mistakes the body for the self. Its present faculties organise around accumulation, comfort, and safety, and mis-evaluation follows.</a:t>
+            </a:r>
+          </a:p>
+          <a:p xmlns:a="http://schemas.openxmlformats.org/drawingml/2006/main">
+            <a:r>
+              <a:t>Under awakening, jeevan knows its true nature and coexistence. Resolve, desire, thought, and hope align around the core self — toward undivided society and universal orderliness.</a:t>
+            </a:r>
+          </a:p>
+          <a:p xmlns:a="http://schemas.openxmlformats.org/drawingml/2006/main">
+            <a:r>
+              <a:t>No faculty is absent. Delusion directs evaluation toward the body; awakening aligns it with coexistence. Study supplies understanding; practice evidences and stabilises that alignment.</a:t>
+            </a:r>
+          </a:p>
+          <a:p xmlns:a="http://schemas.openxmlformats.org/drawingml/2006/main">
+            <a:r>
+              <a:t>When the same fork is resolved in the individual and sustained across a tradition, it is evidenced as resolution, prosperity, fearlessness, and coexistence.</a:t>
+            </a:r>
+          </a:p>
         </p:txBody>
       </p:sp>
       <p:sp>
@@ -1790,7 +2133,27 @@
               <a:buNone/>
             </a:pPr>
             <a:r>
-              <a:t>This is the telos slide - where the completeness drive terminates. The paper's 1.13 is Realisation in coexistence; the former four-senses taxonomy has been removed from the study - the vocabulary discipline now lives in Editorial Notes and the glossary (gyan names intelligibility in Omnipotence, the saturation bond - not a mind that knows; Realisation Knowledge for orderliness in every unit, 1.1; gyan udghatan for unfolding through awakened jeevan, 1.7; gyan-avastha for the fourth order, 1.5). Walk the slide: intro states the termination - not Omnipotence becoming a knower, but awakened jeevan enacting what was latent in the bond; realisation itself is the form of awakening, and recognition and fulfilment then constitute authenticity (SB p. 81). Card 1: realisation is anand - verity chain, MVD pp. 14-15 - and knowledge itself, since what is realised is the ground the unit was always saturated in. Cards 2-4: the AVD p. 217 identity - knowledge in projection (authenticity: gyan-vivek-vigyan, unfolding as gyan udghatan), knower in reflection (jeevan full of realisation; buddhi's reflection toward atma yields atma-bodh and realisation in coexistence together, MVD pp. 286-287), knowable as existence (nature saturated in Omnipotence). Guardrail: uniformity of knowledge, knower, and knowable in coexistence names coordinated roles in one bond - NOT merger into a universal knower; the knower remains distinct jeevan. This is the hinge against the Advaita chit reading (paper 5.6).</a:t>
+              <a:t>This is where the completeness drive terminates: realisation in coexistence.</a:t>
+            </a:r>
+          </a:p>
+          <a:p xmlns:a="http://schemas.openxmlformats.org/drawingml/2006/main">
+            <a:r>
+              <a:t>The drive comes to rest when relationships across nature are fulfilled and made evident in coexistence — not because Omnipresence becomes a knower, but because awakened jeevan realises and evidences the coexistence in which it has always existed. Recognising and fulfilling become its living proof.</a:t>
+            </a:r>
+          </a:p>
+          <a:p xmlns:a="http://schemas.openxmlformats.org/drawingml/2006/main">
+            <a:r>
+              <a:t>Realisation is bliss. Truth itself is abundance — coexistence; realisation of abundance itself is bliss; bliss itself is jeevan. And realisation is knowledge itself, because what is realised is the ground the unit was always soaked in.</a:t>
+            </a:r>
+          </a:p>
+          <a:p xmlns:a="http://schemas.openxmlformats.org/drawingml/2006/main">
+            <a:r>
+              <a:t>In projection, realisation is authenticity — knowledge, wisdom, and science unfolding into conduct. In reflection, the knower is jeevan filled with realisation. When resolve turns inward to the core self, self-realisation and realisation in coexistence arrive together.</a:t>
+            </a:r>
+          </a:p>
+          <a:p xmlns:a="http://schemas.openxmlformats.org/drawingml/2006/main">
+            <a:r>
+              <a:t>What is known is existence itself — nature saturated in Omnipresence. Knowledge, knower, and known become uniform as roles in one bond. This is not merger. The knower remains a distinct jeevan. That guardrail is decisive against reading satta as a universal knowing Self.</a:t>
             </a:r>
           </a:p>
         </p:txBody>
@@ -1869,7 +2232,27 @@
               <a:buNone/>
             </a:pPr>
             <a:r>
-              <a:t>The culmination slide - give it time and let it land. The drive that opened on slide 8 in every atom ends here, in people. Effort settled in realisation is T2 (restfulness of effort, anubhav); understanding proven in daily conduct is T3. The four goals land at their four levels: resolution in every person, prosperity in every family (samriddhi), fearlessness and trust in society (abhay), coexistence with all of nature (sah-astitva). An undivided society  in universal orderliness is their composed form. Tradition: each generation raised into the same understanding through education-sanskar - the humane tradition  that carries on. Highlight the design point: this is not an ideal bolted onto matter - the ontology is such that the progression is designed to arrive here. Development is definite, laws inherent to being (MVD p. 5); the three completenesses are designed stages toward which units are meant (SB pp. 50-52); the drive is built into the design of existence (paper 1.6); nature saturated in Omnipotence is bound for development until realisation in Omnipotence (SB pp. 51, 91). An awakened human tradition is what existence's own progression delivers. Close the arc: what is saturated in the ground has come to realise the ground, and the whole of nature stands fulfilled and evident in coexistence (SB pp. 51, 81; JV p. 61; MVD pp. 14-15).</a:t>
+              <a:t>The drive toward completeness comes to rest in awakened human beings — effort settled, understanding proven in daily conduct, and sustained through a human tradition.</a:t>
+            </a:r>
+          </a:p>
+          <a:p xmlns:a="http://schemas.openxmlformats.org/drawingml/2006/main">
+            <a:r>
+              <a:t>Effort settled in realisation is T2. Understanding proven in daily conduct is T3.</a:t>
+            </a:r>
+          </a:p>
+          <a:p xmlns:a="http://schemas.openxmlformats.org/drawingml/2006/main">
+            <a:r>
+              <a:t>The four goals land at four levels: resolution in every person; prosperity in every family; fearlessness — trust — in society; and coexistence with all of nature.</a:t>
+            </a:r>
+          </a:p>
+          <a:p xmlns:a="http://schemas.openxmlformats.org/drawingml/2006/main">
+            <a:r>
+              <a:t>Five dimensions of continuity carry the tradition: education and sanskar; justice and preservation; health and restraint; production and work; exchange and storage.</a:t>
+            </a:r>
+          </a:p>
+          <a:p xmlns:a="http://schemas.openxmlformats.org/drawingml/2006/main">
+            <a:r>
+              <a:t>This is not an ideal bolted onto matter. On Madhyasth Darshan’s account, the ontology is such that the progression is designed to arrive here. Nature saturated in Omnipresence is bound for development until realisation. An awakened human tradition is what that progression delivers: what is saturated in the ground has come to realise the ground, and nature stands fulfilled and evident in coexistence.</a:t>
             </a:r>
           </a:p>
         </p:txBody>
@@ -1948,7 +2331,47 @@
               <a:buNone/>
             </a:pPr>
             <a:r>
-              <a:t>Close the loop: existence is eternal coexistence; definite bounded units are real bearers whose form, guna, svabhav, and dharma become evident through mutuality. Material reflection and fulfilment are definite. Jeevan is not produced by the body: animal bodily development limits expression, while human mis-evaluation arises from body-identification. Study and self-examination bring understanding; practice tests, evidences, and stabilises it in conduct rather than creating jeevan's faculties.</a:t>
+              <a:t>Let us close the loop and answer the six questions we opened with.</a:t>
+            </a:r>
+          </a:p>
+          <a:p xmlns:a="http://schemas.openxmlformats.org/drawingml/2006/main">
+            <a:r>
+              <a:t>What is existence? Eternal coexistence: countless units saturated in all-pervasive Omnipresence.</a:t>
+            </a:r>
+          </a:p>
+          <a:p xmlns:a="http://schemas.openxmlformats.org/drawingml/2006/main">
+            <a:r>
+              <a:t>What exists? Root atomic units; composite units and bodies; body–jeevan joint forms; and relational human assemblies — all saturated in the ground.</a:t>
+            </a:r>
+          </a:p>
+          <a:p xmlns:a="http://schemas.openxmlformats.org/drawingml/2006/main">
+            <a:r>
+              <a:t>Does existence begin or end? No. Existence is perpetual. Configurations form, transform, and decompose.</a:t>
+            </a:r>
+          </a:p>
+          <a:p xmlns:a="http://schemas.openxmlformats.org/drawingml/2006/main">
+            <a:r>
+              <a:t>What is the self? Jeevan: a constitutionally complete sentient atom working through the body.</a:t>
+            </a:r>
+          </a:p>
+          <a:p xmlns:a="http://schemas.openxmlformats.org/drawingml/2006/main">
+            <a:r>
+              <a:t>Is the world real? Yes. Units, mutual relationships, and definite material fulfilment are real within perpetual coexistence.</a:t>
+            </a:r>
+          </a:p>
+          <a:p xmlns:a="http://schemas.openxmlformats.org/drawingml/2006/main">
+            <a:r>
+              <a:t>How is it known? Through logical exposition, study and self-examination, practice, realisation, and conduct-evidence. Measurable physical claims still require instrument-based testing. These evidence modes should not be conflated.</a:t>
+            </a:r>
+          </a:p>
+          <a:p xmlns:a="http://schemas.openxmlformats.org/drawingml/2006/main">
+            <a:r>
+              <a:t>Fulfilment is resolution and authenticity expressed as humane conduct and participation in orderliness. The ultimate test is pramanikta — lived evidence.</a:t>
+            </a:r>
+          </a:p>
+          <a:p xmlns:a="http://schemas.openxmlformats.org/drawingml/2006/main">
+            <a:r>
+              <a:t>If we continue in a companion session, the natural next step is to place this ontology beside Advaita Vedanta, modern philosophy, and modern science — including the open problems the study names for Madhyasth Darshan itself. Thank you.</a:t>
             </a:r>
           </a:p>
         </p:txBody>
@@ -2027,7 +2450,47 @@
               <a:buNone/>
             </a:pPr>
             <a:r>
-              <a:t>Set up the stakes before the answers. The first five questions are the classic ontological battleground - shared with Advaita Vedanta, Western philosophy, and modern science. The sixth is the epistemic question the study also frames: how can what exists be known, and at what scope? Emphasise that Madhyasth Darshan does not answer these piecemeal: one picture (coexistence) answers all six. The epistemic question gets its payoff mid-deck - the epistemic ladder (what must be understood, from the unit alone up to the whole, to know form, gun, svabhav, and dharma), then realisation in coexistence as where the drive terminates - and the closing slide answers it with the staged method: study, experiment and practice, realisation with conduct-evidence. Flag that we will close the loop at the end.</a:t>
+              <a:t>Every serious ontology has to answer a small set of framing questions. Let us name them before we give Madhyasth Darshan’s answers.</a:t>
+            </a:r>
+          </a:p>
+          <a:p xmlns:a="http://schemas.openxmlformats.org/drawingml/2006/main">
+            <a:r>
+              <a:t>What is existence? Is there one fundamental reality, or many — and how are they related?</a:t>
+            </a:r>
+          </a:p>
+          <a:p xmlns:a="http://schemas.openxmlformats.org/drawingml/2006/main">
+            <a:r>
+              <a:t>What exists? What are the basic constituents of reality, and what is each of them?</a:t>
+            </a:r>
+          </a:p>
+          <a:p xmlns:a="http://schemas.openxmlformats.org/drawingml/2006/main">
+            <a:r>
+              <a:t>Does what exists begin? Did reality originate at some time — or is origination only of configurations?</a:t>
+            </a:r>
+          </a:p>
+          <a:p xmlns:a="http://schemas.openxmlformats.org/drawingml/2006/main">
+            <a:r>
+              <a:t>Does the self begin or end with the body? Is the individual self, jeevan, produced by the body and destroyed with it?</a:t>
+            </a:r>
+          </a:p>
+          <a:p xmlns:a="http://schemas.openxmlformats.org/drawingml/2006/main">
+            <a:r>
+              <a:t>Is the world finally real? Is the plural world of units an appearance, or real in its own right?</a:t>
+            </a:r>
+          </a:p>
+          <a:p xmlns:a="http://schemas.openxmlformats.org/drawingml/2006/main">
+            <a:r>
+              <a:t>And sixth: how can what exists be known? What must be understood — and at what scope — to know each aspect of reality?</a:t>
+            </a:r>
+          </a:p>
+          <a:p xmlns:a="http://schemas.openxmlformats.org/drawingml/2006/main">
+            <a:r>
+              <a:t>Traditions diverge sharply on these questions — Advaita Vedanta, Western philosophy, and modern science among them. Madhyasth Darshan does not answer them piecemeal. One picture — coexistence — answers all six at once.</a:t>
+            </a:r>
+          </a:p>
+          <a:p xmlns:a="http://schemas.openxmlformats.org/drawingml/2006/main">
+            <a:r>
+              <a:t>Later we will see how knowing widens on the epistemic ladder, where the drive terminates in realisation, and how method and evidence are distinguished. At the end we will return to this same list with the answers filled in.</a:t>
             </a:r>
           </a:p>
         </p:txBody>
@@ -2106,7 +2569,27 @@
               <a:buNone/>
             </a:pPr>
             <a:r>
-              <a:t>Use this map as the deck’s organising view. Begin with coexistence: Omnipotence and countless units are inseparable without losing their distinction. Follow the unit-side structure through the four aspects, relationships, four orders, and two developmental lines. The body belongs to compositional progression; jeevan is the result of development in an atom. The two meet in the animal and human joint form. T1 marks sentience; T2 and T3 concern awakening and conduct in jeevan.</a:t>
+              <a:t>This conceptual map is the organising view of Section 1.</a:t>
+            </a:r>
+          </a:p>
+          <a:p xmlns:a="http://schemas.openxmlformats.org/drawingml/2006/main">
+            <a:r>
+              <a:t>Begin at the top with coexistence: Omnipresence and countless units are inseparable, yet they do not lose their distinction. Then follow the unit side: four aspects, relationships, four orders, and two developmental lines.</a:t>
+            </a:r>
+          </a:p>
+          <a:p xmlns:a="http://schemas.openxmlformats.org/drawingml/2006/main">
+            <a:r>
+              <a:t>Notice the fork. The body belongs to compositional progression. Jeevan is the result of development in an atom. The two meet in the animal and human joint form.</a:t>
+            </a:r>
+          </a:p>
+          <a:p xmlns:a="http://schemas.openxmlformats.org/drawingml/2006/main">
+            <a:r>
+              <a:t>T1 marks the arrival of sentience. T2 and T3 concern awakening and conduct in jeevan — they are not further material stages.</a:t>
+            </a:r>
+          </a:p>
+          <a:p xmlns:a="http://schemas.openxmlformats.org/drawingml/2006/main">
+            <a:r>
+              <a:t>When later slides feel dense, return mentally to this map. Most of what follows is a zoom into one node of this picture.</a:t>
             </a:r>
           </a:p>
         </p:txBody>
@@ -2185,7 +2668,32 @@
               <a:buNone/>
             </a:pPr>
             <a:r>
-              <a:t>The two-pole structure is the foundation. Key points: Omnipotence is formless, all-pervasive, non-transforming, actionless energy - the translation prints Omnipotence, the study uses Omnipotence. SB lists several names for it (Uniform Energy, Space, Knowledge, Consciousness); caution the audience that Consciousness and Knowledge here do NOT mean a mind that knows - active sentience belongs to jeevan, not to the ground. Second key point: the poles were never separate - separation 'never happens'. Ground is state-complete (state-complete, changeless); saturated nature is state-dynamic (state-dynamic) - so ALL change is unit-activity. The diagram: units are bounded wholes; the distance between them is held in Omnipotence as Space.</a:t>
+              <a:t>This is the foundation.</a:t>
+            </a:r>
+          </a:p>
+          <a:p xmlns:a="http://schemas.openxmlformats.org/drawingml/2006/main">
+            <a:r>
+              <a:t>Existence has two inseparable aspects. The first is Omnipresence — satta. It is formless, all-pervasive, non-transforming, and immeasurable. It is actionless energy. It performs no actions, yet every unit is energised, regulated, and conserved in it. There is no place where it is absent.</a:t>
+            </a:r>
+          </a:p>
+          <a:p xmlns:a="http://schemas.openxmlformats.org/drawingml/2006/main">
+            <a:r>
+              <a:t>The second aspect is units of nature. They are formful, active, and countable. Each is bounded from six directions and saturated in Omnipresence. Each bears form, guna, svabhav, and dharma, whose expression is evident in definite mutuality.</a:t>
+            </a:r>
+          </a:p>
+          <a:p xmlns:a="http://schemas.openxmlformats.org/drawingml/2006/main">
+            <a:r>
+              <a:t>Do not collapse levels. At the root, nature is analysed as atomic units — a centre with orbiting parts. Compounds and bodies are composite units. Body and jeevan together are a joint form. Families and societies are relational assemblies.</a:t>
+            </a:r>
+          </a:p>
+          <a:p xmlns:a="http://schemas.openxmlformats.org/drawingml/2006/main">
+            <a:r>
+              <a:t>These two poles were never separate. Separation of a unit from the saturated whole never happens. The ground is state-complete — without motion, wave, or pressure. Nature saturated in it is state-dynamic. Therefore all change is unit-activity.</a:t>
+            </a:r>
+          </a:p>
+          <a:p xmlns:a="http://schemas.openxmlformats.org/drawingml/2006/main">
+            <a:r>
+              <a:t>One caution on names. The texts list many English names for satta — Uniform Energy, Space, Knowledge, Consciousness, Omnipresence, Eternity, God, Absolute Energy. When you hear Knowledge or Consciousness in that list, do not hear a mind that knows. Active sentience belongs to jeevan, the sentient unit — never to the ground.</a:t>
             </a:r>
           </a:p>
         </p:txBody>
@@ -2264,7 +2772,32 @@
               <a:buNone/>
             </a:pPr>
             <a:r>
-              <a:t>Saturation (samprikt) is the ever-present state of nature soaked, submerged, and surrounded in Omnipotence. Omnipotence does not push or act on units. Recognition capability, activeness, and inherent regulation are evident on the unit side. In insentient nature, mutual reflection, recognition, evaluation, and fulfilment are definite; they do not require a human observer. The sentient atom additionally knows and can evidence this coexistence consciously.</a:t>
+              <a:t>How exactly are ground and units related? Through saturation — samprikt.</a:t>
+            </a:r>
+          </a:p>
+          <a:p xmlns:a="http://schemas.openxmlformats.org/drawingml/2006/main">
+            <a:r>
+              <a:t>Every formful unit is soaked, submerged, and surrounded in Omnipresence. From this ever-present bond, Madhyasth Darshan says three endowments are evident on the unit side.</a:t>
+            </a:r>
+          </a:p>
+          <a:p xmlns:a="http://schemas.openxmlformats.org/drawingml/2006/main">
+            <a:r>
+              <a:t>First, recognition capability. Complementarity is given in coexistence; it is not created by us. In insentient nature, reflection, recognition, and fulfilment occur definitely through the unit’s capacity, ability, and receptivity. No human observer is required.</a:t>
+            </a:r>
+          </a:p>
+          <a:p xmlns:a="http://schemas.openxmlformats.org/drawingml/2006/main">
+            <a:r>
+              <a:t>Second, activeness. The texts say: unit plus energy fullness equals activeness. Inherent energy and basic impulsion make the unit active, appearing as the inseparable triad of effort, motion, and result.</a:t>
+            </a:r>
+          </a:p>
+          <a:p xmlns:a="http://schemas.openxmlformats.org/drawingml/2006/main">
+            <a:r>
+              <a:t>Third, inherent regulation — orderliness within the unit’s participation in coexistence: mediative and conserving, not an external statutory command.</a:t>
+            </a:r>
+          </a:p>
+          <a:p xmlns:a="http://schemas.openxmlformats.org/drawingml/2006/main">
+            <a:r>
+              <a:t>Please hear the caution on the slide. This is an ontological entailment, not a proposed measurable transfer mechanism. And not every unit progresses to constitutional completeness. Omnipresence does not push units from outside.</a:t>
             </a:r>
           </a:p>
         </p:txBody>
@@ -2343,7 +2876,42 @@
               <a:buNone/>
             </a:pPr>
             <a:r>
-              <a:t>Do not present roop, guna, svabhav, and dharma as a static four-field signature. The bearer is definite: a bounded unit with constitution, state, order, and capacities. Form is real, while what another unit encounters is its definite reflection in mutual facing. Guna is the inseparable relative power or effect of the guni. Svabhav is the usefulness or essentiality of that effect according to state, motion, plane, order, and context. Dharma is inseparable innateness and fulfilment, evidenced in participation. In insentient nature these are definite. Mis-evaluation arises only in human living when jeevan, under delusion, takes the body to be the self.</a:t>
+              <a:t>What is every unit? Four inseparable aspects — but not a static checklist pasted onto things.</a:t>
+            </a:r>
+          </a:p>
+          <a:p xmlns:a="http://schemas.openxmlformats.org/drawingml/2006/main">
+            <a:r>
+              <a:t>The bearer is definite: a bounded unit with constitution, state, order, and capacities.</a:t>
+            </a:r>
+          </a:p>
+          <a:p xmlns:a="http://schemas.openxmlformats.org/drawingml/2006/main">
+            <a:r>
+              <a:t>Form is real boundary and configuration. Take the peepal tree on the slide: one bounded living form with trunk, branches, leaves, and roots.</a:t>
+            </a:r>
+          </a:p>
+          <a:p xmlns:a="http://schemas.openxmlformats.org/drawingml/2006/main">
+            <a:r>
+              <a:t>Properties — guna — are capacity and relative effect. In the peepal: nutrition, growth, repair, seed production, and degeneration become evident under definite conditions.</a:t>
+            </a:r>
+          </a:p>
+          <a:p xmlns:a="http://schemas.openxmlformats.org/drawingml/2006/main">
+            <a:r>
+              <a:t>Essential nature — svabhav — is usefulness in context. For the peepal: vitalising while its living organisation is maintained; devitalising when that organisation breaks down.</a:t>
+            </a:r>
+          </a:p>
+          <a:p xmlns:a="http://schemas.openxmlformats.org/drawingml/2006/main">
+            <a:r>
+              <a:t>Dharma is innateness and order-specific fulfilment. The peepal has existence plus growth. Seed-conformance is its mode of conduct, not an extra dharma piled on top.</a:t>
+            </a:r>
+          </a:p>
+          <a:p xmlns:a="http://schemas.openxmlformats.org/drawingml/2006/main">
+            <a:r>
+              <a:t>Form is real; what another unit encounters is its definite reflection in mutual facing. In insentient nature these aspects are definite. Mis-evaluation arises only in human living, when jeevan under delusion takes the body to be the self.</a:t>
+            </a:r>
+          </a:p>
+          <a:p xmlns:a="http://schemas.openxmlformats.org/drawingml/2006/main">
+            <a:r>
+              <a:t>And notice the persistence note: the tree as a composite form can die and decompose, while its constituent material units persist and enter other compositions. Persistence of existence is not persistence of one configuration.</a:t>
             </a:r>
           </a:p>
         </p:txBody>
@@ -2422,7 +2990,27 @@
               <a:buNone/>
             </a:pPr>
             <a:r>
-              <a:t>Complementarity is actualised as value in mutuality. In material, bio, and animal orders recognition and fulfilment are definite. At the human order evaluation and error enter because jeevan can organise its faculties around body-identification. Awakening does not create new faculties; it aligns knowing, believing, recognising, and fulfilling with coexistence.</a:t>
+              <a:t>Jeevan Vidya states the principle: nothing is isolated.</a:t>
+            </a:r>
+          </a:p>
+          <a:p xmlns:a="http://schemas.openxmlformats.org/drawingml/2006/main">
+            <a:r>
+              <a:t>Existence holds relations between units, and it is in those relations that complementarity is actualised as value in mutuality. Expression is definite in the material, bio, and animal orders. At the human order, evaluation may err under body-identification.</a:t>
+            </a:r>
+          </a:p>
+          <a:p xmlns:a="http://schemas.openxmlformats.org/drawingml/2006/main">
+            <a:r>
+              <a:t>Two kinds of mutuality matter. A relationship — sambandh — is mutuality whose expectations and fulfilment are definite in the relation’s completeness: parent and child. An association or contact — sampark — is mutuality where expectations are voluntary: neighbours who share a wall.</a:t>
+            </a:r>
+          </a:p>
+          <a:p xmlns:a="http://schemas.openxmlformats.org/drawingml/2006/main">
+            <a:r>
+              <a:t>The slide names five value families: object, jeevan, human, relationship, and established or civic. Object values are utility and art. So the six named values are utility, art, jeevan, human, relationship, and established or civic.</a:t>
+            </a:r>
+          </a:p>
+          <a:p xmlns:a="http://schemas.openxmlformats.org/drawingml/2006/main">
+            <a:r>
+              <a:t>At the human order the path runs: knowing, then believing, then recognising, then fulfilling. Awakening does not create new faculties. It aligns this chain with coexistence. Established and civic values articulate that fulfilment in society.</a:t>
             </a:r>
           </a:p>
         </p:txBody>
@@ -2501,7 +3089,22 @@
               <a:buNone/>
             </a:pPr>
             <a:r>
-              <a:t>The four orders are stable modes of participation. Jeevan is present in animal and human joint forms. In animals, species-specific bodily and brain development limits which of jeevan's activities can be expressed through the body. In humans, the bodily medium supports the full range; the distinct problem is delusion and body-identification, which misdirect evaluation. Do not collapse either condition into material emergence of sentience.</a:t>
+              <a:t>Units organise into four stable orders of nature: material; bio or pranic; animal; and knowledge — the human order.</a:t>
+            </a:r>
+          </a:p>
+          <a:p xmlns:a="http://schemas.openxmlformats.org/drawingml/2006/main">
+            <a:r>
+              <a:t>Read the table downward. Dharma is cumulative. Matter has existence. The bio order adds growth. The animal order adds hope to live. The knowledge order adds happiness. Higher orders include the dharmas of the lower ones.</a:t>
+            </a:r>
+          </a:p>
+          <a:p xmlns:a="http://schemas.openxmlformats.org/drawingml/2006/main">
+            <a:r>
+              <a:t>The pivotal boundary is between the pranic and the animal. Material and pranic orders are insentient. Hope to live is where sentience enters. Jeevan is present in animal and human joint forms.</a:t>
+            </a:r>
+          </a:p>
+          <a:p xmlns:a="http://schemas.openxmlformats.org/drawingml/2006/main">
+            <a:r>
+              <a:t>In animals, bodily and brain development limits how jeevan’s faculties can be expressed through the body. In humans, the bodily medium supports the full range, but delusion can misdirect evaluation. Neither body produces sentience. Please do not collapse either condition into a story of mind emerging from matter alone.</a:t>
             </a:r>
           </a:p>
         </p:txBody>

</xml_diff>

<commit_message>
Refine ontology section 1 review issues
</commit_message>
<xml_diff>
--- a/Studies/The-Ontology-of-Coexistence/The-Ontology-of-Existence-Madhyasth-Darshan.pptx
+++ b/Studies/The-Ontology-of-Coexistence/The-Ontology-of-Existence-Madhyasth-Darshan.pptx
@@ -2,38 +2,38 @@
 <file path=ppt/presentation.xml><?xml version="1.0" encoding="utf-8"?>
 <p:presentation xmlns:p="http://schemas.openxmlformats.org/presentationml/2006/main">
   <p:sldMasterIdLst>
-    <p:sldMasterId xmlns:r="http://schemas.openxmlformats.org/officeDocument/2006/relationships" id="2147483648" r:id="R6055c6fd07ce4201"/>
+    <p:sldMasterId xmlns:r="http://schemas.openxmlformats.org/officeDocument/2006/relationships" id="2147483648" r:id="Ra55c80fbc28f4f18"/>
   </p:sldMasterIdLst>
   <p:notesMasterIdLst>
-    <p:notesMasterId xmlns:r="http://schemas.openxmlformats.org/officeDocument/2006/relationships" r:id="Rf8d867df9cf24b24"/>
+    <p:notesMasterId xmlns:r="http://schemas.openxmlformats.org/officeDocument/2006/relationships" r:id="R7c8d086800e04eed"/>
   </p:notesMasterIdLst>
   <p:sldIdLst>
-    <p:sldId xmlns:r="http://schemas.openxmlformats.org/officeDocument/2006/relationships" id="256" r:id="Rf62651482fd64891"/>
-    <p:sldId xmlns:r="http://schemas.openxmlformats.org/officeDocument/2006/relationships" id="257" r:id="R316883c49d8b4fdc"/>
-    <p:sldId xmlns:r="http://schemas.openxmlformats.org/officeDocument/2006/relationships" id="258" r:id="R5fbeae8ec6824505"/>
-    <p:sldId xmlns:r="http://schemas.openxmlformats.org/officeDocument/2006/relationships" id="259" r:id="Rf441cd0d05c74aa6"/>
-    <p:sldId xmlns:r="http://schemas.openxmlformats.org/officeDocument/2006/relationships" id="260" r:id="R1d66dbfa2b234950"/>
-    <p:sldId xmlns:r="http://schemas.openxmlformats.org/officeDocument/2006/relationships" id="261" r:id="R81e34653592e49ba"/>
-    <p:sldId xmlns:r="http://schemas.openxmlformats.org/officeDocument/2006/relationships" id="262" r:id="R6e786645449842b5"/>
-    <p:sldId xmlns:r="http://schemas.openxmlformats.org/officeDocument/2006/relationships" id="263" r:id="R8707da54cd414837"/>
-    <p:sldId xmlns:r="http://schemas.openxmlformats.org/officeDocument/2006/relationships" id="264" r:id="R039492544497463a"/>
-    <p:sldId xmlns:r="http://schemas.openxmlformats.org/officeDocument/2006/relationships" id="265" r:id="R2afd297358264062"/>
-    <p:sldId xmlns:r="http://schemas.openxmlformats.org/officeDocument/2006/relationships" id="266" r:id="Rbcbe54a1f28048e5"/>
-    <p:sldId xmlns:r="http://schemas.openxmlformats.org/officeDocument/2006/relationships" id="267" r:id="R9f458f915492474b"/>
-    <p:sldId xmlns:r="http://schemas.openxmlformats.org/officeDocument/2006/relationships" id="268" r:id="R6fddbb211d6648aa"/>
-    <p:sldId xmlns:r="http://schemas.openxmlformats.org/officeDocument/2006/relationships" id="269" r:id="R6b223340a783449f"/>
-    <p:sldId xmlns:r="http://schemas.openxmlformats.org/officeDocument/2006/relationships" id="270" r:id="Rfcd7ef0cec004985"/>
-    <p:sldId xmlns:r="http://schemas.openxmlformats.org/officeDocument/2006/relationships" id="271" r:id="Rf4ee074f5688498d"/>
-    <p:sldId xmlns:r="http://schemas.openxmlformats.org/officeDocument/2006/relationships" id="272" r:id="Rdd7049f1fd6b4a31"/>
-    <p:sldId xmlns:r="http://schemas.openxmlformats.org/officeDocument/2006/relationships" id="273" r:id="R8702ce0324a04c86"/>
-    <p:sldId xmlns:r="http://schemas.openxmlformats.org/officeDocument/2006/relationships" id="274" r:id="R57ba474117454c34"/>
-    <p:sldId xmlns:r="http://schemas.openxmlformats.org/officeDocument/2006/relationships" id="275" r:id="Re6ed68ad8bf84ca2"/>
-    <p:sldId xmlns:r="http://schemas.openxmlformats.org/officeDocument/2006/relationships" id="276" r:id="Rb41d28aa159a4776"/>
-    <p:sldId xmlns:r="http://schemas.openxmlformats.org/officeDocument/2006/relationships" id="277" r:id="Re50e980df4794685"/>
-    <p:sldId xmlns:r="http://schemas.openxmlformats.org/officeDocument/2006/relationships" id="278" r:id="R2e1414a4e2c24104"/>
-    <p:sldId xmlns:r="http://schemas.openxmlformats.org/officeDocument/2006/relationships" id="279" r:id="R9a0d295377ec45d3"/>
-    <p:sldId xmlns:r="http://schemas.openxmlformats.org/officeDocument/2006/relationships" id="280" r:id="R1fef91ff18154784"/>
-    <p:sldId xmlns:r="http://schemas.openxmlformats.org/officeDocument/2006/relationships" id="281" r:id="R85af59f95ed9426e"/>
+    <p:sldId xmlns:r="http://schemas.openxmlformats.org/officeDocument/2006/relationships" id="256" r:id="Ra7c73a135d554af8"/>
+    <p:sldId xmlns:r="http://schemas.openxmlformats.org/officeDocument/2006/relationships" id="257" r:id="Rf15be8b3a815447c"/>
+    <p:sldId xmlns:r="http://schemas.openxmlformats.org/officeDocument/2006/relationships" id="258" r:id="R94241d9980ff4d83"/>
+    <p:sldId xmlns:r="http://schemas.openxmlformats.org/officeDocument/2006/relationships" id="259" r:id="Rf036a07d0b59475d"/>
+    <p:sldId xmlns:r="http://schemas.openxmlformats.org/officeDocument/2006/relationships" id="260" r:id="R62651d4b5d484225"/>
+    <p:sldId xmlns:r="http://schemas.openxmlformats.org/officeDocument/2006/relationships" id="261" r:id="Rca69948035de4fbd"/>
+    <p:sldId xmlns:r="http://schemas.openxmlformats.org/officeDocument/2006/relationships" id="262" r:id="R4a0630db69ab44ff"/>
+    <p:sldId xmlns:r="http://schemas.openxmlformats.org/officeDocument/2006/relationships" id="263" r:id="R654e14d39d904a45"/>
+    <p:sldId xmlns:r="http://schemas.openxmlformats.org/officeDocument/2006/relationships" id="264" r:id="R59a4b102fc7e4662"/>
+    <p:sldId xmlns:r="http://schemas.openxmlformats.org/officeDocument/2006/relationships" id="265" r:id="Ra440c393548a4a9a"/>
+    <p:sldId xmlns:r="http://schemas.openxmlformats.org/officeDocument/2006/relationships" id="266" r:id="Rb139265a63db4f25"/>
+    <p:sldId xmlns:r="http://schemas.openxmlformats.org/officeDocument/2006/relationships" id="267" r:id="R4ed0383cd6fb4104"/>
+    <p:sldId xmlns:r="http://schemas.openxmlformats.org/officeDocument/2006/relationships" id="268" r:id="R90a16cd21cdc47a1"/>
+    <p:sldId xmlns:r="http://schemas.openxmlformats.org/officeDocument/2006/relationships" id="269" r:id="R37ef4bcc8ed346c0"/>
+    <p:sldId xmlns:r="http://schemas.openxmlformats.org/officeDocument/2006/relationships" id="270" r:id="R5d2e9c39c6c74833"/>
+    <p:sldId xmlns:r="http://schemas.openxmlformats.org/officeDocument/2006/relationships" id="271" r:id="Rd7674d47386f4228"/>
+    <p:sldId xmlns:r="http://schemas.openxmlformats.org/officeDocument/2006/relationships" id="272" r:id="Rf699686f1d77470a"/>
+    <p:sldId xmlns:r="http://schemas.openxmlformats.org/officeDocument/2006/relationships" id="273" r:id="Rbf8bb594a2574885"/>
+    <p:sldId xmlns:r="http://schemas.openxmlformats.org/officeDocument/2006/relationships" id="274" r:id="Recb28bc1fd9344bf"/>
+    <p:sldId xmlns:r="http://schemas.openxmlformats.org/officeDocument/2006/relationships" id="275" r:id="Rc728cb4f9451495e"/>
+    <p:sldId xmlns:r="http://schemas.openxmlformats.org/officeDocument/2006/relationships" id="276" r:id="Rb91598fa7b074479"/>
+    <p:sldId xmlns:r="http://schemas.openxmlformats.org/officeDocument/2006/relationships" id="277" r:id="R880845b9e7b149ee"/>
+    <p:sldId xmlns:r="http://schemas.openxmlformats.org/officeDocument/2006/relationships" id="278" r:id="R7838cd1e37e64014"/>
+    <p:sldId xmlns:r="http://schemas.openxmlformats.org/officeDocument/2006/relationships" id="279" r:id="R56b8efe701f64579"/>
+    <p:sldId xmlns:r="http://schemas.openxmlformats.org/officeDocument/2006/relationships" id="280" r:id="R2aca9b001cf9405e"/>
+    <p:sldId xmlns:r="http://schemas.openxmlformats.org/officeDocument/2006/relationships" id="281" r:id="Rf82c21e1b2d64bba"/>
   </p:sldIdLst>
   <p:sldSz cx="9144000" cy="5143500"/>
   <p:notesSz cx="6858000" cy="9144000"/>
@@ -2576,7 +2576,7 @@
   </p:cSld>
   <p:clrMap bg1="lt1" tx1="dk1" bg2="dk2" tx2="lt2" accent1="accent1" accent2="accent2" accent3="accent3" accent4="accent4" accent5="accent5" accent6="accent6" hlink="hlink" folHlink="folHlink"/>
   <p:sldLayoutIdLst>
-    <p:sldLayoutId xmlns:r="http://schemas.openxmlformats.org/officeDocument/2006/relationships" id="2147483649" r:id="R930dbeaa02974b77"/>
+    <p:sldLayoutId xmlns:r="http://schemas.openxmlformats.org/officeDocument/2006/relationships" id="2147483649" r:id="Rb074903b30e84daf"/>
   </p:sldLayoutIdLst>
   <p:hf sldNum="0" hdr="0" ftr="0" dt="0"/>
   <p:txStyles>
@@ -22302,7 +22302,7 @@
       </p:sp>
       <p:cxnSp>
         <p:nvCxnSpPr>
-          <p:cNvPr id="825" name="Google Shape;445;p18"/>
+          <p:cNvPr id="899" name="Google Shape;445;p18"/>
           <p:cNvCxnSpPr/>
           <p:nvPr/>
         </p:nvCxnSpPr>
@@ -22383,7 +22383,7 @@
       </p:sp>
       <p:cxnSp>
         <p:nvCxnSpPr>
-          <p:cNvPr id="827" name="Google Shape;447;p18"/>
+          <p:cNvPr id="901" name="Google Shape;447;p18"/>
           <p:cNvCxnSpPr/>
           <p:nvPr/>
         </p:nvCxnSpPr>
@@ -24341,7 +24341,7 @@
                 <a:ea typeface="Calibri"/>
                 <a:cs typeface="Calibri"/>
               </a:rPr>
-              <a:t>jeevan mistakes the body for the self — its present faculties organise around accumulation, comfort, and safety; mis-evaluation follows</a:t>
+              <a:t>Body-identification leaves sensitivity unguided by cognisance; selection and evaluation remain organised around pleasure, health, and profit.</a:t>
             </a:r>
           </a:p>
         </p:txBody>
@@ -24509,7 +24509,7 @@
                 <a:ea typeface="Calibri"/>
                 <a:cs typeface="Calibri"/>
               </a:rPr>
-              <a:t>jeevan knows its true nature and coexistence — resolve, desire, thought, and hope align around the core self — undivided society, universal orderliness</a:t>
+              <a:t>Cognisance regulates sensitivity; knowing and believing guide recognition and fulfilment toward justice, dharma, truth, and coexistence.</a:t>
             </a:r>
           </a:p>
         </p:txBody>
@@ -24565,7 +24565,7 @@
                 <a:ea typeface="Calibri"/>
                 <a:cs typeface="Calibri"/>
               </a:rPr>
-              <a:t>No faculty is absent. Delusion directs evaluation toward the body; awakening aligns it with coexistence. Study supplies understanding; practice evidences and stabilises that alignment.</a:t>
+              <a:t>No faculty is absent, and sensitivity is not rejected. Delusion lets sensory criteria rule; awakening balances sensitivity with cognisance, so understanding guides conduct.</a:t>
             </a:r>
           </a:p>
         </p:txBody>
@@ -25265,7 +25265,7 @@
                 <a:ea typeface="Calibri"/>
                 <a:cs typeface="Calibri"/>
               </a:rPr>
-              <a:t>JV p. 93 (root of delusion: body mistaken for jeevan)  ·  MVD Ch. 17 (ego → stubbornness → delusion)  ·  JV p. 61; MVD p. 13 (§1.15)</a:t>
+              <a:t>SB p. 64 (cognisance–sensitivity balance)  ·  JV pp. 73–74, 92–94 (four-and-a-half activities)  ·  MVD pp. 274–275</a:t>
             </a:r>
           </a:p>
         </p:txBody>
@@ -25609,7 +25609,7 @@
                 <a:ea typeface="Calibri"/>
                 <a:cs typeface="Calibri"/>
               </a:rPr>
-              <a:t>The drive comes to rest when relationships across nature are fulfilled and made evident in coexistence — not because Omnipotence becomes a knower, but because awakened jeevan realises and evidences the coexistence in which it has always existed. Recognising and fulfilling become its living proof.</a:t>
+              <a:t>Realisation coordinates three distinct roles: jeevan remains the knower, existence as coexistence remains the known, and threefold knowledge becomes evident through humane conduct.</a:t>
             </a:r>
           </a:p>
         </p:txBody>
@@ -25889,7 +25889,7 @@
                 <a:ea typeface="Cambria"/>
                 <a:cs typeface="Cambria"/>
               </a:rPr>
-              <a:t>Knowledge — in projection</a:t>
+              <a:t>Threefold knowledge</a:t>
             </a:r>
           </a:p>
         </p:txBody>
@@ -25945,7 +25945,7 @@
                 <a:ea typeface="Calibri"/>
                 <a:cs typeface="Calibri"/>
               </a:rPr>
-              <a:t>Realisation projected outward is authenticity — knowledge, wisdom, and science unfolding into conduct.</a:t>
+              <a:t>Knowledge comprises the holistic view of coexistence, knowledge of jeevan, and knowledge of humane conduct. Projection makes that understanding evident.</a:t>
             </a:r>
           </a:p>
         </p:txBody>
@@ -26057,7 +26057,7 @@
                 <a:ea typeface="Cambria"/>
                 <a:cs typeface="Cambria"/>
               </a:rPr>
-              <a:t>Knower — in reflection</a:t>
+              <a:t>Knower — jeevan remains distinct</a:t>
             </a:r>
           </a:p>
         </p:txBody>
@@ -26113,7 +26113,7 @@
                 <a:ea typeface="Calibri"/>
                 <a:cs typeface="Calibri"/>
               </a:rPr>
-              <a:t>The knower is jeevan filled with realisation. When resolve turns inward to the core self, self-realisation and realisation in coexistence arrive together.</a:t>
+              <a:t>Jeevan remains the knower and seer. Realisation clarifies its own nature and the coexistence in which it participates; it does not dissolve the individual unit.</a:t>
             </a:r>
           </a:p>
         </p:txBody>
@@ -26225,7 +26225,7 @@
                 <a:ea typeface="Cambria"/>
                 <a:cs typeface="Cambria"/>
               </a:rPr>
-              <a:t>Knowable — and no merger</a:t>
+              <a:t>Known — coexistence</a:t>
             </a:r>
           </a:p>
         </p:txBody>
@@ -26281,7 +26281,7 @@
                 <a:ea typeface="Calibri"/>
                 <a:cs typeface="Calibri"/>
               </a:rPr>
-              <a:t>What is known is existence itself — nature saturated in Omnipotence. Knowledge, knower, and known become uniform as roles in one bond — not a merger: the knower remains a distinct jeevan.</a:t>
+              <a:t>The known is existence as coexistence: Omnipresence and real units in mutuality. Knowledge, knower, and known become coherent without becoming identical.</a:t>
             </a:r>
           </a:p>
         </p:txBody>
@@ -26337,7 +26337,7 @@
                 <a:ea typeface="Calibri"/>
                 <a:cs typeface="Calibri"/>
               </a:rPr>
-              <a:t>“In the state of realisation in existence, uniformity in knowledge, knowable &amp; knower has been observed to be in the form of coexistence” — AVD p. 217 · SB p. 81 · MVD pp. 14–15</a:t>
+              <a:t>— SB p. 81 (realisation and authenticity)  ·  SB p. 116; MVD p. 126 (threefold knowledge)  ·  KD §§3.17–3.18 (knowledge, knower, known)</a:t>
             </a:r>
           </a:p>
         </p:txBody>
@@ -29120,7 +29120,7 @@
           <p:nvPr/>
         </p:nvPicPr>
         <p:blipFill rotWithShape="1">
-          <a:blip xmlns:r="http://schemas.openxmlformats.org/officeDocument/2006/relationships" xmlns:a="http://schemas.openxmlformats.org/drawingml/2006/main" r:embed="R0664648e943b4a52">
+          <a:blip xmlns:r="http://schemas.openxmlformats.org/officeDocument/2006/relationships" xmlns:a="http://schemas.openxmlformats.org/drawingml/2006/main" r:embed="Ree50662bd2c64574">
             <a:alphaModFix/>
           </a:blip>
           <a:srcRect xmlns:a="http://schemas.openxmlformats.org/drawingml/2006/main" l="0" t="0" r="0" b="0"/>
@@ -29262,7 +29262,7 @@
           <p:nvPr/>
         </p:nvPicPr>
         <p:blipFill rotWithShape="1">
-          <a:blip xmlns:r="http://schemas.openxmlformats.org/officeDocument/2006/relationships" xmlns:a="http://schemas.openxmlformats.org/drawingml/2006/main" r:embed="R0664648e943b4a52">
+          <a:blip xmlns:r="http://schemas.openxmlformats.org/officeDocument/2006/relationships" xmlns:a="http://schemas.openxmlformats.org/drawingml/2006/main" r:embed="Ree50662bd2c64574">
             <a:alphaModFix/>
           </a:blip>
           <a:srcRect xmlns:a="http://schemas.openxmlformats.org/drawingml/2006/main" l="0" t="0" r="0" b="0"/>
@@ -29404,7 +29404,7 @@
           <p:nvPr/>
         </p:nvPicPr>
         <p:blipFill rotWithShape="1">
-          <a:blip xmlns:r="http://schemas.openxmlformats.org/officeDocument/2006/relationships" xmlns:a="http://schemas.openxmlformats.org/drawingml/2006/main" r:embed="R0664648e943b4a52">
+          <a:blip xmlns:r="http://schemas.openxmlformats.org/officeDocument/2006/relationships" xmlns:a="http://schemas.openxmlformats.org/drawingml/2006/main" r:embed="Ree50662bd2c64574">
             <a:alphaModFix/>
           </a:blip>
           <a:srcRect xmlns:a="http://schemas.openxmlformats.org/drawingml/2006/main" l="0" t="0" r="0" b="0"/>
@@ -29546,7 +29546,7 @@
           <p:nvPr/>
         </p:nvPicPr>
         <p:blipFill rotWithShape="1">
-          <a:blip xmlns:r="http://schemas.openxmlformats.org/officeDocument/2006/relationships" xmlns:a="http://schemas.openxmlformats.org/drawingml/2006/main" r:embed="R0664648e943b4a52">
+          <a:blip xmlns:r="http://schemas.openxmlformats.org/officeDocument/2006/relationships" xmlns:a="http://schemas.openxmlformats.org/drawingml/2006/main" r:embed="Ree50662bd2c64574">
             <a:alphaModFix/>
           </a:blip>
           <a:srcRect xmlns:a="http://schemas.openxmlformats.org/drawingml/2006/main" l="0" t="0" r="0" b="0"/>
@@ -29688,7 +29688,7 @@
           <p:nvPr/>
         </p:nvPicPr>
         <p:blipFill rotWithShape="1">
-          <a:blip xmlns:r="http://schemas.openxmlformats.org/officeDocument/2006/relationships" xmlns:a="http://schemas.openxmlformats.org/drawingml/2006/main" r:embed="R0664648e943b4a52">
+          <a:blip xmlns:r="http://schemas.openxmlformats.org/officeDocument/2006/relationships" xmlns:a="http://schemas.openxmlformats.org/drawingml/2006/main" r:embed="Ree50662bd2c64574">
             <a:alphaModFix/>
           </a:blip>
           <a:srcRect xmlns:a="http://schemas.openxmlformats.org/drawingml/2006/main" l="0" t="0" r="0" b="0"/>
@@ -29830,7 +29830,7 @@
           <p:nvPr/>
         </p:nvPicPr>
         <p:blipFill rotWithShape="1">
-          <a:blip xmlns:r="http://schemas.openxmlformats.org/officeDocument/2006/relationships" xmlns:a="http://schemas.openxmlformats.org/drawingml/2006/main" r:embed="R0664648e943b4a52">
+          <a:blip xmlns:r="http://schemas.openxmlformats.org/officeDocument/2006/relationships" xmlns:a="http://schemas.openxmlformats.org/drawingml/2006/main" r:embed="Ree50662bd2c64574">
             <a:alphaModFix/>
           </a:blip>
           <a:srcRect xmlns:a="http://schemas.openxmlformats.org/drawingml/2006/main" l="0" t="0" r="0" b="0"/>
@@ -30381,7 +30381,7 @@
           <p:nvPr/>
         </p:nvPicPr>
         <p:blipFill>
-          <a:blip xmlns:r="http://schemas.openxmlformats.org/officeDocument/2006/relationships" xmlns:a="http://schemas.openxmlformats.org/drawingml/2006/main" r:embed="R3b6e4667f9df4a21"/>
+          <a:blip xmlns:r="http://schemas.openxmlformats.org/officeDocument/2006/relationships" xmlns:a="http://schemas.openxmlformats.org/drawingml/2006/main" r:embed="R9592ba783c444931"/>
           <a:stretch xmlns:a="http://schemas.openxmlformats.org/drawingml/2006/main"/>
         </p:blipFill>
         <p:spPr>
@@ -32296,7 +32296,7 @@
           <p:nvPr/>
         </p:nvPicPr>
         <p:blipFill rotWithShape="1">
-          <a:blip xmlns:r="http://schemas.openxmlformats.org/officeDocument/2006/relationships" xmlns:a="http://schemas.openxmlformats.org/drawingml/2006/main" r:embed="R978d0a1f843049c3">
+          <a:blip xmlns:r="http://schemas.openxmlformats.org/officeDocument/2006/relationships" xmlns:a="http://schemas.openxmlformats.org/drawingml/2006/main" r:embed="R009f2c7d08ea487e">
             <a:alphaModFix/>
           </a:blip>
           <a:srcRect xmlns:a="http://schemas.openxmlformats.org/drawingml/2006/main" l="0" t="0" r="0" b="0"/>
@@ -32539,7 +32539,7 @@
           <p:nvPr/>
         </p:nvPicPr>
         <p:blipFill rotWithShape="1">
-          <a:blip xmlns:r="http://schemas.openxmlformats.org/officeDocument/2006/relationships" xmlns:a="http://schemas.openxmlformats.org/drawingml/2006/main" r:embed="R265feef7dd2849ea">
+          <a:blip xmlns:r="http://schemas.openxmlformats.org/officeDocument/2006/relationships" xmlns:a="http://schemas.openxmlformats.org/drawingml/2006/main" r:embed="R82de30f78aa24f2f">
             <a:alphaModFix/>
           </a:blip>
           <a:srcRect xmlns:a="http://schemas.openxmlformats.org/drawingml/2006/main" l="0" t="0" r="0" b="0"/>
@@ -32782,7 +32782,7 @@
           <p:nvPr/>
         </p:nvPicPr>
         <p:blipFill rotWithShape="1">
-          <a:blip xmlns:r="http://schemas.openxmlformats.org/officeDocument/2006/relationships" xmlns:a="http://schemas.openxmlformats.org/drawingml/2006/main" r:embed="Rdb12d5633aaf4e80">
+          <a:blip xmlns:r="http://schemas.openxmlformats.org/officeDocument/2006/relationships" xmlns:a="http://schemas.openxmlformats.org/drawingml/2006/main" r:embed="R03fcc80c3b1943bd">
             <a:alphaModFix/>
           </a:blip>
           <a:srcRect xmlns:a="http://schemas.openxmlformats.org/drawingml/2006/main" l="0" t="0" r="0" b="0"/>

</xml_diff>

<commit_message>
Clarify Ontology presenter scripts for a smart non-MD audience.
Rewrite read-aloud notes with English-first glosses, section bridges, and deferred T1–T3 labels while keeping the 26-slide deck order.

Co-authored-by: Cursor <cursoragent@cursor.com>
</commit_message>
<xml_diff>
--- a/Studies/The-Ontology-of-Coexistence/The-Ontology-of-Existence-Madhyasth-Darshan.pptx
+++ b/Studies/The-Ontology-of-Coexistence/The-Ontology-of-Existence-Madhyasth-Darshan.pptx
@@ -594,27 +594,27 @@
               <a:buNone/>
             </a:pPr>
             <a:r>
-              <a:t>Welcome, and thank you for joining this session.</a:t>
-            </a:r>
-          </a:p>
-          <a:p xmlns:a="http://schemas.openxmlformats.org/drawingml/2006/main">
-            <a:r>
-              <a:t>Today we will study the ontology of existence as stated in Madhyasth Darshan, also called Co-existentialism, propounded by Shri A. Nagraj. The name itself carries a thesis: madhyasth means mediative. The darshan holds that reality is regulated and conserved through an inherent, mediative orderliness, not by an external governor.</a:t>
-            </a:r>
-          </a:p>
-          <a:p xmlns:a="http://schemas.openxmlformats.org/drawingml/2006/main">
-            <a:r>
-              <a:t>This presentation follows Section 1 of the study The Ontology of Coexistence. It states the darshan’s ontology on its own terms, grounded in the primary texts — Madhyasth Darshan, Manav Karm Darshan, Samadhanatmak Bhautikvad, and Jeevan Vidya.</a:t>
-            </a:r>
-          </a:p>
-          <a:p xmlns:a="http://schemas.openxmlformats.org/drawingml/2006/main">
-            <a:r>
-              <a:t>Here is the core claim I want you to hold for the whole session: existence is coexistence. It is the ever-present togetherness of a formless, all-pervasive ground — satta — and countless real, bounded units of nature, each saturated in that ground. You will see the slides use the translation’s word Omnipotence for that ground; in spoken explanation I will often say Omnipresence. Both names point to the same reality.</a:t>
-            </a:r>
-          </a:p>
-          <a:p xmlns:a="http://schemas.openxmlformats.org/drawingml/2006/main">
-            <a:r>
-              <a:t>Everything that follows — sentience, values, justice, and humane society — unfolds from this one picture. The study is written from a scientist-technologist standpoint. Our aim is rigorous understanding: testing definitions and internal consistency — not persuasion, and not devotion.</a:t>
+              <a:t>Welcome, and thank you for joining.</a:t>
+            </a:r>
+          </a:p>
+          <a:p xmlns:a="http://schemas.openxmlformats.org/drawingml/2006/main">
+            <a:r>
+              <a:t>You do not need any prior familiarity with Madhyasth Darshan, or with formal philosophy, to follow this session. I will use ordinary English first, and introduce source terms only when they help. Our aim is not persuasion or devotion. It is to examine one coherent account of reality — testing its definitions and internal consistency.</a:t>
+            </a:r>
+          </a:p>
+          <a:p xmlns:a="http://schemas.openxmlformats.org/drawingml/2006/main">
+            <a:r>
+              <a:t>Madhyasth Darshan — also called Co-existentialism — was propounded by Shri A. Nagraj. The name points to a thesis we will unpack later: order in nature is mediative and inherent, not imposed by an external governor.</a:t>
+            </a:r>
+          </a:p>
+          <a:p xmlns:a="http://schemas.openxmlformats.org/drawingml/2006/main">
+            <a:r>
+              <a:t>Here is the one claim to hold for the whole talk: existence is coexistence. Reality is the ever-present togetherness of a formless, all-pervasive ground and countless real, bounded units of nature, each saturated in that ground. Everything else — sentience, values, justice, society — unfolds from this picture.</a:t>
+            </a:r>
+          </a:p>
+          <a:p xmlns:a="http://schemas.openxmlformats.org/drawingml/2006/main">
+            <a:r>
+              <a:t>The slides sometimes print Omnipotence for that ground; I will usually say Omnipresence. Same reality; different English labels in the translations.</a:t>
             </a:r>
           </a:p>
         </p:txBody>
@@ -698,22 +698,22 @@
           </a:p>
           <a:p xmlns:a="http://schemas.openxmlformats.org/drawingml/2006/main">
             <a:r>
-              <a:t>Compositional progression joins particles, atoms, molecules, cells, and bodies into larger configurations. Development in an atom can reach constitutional completeness as jeevan. These lines meet in living joint forms, but they remain distinct.</a:t>
-            </a:r>
-          </a:p>
-          <a:p xmlns:a="http://schemas.openxmlformats.org/drawingml/2006/main">
-            <a:r>
-              <a:t>Across both, activity is one inseparable triad: effort, motion, and result. These are three joint aspects of one activity, not three steps in a sequence. When sodium and chlorine approach one another, the approach is effort and motion together; the stable salt crystal is the result.</a:t>
-            </a:r>
-          </a:p>
-          <a:p xmlns:a="http://schemas.openxmlformats.org/drawingml/2006/main">
-            <a:r>
-              <a:t>The texts compress the engine of development this way: saturation itself is forcefulness; forcefulness is basic impulsion; impulsion is activity; activity is effort-motion-result; and that is development and its continuity.</a:t>
-            </a:r>
-          </a:p>
-          <a:p xmlns:a="http://schemas.openxmlformats.org/drawingml/2006/main">
-            <a:r>
-              <a:t>Each term has a goal: restfulness of effort, destination of motion, immortality of result. Nature saturated in the ground is oriented for development and awakening until realisation. That bound is called an existential truth. Development pervades nature; awakening occurs in the sentient. Insentient units participate by composing bodies and environments without each individually completing the drive.</a:t>
+              <a:t>Compositional progression joins particles, atoms, molecules, cells, and bodies into larger configurations. Separately, development in an atom can reach constitutional completeness as a sentient unit. These lines meet in living joint forms, but they remain distinct.</a:t>
+            </a:r>
+          </a:p>
+          <a:p xmlns:a="http://schemas.openxmlformats.org/drawingml/2006/main">
+            <a:r>
+              <a:t>Across both, activity is one inseparable triad: effort, motion, and result — three aspects of one activity, not three sequential steps. When sodium and chlorine approach, the approach is effort and motion together; the stable salt crystal is the result.</a:t>
+            </a:r>
+          </a:p>
+          <a:p xmlns:a="http://schemas.openxmlformats.org/drawingml/2006/main">
+            <a:r>
+              <a:t>The texts compress the engine this way: saturation is forcefulness; forcefulness is basic impulsion; impulsion is activity; activity is effort-motion-result; and that is development.</a:t>
+            </a:r>
+          </a:p>
+          <a:p xmlns:a="http://schemas.openxmlformats.org/drawingml/2006/main">
+            <a:r>
+              <a:t>Each term has a goal: restfulness of effort, destination of motion, immortality of result. Nature saturated in the ground is oriented for development and awakening until realisation. Development pervades nature; awakening occurs in the sentient. Non-sentient units participate by composing bodies and environments without each individually completing the drive.</a:t>
             </a:r>
           </a:p>
         </p:txBody>
@@ -792,32 +792,32 @@
               <a:buNone/>
             </a:pPr>
             <a:r>
-              <a:t>The three transitions are developmental milestones.</a:t>
-            </a:r>
-          </a:p>
-          <a:p xmlns:a="http://schemas.openxmlformats.org/drawingml/2006/main">
-            <a:r>
-              <a:t>T1 is constitutional completeness — gathanpurnata: immortality of result. A developing atom becomes sentient jeevan. The plane shifts from physicochemical to delusional — meaning the body is mistaken for the self, not psychiatric illness.</a:t>
-            </a:r>
-          </a:p>
-          <a:p xmlns:a="http://schemas.openxmlformats.org/drawingml/2006/main">
-            <a:r>
-              <a:t>T2 is activity completeness — kriyapurnata: restfulness of effort. Internal seeking resolves into direct realisation and absolute resolution. The plane shifts from delusional to deific.</a:t>
-            </a:r>
-          </a:p>
-          <a:p xmlns:a="http://schemas.openxmlformats.org/drawingml/2006/main">
-            <a:r>
-              <a:t>T3 is conduct completeness — acharanpurnata: destination of motion. Authentic conduct becomes living proof. The plane shifts from deific to divine.</a:t>
-            </a:r>
-          </a:p>
-          <a:p xmlns:a="http://schemas.openxmlformats.org/drawingml/2006/main">
-            <a:r>
-              <a:t>Keep T2 and T3 apart. T2 is internal settlement of effort. T3 is external destination in conduct. And do not confuse T2’s restfulness with the ease of insentient natural-state complementarity.</a:t>
-            </a:r>
-          </a:p>
-          <a:p xmlns:a="http://schemas.openxmlformats.org/drawingml/2006/main">
-            <a:r>
-              <a:t>T1 is constitutional completeness of an atom. T2 and T3 are not further material stages; they name completeness of activity and conduct in awakened jeevan. In one line: the saturated realises the ground it is saturated in. That is the completeness drive.</a:t>
+              <a:t>Now we name three milestones — T1, T2, and T3.</a:t>
+            </a:r>
+          </a:p>
+          <a:p xmlns:a="http://schemas.openxmlformats.org/drawingml/2006/main">
+            <a:r>
+              <a:t>T1 is constitutional completeness: the immortality of result. A developing atom becomes a sentient unit — jeevan. Status shifts from physicochemical to what the texts call delusional — meaning the body is mistaken for the self. That is a stage label, not a psychiatric diagnosis.</a:t>
+            </a:r>
+          </a:p>
+          <a:p xmlns:a="http://schemas.openxmlformats.org/drawingml/2006/main">
+            <a:r>
+              <a:t>T2 is activity completeness: restfulness of effort. Inner seeking settles into direct realisation and resolution. Status shifts toward awakened understanding.</a:t>
+            </a:r>
+          </a:p>
+          <a:p xmlns:a="http://schemas.openxmlformats.org/drawingml/2006/main">
+            <a:r>
+              <a:t>T3 is conduct completeness: destination of motion. Understanding becomes authentic conduct — living proof.</a:t>
+            </a:r>
+          </a:p>
+          <a:p xmlns:a="http://schemas.openxmlformats.org/drawingml/2006/main">
+            <a:r>
+              <a:t>Keep T2 and T3 apart. T2 is internal settlement. T3 is outer destination in conduct. And do not confuse T2’s restfulness with the ease of non-sentient natural complementarity.</a:t>
+            </a:r>
+          </a:p>
+          <a:p xmlns:a="http://schemas.openxmlformats.org/drawingml/2006/main">
+            <a:r>
+              <a:t>T1 is completeness of an atom’s constitution. T2 and T3 are not further material stages; they name completeness of activity and conduct in the awakened sentient unit. In one line: the saturated realises the ground it is saturated in.</a:t>
             </a:r>
           </a:p>
         </p:txBody>
@@ -896,32 +896,17 @@
               <a:buNone/>
             </a:pPr>
             <a:r>
-              <a:t>This slide is a confusion-preventer. Madhyasth Darshan uses several classifications that overlap without being interchangeable. Each answers a different question.</a:t>
-            </a:r>
-          </a:p>
-          <a:p xmlns:a="http://schemas.openxmlformats.org/drawingml/2006/main">
-            <a:r>
-              <a:t>Orders — material, bio, animal, knowledge — classify organisation, svabhav, and dharma. Do not confuse orders with planes.</a:t>
-            </a:r>
-          </a:p>
-          <a:p xmlns:a="http://schemas.openxmlformats.org/drawingml/2006/main">
-            <a:r>
-              <a:t>Progressions — physicochemical, delusional, deific, divine — track status across T1, T2, and T3. Do not confuse them with orders or planes.</a:t>
-            </a:r>
-          </a:p>
-          <a:p xmlns:a="http://schemas.openxmlformats.org/drawingml/2006/main">
-            <a:r>
-              <a:t>Planes name scope of knowing and experience. They are not simply material stages.</a:t>
-            </a:r>
-          </a:p>
-          <a:p xmlns:a="http://schemas.openxmlformats.org/drawingml/2006/main">
-            <a:r>
-              <a:t>Human types — animal, demon, human, divine, transcendental — mark orientation of human living. Do not confuse them with value families.</a:t>
-            </a:r>
-          </a:p>
-          <a:p xmlns:a="http://schemas.openxmlformats.org/drawingml/2006/main">
-            <a:r>
-              <a:t>T1 separates the physicochemical from the sentient. T2 and T3 concern awakening and conduct. So if someone asks whether the human order is the same as the divine plane, the answer is no. One human order can span multiple planes.</a:t>
+              <a:t>One short caution, then we move on.</a:t>
+            </a:r>
+          </a:p>
+          <a:p xmlns:a="http://schemas.openxmlformats.org/drawingml/2006/main">
+            <a:r>
+              <a:t>This tradition uses several overlapping lists — orders of nature, developmental statuses, scopes of knowing, and types of human orientation. They answer different questions. Do not equate them.</a:t>
+            </a:r>
+          </a:p>
+          <a:p xmlns:a="http://schemas.openxmlformats.org/drawingml/2006/main">
+            <a:r>
+              <a:t>In particular: the human order is not the same thing as the highest developmental status. One human order can span more than one status. Sentience arrives at T1; awakening and conduct are T2 and T3.</a:t>
             </a:r>
           </a:p>
         </p:txBody>
@@ -1000,32 +985,32 @@
               <a:buNone/>
             </a:pPr>
             <a:r>
-              <a:t>T1 is the hinge of the ontology: where sentience enters.</a:t>
-            </a:r>
-          </a:p>
-          <a:p xmlns:a="http://schemas.openxmlformats.org/drawingml/2006/main">
-            <a:r>
-              <a:t>It is constitutional completeness at the atomic level — not neural complexity, not molecular size, and not mere elevation along the order chain.</a:t>
-            </a:r>
-          </a:p>
-          <a:p xmlns:a="http://schemas.openxmlformats.org/drawingml/2006/main">
-            <a:r>
-              <a:t>The texts describe a constitution-oriented developing atom that takes in particles — hungry and overfull atoms completing each other — within a suitable environment. When the required constitution closes, the particle count no longer increases or decreases.</a:t>
-            </a:r>
-          </a:p>
-          <a:p xmlns:a="http://schemas.openxmlformats.org/drawingml/2006/main">
-            <a:r>
-              <a:t>Before T1, the evolving atom is still bound by molecular weight and structure; particle count is still changing; it exhibits radiance and projection as an insentient unit. After T1, it is released from molecular and weight bondage and carried by hope. Sentient jeevan shows a finer mode of recognition.</a:t>
-            </a:r>
-          </a:p>
-          <a:p xmlns:a="http://schemas.openxmlformats.org/drawingml/2006/main">
-            <a:r>
-              <a:t>T1 is irreversible because the completed constitution no longer decomposes. That completed constitution grounds jeevan’s continuity beyond the body.</a:t>
-            </a:r>
-          </a:p>
-          <a:p xmlns:a="http://schemas.openxmlformats.org/drawingml/2006/main">
-            <a:r>
-              <a:t>I want to be plain: this is an ontological account. No accepted empirical procedure currently identifies the threshold. We will return to that honesty when we discuss method and evidence.</a:t>
+              <a:t>T1 is the hinge: where sentience enters.</a:t>
+            </a:r>
+          </a:p>
+          <a:p xmlns:a="http://schemas.openxmlformats.org/drawingml/2006/main">
+            <a:r>
+              <a:t>It is constitutional completeness at the atomic level — not neural complexity, not molecular size, and not merely climbing the order chain.</a:t>
+            </a:r>
+          </a:p>
+          <a:p xmlns:a="http://schemas.openxmlformats.org/drawingml/2006/main">
+            <a:r>
+              <a:t>The texts describe a developing atom that incorporates particles — complementary “hungry” and “overfull” completions — in a suitable environment. When the required constitution closes, particle count no longer increases or decreases.</a:t>
+            </a:r>
+          </a:p>
+          <a:p xmlns:a="http://schemas.openxmlformats.org/drawingml/2006/main">
+            <a:r>
+              <a:t>Before T1: still changing structure and particle count; non-sentient radiance and projection. After T1: released from molecular and weight bondage, carried by hope; a finer mode of recognition as the sentient unit.</a:t>
+            </a:r>
+          </a:p>
+          <a:p xmlns:a="http://schemas.openxmlformats.org/drawingml/2006/main">
+            <a:r>
+              <a:t>T1 is irreversible because the completed constitution no longer decomposes. That is the textual basis for continuity of the knower beyond a particular body.</a:t>
+            </a:r>
+          </a:p>
+          <a:p xmlns:a="http://schemas.openxmlformats.org/drawingml/2006/main">
+            <a:r>
+              <a:t>I want to be plain: this is an ontological account. No accepted empirical procedure currently identifies the threshold. We will return to that honesty under method and evidence.</a:t>
             </a:r>
           </a:p>
         </p:txBody>
@@ -1104,22 +1089,27 @@
               <a:buNone/>
             </a:pPr>
             <a:r>
-              <a:t>Animal and human living is a joint form.</a:t>
-            </a:r>
-          </a:p>
-          <a:p xmlns:a="http://schemas.openxmlformats.org/drawingml/2006/main">
-            <a:r>
-              <a:t>Jeevan brings all ten activities. The body supplies the species-specific medium. Animal bodily and brain development limits their expression. The human medium supports the full range, while body-identification can still misdirect evaluation.</a:t>
-            </a:r>
-          </a:p>
-          <a:p xmlns:a="http://schemas.openxmlformats.org/drawingml/2006/main">
-            <a:r>
-              <a:t>On one side is the body: a pranic composition — sense organs, brain, and physical expression; decomposable. On the other side is jeevan: the constitutionally complete sentient atom; five faculties and ten activities inherent; continuing when the joint form ends.</a:t>
-            </a:r>
-          </a:p>
-          <a:p xmlns:a="http://schemas.openxmlformats.org/drawingml/2006/main">
-            <a:r>
-              <a:t>The body gates expression. Jeevan is seer, doer, and enjoyer through the body. Animal limitation belongs to the medium. Human mis-evaluation belongs to body-delusion. The body does not produce sentience, and those two problems are not the same problem.</a:t>
+              <a:t>We now turn to human living — movement three.</a:t>
+            </a:r>
+          </a:p>
+          <a:p xmlns:a="http://schemas.openxmlformats.org/drawingml/2006/main">
+            <a:r>
+              <a:t>Animal and human living is a joint form. The sentient unit brings the full set of faculties and activities. The body supplies the species-specific medium.</a:t>
+            </a:r>
+          </a:p>
+          <a:p xmlns:a="http://schemas.openxmlformats.org/drawingml/2006/main">
+            <a:r>
+              <a:t>On one side: the body — living composition, sense organs, brain, physical expression; decomposable. On the other: the sentient unit — constitutionally complete; faculties inherent; continuing when the joint form ends.</a:t>
+            </a:r>
+          </a:p>
+          <a:p xmlns:a="http://schemas.openxmlformats.org/drawingml/2006/main">
+            <a:r>
+              <a:t>Animal bodily development limits expression. The human medium can support the full range, while mistaking the body for the self can still misdirect evaluation.</a:t>
+            </a:r>
+          </a:p>
+          <a:p xmlns:a="http://schemas.openxmlformats.org/drawingml/2006/main">
+            <a:r>
+              <a:t>The body gates expression. The sentient unit is seer, doer, and enjoyer through the body. Animal limitation belongs to the medium. Human mis-evaluation belongs to that confusion. The body does not produce sentience, and those two problems are not the same problem.</a:t>
             </a:r>
           </a:p>
         </p:txBody>
@@ -1198,27 +1188,27 @@
               <a:buNone/>
             </a:pPr>
             <a:r>
-              <a:t>Jeevan is a constitutionally complete sentient atom.</a:t>
-            </a:r>
-          </a:p>
-          <a:p xmlns:a="http://schemas.openxmlformats.org/drawingml/2006/main">
-            <a:r>
-              <a:t>Structurally, the nucleus is atma, the core self. The rings around it are buddhi, chitta, vritti, and mun — resolve, desire, thought, and hope.</a:t>
-            </a:r>
-          </a:p>
-          <a:p xmlns:a="http://schemas.openxmlformats.org/drawingml/2006/main">
-            <a:r>
-              <a:t>Each faculty works outward in projection and inward in reflection. Hope selects outward and tastes inward. Thought analyses and deliberates. Desire visualises and contemplates. Resolve resolves and receives enlightenment. The core self authenticates and realises.</a:t>
-            </a:r>
-          </a:p>
-          <a:p xmlns:a="http://schemas.openxmlformats.org/drawingml/2006/main">
-            <a:r>
-              <a:t>All five faculties and all ten activities belong to jeevan. Presence must be distinguished from expression and from effective organisation. Animal bodies limit expression through the medium. Humans have the bodily medium for the full range, yet under body-delusion only four and a half activities may be effectively organised.</a:t>
-            </a:r>
-          </a:p>
-          <a:p xmlns:a="http://schemas.openxmlformats.org/drawingml/2006/main">
-            <a:r>
-              <a:t>Study brings understanding. Practice evidences and stabilises it. Practice does not manufacture faculties that were missing.</a:t>
+              <a:t>The sentient unit — jeevan — is a constitutionally complete atom.</a:t>
+            </a:r>
+          </a:p>
+          <a:p xmlns:a="http://schemas.openxmlformats.org/drawingml/2006/main">
+            <a:r>
+              <a:t>Structurally, the centre is the core self. Around it: resolve, desire, thought, and hope — the texts’ buddhi, chitta, vritti, and mun.</a:t>
+            </a:r>
+          </a:p>
+          <a:p xmlns:a="http://schemas.openxmlformats.org/drawingml/2006/main">
+            <a:r>
+              <a:t>Each works outward and inward. Hope selects and tastes. Thought analyses and deliberates. Desire visualises and contemplates. Resolve resolves and receives clear understanding. The core self authenticates and realises.</a:t>
+            </a:r>
+          </a:p>
+          <a:p xmlns:a="http://schemas.openxmlformats.org/drawingml/2006/main">
+            <a:r>
+              <a:t>All five faculties and ten activities belong to the sentient unit. Presence is not the same as expression or effective organisation. Animal bodies limit expression. Humans have the medium for the full range, yet under body-confusion only part of that range may be effectively organised.</a:t>
+            </a:r>
+          </a:p>
+          <a:p xmlns:a="http://schemas.openxmlformats.org/drawingml/2006/main">
+            <a:r>
+              <a:t>Study brings understanding. Practice tests and stabilises it. Practice does not manufacture faculties that were missing.</a:t>
             </a:r>
           </a:p>
         </p:txBody>
@@ -1288,27 +1278,27 @@
           <a:lstStyle xmlns:a="http://schemas.openxmlformats.org/drawingml/2006/main"/>
           <a:p xmlns:a="http://schemas.openxmlformats.org/drawingml/2006/main">
             <a:r>
-              <a:t>From Manav Karm Darshan, Chapter 1: the structure of karma.</a:t>
-            </a:r>
-          </a:p>
-          <a:p xmlns:a="http://schemas.openxmlformats.org/drawingml/2006/main">
-            <a:r>
-              <a:t>Every karma — every activity done with desire — carries five limbs: doer, cause, objective, result, and effect. Effect names the act’s reach or consequence. The text does not add a separate cosmic reward-and-punishment ledger on this slide.</a:t>
-            </a:r>
-          </a:p>
-          <a:p xmlns:a="http://schemas.openxmlformats.org/drawingml/2006/main">
-            <a:r>
-              <a:t>Desire is the aspiration. Karma is the doing — activity together with aspiration. Result is the fruit. Desire, karma, and result must balance for the desire to be truly accomplished.</a:t>
-            </a:r>
-          </a:p>
-          <a:p xmlns:a="http://schemas.openxmlformats.org/drawingml/2006/main">
-            <a:r>
-              <a:t>Understanding alone changes nothing. It is the doing that yields the fruit. Book knowledge is only half the work.</a:t>
-            </a:r>
-          </a:p>
-          <a:p xmlns:a="http://schemas.openxmlformats.org/drawingml/2006/main">
-            <a:r>
-              <a:t>Hold this beside the earlier triad of effort, motion, and result. Karma is the desire-laden framing of activity in sentient living. Later we will see how desire and doing are reorganised under justice, dharma, and truth.</a:t>
+              <a:t>A brief structural note on intentional activity — what this text calls karma. Please hear it in this technical sense, not as a popular cosmic reward-and-punishment story.</a:t>
+            </a:r>
+          </a:p>
+          <a:p xmlns:a="http://schemas.openxmlformats.org/drawingml/2006/main">
+            <a:r>
+              <a:t>Every activity done with desire has five limbs: doer, cause, objective, result, and effect. Effect means the act’s reach or consequence — not a separate ledger of destiny on this slide.</a:t>
+            </a:r>
+          </a:p>
+          <a:p xmlns:a="http://schemas.openxmlformats.org/drawingml/2006/main">
+            <a:r>
+              <a:t>Desire is the aspiration. Karma here is the doing — activity together with aspiration. Result is the fruit. Desire, doing, and result must balance for the desire to be truly accomplished.</a:t>
+            </a:r>
+          </a:p>
+          <a:p xmlns:a="http://schemas.openxmlformats.org/drawingml/2006/main">
+            <a:r>
+              <a:t>Understanding alone changes nothing. Doing yields the fruit. Book knowledge is half the work.</a:t>
+            </a:r>
+          </a:p>
+          <a:p xmlns:a="http://schemas.openxmlformats.org/drawingml/2006/main">
+            <a:r>
+              <a:t>Hold this beside the earlier triad of effort, motion, and result. This is the desire-laden framing of activity in sentient living. Later we will see how desire and doing are reorganised under justice, innateness, and truth.</a:t>
             </a:r>
           </a:p>
         </p:txBody>
@@ -1378,22 +1368,22 @@
           <a:lstStyle xmlns:a="http://schemas.openxmlformats.org/drawingml/2006/main"/>
           <a:p xmlns:a="http://schemas.openxmlformats.org/drawingml/2006/main">
             <a:r>
-              <a:t>Happiness, peace, contentment, and bliss are not passing moods, and they are not a fourth sequence after T1, T2, and T3.</a:t>
-            </a:r>
-          </a:p>
-          <a:p xmlns:a="http://schemas.openxmlformats.org/drawingml/2006/main">
-            <a:r>
-              <a:t>They name harmonies within jeevan. Happiness is harmony of mun and vritti — hope and thought. Peace is harmony of vritti and chitta — thought and desire. Contentment is harmony of chitta and buddhi — desire and resolve. Bliss is harmony of buddhi and atma — resolve and the core self.</a:t>
-            </a:r>
-          </a:p>
-          <a:p xmlns:a="http://schemas.openxmlformats.org/drawingml/2006/main">
-            <a:r>
-              <a:t>Evidenced outwardly, these harmonies support resolution, prosperity, fearlessness, and coexistence in human living.</a:t>
-            </a:r>
-          </a:p>
-          <a:p xmlns:a="http://schemas.openxmlformats.org/drawingml/2006/main">
-            <a:r>
-              <a:t>Karm Darshan puts the living cycle this way: reflection feeds projection, and projection feeds deeper reflection — this alone is what living means. Continuous happiness is harmony evidenced in resolved living, not a sensory spike.</a:t>
+              <a:t>Happiness, peace, contentment, and bliss are not passing moods, and they are not a fourth milestone after T1, T2, and T3.</a:t>
+            </a:r>
+          </a:p>
+          <a:p xmlns:a="http://schemas.openxmlformats.org/drawingml/2006/main">
+            <a:r>
+              <a:t>They name harmonies within the sentient unit. Happiness: harmony of hope and thought. Peace: thought and desire. Contentment: desire and resolve. Bliss: resolve and the core self.</a:t>
+            </a:r>
+          </a:p>
+          <a:p xmlns:a="http://schemas.openxmlformats.org/drawingml/2006/main">
+            <a:r>
+              <a:t>Evidenced outwardly, these support resolution, prosperity, fearlessness, and coexistence in human living.</a:t>
+            </a:r>
+          </a:p>
+          <a:p xmlns:a="http://schemas.openxmlformats.org/drawingml/2006/main">
+            <a:r>
+              <a:t>The living cycle is: reflection feeds projection, and projection feeds deeper reflection — that is what living means here. Continuous happiness is harmony evidenced in resolved living, not a sensory spike.</a:t>
             </a:r>
           </a:p>
         </p:txBody>
@@ -1472,7 +1462,7 @@
               <a:buNone/>
             </a:pPr>
             <a:r>
-              <a:t>Composition is not the same as development.</a:t>
+              <a:t>Composition is not the same as the developmental line that produces sentience.</a:t>
             </a:r>
           </a:p>
           <a:p xmlns:a="http://schemas.openxmlformats.org/drawingml/2006/main">
@@ -1482,12 +1472,12 @@
           </a:p>
           <a:p xmlns:a="http://schemas.openxmlformats.org/drawingml/2006/main">
             <a:r>
-              <a:t>In a mixture, components stay side by side and each maintains its own conduct — no new unit is formed. In a compound, definite proportion yields a new bounded unit, and its form, guna, svabhav, and dharma are evidenced in that new unit’s mutuality.</a:t>
-            </a:r>
-          </a:p>
-          <a:p xmlns:a="http://schemas.openxmlformats.org/drawingml/2006/main">
-            <a:r>
-              <a:t>Particles to molecules to cells and bodies is composition. Humane assemblies are relational achievements, not a further chemical tier. T1 occurs only when an atom reaches constitutional completeness. Insentient assemblies persist or decline according to whether constituent relationships are fulfilled.</a:t>
+              <a:t>In a mixture, components stay side by side — no new unit. In a compound, definite proportion yields a new bounded unit with its own form and capacities in mutuality.</a:t>
+            </a:r>
+          </a:p>
+          <a:p xmlns:a="http://schemas.openxmlformats.org/drawingml/2006/main">
+            <a:r>
+              <a:t>Particles to molecules to cells and bodies is composition. Humane assemblies are relational achievements, not a further chemical tier. Sentience arrives only when an atom reaches constitutional completeness. Non-sentient assemblies persist or decline according to whether constituent relationships are fulfilled.</a:t>
             </a:r>
           </a:p>
         </p:txBody>
@@ -1566,22 +1556,22 @@
               <a:buNone/>
             </a:pPr>
             <a:r>
-              <a:t>This slide explains the darshan’s name.</a:t>
-            </a:r>
-          </a:p>
-          <a:p xmlns:a="http://schemas.openxmlformats.org/drawingml/2006/main">
-            <a:r>
-              <a:t>Orderliness is self-regulation, inherent in saturated units — not dispensed by a cosmic governor. This mediative — madhyasth — regulation, which regulates and conserves every unit, gives Madhyasth Darshan its name.</a:t>
-            </a:r>
-          </a:p>
-          <a:p xmlns:a="http://schemas.openxmlformats.org/drawingml/2006/main">
-            <a:r>
-              <a:t>Conformance has order-specific modes. Material: result or structural conformance. Bio: seed-conformance. Animal: species-conformance, inherited from gestation. Human: learned conformance through understanding.</a:t>
-            </a:r>
-          </a:p>
-          <a:p xmlns:a="http://schemas.openxmlformats.org/drawingml/2006/main">
-            <a:r>
-              <a:t>Material, bio, and animal regulation is definite. An animal body’s expressive limits do not introduce mis-evaluation. In human living, jeevan can judge wrongly when delusion mistakes the body for the self. Awakening aligns evaluation and fulfilment with coexistence. That is why justice becomes necessary at the knowledge order.</a:t>
+              <a:t>This slide explains the name Madhyasth.</a:t>
+            </a:r>
+          </a:p>
+          <a:p xmlns:a="http://schemas.openxmlformats.org/drawingml/2006/main">
+            <a:r>
+              <a:t>Orderliness is self-regulation inherent in saturated units — not dispensed by a cosmic governor. That mediative regulation, which regulates and conserves every unit, gives the darshan its name.</a:t>
+            </a:r>
+          </a:p>
+          <a:p xmlns:a="http://schemas.openxmlformats.org/drawingml/2006/main">
+            <a:r>
+              <a:t>Conformance has order-specific modes. Material: structural or result conformance. Bio: seed-conformance. Animal: species-conformance, inherited from gestation. Human: learned conformance through understanding.</a:t>
+            </a:r>
+          </a:p>
+          <a:p xmlns:a="http://schemas.openxmlformats.org/drawingml/2006/main">
+            <a:r>
+              <a:t>Material, bio, and animal regulation is definite. An animal body’s expressive limits do not introduce evaluative error. In human living, the sentient unit can judge wrongly when it mistakes the body for the self. Awakening aligns evaluation with coexistence. That is why justice becomes necessary at the human order.</a:t>
             </a:r>
           </a:p>
         </p:txBody>
@@ -1651,32 +1641,27 @@
           <a:lstStyle xmlns:a="http://schemas.openxmlformats.org/drawingml/2006/main"/>
           <a:p xmlns:a="http://schemas.openxmlformats.org/drawingml/2006/main">
             <a:r>
-              <a:t>Before we enter the details, here is the map of the argument.</a:t>
-            </a:r>
-          </a:p>
-          <a:p xmlns:a="http://schemas.openxmlformats.org/drawingml/2006/main">
-            <a:r>
-              <a:t>One claim — existence is coexistence — will be carried through three movements.</a:t>
-            </a:r>
-          </a:p>
-          <a:p xmlns:a="http://schemas.openxmlformats.org/drawingml/2006/main">
-            <a:r>
-              <a:t>First: what is real, and how it is ordered. Coexistence is the bond of an all-pervasive ground and countable units. Each definite unit bears form, properties or guna, essential nature or svabhav, and dharma. Their expression becomes evident in mutuality across four orders of nature.</a:t>
-            </a:r>
-          </a:p>
-          <a:p xmlns:a="http://schemas.openxmlformats.org/drawingml/2006/main">
-            <a:r>
-              <a:t>Second: how two developmental lines proceed. One line is compositional: particles, atoms, molecules, cells, and bodies form larger configurations. The other is development in an atom, which can reach constitutional completeness as sentient jeevan. Across both lines, every activity is effort, motion, and result together.</a:t>
-            </a:r>
-          </a:p>
-          <a:p xmlns:a="http://schemas.openxmlformats.org/drawingml/2006/main">
-            <a:r>
-              <a:t>Third: how sentient living becomes awakened conduct — the human joint form of body and jeevan, the faculties and activities of jeevan, the four harmonies, evaluation, realisation, and participation in humane order.</a:t>
-            </a:r>
-          </a:p>
-          <a:p xmlns:a="http://schemas.openxmlformats.org/drawingml/2006/main">
-            <a:r>
-              <a:t>Please keep this distinction early: the body’s compositional line and jeevan’s atomic line meet in animal and human living, but they do not become the same process. That prevents the most common confusion — treating the body as the producer of sentience.</a:t>
+              <a:t>Before the details, here is the map of the argument. One claim — existence is coexistence — moves through three parts.</a:t>
+            </a:r>
+          </a:p>
+          <a:p xmlns:a="http://schemas.openxmlformats.org/drawingml/2006/main">
+            <a:r>
+              <a:t>First: what is real, and how it is ordered. There is an all-pervasive ground and countable units. Each unit has a definite form, capacities, a way of participating among others, and an inseparable innateness. These show up in mutual relations across four orders of nature.</a:t>
+            </a:r>
+          </a:p>
+          <a:p xmlns:a="http://schemas.openxmlformats.org/drawingml/2006/main">
+            <a:r>
+              <a:t>Second: how development proceeds along two lines that must not be collapsed. One line builds larger configurations — particles, molecules, cells, bodies. The other is development in an atom that can become a complete sentient unit. Across both, activity is effort, motion, and result together — not three separate steps.</a:t>
+            </a:r>
+          </a:p>
+          <a:p xmlns:a="http://schemas.openxmlformats.org/drawingml/2006/main">
+            <a:r>
+              <a:t>Third: how sentient living becomes awakened conduct — the human as a joint form of body and sentient unit; evaluation; realisation; and participation in humane order.</a:t>
+            </a:r>
+          </a:p>
+          <a:p xmlns:a="http://schemas.openxmlformats.org/drawingml/2006/main">
+            <a:r>
+              <a:t>Please keep one distinction early: the body line and the sentient-unit line meet in animal and human living, but they are not the same process. That blocks the most common confusion — treating the body as the producer of the knower.</a:t>
             </a:r>
           </a:p>
         </p:txBody>
@@ -1746,12 +1731,12 @@
           <a:lstStyle xmlns:a="http://schemas.openxmlformats.org/drawingml/2006/main"/>
           <a:p xmlns:a="http://schemas.openxmlformats.org/drawingml/2006/main">
             <a:r>
-              <a:t>Karm Darshan names six evaluative perspectives: pleasant, healthy, profit, justice, dharma, and truth. They widen from sensation, body, and gain to relationship, orderliness, and coexistence.</a:t>
-            </a:r>
-          </a:p>
-          <a:p xmlns:a="http://schemas.openxmlformats.org/drawingml/2006/main">
-            <a:r>
-              <a:t>Justice has a dual role: it is one of the six, and it is the principle of fulfilled relationship. Dharma here as an evaluative perspective means fitting the wider pattern — discipline in thought, not only in outer conduct. Truth means alignment with the whole, grounded in realisation, not in liking or gain.</a:t>
+              <a:t>Human evaluation widens across six perspectives: pleasant, healthy, profit, justice, innateness or dharma as an evaluative lens, and truth. They move from sensation, body, and gain to relationship, orderliness, and coexistence.</a:t>
+            </a:r>
+          </a:p>
+          <a:p xmlns:a="http://schemas.openxmlformats.org/drawingml/2006/main">
+            <a:r>
+              <a:t>Justice is both one of the six and the principle of fulfilled relationship. Dharma here means fitting the wider pattern — discipline in thought, not only outer conduct. Truth means alignment with the whole, grounded in realisation, not in liking or gain.</a:t>
             </a:r>
           </a:p>
           <a:p xmlns:a="http://schemas.openxmlformats.org/drawingml/2006/main">
@@ -1761,12 +1746,12 @@
           </a:p>
           <a:p xmlns:a="http://schemas.openxmlformats.org/drawingml/2006/main">
             <a:r>
-              <a:t>Pleasure, health, and profit are not condemned. They remain legitimate in their domain. Awakening changes the organising refuge: they are subordinated under justice, dharma, and truth, not abandoned.</a:t>
-            </a:r>
-          </a:p>
-          <a:p xmlns:a="http://schemas.openxmlformats.org/drawingml/2006/main">
-            <a:r>
-              <a:t>Keep this distinct from unit-dharma on the earlier slide. Unit-dharma is innateness. The dharma–adharma perspective is an evaluative lens on thought and resolution.</a:t>
+              <a:t>Pleasure, health, and profit are not condemned. They remain legitimate in their domain. Awakening changes the organising refuge: they are subordinated under justice, dharma, and truth — not abandoned.</a:t>
+            </a:r>
+          </a:p>
+          <a:p xmlns:a="http://schemas.openxmlformats.org/drawingml/2006/main">
+            <a:r>
+              <a:t>Keep this distinct from unit-innateness earlier. One word, two levels: what a unit cannot be separated from, versus how we evaluate thought and resolution.</a:t>
             </a:r>
           </a:p>
         </p:txBody>
@@ -1845,22 +1830,22 @@
               <a:buNone/>
             </a:pPr>
             <a:r>
-              <a:t>Here are two ladders that meet.</a:t>
-            </a:r>
-          </a:p>
-          <a:p xmlns:a="http://schemas.openxmlformats.org/drawingml/2006/main">
-            <a:r>
-              <a:t>On the left: what must be understood, as mutual context widens. Form is real structure reflected in mutual facing. Guna is effects evident in definite mutuality. Svabhav is usefulness within state, plane, and order. Dharma is innateness evidenced in whole-order fulfilment. Relationships are shared expectations weighed by justice, dharma, and truth. At the top is coexistence itself — the telos of knowing. This is not a climb away from the unit; it is a widening of the context in which a real unit is understood.</a:t>
-            </a:r>
-          </a:p>
-          <a:p xmlns:a="http://schemas.openxmlformats.org/drawingml/2006/main">
-            <a:r>
-              <a:t>On the right: how knowing happens within jeevan. Hope tastes and selects. Thought deliberates and analyses. Desire contemplates and visualises. Resolve receives enlightenment and resolves. The core self realises — and realisation takes place through truth. When each level is acted in alignment, it is felt as happiness, peace, contentment, and bliss.</a:t>
-            </a:r>
-          </a:p>
-          <a:p xmlns:a="http://schemas.openxmlformats.org/drawingml/2006/main">
-            <a:r>
-              <a:t>The ladders meet at the top: coexistence known and acted in the core self is felt as bliss. Human error belongs to deluded evaluation, not to indeterminacy in the reality reflected.</a:t>
+              <a:t>We turn now to knowing — how understanding widens, and how it happens in the sentient unit.</a:t>
+            </a:r>
+          </a:p>
+          <a:p xmlns:a="http://schemas.openxmlformats.org/drawingml/2006/main">
+            <a:r>
+              <a:t>On the left: what must be understood as mutual context widens. Form is real structure encountered in mutual facing. Capacities show as effects between units. Essential nature needs state, order, and context. Innateness is evidenced in whole-order fulfilment. Relationships are shared expectations weighed by justice, dharma, and truth. At the top is coexistence itself — not another observed detail, but the aim of knowing.</a:t>
+            </a:r>
+          </a:p>
+          <a:p xmlns:a="http://schemas.openxmlformats.org/drawingml/2006/main">
+            <a:r>
+              <a:t>On the right: how knowing happens within the sentient unit. Hope tastes and selects. Thought deliberates. Desire contemplates. Resolve clarifies and resolves. The core self realises — through truth. When each level is acted in alignment, it is felt as happiness, peace, contentment, and bliss.</a:t>
+            </a:r>
+          </a:p>
+          <a:p xmlns:a="http://schemas.openxmlformats.org/drawingml/2006/main">
+            <a:r>
+              <a:t>The ladders meet at the top: coexistence known and lived is felt as bliss. Human error belongs to confused evaluation, not to fuzziness in the reality reflected.</a:t>
             </a:r>
           </a:p>
         </p:txBody>
@@ -1939,32 +1924,32 @@
               <a:buNone/>
             </a:pPr>
             <a:r>
-              <a:t>Madhyasth Darshan uses several modes of warrant. They can support one another, but they do not establish the same thing.</a:t>
-            </a:r>
-          </a:p>
-          <a:p xmlns:a="http://schemas.openxmlformats.org/drawingml/2006/main">
-            <a:r>
-              <a:t>Logical exposition can establish internal coherence and entailment. It cannot by itself establish empirical truth.</a:t>
-            </a:r>
-          </a:p>
-          <a:p xmlns:a="http://schemas.openxmlformats.org/drawingml/2006/main">
-            <a:r>
-              <a:t>Study and self-examination can establish intelligibility and first-person recognition. They cannot by themselves physically identify jeevan.</a:t>
-            </a:r>
-          </a:p>
-          <a:p xmlns:a="http://schemas.openxmlformats.org/drawingml/2006/main">
-            <a:r>
-              <a:t>Experiment, practice, and conduct-evidence can establish effects in work, behaviour, and mutual satisfaction. They cannot by themselves measure T1 or the jeevan–body interface.</a:t>
-            </a:r>
-          </a:p>
-          <a:p xmlns:a="http://schemas.openxmlformats.org/drawingml/2006/main">
-            <a:r>
-              <a:t>Realisation is the darshan’s claimed completion of knowing. It does not force agreement from other methods.</a:t>
-            </a:r>
-          </a:p>
-          <a:p xmlns:a="http://schemas.openxmlformats.org/drawingml/2006/main">
-            <a:r>
-              <a:t>Publicly measurable physical claims remain answerable to instrument-based scientific inquiry. No accepted measurement procedure currently identifies T1, the jeevan–body interface, or post-body reassociation. Stating that plainly is part of responsible presentation.</a:t>
+              <a:t>Different methods establish different things. They can support one another, but they are not interchangeable.</a:t>
+            </a:r>
+          </a:p>
+          <a:p xmlns:a="http://schemas.openxmlformats.org/drawingml/2006/main">
+            <a:r>
+              <a:t>Logical exposition can show internal coherence. It cannot by itself prove empirical fact.</a:t>
+            </a:r>
+          </a:p>
+          <a:p xmlns:a="http://schemas.openxmlformats.org/drawingml/2006/main">
+            <a:r>
+              <a:t>Study and self-examination can show intelligibility and first-person recognition. They cannot by themselves physically identify the sentient unit.</a:t>
+            </a:r>
+          </a:p>
+          <a:p xmlns:a="http://schemas.openxmlformats.org/drawingml/2006/main">
+            <a:r>
+              <a:t>Practice and conduct-evidence can show effects in work, behaviour, and mutual satisfaction. They cannot by themselves measure T1 or the unit–body interface.</a:t>
+            </a:r>
+          </a:p>
+          <a:p xmlns:a="http://schemas.openxmlformats.org/drawingml/2006/main">
+            <a:r>
+              <a:t>Realisation is this tradition’s claimed completion of knowing. It does not force agreement from other methods.</a:t>
+            </a:r>
+          </a:p>
+          <a:p xmlns:a="http://schemas.openxmlformats.org/drawingml/2006/main">
+            <a:r>
+              <a:t>Publicly measurable physical claims remain answerable to instrument-based science. No accepted measurement currently identifies T1, the unit–body interface, or post-body reassociation. Stating that plainly is part of responsible presentation.</a:t>
             </a:r>
           </a:p>
         </p:txBody>
@@ -2034,27 +2019,27 @@
           <a:lstStyle xmlns:a="http://schemas.openxmlformats.org/drawingml/2006/main"/>
           <a:p xmlns:a="http://schemas.openxmlformats.org/drawingml/2006/main">
             <a:r>
-              <a:t>Every jeevan bears the same five faculties and ten activities. In human living they answer one question — what makes me happy? — by organising in one of two ways.</a:t>
-            </a:r>
-          </a:p>
-          <a:p xmlns:a="http://schemas.openxmlformats.org/drawingml/2006/main">
-            <a:r>
-              <a:t>Under delusion, body-identification leaves sensitivity unguided by cognisance. Selection and evaluation remain organised around pleasure, health, and profit.</a:t>
-            </a:r>
-          </a:p>
-          <a:p xmlns:a="http://schemas.openxmlformats.org/drawingml/2006/main">
-            <a:r>
-              <a:t>Under awakening, cognisance regulates sensitivity. Knowing and believing guide recognition and fulfilment toward justice, dharma, truth, and coexistence.</a:t>
-            </a:r>
-          </a:p>
-          <a:p xmlns:a="http://schemas.openxmlformats.org/drawingml/2006/main">
-            <a:r>
-              <a:t>No faculty is absent, and sensitivity is not rejected. Delusion lets sensory criteria rule; awakening balances sensitivity with cognisance, so understanding guides conduct.</a:t>
-            </a:r>
-          </a:p>
-          <a:p xmlns:a="http://schemas.openxmlformats.org/drawingml/2006/main">
-            <a:r>
-              <a:t>When the same fork is resolved in the individual and sustained across a tradition, it is evidenced as resolution, prosperity, fearlessness, and coexistence.</a:t>
+              <a:t>Every sentient unit bears the same faculties. In human living they answer one practical question — what makes me happy? — by organising in one of two ways.</a:t>
+            </a:r>
+          </a:p>
+          <a:p xmlns:a="http://schemas.openxmlformats.org/drawingml/2006/main">
+            <a:r>
+              <a:t>Under confusion, the body is mistaken for the self. Selection and evaluation organise around pleasure, health, and profit.</a:t>
+            </a:r>
+          </a:p>
+          <a:p xmlns:a="http://schemas.openxmlformats.org/drawingml/2006/main">
+            <a:r>
+              <a:t>Under awakening, clear knowing regulates sensory life. Knowing and believing guide recognition and fulfilment toward justice, innateness, truth, and coexistence.</a:t>
+            </a:r>
+          </a:p>
+          <a:p xmlns:a="http://schemas.openxmlformats.org/drawingml/2006/main">
+            <a:r>
+              <a:t>No faculty is missing, and sensation is not rejected. Confusion lets sensory criteria rule; awakening balances sensation with understanding, so understanding guides conduct.</a:t>
+            </a:r>
+          </a:p>
+          <a:p xmlns:a="http://schemas.openxmlformats.org/drawingml/2006/main">
+            <a:r>
+              <a:t>When the same fork is resolved in a person and sustained across a tradition, it shows as resolution, prosperity, fearlessness, and coexistence.</a:t>
             </a:r>
           </a:p>
         </p:txBody>
@@ -2133,27 +2118,22 @@
               <a:buNone/>
             </a:pPr>
             <a:r>
-              <a:t>This is where the completeness drive terminates: realisation in coexistence.</a:t>
-            </a:r>
-          </a:p>
-          <a:p xmlns:a="http://schemas.openxmlformats.org/drawingml/2006/main">
-            <a:r>
-              <a:t>Realisation coordinates three distinct roles: jeevan remains the knower, existence as coexistence remains the known, and threefold knowledge becomes evident through humane conduct.</a:t>
-            </a:r>
-          </a:p>
-          <a:p xmlns:a="http://schemas.openxmlformats.org/drawingml/2006/main">
-            <a:r>
-              <a:t>Realisation is bliss. Truth itself is abundance — coexistence; realisation of abundance itself is bliss; bliss itself is jeevan. And realisation is knowledge itself, because what is realised is the ground the unit was always soaked in.</a:t>
-            </a:r>
-          </a:p>
-          <a:p xmlns:a="http://schemas.openxmlformats.org/drawingml/2006/main">
-            <a:r>
-              <a:t>Threefold knowledge comprises the holistic view of coexistence, knowledge of jeevan, and knowledge of humane conduct. Projection makes that understanding evident as authenticity.</a:t>
-            </a:r>
-          </a:p>
-          <a:p xmlns:a="http://schemas.openxmlformats.org/drawingml/2006/main">
-            <a:r>
-              <a:t>Jeevan remains the knower and seer. Realisation clarifies its own nature and the coexistence in which it participates; it does not dissolve the individual unit. The known is existence as coexistence: Omnipresence and real units in mutuality. Knowledge, knower, and known become coherent without becoming identical. That guardrail is decisive against reading satta as a universal knowing Self.</a:t>
+              <a:t>This is where the developmental drive comes to rest: realisation in coexistence.</a:t>
+            </a:r>
+          </a:p>
+          <a:p xmlns:a="http://schemas.openxmlformats.org/drawingml/2006/main">
+            <a:r>
+              <a:t>The drive settles when relationships across nature are fulfilled and made evident — not because the ground becomes a knower, but because the awakened sentient unit realises and evidences the coexistence in which it has always existed.</a:t>
+            </a:r>
+          </a:p>
+          <a:p xmlns:a="http://schemas.openxmlformats.org/drawingml/2006/main">
+            <a:r>
+              <a:t>Realisation is bliss. Truth itself is abundance — coexistence; realisation of abundance is bliss; bliss is the living of the sentient unit. What is realised is the ground the unit was always saturated in.</a:t>
+            </a:r>
+          </a:p>
+          <a:p xmlns:a="http://schemas.openxmlformats.org/drawingml/2006/main">
+            <a:r>
+              <a:t>Three roles stay distinct: the sentient unit remains the knower; existence as coexistence remains the known; knowledge becomes evident as authentic conduct. They become coherent without becoming identical. The individual knower is not dissolved into a single universal Self.</a:t>
             </a:r>
           </a:p>
         </p:txBody>
@@ -2232,27 +2212,27 @@
               <a:buNone/>
             </a:pPr>
             <a:r>
-              <a:t>The drive toward completeness comes to rest in awakened human beings — effort settled, understanding proven in daily conduct, and sustained through a human tradition.</a:t>
-            </a:r>
-          </a:p>
-          <a:p xmlns:a="http://schemas.openxmlformats.org/drawingml/2006/main">
-            <a:r>
-              <a:t>Effort settled in realisation is T2. Understanding proven in daily conduct is T3.</a:t>
-            </a:r>
-          </a:p>
-          <a:p xmlns:a="http://schemas.openxmlformats.org/drawingml/2006/main">
-            <a:r>
-              <a:t>The four goals land at four levels: resolution in every person; prosperity in every family; fearlessness — trust — in society; and coexistence with all of nature.</a:t>
-            </a:r>
-          </a:p>
-          <a:p xmlns:a="http://schemas.openxmlformats.org/drawingml/2006/main">
-            <a:r>
-              <a:t>Five dimensions of continuity carry the tradition: education and sanskar; justice and preservation; health and restraint; production and work; exchange and storage.</a:t>
-            </a:r>
-          </a:p>
-          <a:p xmlns:a="http://schemas.openxmlformats.org/drawingml/2006/main">
-            <a:r>
-              <a:t>This is not an ideal bolted onto matter. On Madhyasth Darshan’s account, the ontology is such that the progression is designed to arrive here. Nature saturated in Omnipresence is bound for development until realisation. An awakened human tradition is what that progression delivers: what is saturated in the ground has come to realise the ground, and nature stands fulfilled and evident in coexistence.</a:t>
+              <a:t>The drive comes to rest in awakened human beings — effort settled, understanding proven in daily conduct, and carried as a tradition.</a:t>
+            </a:r>
+          </a:p>
+          <a:p xmlns:a="http://schemas.openxmlformats.org/drawingml/2006/main">
+            <a:r>
+              <a:t>Effort settled in realisation is T2. Understanding proven in conduct is T3.</a:t>
+            </a:r>
+          </a:p>
+          <a:p xmlns:a="http://schemas.openxmlformats.org/drawingml/2006/main">
+            <a:r>
+              <a:t>Four goals at four levels: resolution in every person; prosperity in every family; fearlessness — trust — in society; coexistence with all of nature.</a:t>
+            </a:r>
+          </a:p>
+          <a:p xmlns:a="http://schemas.openxmlformats.org/drawingml/2006/main">
+            <a:r>
+              <a:t>Five dimensions of continuity carry the tradition: education and formative culture; justice and preservation; health and restraint; production and work; exchange and storage.</a:t>
+            </a:r>
+          </a:p>
+          <a:p xmlns:a="http://schemas.openxmlformats.org/drawingml/2006/main">
+            <a:r>
+              <a:t>This is not an ideal bolted onto matter. On this account, the progression is designed to arrive here. Nature saturated in Omnipresence is bound for development until realisation. An awakened human tradition is what that progression delivers.</a:t>
             </a:r>
           </a:p>
         </p:txBody>
@@ -2331,7 +2311,7 @@
               <a:buNone/>
             </a:pPr>
             <a:r>
-              <a:t>Let us close the loop and answer the six questions we opened with.</a:t>
+              <a:t>Let us close the loop on the six questions.</a:t>
             </a:r>
           </a:p>
           <a:p xmlns:a="http://schemas.openxmlformats.org/drawingml/2006/main">
@@ -2341,7 +2321,7 @@
           </a:p>
           <a:p xmlns:a="http://schemas.openxmlformats.org/drawingml/2006/main">
             <a:r>
-              <a:t>What exists? Root atomic units; composite units and bodies; body–jeevan joint forms; and relational human assemblies — all saturated in the ground.</a:t>
+              <a:t>What exists? Root atomic units; composite units and bodies; body–sentient-unit joint forms; and relational human assemblies — all saturated in the ground.</a:t>
             </a:r>
           </a:p>
           <a:p xmlns:a="http://schemas.openxmlformats.org/drawingml/2006/main">
@@ -2351,7 +2331,7 @@
           </a:p>
           <a:p xmlns:a="http://schemas.openxmlformats.org/drawingml/2006/main">
             <a:r>
-              <a:t>What is the self? Jeevan: a constitutionally complete sentient atom working through the body.</a:t>
+              <a:t>What is the self? The constitutionally complete sentient unit working through the body.</a:t>
             </a:r>
           </a:p>
           <a:p xmlns:a="http://schemas.openxmlformats.org/drawingml/2006/main">
@@ -2361,17 +2341,12 @@
           </a:p>
           <a:p xmlns:a="http://schemas.openxmlformats.org/drawingml/2006/main">
             <a:r>
-              <a:t>How is it known? Through logical exposition, study and self-examination, practice, realisation, and conduct-evidence. Measurable physical claims still require instrument-based testing. These evidence modes should not be conflated.</a:t>
-            </a:r>
-          </a:p>
-          <a:p xmlns:a="http://schemas.openxmlformats.org/drawingml/2006/main">
-            <a:r>
-              <a:t>Fulfilment is resolution and authenticity expressed as humane conduct and participation in orderliness. The ultimate test is pramanikta — lived evidence.</a:t>
-            </a:r>
-          </a:p>
-          <a:p xmlns:a="http://schemas.openxmlformats.org/drawingml/2006/main">
-            <a:r>
-              <a:t>If we continue in a companion session, the natural next step is to place this ontology beside Advaita Vedanta, modern philosophy, and modern science — including the open problems the study names for Madhyasth Darshan itself. Thank you.</a:t>
+              <a:t>How is it known? Through logical exposition, study and self-examination, practice, realisation, and conduct-evidence — without conflating those with instrument measurement of T1. The lived test is evidence in humane conduct.</a:t>
+            </a:r>
+          </a:p>
+          <a:p xmlns:a="http://schemas.openxmlformats.org/drawingml/2006/main">
+            <a:r>
+              <a:t>If we continue later, the natural next step is comparison with other traditions and with science — including open problems this study names for Madhyasth Darshan itself. Thank you.</a:t>
             </a:r>
           </a:p>
         </p:txBody>
@@ -2450,7 +2425,7 @@
               <a:buNone/>
             </a:pPr>
             <a:r>
-              <a:t>Every serious ontology has to answer a small set of framing questions. Let us name them before we give Madhyasth Darshan’s answers.</a:t>
+              <a:t>Any serious account of reality has to face a small set of questions. Let us name them before we give this tradition’s answers.</a:t>
             </a:r>
           </a:p>
           <a:p xmlns:a="http://schemas.openxmlformats.org/drawingml/2006/main">
@@ -2460,37 +2435,37 @@
           </a:p>
           <a:p xmlns:a="http://schemas.openxmlformats.org/drawingml/2006/main">
             <a:r>
-              <a:t>What exists? What are the basic constituents of reality, and what is each of them?</a:t>
-            </a:r>
-          </a:p>
-          <a:p xmlns:a="http://schemas.openxmlformats.org/drawingml/2006/main">
-            <a:r>
-              <a:t>Does what exists begin? Did reality originate at some time — or is origination only of configurations?</a:t>
-            </a:r>
-          </a:p>
-          <a:p xmlns:a="http://schemas.openxmlformats.org/drawingml/2006/main">
-            <a:r>
-              <a:t>Does the self begin or end with the body? Is the individual self, jeevan, produced by the body and destroyed with it?</a:t>
-            </a:r>
-          </a:p>
-          <a:p xmlns:a="http://schemas.openxmlformats.org/drawingml/2006/main">
-            <a:r>
-              <a:t>Is the world finally real? Is the plural world of units an appearance, or real in its own right?</a:t>
-            </a:r>
-          </a:p>
-          <a:p xmlns:a="http://schemas.openxmlformats.org/drawingml/2006/main">
-            <a:r>
-              <a:t>And sixth: how can what exists be known? What must be understood — and at what scope — to know each aspect of reality?</a:t>
-            </a:r>
-          </a:p>
-          <a:p xmlns:a="http://schemas.openxmlformats.org/drawingml/2006/main">
-            <a:r>
-              <a:t>Traditions diverge sharply on these questions — Advaita Vedanta, Western philosophy, and modern science among them. Madhyasth Darshan does not answer them piecemeal. One picture — coexistence — answers all six at once.</a:t>
-            </a:r>
-          </a:p>
-          <a:p xmlns:a="http://schemas.openxmlformats.org/drawingml/2006/main">
-            <a:r>
-              <a:t>Later we will see how knowing widens on the epistemic ladder, where the drive terminates in realisation, and how method and evidence are distinguished. At the end we will return to this same list with the answers filled in.</a:t>
+              <a:t>What exists? What are the basic constituents, and what is each of them?</a:t>
+            </a:r>
+          </a:p>
+          <a:p xmlns:a="http://schemas.openxmlformats.org/drawingml/2006/main">
+            <a:r>
+              <a:t>Does what exists begin? Did reality originate at some time — or do only configurations begin and end?</a:t>
+            </a:r>
+          </a:p>
+          <a:p xmlns:a="http://schemas.openxmlformats.org/drawingml/2006/main">
+            <a:r>
+              <a:t>Does the self begin or end with the body?</a:t>
+            </a:r>
+          </a:p>
+          <a:p xmlns:a="http://schemas.openxmlformats.org/drawingml/2006/main">
+            <a:r>
+              <a:t>Is the plural world finally real, or only an appearance?</a:t>
+            </a:r>
+          </a:p>
+          <a:p xmlns:a="http://schemas.openxmlformats.org/drawingml/2006/main">
+            <a:r>
+              <a:t>And sixth: how can what exists be known — what must be understood, and at what scope?</a:t>
+            </a:r>
+          </a:p>
+          <a:p xmlns:a="http://schemas.openxmlformats.org/drawingml/2006/main">
+            <a:r>
+              <a:t>Different traditions answer these differently. Madhyasth Darshan does not answer them with six separate doctrines. One picture — coexistence — is meant to answer all six at once.</a:t>
+            </a:r>
+          </a:p>
+          <a:p xmlns:a="http://schemas.openxmlformats.org/drawingml/2006/main">
+            <a:r>
+              <a:t>We will return to this list at the end with the answers filled in. Along the way you will also see how knowing widens, where the developmental drive comes to rest, and how different kinds of evidence are kept distinct.</a:t>
             </a:r>
           </a:p>
         </p:txBody>
@@ -2569,27 +2544,27 @@
               <a:buNone/>
             </a:pPr>
             <a:r>
-              <a:t>This conceptual map is the organising view of Section 1.</a:t>
-            </a:r>
-          </a:p>
-          <a:p xmlns:a="http://schemas.openxmlformats.org/drawingml/2006/main">
-            <a:r>
-              <a:t>Begin at the top with coexistence: Omnipresence and countless units are inseparable, yet they do not lose their distinction. Then follow the unit side: four aspects, relationships, four orders, and two developmental lines.</a:t>
-            </a:r>
-          </a:p>
-          <a:p xmlns:a="http://schemas.openxmlformats.org/drawingml/2006/main">
-            <a:r>
-              <a:t>Notice the fork. The body belongs to compositional progression. Jeevan is the result of development in an atom. The two meet in the animal and human joint form.</a:t>
-            </a:r>
-          </a:p>
-          <a:p xmlns:a="http://schemas.openxmlformats.org/drawingml/2006/main">
-            <a:r>
-              <a:t>T1 marks the arrival of sentience. T2 and T3 concern awakening and conduct in jeevan — they are not further material stages.</a:t>
-            </a:r>
-          </a:p>
-          <a:p xmlns:a="http://schemas.openxmlformats.org/drawingml/2006/main">
-            <a:r>
-              <a:t>When later slides feel dense, return mentally to this map. Most of what follows is a zoom into one node of this picture.</a:t>
+              <a:t>This map is the organising picture for what follows. You do not need to memorise every node. Use it as a place to return when later slides feel dense.</a:t>
+            </a:r>
+          </a:p>
+          <a:p xmlns:a="http://schemas.openxmlformats.org/drawingml/2006/main">
+            <a:r>
+              <a:t>At the top: coexistence — the ground and countless units, inseparable without losing their distinction. Then, on the unit side: four aspects of every unit; relationships; four orders of nature; and two developmental lines.</a:t>
+            </a:r>
+          </a:p>
+          <a:p xmlns:a="http://schemas.openxmlformats.org/drawingml/2006/main">
+            <a:r>
+              <a:t>Notice the fork. Bodies belong to compositional building. The sentient unit is the result of a different line — development in an atom. The two meet in animal and human living.</a:t>
+            </a:r>
+          </a:p>
+          <a:p xmlns:a="http://schemas.openxmlformats.org/drawingml/2006/main">
+            <a:r>
+              <a:t>Later we will name three milestones on the sentient path: the arrival of sentience, then settlement of inner seeking, then authentic conduct. Those are not further material stages.</a:t>
+            </a:r>
+          </a:p>
+          <a:p xmlns:a="http://schemas.openxmlformats.org/drawingml/2006/main">
+            <a:r>
+              <a:t>Most of the deck is a zoom into one region of this map.</a:t>
             </a:r>
           </a:p>
         </p:txBody>
@@ -2668,32 +2643,37 @@
               <a:buNone/>
             </a:pPr>
             <a:r>
-              <a:t>This is the foundation.</a:t>
-            </a:r>
-          </a:p>
-          <a:p xmlns:a="http://schemas.openxmlformats.org/drawingml/2006/main">
-            <a:r>
-              <a:t>Existence has two inseparable aspects. The first is Omnipresence — satta. It is formless, all-pervasive, non-transforming, and immeasurable. It is actionless energy. It performs no actions, yet every unit is energised, regulated, and conserved in it. There is no place where it is absent.</a:t>
-            </a:r>
-          </a:p>
-          <a:p xmlns:a="http://schemas.openxmlformats.org/drawingml/2006/main">
-            <a:r>
-              <a:t>The second aspect is units of nature. They are formful, active, and countable. Each is bounded from six directions and saturated in Omnipresence. Each bears form, guna, svabhav, and dharma, whose expression is evident in definite mutuality.</a:t>
-            </a:r>
-          </a:p>
-          <a:p xmlns:a="http://schemas.openxmlformats.org/drawingml/2006/main">
-            <a:r>
-              <a:t>Do not collapse levels. At the root, nature is analysed as atomic units — a centre with orbiting parts. Compounds and bodies are composite units. Body and jeevan together are a joint form. Families and societies are relational assemblies.</a:t>
-            </a:r>
-          </a:p>
-          <a:p xmlns:a="http://schemas.openxmlformats.org/drawingml/2006/main">
-            <a:r>
-              <a:t>These two poles were never separate. Separation of a unit from the saturated whole never happens. The ground is state-complete — without motion, wave, or pressure. Nature saturated in it is state-dynamic. Therefore all change is unit-activity.</a:t>
-            </a:r>
-          </a:p>
-          <a:p xmlns:a="http://schemas.openxmlformats.org/drawingml/2006/main">
-            <a:r>
-              <a:t>One caution on names. The texts list many English names for satta — Uniform Energy, Space, Knowledge, Consciousness, Omnipresence, Eternity, God, Absolute Energy. When you hear Knowledge or Consciousness in that list, do not hear a mind that knows. Active sentience belongs to jeevan, the sentient unit — never to the ground.</a:t>
+              <a:t>We now enter the foundations — what this account says exists.</a:t>
+            </a:r>
+          </a:p>
+          <a:p xmlns:a="http://schemas.openxmlformats.org/drawingml/2006/main">
+            <a:r>
+              <a:t>Existence has two inseparable aspects.</a:t>
+            </a:r>
+          </a:p>
+          <a:p xmlns:a="http://schemas.openxmlformats.org/drawingml/2006/main">
+            <a:r>
+              <a:t>First, the ground — Omnipresence. Formless, all-pervasive, non-transforming, immeasurable. Actionless energy: it performs no actions, yet every unit is energised, regulated, and conserved in it. There is no place where it is absent.</a:t>
+            </a:r>
+          </a:p>
+          <a:p xmlns:a="http://schemas.openxmlformats.org/drawingml/2006/main">
+            <a:r>
+              <a:t>Second, units of nature. Formful, active, countable. Each is bounded and saturated in the ground. Each has form, capacities, a way of participating, and an inseparable innateness — we will walk those four shortly.</a:t>
+            </a:r>
+          </a:p>
+          <a:p xmlns:a="http://schemas.openxmlformats.org/drawingml/2006/main">
+            <a:r>
+              <a:t>Do not collapse levels. At the root, nature is analysed as atomic units — a centre with orbiting parts. Compounds and bodies are composite units. Body and sentient unit together are a joint form. Families and societies are relational assemblies.</a:t>
+            </a:r>
+          </a:p>
+          <a:p xmlns:a="http://schemas.openxmlformats.org/drawingml/2006/main">
+            <a:r>
+              <a:t>These two poles were never separate. Separation of a unit from the saturated whole never happens. The ground does not change. Nature saturated in it is dynamic. Therefore all change is unit-activity.</a:t>
+            </a:r>
+          </a:p>
+          <a:p xmlns:a="http://schemas.openxmlformats.org/drawingml/2006/main">
+            <a:r>
+              <a:t>One naming caution. The texts list many English names for the ground — including Knowledge and Consciousness. Those names do not mean a mind that knows. Active knowing belongs to the sentient unit, never to the ground.</a:t>
             </a:r>
           </a:p>
         </p:txBody>
@@ -2772,32 +2752,32 @@
               <a:buNone/>
             </a:pPr>
             <a:r>
-              <a:t>How exactly are ground and units related? Through saturation — samprikt.</a:t>
-            </a:r>
-          </a:p>
-          <a:p xmlns:a="http://schemas.openxmlformats.org/drawingml/2006/main">
-            <a:r>
-              <a:t>Every formful unit is soaked, submerged, and surrounded in Omnipresence. From this ever-present bond, Madhyasth Darshan says three endowments are evident on the unit side.</a:t>
-            </a:r>
-          </a:p>
-          <a:p xmlns:a="http://schemas.openxmlformats.org/drawingml/2006/main">
-            <a:r>
-              <a:t>First, recognition capability. Complementarity is given in coexistence; it is not created by us. In insentient nature, reflection, recognition, and fulfilment occur definitely through the unit’s capacity, ability, and receptivity. No human observer is required.</a:t>
-            </a:r>
-          </a:p>
-          <a:p xmlns:a="http://schemas.openxmlformats.org/drawingml/2006/main">
-            <a:r>
-              <a:t>Second, activeness. The texts say: unit plus energy fullness equals activeness. Inherent energy and basic impulsion make the unit active, appearing as the inseparable triad of effort, motion, and result.</a:t>
-            </a:r>
-          </a:p>
-          <a:p xmlns:a="http://schemas.openxmlformats.org/drawingml/2006/main">
-            <a:r>
-              <a:t>Third, inherent regulation — orderliness within the unit’s participation in coexistence: mediative and conserving, not an external statutory command.</a:t>
-            </a:r>
-          </a:p>
-          <a:p xmlns:a="http://schemas.openxmlformats.org/drawingml/2006/main">
-            <a:r>
-              <a:t>Please hear the caution on the slide. This is an ontological entailment, not a proposed measurable transfer mechanism. And not every unit progresses to constitutional completeness. Omnipresence does not push units from outside.</a:t>
+              <a:t>How are ground and units related? Through saturation: every formful unit is soaked, submerged, and surrounded in Omnipresence.</a:t>
+            </a:r>
+          </a:p>
+          <a:p xmlns:a="http://schemas.openxmlformats.org/drawingml/2006/main">
+            <a:r>
+              <a:t>From that ever-present bond, three endowments show on the unit side.</a:t>
+            </a:r>
+          </a:p>
+          <a:p xmlns:a="http://schemas.openxmlformats.org/drawingml/2006/main">
+            <a:r>
+              <a:t>First, recognition capability. Complementarity is given in coexistence; it is not invented by us. Even in non-sentient nature, units respond to one another definitely — no human observer required.</a:t>
+            </a:r>
+          </a:p>
+          <a:p xmlns:a="http://schemas.openxmlformats.org/drawingml/2006/main">
+            <a:r>
+              <a:t>Second, activeness. Unit plus energy fullness equals activeness. Inherent energy and basic impulsion appear as effort, motion, and result together.</a:t>
+            </a:r>
+          </a:p>
+          <a:p xmlns:a="http://schemas.openxmlformats.org/drawingml/2006/main">
+            <a:r>
+              <a:t>Third, inherent regulation — orderliness from within participation in coexistence; mediative and conserving, not a statute from outside.</a:t>
+            </a:r>
+          </a:p>
+          <a:p xmlns:a="http://schemas.openxmlformats.org/drawingml/2006/main">
+            <a:r>
+              <a:t>Please hear the caution: this is a claim about what existence is like, not a proposed laboratory transfer mechanism. And not every unit progresses to sentient completeness. The ground does not push units from outside.</a:t>
             </a:r>
           </a:p>
         </p:txBody>
@@ -2876,12 +2856,7 @@
               <a:buNone/>
             </a:pPr>
             <a:r>
-              <a:t>What is every unit? Four inseparable aspects — but not a static checklist pasted onto things.</a:t>
-            </a:r>
-          </a:p>
-          <a:p xmlns:a="http://schemas.openxmlformats.org/drawingml/2006/main">
-            <a:r>
-              <a:t>The bearer is definite: a bounded unit with constitution, state, order, and capacities.</a:t>
+              <a:t>What is every unit? Four inseparable aspects — not a static checklist pasted onto things, but how a definite bearer shows up in the world.</a:t>
             </a:r>
           </a:p>
           <a:p xmlns:a="http://schemas.openxmlformats.org/drawingml/2006/main">
@@ -2891,27 +2866,27 @@
           </a:p>
           <a:p xmlns:a="http://schemas.openxmlformats.org/drawingml/2006/main">
             <a:r>
-              <a:t>Properties — guna — are capacity and relative effect. In the peepal: nutrition, growth, repair, seed production, and degeneration become evident under definite conditions.</a:t>
-            </a:r>
-          </a:p>
-          <a:p xmlns:a="http://schemas.openxmlformats.org/drawingml/2006/main">
-            <a:r>
-              <a:t>Essential nature — svabhav — is usefulness in context. For the peepal: vitalising while its living organisation is maintained; devitalising when that organisation breaks down.</a:t>
-            </a:r>
-          </a:p>
-          <a:p xmlns:a="http://schemas.openxmlformats.org/drawingml/2006/main">
-            <a:r>
-              <a:t>Dharma is innateness and order-specific fulfilment. The peepal has existence plus growth. Seed-conformance is its mode of conduct, not an extra dharma piled on top.</a:t>
-            </a:r>
-          </a:p>
-          <a:p xmlns:a="http://schemas.openxmlformats.org/drawingml/2006/main">
-            <a:r>
-              <a:t>Form is real; what another unit encounters is its definite reflection in mutual facing. In insentient nature these aspects are definite. Mis-evaluation arises only in human living, when jeevan under delusion takes the body to be the self.</a:t>
-            </a:r>
-          </a:p>
-          <a:p xmlns:a="http://schemas.openxmlformats.org/drawingml/2006/main">
-            <a:r>
-              <a:t>And notice the persistence note: the tree as a composite form can die and decompose, while its constituent material units persist and enter other compositions. Persistence of existence is not persistence of one configuration.</a:t>
+              <a:t>Properties — capacities and relative effects. In the peepal: nutrition, growth, repair, seed production, degeneration under definite conditions.</a:t>
+            </a:r>
+          </a:p>
+          <a:p xmlns:a="http://schemas.openxmlformats.org/drawingml/2006/main">
+            <a:r>
+              <a:t>Essential nature is usefulness in context: vitalising while the living organisation holds; devitalising when it breaks down.</a:t>
+            </a:r>
+          </a:p>
+          <a:p xmlns:a="http://schemas.openxmlformats.org/drawingml/2006/main">
+            <a:r>
+              <a:t>Innateness — dharma in this technical sense — is what cannot be separated from the unit, plus order-specific fulfilment. For the peepal: existence plus growth. Seed-conformance is how it conducts itself, not an extra label piled on top.</a:t>
+            </a:r>
+          </a:p>
+          <a:p xmlns:a="http://schemas.openxmlformats.org/drawingml/2006/main">
+            <a:r>
+              <a:t>Form is real; what another unit encounters is its definite presentation in mutual facing. In non-sentient nature these aspects are definite. Misreading arises mainly in human living, when the sentient unit mistakes the body for the self.</a:t>
+            </a:r>
+          </a:p>
+          <a:p xmlns:a="http://schemas.openxmlformats.org/drawingml/2006/main">
+            <a:r>
+              <a:t>And notice: the tree as a composite can die while its material constituents persist. Persistence of existence is not persistence of one configuration.</a:t>
             </a:r>
           </a:p>
         </p:txBody>
@@ -2990,27 +2965,27 @@
               <a:buNone/>
             </a:pPr>
             <a:r>
-              <a:t>Jeevan Vidya states the principle: nothing is isolated.</a:t>
-            </a:r>
-          </a:p>
-          <a:p xmlns:a="http://schemas.openxmlformats.org/drawingml/2006/main">
-            <a:r>
-              <a:t>Existence holds relations between units, and it is in those relations that complementarity is actualised as value in mutuality. Expression is definite in the material, bio, and animal orders. At the human order, evaluation may err under body-identification.</a:t>
-            </a:r>
-          </a:p>
-          <a:p xmlns:a="http://schemas.openxmlformats.org/drawingml/2006/main">
-            <a:r>
-              <a:t>Two kinds of mutuality matter. A relationship — sambandh — is mutuality whose expectations and fulfilment are definite in the relation’s completeness: parent and child. An association or contact — sampark — is mutuality where expectations are voluntary: neighbours who share a wall.</a:t>
-            </a:r>
-          </a:p>
-          <a:p xmlns:a="http://schemas.openxmlformats.org/drawingml/2006/main">
-            <a:r>
-              <a:t>The slide names five value families: object, jeevan, human, relationship, and established or civic. Object values are utility and art. So the six named values are utility, art, jeevan, human, relationship, and established or civic.</a:t>
-            </a:r>
-          </a:p>
-          <a:p xmlns:a="http://schemas.openxmlformats.org/drawingml/2006/main">
-            <a:r>
-              <a:t>At the human order the path runs: knowing, then believing, then recognising, then fulfilling. Awakening does not create new faculties. It aligns this chain with coexistence. Established and civic values articulate that fulfilment in society.</a:t>
+              <a:t>Nothing is isolated — that is the principle.</a:t>
+            </a:r>
+          </a:p>
+          <a:p xmlns:a="http://schemas.openxmlformats.org/drawingml/2006/main">
+            <a:r>
+              <a:t>Existence holds relations between units, and in those relations complementarity becomes value in mutuality. In material, plant, and animal orders, recognition and fulfilment are definite. At the human order, evaluation can err when the body is mistaken for the self.</a:t>
+            </a:r>
+          </a:p>
+          <a:p xmlns:a="http://schemas.openxmlformats.org/drawingml/2006/main">
+            <a:r>
+              <a:t>Two kinds of mutuality matter. A relationship is mutuality whose expectations are definite in the completeness of the bond — parent and child. An association or contact is mutuality where expectations are voluntary — neighbours who share a wall.</a:t>
+            </a:r>
+          </a:p>
+          <a:p xmlns:a="http://schemas.openxmlformats.org/drawingml/2006/main">
+            <a:r>
+              <a:t>The slide groups values into families: object values such as utility and art; then values that presuppose sentient living — inner harmonies, human values, relationship values, and civic or established values.</a:t>
+            </a:r>
+          </a:p>
+          <a:p xmlns:a="http://schemas.openxmlformats.org/drawingml/2006/main">
+            <a:r>
+              <a:t>At the human order the path runs: knowing, then believing, then recognising, then fulfilling. Awakening does not invent new faculties. It aligns this chain with coexistence.</a:t>
             </a:r>
           </a:p>
         </p:txBody>
@@ -3089,22 +3064,27 @@
               <a:buNone/>
             </a:pPr>
             <a:r>
-              <a:t>Units organise into four stable orders of nature: material; bio or pranic; animal; and knowledge — the human order.</a:t>
-            </a:r>
-          </a:p>
-          <a:p xmlns:a="http://schemas.openxmlformats.org/drawingml/2006/main">
-            <a:r>
-              <a:t>Read the table downward. Dharma is cumulative. Matter has existence. The bio order adds growth. The animal order adds hope to live. The knowledge order adds happiness. Higher orders include the dharmas of the lower ones.</a:t>
-            </a:r>
-          </a:p>
-          <a:p xmlns:a="http://schemas.openxmlformats.org/drawingml/2006/main">
-            <a:r>
-              <a:t>The pivotal boundary is between the pranic and the animal. Material and pranic orders are insentient. Hope to live is where sentience enters. Jeevan is present in animal and human joint forms.</a:t>
-            </a:r>
-          </a:p>
-          <a:p xmlns:a="http://schemas.openxmlformats.org/drawingml/2006/main">
-            <a:r>
-              <a:t>In animals, bodily and brain development limits how jeevan’s faculties can be expressed through the body. In humans, the bodily medium supports the full range, but delusion can misdirect evaluation. Neither body produces sentience. Please do not collapse either condition into a story of mind emerging from matter alone.</a:t>
+              <a:t>Units organise into four stable orders: material; bio or living-plant order; animal; and knowledge — the human order.</a:t>
+            </a:r>
+          </a:p>
+          <a:p xmlns:a="http://schemas.openxmlformats.org/drawingml/2006/main">
+            <a:r>
+              <a:t>Read the table downward. Innateness is cumulative. Matter has existence. The bio order adds growth. The animal order adds hope to live. The human order adds happiness. Higher orders include the lower ones.</a:t>
+            </a:r>
+          </a:p>
+          <a:p xmlns:a="http://schemas.openxmlformats.org/drawingml/2006/main">
+            <a:r>
+              <a:t>The pivotal boundary is between plant life and animal life. Material and bio orders are non-sentient. Hope to live is where sentience enters. The sentient unit is present in animal and human joint forms.</a:t>
+            </a:r>
+          </a:p>
+          <a:p xmlns:a="http://schemas.openxmlformats.org/drawingml/2006/main">
+            <a:r>
+              <a:t>In animals, bodily and brain development limits how much of that unit’s range can be expressed. In humans, the bodily medium can support the full range, but confusion can still misdirect evaluation. Neither body produces sentience. Please do not collapse either case into “mind emerging from matter alone.”</a:t>
+            </a:r>
+          </a:p>
+          <a:p xmlns:a="http://schemas.openxmlformats.org/drawingml/2006/main">
+            <a:r>
+              <a:t>We have now stated what exists and how it is ordered. Next: how development proceeds.</a:t>
             </a:r>
           </a:p>
         </p:txBody>

</xml_diff>

<commit_message>
Clarify ontology order progression in slide deck
</commit_message>
<xml_diff>
--- a/Studies/The-Ontology-of-Coexistence/The-Ontology-of-Existence-Madhyasth-Darshan.pptx
+++ b/Studies/The-Ontology-of-Coexistence/The-Ontology-of-Existence-Madhyasth-Darshan.pptx
@@ -2,138 +2,43 @@
 <file path=ppt/presentation.xml><?xml version="1.0" encoding="utf-8"?>
 <p:presentation xmlns:p="http://schemas.openxmlformats.org/presentationml/2006/main">
   <p:sldMasterIdLst>
-    <p:sldMasterId xmlns:r="http://schemas.openxmlformats.org/officeDocument/2006/relationships" id="2147483648" r:id="Rb9bb0289ef914a7d"/>
+    <p:sldMasterId xmlns:r="http://schemas.openxmlformats.org/officeDocument/2006/relationships" id="2147483648" r:id="R36c3b345eaf24a80"/>
   </p:sldMasterIdLst>
   <p:notesMasterIdLst>
-    <p:notesMasterId xmlns:r="http://schemas.openxmlformats.org/officeDocument/2006/relationships" r:id="Re04d1a3300924db2"/>
+    <p:notesMasterId xmlns:r="http://schemas.openxmlformats.org/officeDocument/2006/relationships" r:id="Re7e183d1d8474863"/>
   </p:notesMasterIdLst>
   <p:sldIdLst>
-    <p:sldId xmlns:r="http://schemas.openxmlformats.org/officeDocument/2006/relationships" id="256" r:id="R9e6536eda00144e7"/>
-    <p:sldId xmlns:r="http://schemas.openxmlformats.org/officeDocument/2006/relationships" id="257" r:id="Rf76ddbaa01074479"/>
-    <p:sldId xmlns:r="http://schemas.openxmlformats.org/officeDocument/2006/relationships" id="258" r:id="R16f4554795ad49bf"/>
-    <p:sldId xmlns:r="http://schemas.openxmlformats.org/officeDocument/2006/relationships" id="259" r:id="R08a83617ae454b53"/>
-    <p:sldId xmlns:r="http://schemas.openxmlformats.org/officeDocument/2006/relationships" id="260" r:id="Rec544795b4fd44b9"/>
-    <p:sldId xmlns:r="http://schemas.openxmlformats.org/officeDocument/2006/relationships" id="261" r:id="Rc5dba0086a6d4f0a"/>
-    <p:sldId xmlns:r="http://schemas.openxmlformats.org/officeDocument/2006/relationships" id="282" r:id="rId1"/>
-    <p:sldId xmlns:r="http://schemas.openxmlformats.org/officeDocument/2006/relationships" id="283" r:id="rId2"/>
-    <p:sldId xmlns:r="http://schemas.openxmlformats.org/officeDocument/2006/relationships" id="262" r:id="Rb3528f1c2b0542e7"/>
-    <p:sldId xmlns:r="http://schemas.openxmlformats.org/officeDocument/2006/relationships" id="263" r:id="Rdf430edcdf8c4c7b"/>
-    <p:sldId xmlns:r="http://schemas.openxmlformats.org/officeDocument/2006/relationships" id="264" r:id="R2bfd8ef300f84303"/>
-    <p:sldId xmlns:r="http://schemas.openxmlformats.org/officeDocument/2006/relationships" id="265" r:id="R70b4d4f668624d32"/>
-    <p:sldId xmlns:r="http://schemas.openxmlformats.org/officeDocument/2006/relationships" id="273" r:id="Raa9afacfa71843bb"/>
-    <p:sldId xmlns:r="http://schemas.openxmlformats.org/officeDocument/2006/relationships" id="266" r:id="R15c4811db8db4af7"/>
-    <p:sldId xmlns:r="http://schemas.openxmlformats.org/officeDocument/2006/relationships" id="267" r:id="R2303327d17b0474d"/>
-    <p:sldId xmlns:r="http://schemas.openxmlformats.org/officeDocument/2006/relationships" id="268" r:id="R3ad503f37e33485e"/>
-    <p:sldId xmlns:r="http://schemas.openxmlformats.org/officeDocument/2006/relationships" id="269" r:id="R804308cb906d4b3b"/>
-    <p:sldId xmlns:r="http://schemas.openxmlformats.org/officeDocument/2006/relationships" id="270" r:id="Rb18964d791fc47a3"/>
-    <p:sldId xmlns:r="http://schemas.openxmlformats.org/officeDocument/2006/relationships" id="272" r:id="R288570690c0c4146"/>
-    <p:sldId xmlns:r="http://schemas.openxmlformats.org/officeDocument/2006/relationships" id="278" r:id="R663600f2715b424b"/>
-    <p:sldId xmlns:r="http://schemas.openxmlformats.org/officeDocument/2006/relationships" id="271" r:id="Ra3cc3f6f28864d7d"/>
-    <p:sldId xmlns:r="http://schemas.openxmlformats.org/officeDocument/2006/relationships" id="274" r:id="R7ffc4e4ccaff4191"/>
-    <p:sldId xmlns:r="http://schemas.openxmlformats.org/officeDocument/2006/relationships" id="275" r:id="R57f6c0ae66c045cc"/>
-    <p:sldId xmlns:r="http://schemas.openxmlformats.org/officeDocument/2006/relationships" id="276" r:id="R0a144d2a29204b72"/>
-    <p:sldId xmlns:r="http://schemas.openxmlformats.org/officeDocument/2006/relationships" id="279" r:id="R96f897ace9bc4afb"/>
-    <p:sldId xmlns:r="http://schemas.openxmlformats.org/officeDocument/2006/relationships" id="280" r:id="R1213c328788d4229"/>
-    <p:sldId xmlns:r="http://schemas.openxmlformats.org/officeDocument/2006/relationships" id="277" r:id="Rabe98989449740d8"/>
-    <p:sldId xmlns:r="http://schemas.openxmlformats.org/officeDocument/2006/relationships" id="281" r:id="Rf16a6e1aacd4450c"/>
+    <p:sldId xmlns:r="http://schemas.openxmlformats.org/officeDocument/2006/relationships" id="256" r:id="R8e93baf735ab49dd"/>
+    <p:sldId xmlns:r="http://schemas.openxmlformats.org/officeDocument/2006/relationships" id="257" r:id="Re923161173384642"/>
+    <p:sldId xmlns:r="http://schemas.openxmlformats.org/officeDocument/2006/relationships" id="258" r:id="R823ebfb2a7264c5e"/>
+    <p:sldId xmlns:r="http://schemas.openxmlformats.org/officeDocument/2006/relationships" id="259" r:id="R96fdd392b00a4c4d"/>
+    <p:sldId xmlns:r="http://schemas.openxmlformats.org/officeDocument/2006/relationships" id="260" r:id="R924fc04ecd654954"/>
+    <p:sldId xmlns:r="http://schemas.openxmlformats.org/officeDocument/2006/relationships" id="261" r:id="Ra3d054b6923044d9"/>
+    <p:sldId xmlns:r="http://schemas.openxmlformats.org/officeDocument/2006/relationships" id="262" r:id="R90942b1331e149c6"/>
+    <p:sldId xmlns:r="http://schemas.openxmlformats.org/officeDocument/2006/relationships" id="263" r:id="Rae2e1f1948994179"/>
+    <p:sldId xmlns:r="http://schemas.openxmlformats.org/officeDocument/2006/relationships" id="264" r:id="Rb4fe29ff578c4c1a"/>
+    <p:sldId xmlns:r="http://schemas.openxmlformats.org/officeDocument/2006/relationships" id="265" r:id="R1c04e7d829af497b"/>
+    <p:sldId xmlns:r="http://schemas.openxmlformats.org/officeDocument/2006/relationships" id="266" r:id="R012590733b8f4f48"/>
+    <p:sldId xmlns:r="http://schemas.openxmlformats.org/officeDocument/2006/relationships" id="267" r:id="Rf7c429f9714f40ea"/>
+    <p:sldId xmlns:r="http://schemas.openxmlformats.org/officeDocument/2006/relationships" id="268" r:id="R4f0c63996a9847c3"/>
+    <p:sldId xmlns:r="http://schemas.openxmlformats.org/officeDocument/2006/relationships" id="269" r:id="R216a1fd1a9a8498a"/>
+    <p:sldId xmlns:r="http://schemas.openxmlformats.org/officeDocument/2006/relationships" id="270" r:id="R9b907f3063a247d3"/>
+    <p:sldId xmlns:r="http://schemas.openxmlformats.org/officeDocument/2006/relationships" id="271" r:id="Re111fb24de434fbf"/>
+    <p:sldId xmlns:r="http://schemas.openxmlformats.org/officeDocument/2006/relationships" id="272" r:id="R8e75b285dc994036"/>
+    <p:sldId xmlns:r="http://schemas.openxmlformats.org/officeDocument/2006/relationships" id="273" r:id="Rc051ce4dc9a04231"/>
+    <p:sldId xmlns:r="http://schemas.openxmlformats.org/officeDocument/2006/relationships" id="274" r:id="Re2809ee22f4c4d87"/>
+    <p:sldId xmlns:r="http://schemas.openxmlformats.org/officeDocument/2006/relationships" id="275" r:id="R9569ed22d2b84ead"/>
+    <p:sldId xmlns:r="http://schemas.openxmlformats.org/officeDocument/2006/relationships" id="276" r:id="Rd303ce6447bb4871"/>
+    <p:sldId xmlns:r="http://schemas.openxmlformats.org/officeDocument/2006/relationships" id="277" r:id="R60743571f4c343c2"/>
+    <p:sldId xmlns:r="http://schemas.openxmlformats.org/officeDocument/2006/relationships" id="278" r:id="Rb892ce7f38a84cb0"/>
+    <p:sldId xmlns:r="http://schemas.openxmlformats.org/officeDocument/2006/relationships" id="279" r:id="R73658b09b77d4348"/>
+    <p:sldId xmlns:r="http://schemas.openxmlformats.org/officeDocument/2006/relationships" id="280" r:id="Rdd2eee1401504460"/>
+    <p:sldId xmlns:r="http://schemas.openxmlformats.org/officeDocument/2006/relationships" id="281" r:id="R163cbc1424cf4090"/>
+    <p:sldId xmlns:r="http://schemas.openxmlformats.org/officeDocument/2006/relationships" id="282" r:id="R264b946c389c4d0f"/>
+    <p:sldId xmlns:r="http://schemas.openxmlformats.org/officeDocument/2006/relationships" id="283" r:id="R997e15c41f9e467e"/>
   </p:sldIdLst>
   <p:sldSz cx="9144000" cy="5143500"/>
   <p:notesSz cx="6858000" cy="9144000"/>
-  <p:defaultTextStyle>
-    <a:defPPr xmlns:a="http://schemas.openxmlformats.org/drawingml/2006/main">
-      <a:defRPr lang="en-US"/>
-    </a:defPPr>
-    <a:lvl1pPr xmlns:a="http://schemas.openxmlformats.org/drawingml/2006/main" marL="0" indent="0" algn="l" defTabSz="914400">
-      <a:defRPr sz="1800" kern="1200">
-        <a:solidFill>
-          <a:schemeClr val="tx1"/>
-        </a:solidFill>
-        <a:latin typeface="+mn-lt"/>
-        <a:ea typeface="+mn-ea"/>
-        <a:cs typeface="+mn-cs"/>
-      </a:defRPr>
-    </a:lvl1pPr>
-    <a:lvl2pPr xmlns:a="http://schemas.openxmlformats.org/drawingml/2006/main" marL="457200" indent="0" algn="l" defTabSz="914400">
-      <a:defRPr sz="1800" kern="1200">
-        <a:solidFill>
-          <a:schemeClr val="tx1"/>
-        </a:solidFill>
-        <a:latin typeface="+mn-lt"/>
-        <a:ea typeface="+mn-ea"/>
-        <a:cs typeface="+mn-cs"/>
-      </a:defRPr>
-    </a:lvl2pPr>
-    <a:lvl3pPr xmlns:a="http://schemas.openxmlformats.org/drawingml/2006/main" marL="914400" indent="0" algn="l" defTabSz="914400">
-      <a:defRPr sz="1800" kern="1200">
-        <a:solidFill>
-          <a:schemeClr val="tx1"/>
-        </a:solidFill>
-        <a:latin typeface="+mn-lt"/>
-        <a:ea typeface="+mn-ea"/>
-        <a:cs typeface="+mn-cs"/>
-      </a:defRPr>
-    </a:lvl3pPr>
-    <a:lvl4pPr xmlns:a="http://schemas.openxmlformats.org/drawingml/2006/main" marL="1371600" indent="0" algn="l" defTabSz="914400">
-      <a:defRPr sz="1800" kern="1200">
-        <a:solidFill>
-          <a:schemeClr val="tx1"/>
-        </a:solidFill>
-        <a:latin typeface="+mn-lt"/>
-        <a:ea typeface="+mn-ea"/>
-        <a:cs typeface="+mn-cs"/>
-      </a:defRPr>
-    </a:lvl4pPr>
-    <a:lvl5pPr xmlns:a="http://schemas.openxmlformats.org/drawingml/2006/main" marL="1828800" indent="0" algn="l" defTabSz="914400">
-      <a:defRPr sz="1800" kern="1200">
-        <a:solidFill>
-          <a:schemeClr val="tx1"/>
-        </a:solidFill>
-        <a:latin typeface="+mn-lt"/>
-        <a:ea typeface="+mn-ea"/>
-        <a:cs typeface="+mn-cs"/>
-      </a:defRPr>
-    </a:lvl5pPr>
-    <a:lvl6pPr xmlns:a="http://schemas.openxmlformats.org/drawingml/2006/main" marL="2286000" indent="0" algn="l" defTabSz="914400">
-      <a:defRPr sz="1800" kern="1200">
-        <a:solidFill>
-          <a:schemeClr val="tx1"/>
-        </a:solidFill>
-        <a:latin typeface="+mn-lt"/>
-        <a:ea typeface="+mn-ea"/>
-        <a:cs typeface="+mn-cs"/>
-      </a:defRPr>
-    </a:lvl6pPr>
-    <a:lvl7pPr xmlns:a="http://schemas.openxmlformats.org/drawingml/2006/main" marL="2743200" indent="0" algn="l" defTabSz="914400">
-      <a:defRPr sz="1800" kern="1200">
-        <a:solidFill>
-          <a:schemeClr val="tx1"/>
-        </a:solidFill>
-        <a:latin typeface="+mn-lt"/>
-        <a:ea typeface="+mn-ea"/>
-        <a:cs typeface="+mn-cs"/>
-      </a:defRPr>
-    </a:lvl7pPr>
-    <a:lvl8pPr xmlns:a="http://schemas.openxmlformats.org/drawingml/2006/main" marL="3200400" indent="0" algn="l" defTabSz="914400">
-      <a:defRPr sz="1800" kern="1200">
-        <a:solidFill>
-          <a:schemeClr val="tx1"/>
-        </a:solidFill>
-        <a:latin typeface="+mn-lt"/>
-        <a:ea typeface="+mn-ea"/>
-        <a:cs typeface="+mn-cs"/>
-      </a:defRPr>
-    </a:lvl8pPr>
-    <a:lvl9pPr xmlns:a="http://schemas.openxmlformats.org/drawingml/2006/main" marL="3657600" indent="0" algn="l" defTabSz="914400">
-      <a:defRPr sz="1800" kern="1200">
-        <a:solidFill>
-          <a:schemeClr val="tx1"/>
-        </a:solidFill>
-        <a:latin typeface="+mn-lt"/>
-        <a:ea typeface="+mn-ea"/>
-        <a:cs typeface="+mn-cs"/>
-      </a:defRPr>
-    </a:lvl9pPr>
-  </p:defaultTextStyle>
 </p:presentation>
 </file>
 
@@ -695,47 +600,27 @@
               <a:buNone/>
             </a:pPr>
             <a:r>
-              <a:t>Start with the question the last three slides have been building toward: why does anything develop at all?</a:t>
-            </a:r>
-          </a:p>
-          <a:p xmlns:a="http://schemas.openxmlformats.org/drawingml/2006/main">
-            <a:r>
-              <a:t>The answer the texts give is the completeness drive. Nature saturated in state-complete Omnipresence is oriented toward development and awakening, until realisation. “Oriented” is doing careful work there — it names a direction inherent in the order of coexistence, not a guarantee that every unit travels the whole way.</a:t>
-            </a:r>
-          </a:p>
-          <a:p xmlns:a="http://schemas.openxmlformats.org/drawingml/2006/main">
-            <a:r>
-              <a:t>And here is the connection back to slide 8, which is the one I most want to land: that drive is the drive to fulfil complementarity. Complementarity is given; fulfilling it is what development *is*. Everything in this movement, and everything in the movement after it, is a specification of that one sentence.</a:t>
-            </a:r>
-          </a:p>
-          <a:p xmlns:a="http://schemas.openxmlformats.org/drawingml/2006/main">
-            <a:r>
-              <a:t>That drive proceeds along two distinct lines, and Madhyasth Darshan insists they must not be collapsed.</a:t>
-            </a:r>
-          </a:p>
-          <a:p xmlns:a="http://schemas.openxmlformats.org/drawingml/2006/main">
-            <a:r>
-              <a:t>Compositional progression joins particles, atoms, molecules, cells, and bodies into larger configurations. Separately, development in an atom can reach constitutional completeness as a sentient unit. These lines meet in living joint forms, but they remain distinct.</a:t>
-            </a:r>
-          </a:p>
-          <a:p xmlns:a="http://schemas.openxmlformats.org/drawingml/2006/main">
-            <a:r>
-              <a:t>Across both, activity is one inseparable triad: effort, motion, and result — three aspects of one activity, not three sequential steps. When sodium and chlorine approach, the approach is effort and motion together; the stable salt crystal is the result.</a:t>
-            </a:r>
-          </a:p>
-          <a:p xmlns:a="http://schemas.openxmlformats.org/drawingml/2006/main">
-            <a:r>
-              <a:t>The texts compress the engine this way: saturation is forcefulness; forcefulness is basic impulsion; impulsion is activity; activity is effort-motion-result; and that is development.</a:t>
-            </a:r>
-          </a:p>
-          <a:p xmlns:a="http://schemas.openxmlformats.org/drawingml/2006/main">
-            <a:r>
-              <a:t>Each term has a goal: restfulness of effort, destination of motion, immortality of result. Development pervades nature; awakening occurs in the sentient. Non-sentient units participate by composing bodies and environments without each individually completing the drive.</a:t>
-            </a:r>
-          </a:p>
-          <a:p xmlns:a="http://schemas.openxmlformats.org/drawingml/2006/main">
-            <a:r>
-              <a:t>The next slide shows why the composing line, however far it goes, never gets there on its own.</a:t>
+              <a:t>The complementarity we just established becomes evident through relationships among units — this slide is what it looks like in practice.</a:t>
+            </a:r>
+          </a:p>
+          <a:p xmlns:a="http://schemas.openxmlformats.org/drawingml/2006/main">
+            <a:r>
+              <a:t>In the material, plant, and animal orders its expression is definite: recognition happens, fulfilment happens. At the human order alone it has to be recognised, evaluated, and fulfilled — so at the human order alone it can be got wrong, and it is got wrong when the body is mistaken for the self.</a:t>
+            </a:r>
+          </a:p>
+          <a:p xmlns:a="http://schemas.openxmlformats.org/drawingml/2006/main">
+            <a:r>
+              <a:t>Two kinds of mutuality matter. A relationship is mutuality whose expectations are definite in the completeness of the bond — parent and child. An association or contact is mutuality where expectations are voluntary — neighbours who share a wall.</a:t>
+            </a:r>
+          </a:p>
+          <a:p xmlns:a="http://schemas.openxmlformats.org/drawingml/2006/main">
+            <a:r>
+              <a:t>The slide names five value families: object, *jeevan*, human, established, and civic — the last is *shishta-mulya* in the source. Object values are two, utility and art, so the same list is often counted as six types: utility, art, *jeevan*, human, established, and civic. Established values are the ones that become evident when human relationships are recognised and fulfilled — trust, respect, affection, care, and so on. Civic values are how all of that is expressed in social participation.</a:t>
+            </a:r>
+          </a:p>
+          <a:p xmlns:a="http://schemas.openxmlformats.org/drawingml/2006/main">
+            <a:r>
+              <a:t>At the human order the path runs: knowing, then believing, then recognising, then fulfilling. Awakening does not invent new faculties. It aligns this chain with coexistence.</a:t>
             </a:r>
           </a:p>
         </p:txBody>
@@ -814,37 +699,27 @@
               <a:buNone/>
             </a:pPr>
             <a:r>
-              <a:t>Now we name three milestones — T1, T2, and T3.</a:t>
-            </a:r>
-          </a:p>
-          <a:p xmlns:a="http://schemas.openxmlformats.org/drawingml/2006/main">
-            <a:r>
-              <a:t>T1 is constitutional completeness: the immortality of result. A developing atom becomes a sentient unit — jeevan. Status shifts from physicochemical to what the texts call delusional — meaning the body is mistaken for the self. That is a stage label, not a psychiatric diagnosis.</a:t>
-            </a:r>
-          </a:p>
-          <a:p xmlns:a="http://schemas.openxmlformats.org/drawingml/2006/main">
-            <a:r>
-              <a:t>T2 is activity completeness: restfulness of effort. Inner seeking settles into direct realisation and resolution. Status shifts toward awakened understanding.</a:t>
-            </a:r>
-          </a:p>
-          <a:p xmlns:a="http://schemas.openxmlformats.org/drawingml/2006/main">
-            <a:r>
-              <a:t>T3 is conduct completeness: destination of motion. Understanding becomes authentic conduct — living proof.</a:t>
-            </a:r>
-          </a:p>
-          <a:p xmlns:a="http://schemas.openxmlformats.org/drawingml/2006/main">
-            <a:r>
-              <a:t>Keep T2 and T3 apart. T2 is internal settlement. T3 is outer destination in conduct. And do not confuse T2’s restfulness with the ease of non-sentient natural complementarity.</a:t>
-            </a:r>
-          </a:p>
-          <a:p xmlns:a="http://schemas.openxmlformats.org/drawingml/2006/main">
-            <a:r>
-              <a:t>T1 is completeness of an atom’s constitution. T2 and T3 are not further material stages; they name completeness of activity and conduct in the awakened sentient unit. In one line: the saturated realises the ground it is saturated in.</a:t>
-            </a:r>
-          </a:p>
-          <a:p xmlns:a="http://schemas.openxmlformats.org/drawingml/2006/main">
-            <a:r>
-              <a:t>One naming point, since I have just used the words. Physicochemical, delusional, deific, divine — the band across the top of this slide — are what the texts call the four **planes**. A plane is the developmental standing a thing has reached. It is not a kind of thing, and it is not the same as an order of nature. The next slide sorts that out properly.</a:t>
+              <a:t>Units organise into four stable orders: material; bio or living-plant order; animal; and knowledge — the human order.</a:t>
+            </a:r>
+          </a:p>
+          <a:p xmlns:a="http://schemas.openxmlformats.org/drawingml/2006/main">
+            <a:r>
+              <a:t>Read the table downward. Innateness is cumulative. Matter has existence. The bio order adds growth. The animal order adds hope to live. The human order adds happiness. Higher orders include the lower ones.</a:t>
+            </a:r>
+          </a:p>
+          <a:p xmlns:a="http://schemas.openxmlformats.org/drawingml/2006/main">
+            <a:r>
+              <a:t>The pivotal boundary is between plant life and animal life. Material and bio orders are non-sentient. Hope to live is where sentience enters. The sentient unit is present in animal and human joint forms.</a:t>
+            </a:r>
+          </a:p>
+          <a:p xmlns:a="http://schemas.openxmlformats.org/drawingml/2006/main">
+            <a:r>
+              <a:t>In animals, bodily and brain development limits how much of that unit’s range can be expressed. In humans, the bodily medium can support the full range, but confusion can still misdirect evaluation. Neither body produces sentience. Please do not collapse either case into “mind emerging from matter alone.”</a:t>
+            </a:r>
+          </a:p>
+          <a:p xmlns:a="http://schemas.openxmlformats.org/drawingml/2006/main">
+            <a:r>
+              <a:t>We have now stated what exists and how it is ordered. Next: how development proceeds.</a:t>
             </a:r>
           </a:p>
         </p:txBody>
@@ -923,37 +798,47 @@
               <a:buNone/>
             </a:pPr>
             <a:r>
-              <a:t>Let me consolidate, because this tradition uses four different vocabularies for what is fundamentally one thing, and mixing them up is the commonest way to get lost in it.</a:t>
-            </a:r>
-          </a:p>
-          <a:p xmlns:a="http://schemas.openxmlformats.org/drawingml/2006/main">
-            <a:r>
-              <a:t>There is one drive: nature saturated in state-complete Omnipresence, oriented toward development and awakening until realisation. Everything on this table is a way of describing where something stands in that drive.</a:t>
-            </a:r>
-          </a:p>
-          <a:p xmlns:a="http://schemas.openxmlformats.org/drawingml/2006/main">
-            <a:r>
-              <a:t>**Orders** — material, bio, animal, knowledge — say what *kind* of thing a unit is: its organisation, its essential nature, its innateness. Four orders.</a:t>
-            </a:r>
-          </a:p>
-          <a:p xmlns:a="http://schemas.openxmlformats.org/drawingml/2006/main">
-            <a:r>
-              <a:t>**Progressions** — existential, way of existence, development, awakening — say how the drive *moves*. The first names the definite sequence in which the orders become manifest; the second, the conformance by which each order keeps its conduct; the third, physicochemical and atomic development up to T1; the fourth, qualitative development inside a complete sentient unit toward T2 and T3.</a:t>
-            </a:r>
-          </a:p>
-          <a:p xmlns:a="http://schemas.openxmlformats.org/drawingml/2006/main">
-            <a:r>
-              <a:t>**Planes** — physicochemical, delusional, deific, divine — say how *far* something has come. These are the four we just saw across the top of the last slide. Before T1; T1 only; T2; T3.</a:t>
-            </a:r>
-          </a:p>
-          <a:p xmlns:a="http://schemas.openxmlformats.org/drawingml/2006/main">
-            <a:r>
-              <a:t>**Human types** — animalistic, demonic, humane or discerning, deific, divine — say how a human *life is oriented*. Five of them, and they classify modes of consciousness and conduct. Not biological species. Not social classes. Not castes.</a:t>
-            </a:r>
-          </a:p>
-          <a:p xmlns:a="http://schemas.openxmlformats.org/drawingml/2006/main">
-            <a:r>
-              <a:t>The one caution worth stating out loud: an order is not a plane. The knowledge order spans more than one plane — most human beings are in the knowledge order and on the delusional plane at the same time, and there is nothing insulting in that; it just means realisation has not happened yet. T1 separates physicochemical from sentient standing. T2 and T3 are completeness within an awakened sentient unit, and no fifth plane is added beyond them.</a:t>
+              <a:t>Start with the question the last three slides have been building toward: why does anything develop at all?</a:t>
+            </a:r>
+          </a:p>
+          <a:p xmlns:a="http://schemas.openxmlformats.org/drawingml/2006/main">
+            <a:r>
+              <a:t>The answer the texts give is the completeness drive. Nature saturated in state-complete Omnipresence is oriented toward development and awakening, until realisation. “Oriented” is doing careful work there — it names a direction inherent in the order of coexistence, not a guarantee that every unit travels the whole way.</a:t>
+            </a:r>
+          </a:p>
+          <a:p xmlns:a="http://schemas.openxmlformats.org/drawingml/2006/main">
+            <a:r>
+              <a:t>And here is the connection back to slide 8, which is the one I most want to land: that drive is the drive to fulfil complementarity. Complementarity is given; fulfilling it is what development *is*. Everything in this movement, and everything in the movement after it, is a specification of that one sentence.</a:t>
+            </a:r>
+          </a:p>
+          <a:p xmlns:a="http://schemas.openxmlformats.org/drawingml/2006/main">
+            <a:r>
+              <a:t>That drive proceeds along two distinct lines, and Madhyasth Darshan insists they must not be collapsed.</a:t>
+            </a:r>
+          </a:p>
+          <a:p xmlns:a="http://schemas.openxmlformats.org/drawingml/2006/main">
+            <a:r>
+              <a:t>Compositional progression joins particles, atoms, molecules, cells, and bodies into larger configurations. Separately, development in an atom can reach constitutional completeness as a sentient unit. These lines meet in living joint forms, but they remain distinct.</a:t>
+            </a:r>
+          </a:p>
+          <a:p xmlns:a="http://schemas.openxmlformats.org/drawingml/2006/main">
+            <a:r>
+              <a:t>Across both, activity is one inseparable triad: effort, motion, and result — three aspects of one activity, not three sequential steps. When sodium and chlorine approach, the approach is effort and motion together; the stable salt crystal is the result.</a:t>
+            </a:r>
+          </a:p>
+          <a:p xmlns:a="http://schemas.openxmlformats.org/drawingml/2006/main">
+            <a:r>
+              <a:t>The texts compress the engine this way: saturation is forcefulness; forcefulness is basic impulsion; impulsion is activity; activity is effort-motion-result; and that is development.</a:t>
+            </a:r>
+          </a:p>
+          <a:p xmlns:a="http://schemas.openxmlformats.org/drawingml/2006/main">
+            <a:r>
+              <a:t>Each term has a goal: restfulness of effort, destination of motion, immortality of result. Development pervades nature; awakening occurs in the sentient. Non-sentient units participate by composing bodies and environments without each individually completing the drive.</a:t>
+            </a:r>
+          </a:p>
+          <a:p xmlns:a="http://schemas.openxmlformats.org/drawingml/2006/main">
+            <a:r>
+              <a:t>The next slide follows both paths through their convergence in animal and human living.</a:t>
             </a:r>
           </a:p>
         </p:txBody>
@@ -1032,37 +917,32 @@
               <a:buNone/>
             </a:pPr>
             <a:r>
-              <a:t>T1 is the hinge: where sentience enters.</a:t>
-            </a:r>
-          </a:p>
-          <a:p xmlns:a="http://schemas.openxmlformats.org/drawingml/2006/main">
-            <a:r>
-              <a:t>It is constitutional completeness at the atomic level — not neural complexity, not molecular size, and not merely climbing the order chain.</a:t>
-            </a:r>
-          </a:p>
-          <a:p xmlns:a="http://schemas.openxmlformats.org/drawingml/2006/main">
-            <a:r>
-              <a:t>And complementarity is doing the work here too, which is worth saying out loud because it is the same principle as the composing line, not a different mechanism. The texts describe a developing atom that incorporates particles — “hungry” atoms and “overfull” atoms completing each other — in a suitable environment. Two incompletenesses fulfil one another. When the required constitution closes, particle count no longer increases or decreases.</a:t>
-            </a:r>
-          </a:p>
-          <a:p xmlns:a="http://schemas.openxmlformats.org/drawingml/2006/main">
-            <a:r>
-              <a:t>Here is the criterion, and it is sharper than it first looks. In matter, qualitative change does not happen without quantitative change: an atom's kind and capacity track its particle number. Change what it can do and you have changed how many particles it has. Those two kinds of change are tied together — right up to completeness. Completeness is where they come apart. After it, qualitative activity continues while the particle count is fixed. That separation is the criterion.</a:t>
-            </a:r>
-          </a:p>
-          <a:p xmlns:a="http://schemas.openxmlformats.org/drawingml/2006/main">
-            <a:r>
-              <a:t>So: before T1, still changing structure and particle count; non-sentient radiance and projection. After T1, released from molecular and weight bondage, carried by hope; qualitative change without quantitative change; a finer mode of recognition as the sentient unit.</a:t>
-            </a:r>
-          </a:p>
-          <a:p xmlns:a="http://schemas.openxmlformats.org/drawingml/2006/main">
-            <a:r>
-              <a:t>T1 is irreversible because the completed constitution no longer decomposes. That is also the textual basis for continuity of the knower beyond a particular body — the constitution has closed, so the death of a body is not the end of the sentient unit. JV goes further and describes its subsequent association with another body. I will flag now what I will repeat under method and evidence: these are claims of the primary texts, grounded in constitutional completeness, and no accepted procedure measures any of it.</a:t>
-            </a:r>
-          </a:p>
-          <a:p xmlns:a="http://schemas.openxmlformats.org/drawingml/2006/main">
-            <a:r>
-              <a:t>I want to be plain: this is an ontological account. No accepted empirical procedure currently identifies the threshold. We will return to that honesty under method and evidence.</a:t>
+              <a:t>The completeness drive unfolds along two parallel paths.</a:t>
+            </a:r>
+          </a:p>
+          <a:p xmlns:a="http://schemas.openxmlformats.org/drawingml/2006/main">
+            <a:r>
+              <a:t>The first is the compositional path, *rachna*. Atoms and molecules form material-order structures. Under appropriate chemical and environmental conditions, pranic cells and biological formations appear. This is the material-to-biological order change, and both orders remain insentient.</a:t>
+            </a:r>
+          </a:p>
+          <a:p xmlns:a="http://schemas.openxmlformats.org/drawingml/2006/main">
+            <a:r>
+              <a:t>The second is the atomic path, *gathan*. A developing atom integrates the particle constitution required for completeness. At constitutional completeness, the texts classify that atom as sentient *jeevan*.</a:t>
+            </a:r>
+          </a:p>
+          <a:p xmlns:a="http://schemas.openxmlformats.org/drawingml/2006/main">
+            <a:r>
+              <a:t>The two paths meet in the animal order as a joint form: a biological body plus sentient *jeevan*. One does not manufacture the other; they work together.</a:t>
+            </a:r>
+          </a:p>
+          <a:p xmlns:a="http://schemas.openxmlformats.org/drawingml/2006/main">
+            <a:r>
+              <a:t>Development then continues along both aspects of the joint form. Bodily lineages develop through species-conforming biological organisation, while *jeevan*’s expression widens through those bodily media. In the animal order that expression remains limited by the body.</a:t>
+            </a:r>
+          </a:p>
+          <a:p xmlns:a="http://schemas.openxmlformats.org/drawingml/2006/main">
+            <a:r>
+              <a:t>The human body, in the knowledge order, is described as capable of evidencing all ten activities of *jeevan*. That does not mean the body owns those activities. It means the bodily medium is adequate for their expression. Once that capacity is present, the remaining development is awakening in *jeevan*, evidenced through understanding and conduct.</a:t>
             </a:r>
           </a:p>
         </p:txBody>
@@ -1141,27 +1021,37 @@
               <a:buNone/>
             </a:pPr>
             <a:r>
-              <a:t>We now turn to human living — movement three.</a:t>
-            </a:r>
-          </a:p>
-          <a:p xmlns:a="http://schemas.openxmlformats.org/drawingml/2006/main">
-            <a:r>
-              <a:t>Animal and human living is a joint form. The sentient unit brings the full set of faculties and activities. The body supplies the species-specific medium.</a:t>
-            </a:r>
-          </a:p>
-          <a:p xmlns:a="http://schemas.openxmlformats.org/drawingml/2006/main">
-            <a:r>
-              <a:t>On one side: the body — living composition, sense organs, brain, physical expression; decomposable. On the other: the sentient unit — constitutionally complete; faculties inherent; continuing when the joint form ends.</a:t>
-            </a:r>
-          </a:p>
-          <a:p xmlns:a="http://schemas.openxmlformats.org/drawingml/2006/main">
-            <a:r>
-              <a:t>Animal bodily development limits expression. The human medium can support the full range, while mistaking the body for the self can still misdirect evaluation.</a:t>
-            </a:r>
-          </a:p>
-          <a:p xmlns:a="http://schemas.openxmlformats.org/drawingml/2006/main">
-            <a:r>
-              <a:t>The body gates expression. The sentient unit is seer, doer, and enjoyer through the body. Animal limitation belongs to the medium. Human mis-evaluation belongs to that confusion. The body does not produce sentience, and those two problems are not the same problem.</a:t>
+              <a:t>Now we name three milestones — T1, T2, and T3.</a:t>
+            </a:r>
+          </a:p>
+          <a:p xmlns:a="http://schemas.openxmlformats.org/drawingml/2006/main">
+            <a:r>
+              <a:t>T1 is constitutional completeness: the immortality of result. A developing atom becomes a sentient unit — jeevan. Status shifts from physicochemical to what the texts call delusional — meaning the body is mistaken for the self. That is a stage label, not a psychiatric diagnosis.</a:t>
+            </a:r>
+          </a:p>
+          <a:p xmlns:a="http://schemas.openxmlformats.org/drawingml/2006/main">
+            <a:r>
+              <a:t>T2 is activity completeness: restfulness of effort. Inner seeking settles into direct realisation and resolution. Status shifts toward awakened understanding.</a:t>
+            </a:r>
+          </a:p>
+          <a:p xmlns:a="http://schemas.openxmlformats.org/drawingml/2006/main">
+            <a:r>
+              <a:t>T3 is conduct completeness: destination of motion. Understanding becomes authentic conduct — living proof.</a:t>
+            </a:r>
+          </a:p>
+          <a:p xmlns:a="http://schemas.openxmlformats.org/drawingml/2006/main">
+            <a:r>
+              <a:t>Keep T2 and T3 apart. T2 is internal settlement. T3 is outer destination in conduct. And do not confuse T2’s restfulness with the ease of non-sentient natural complementarity.</a:t>
+            </a:r>
+          </a:p>
+          <a:p xmlns:a="http://schemas.openxmlformats.org/drawingml/2006/main">
+            <a:r>
+              <a:t>T1 is completeness of an atom’s constitution. T2 and T3 are not further material stages; they name completeness of activity and conduct in the awakened sentient unit. In one line: the saturated realises the ground it is saturated in.</a:t>
+            </a:r>
+          </a:p>
+          <a:p xmlns:a="http://schemas.openxmlformats.org/drawingml/2006/main">
+            <a:r>
+              <a:t>One naming point, since I have just used the words. Physicochemical, delusional, deific, divine — the band across the top of this slide — are what the texts call the four **planes**. A plane is the developmental standing a thing has reached. It is not a kind of thing, and it is not the same as an order of nature. The next slide sorts that out properly.</a:t>
             </a:r>
           </a:p>
         </p:txBody>
@@ -1240,27 +1130,37 @@
               <a:buNone/>
             </a:pPr>
             <a:r>
-              <a:t>The sentient unit — jeevan — is a constitutionally complete atom.</a:t>
-            </a:r>
-          </a:p>
-          <a:p xmlns:a="http://schemas.openxmlformats.org/drawingml/2006/main">
-            <a:r>
-              <a:t>Structurally, the centre is the core self. Around it: resolve, desire, thought, and hope — the texts’ buddhi, chitta, vritti, and mun.</a:t>
-            </a:r>
-          </a:p>
-          <a:p xmlns:a="http://schemas.openxmlformats.org/drawingml/2006/main">
-            <a:r>
-              <a:t>Each works outward and inward. Hope selects and tastes. Thought analyses and deliberates. Desire visualises and contemplates. Resolve resolves and receives clear understanding. The core self authenticates and realises.</a:t>
-            </a:r>
-          </a:p>
-          <a:p xmlns:a="http://schemas.openxmlformats.org/drawingml/2006/main">
-            <a:r>
-              <a:t>All five faculties and ten activities belong to the sentient unit. Presence is not the same as expression or effective organisation. Animal bodies limit expression. Humans have the medium for the full range, yet under body-confusion only part of that range may be effectively organised.</a:t>
-            </a:r>
-          </a:p>
-          <a:p xmlns:a="http://schemas.openxmlformats.org/drawingml/2006/main">
-            <a:r>
-              <a:t>Study brings understanding. Practice tests and stabilises it. Practice does not manufacture faculties that were missing.</a:t>
+              <a:t>Let me consolidate, because this tradition uses four different vocabularies for what is fundamentally one thing, and mixing them up is the commonest way to get lost in it.</a:t>
+            </a:r>
+          </a:p>
+          <a:p xmlns:a="http://schemas.openxmlformats.org/drawingml/2006/main">
+            <a:r>
+              <a:t>There is one drive: nature saturated in state-complete Omnipresence, oriented toward development and awakening until realisation. Everything on this table is a way of describing where something stands in that drive.</a:t>
+            </a:r>
+          </a:p>
+          <a:p xmlns:a="http://schemas.openxmlformats.org/drawingml/2006/main">
+            <a:r>
+              <a:t>**Orders** — material, bio, animal, knowledge — say what *kind* of thing a unit is: its organisation, its essential nature, its innateness. Four orders.</a:t>
+            </a:r>
+          </a:p>
+          <a:p xmlns:a="http://schemas.openxmlformats.org/drawingml/2006/main">
+            <a:r>
+              <a:t>**Progressions** — existential, way of existence, development, awakening — say how the drive *moves*. The first names the definite sequence in which the orders become manifest; the second, the conformance by which each order keeps its conduct; the third, physicochemical and atomic development up to T1; the fourth, qualitative development inside a complete sentient unit toward T2 and T3.</a:t>
+            </a:r>
+          </a:p>
+          <a:p xmlns:a="http://schemas.openxmlformats.org/drawingml/2006/main">
+            <a:r>
+              <a:t>**Planes** — physicochemical, delusional, deific, divine — say how *far* something has come. These are the four we just saw across the top of the last slide. Before T1; T1 only; T2; T3.</a:t>
+            </a:r>
+          </a:p>
+          <a:p xmlns:a="http://schemas.openxmlformats.org/drawingml/2006/main">
+            <a:r>
+              <a:t>**Human types** — animalistic, demonic, humane or discerning, deific, divine — say how a human *life is oriented*. Five of them, and they classify modes of consciousness and conduct. Not biological species. Not social classes. Not castes.</a:t>
+            </a:r>
+          </a:p>
+          <a:p xmlns:a="http://schemas.openxmlformats.org/drawingml/2006/main">
+            <a:r>
+              <a:t>The one caution worth stating out loud: an order is not a plane. The knowledge order spans more than one plane — most human beings are in the knowledge order and on the delusional plane at the same time, and there is nothing insulting in that; it just means realisation has not happened yet. T1 separates physicochemical from sentient standing. T2 and T3 are completeness within an awakened sentient unit, and no fifth plane is added beyond them.</a:t>
             </a:r>
           </a:p>
         </p:txBody>
@@ -1329,38 +1229,42 @@
           <a:bodyPr xmlns:a="http://schemas.openxmlformats.org/drawingml/2006/main"/>
           <a:lstStyle xmlns:a="http://schemas.openxmlformats.org/drawingml/2006/main"/>
           <a:p xmlns:a="http://schemas.openxmlformats.org/drawingml/2006/main">
-            <a:r>
-              <a:t>So: peace, contentment, bliss. How does a person actually get them?</a:t>
-            </a:r>
-          </a:p>
-          <a:p xmlns:a="http://schemas.openxmlformats.org/drawingml/2006/main">
-            <a:r>
-              <a:t>Let me put the shape of the answer first, because it is the hinge of this whole movement. Below the human order, fulfilment is definite — it needs no deciding. A molecule does not choose. A plant does not deliberate. Even the animal, which has a complete sentient unit, is carried by species-conformance to the fulfilment available through its body. Nothing there has to be *worked out*.</a:t>
-            </a:r>
-          </a:p>
-          <a:p xmlns:a="http://schemas.openxmlformats.org/drawingml/2006/main">
-            <a:r>
-              <a:t>The human order is the one place where complementarity has to be fulfilled *knowingly* — where the higher harmonies are on offer and nothing delivers them automatically. And here is the part people resist: understanding does not deliver them either. Study is necessary. It is not sufficient. You can recognise the higher faculties, grasp the whole account, hold it clearly — and still not have peace, contentment, or bliss, because those are harmonies of the unit in *activity*, and there is no activity in knowing about activity.</a:t>
-            </a:r>
-          </a:p>
-          <a:p xmlns:a="http://schemas.openxmlformats.org/drawingml/2006/main">
-            <a:r>
-              <a:t>What delivers them is performed action — specifically, action that fulfils relationships. Recognise the higher faculties; study until you understand; then act so that what you owe in each relationship is actually fulfilled. That third step is not optional decoration on the first two. It is where the harmony happens.</a:t>
-            </a:r>
-          </a:p>
-          <a:p xmlns:a="http://schemas.openxmlformats.org/drawingml/2006/main">
-            <a:r>
-              <a:t>That is why the text bothers with the anatomy of action at all. Every activity done with desire has five limbs: doer, cause, objective, result, and effect. Effect means the act's reach or consequence — not a separate ledger of destiny. Desire is the aspiration; karma is the doing, activity together with aspiration; result is the fruit. And the text's own criterion: desire, doing, and result must *balance* for the desire to be truly accomplished. Wanting without doing is not accomplishment. Doing that misses the result is not accomplishment either.</a:t>
-            </a:r>
-          </a:p>
-          <a:p xmlns:a="http://schemas.openxmlformats.org/drawingml/2006/main">
-            <a:r>
-              <a:t>So: understanding alone changes nothing. It is the doing that yields the fruit. Book knowledge is half the work — the other half is conduct that fulfils relationships.</a:t>
-            </a:r>
-          </a:p>
-          <a:p xmlns:a="http://schemas.openxmlformats.org/drawingml/2006/main">
-            <a:r>
-              <a:t>Hold this beside the earlier triad of effort, motion, and result. This is the desire-laden framing of the same activity ontology in sentient living. The next slides show how desire and doing get reorganised under justice, innateness, and truth.</a:t>
+            <a:pPr marL="0" indent="0" algn="l">
+              <a:spcBef>
+                <a:spcPts val="0"/>
+              </a:spcBef>
+              <a:spcAft>
+                <a:spcPts val="0"/>
+              </a:spcAft>
+              <a:buNone/>
+            </a:pPr>
+            <a:r>
+              <a:t>This is the claimed sentience threshold. The technical transitions slide names it T1; here the audience-facing question is how the texts say sentience enters.</a:t>
+            </a:r>
+          </a:p>
+          <a:p xmlns:a="http://schemas.openxmlformats.org/drawingml/2006/main">
+            <a:r>
+              <a:t>According to the primary texts, sentience appears when one developing atom reaches constitutional completeness — not through neural complexity, molecular size, or the material-to-biological order change.</a:t>
+            </a:r>
+          </a:p>
+          <a:p xmlns:a="http://schemas.openxmlformats.org/drawingml/2006/main">
+            <a:r>
+              <a:t>The described process begins with particle exchange. Hungry atoms can incorporate particles; overfull or undigested atoms seek to expel them. Under suitable mutuality, a developing atom integrates the full count required by its constitution. When that requirement is satisfied, the constitution closes and particle count no longer increases or decreases.</a:t>
+            </a:r>
+          </a:p>
+          <a:p xmlns:a="http://schemas.openxmlformats.org/drawingml/2006/main">
+            <a:r>
+              <a:t>The slide shows the before and after. Before sentience, the constitution remains open: particles are absorbed or expelled, molecular and weight bondage continue, and kind, capacity, and qualitative change track particle count. At the sentience threshold, all required particles are integrated. The count becomes fixed, molecular and weight bondage end, and qualitative activity continues. The texts classify that closed unit as sentient *jeevan*.</a:t>
+            </a:r>
+          </a:p>
+          <a:p xmlns:a="http://schemas.openxmlformats.org/drawingml/2006/main">
+            <a:r>
+              <a:t>That separation of qualitative from quantitative change is the stated criterion. MVD adds the visible signs of release from the molecular group, liberation from molecular- and weight-bondage, and establishment in hope-bondage.</a:t>
+            </a:r>
+          </a:p>
+          <a:p xmlns:a="http://schemas.openxmlformats.org/drawingml/2006/main">
+            <a:r>
+              <a:t>The transition to sentience is therefore a claim of reclassification at atomic closure: one atom becomes *jeevan*; a body does not become conscious by becoming more complex. The texts give a process and a criterion, but not an accepted physical measurement of this threshold or a causal explanation of why closure is sentience. We will return to that open bridge under method and evidence.</a:t>
             </a:r>
           </a:p>
         </p:txBody>
@@ -1429,28 +1333,37 @@
           <a:bodyPr xmlns:a="http://schemas.openxmlformats.org/drawingml/2006/main"/>
           <a:lstStyle xmlns:a="http://schemas.openxmlformats.org/drawingml/2006/main"/>
           <a:p xmlns:a="http://schemas.openxmlformats.org/drawingml/2006/main">
-            <a:r>
-              <a:t>Happiness, peace, contentment, and bliss are not passing moods, and they are not a fourth milestone after T1, T2, and T3.</a:t>
-            </a:r>
-          </a:p>
-          <a:p xmlns:a="http://schemas.openxmlformats.org/drawingml/2006/main">
-            <a:r>
-              <a:t>They name harmonies within the sentient unit. Happiness: harmony of hope and thought. Peace: thought and desire. Contentment: desire and resolve. Bliss: resolve and the core self.</a:t>
-            </a:r>
-          </a:p>
-          <a:p xmlns:a="http://schemas.openxmlformats.org/drawingml/2006/main">
-            <a:r>
-              <a:t>Now hold all four in view, because they are what the knowledge order is actually after. This is the answer to “what is a human life for?” in this system — and notice that only the first of the four is reachable by sensory living. Happiness, the harmony of hope and thought, an animal can have. Peace, contentment, and bliss it cannot even see.</a:t>
-            </a:r>
-          </a:p>
-          <a:p xmlns:a="http://schemas.openxmlformats.org/drawingml/2006/main">
-            <a:r>
-              <a:t>The living cycle is: reflection feeds projection, and projection feeds deeper reflection — that is what living means here. Continuous happiness is harmony evidenced in resolved living, not a sensory spike.</a:t>
-            </a:r>
-          </a:p>
-          <a:p xmlns:a="http://schemas.openxmlformats.org/drawingml/2006/main">
-            <a:r>
-              <a:t>The next two slides ask how a human being actually gets from the first harmony to the other three.</a:t>
+            <a:pPr marL="0" indent="0" algn="l">
+              <a:spcBef>
+                <a:spcPts val="0"/>
+              </a:spcBef>
+              <a:spcAft>
+                <a:spcPts val="0"/>
+              </a:spcAft>
+              <a:buNone/>
+            </a:pPr>
+            <a:r>
+              <a:t>We now turn to human living — movement three.</a:t>
+            </a:r>
+          </a:p>
+          <a:p xmlns:a="http://schemas.openxmlformats.org/drawingml/2006/main">
+            <a:r>
+              <a:t>Animal and human living is a joint form. The sentient unit brings the full set of faculties and activities. The body supplies the species-specific medium.</a:t>
+            </a:r>
+          </a:p>
+          <a:p xmlns:a="http://schemas.openxmlformats.org/drawingml/2006/main">
+            <a:r>
+              <a:t>On one side: the body — living composition, sense organs, brain, physical expression; decomposable. On the other: the sentient unit — constitutionally complete; faculties inherent; continuing when the joint form ends.</a:t>
+            </a:r>
+          </a:p>
+          <a:p xmlns:a="http://schemas.openxmlformats.org/drawingml/2006/main">
+            <a:r>
+              <a:t>Animal bodily development limits expression. The human medium can support the full range, while mistaking the body for the self can still misdirect evaluation.</a:t>
+            </a:r>
+          </a:p>
+          <a:p xmlns:a="http://schemas.openxmlformats.org/drawingml/2006/main">
+            <a:r>
+              <a:t>The body gates expression. The sentient unit is seer, doer, and enjoyer through the body. Animal limitation belongs to the medium. Human mis-evaluation belongs to that confusion. The body does not produce sentience, and those two problems are not the same problem.</a:t>
             </a:r>
           </a:p>
         </p:txBody>
@@ -1529,32 +1442,27 @@
               <a:buNone/>
             </a:pPr>
             <a:r>
-              <a:t>I have now told you twice that the composing line and the atomic line are different. This slide is where I owe you the reason.</a:t>
-            </a:r>
-          </a:p>
-          <a:p xmlns:a="http://schemas.openxmlformats.org/drawingml/2006/main">
-            <a:r>
-              <a:t>Start with what is true, and notice it is complementarity doing the work: there is a natural inclination toward coexistence everywhere. That inclination is what leads particles into atoms, atoms into molecules, molecules into cells and bodies. It is real, and it builds a great deal.</a:t>
-            </a:r>
-          </a:p>
-          <a:p xmlns:a="http://schemas.openxmlformats.org/drawingml/2006/main">
-            <a:r>
-              <a:t>Now the constraint. Whatever a thing is constituted of, it remains of the order of that constituent — however vast the formation. Three of the texts' own examples. Objects made from soil remain soil, no matter how elaborate the object. A body built from living cells remains of the order of the living cell. And the Earth entire is of the order of the atoms, molecules, and cells composing it.</a:t>
-            </a:r>
-          </a:p>
-          <a:p xmlns:a="http://schemas.openxmlformats.org/drawingml/2006/main">
-            <a:r>
-              <a:t>So change of composition is recognised as development or decline *within* an order. It is never passage beyond the order. Compositional progression can give you an atom, then a molecule, then a cell, then a body of extraordinary complexity — and every one of those is still of the order of what it is made from.</a:t>
-            </a:r>
-          </a:p>
-          <a:p xmlns:a="http://schemas.openxmlformats.org/drawingml/2006/main">
-            <a:r>
-              <a:t>That is the argument. Composition supplies bodies and environments, and it never reaches constitutional completeness, because reaching it would mean exceeding the order of your own constituents. Which is exactly why development in the atom has to be kept as a separate line.</a:t>
-            </a:r>
-          </a:p>
-          <a:p xmlns:a="http://schemas.openxmlformats.org/drawingml/2006/main">
-            <a:r>
-              <a:t>Two smaller distinctions while we are here. In a mixture, components stay side by side and each keeps its own conduct — no new unit is formed. In a compound, definite proportion yields a genuinely new bounded unit, with its own form and its own capacities in mutuality. A compound is a real new unit; it is still not a step toward sentience.</a:t>
+              <a:t>The sentient unit — jeevan — is a constitutionally complete atom.</a:t>
+            </a:r>
+          </a:p>
+          <a:p xmlns:a="http://schemas.openxmlformats.org/drawingml/2006/main">
+            <a:r>
+              <a:t>Structurally, the centre is the core self. Around it: resolve, desire, thought, and hope — the texts’ buddhi, chitta, vritti, and mun.</a:t>
+            </a:r>
+          </a:p>
+          <a:p xmlns:a="http://schemas.openxmlformats.org/drawingml/2006/main">
+            <a:r>
+              <a:t>Each works outward and inward. Hope selects and tastes. Thought analyses and deliberates. Desire visualises and contemplates. Resolve resolves and receives clear understanding. The core self authenticates and realises.</a:t>
+            </a:r>
+          </a:p>
+          <a:p xmlns:a="http://schemas.openxmlformats.org/drawingml/2006/main">
+            <a:r>
+              <a:t>All five faculties and ten activities belong to the sentient unit. Presence is not the same as expression or effective organisation. Animal bodies limit expression. Humans have the medium for the full range, yet under body-confusion only part of that range may be effectively organised.</a:t>
+            </a:r>
+          </a:p>
+          <a:p xmlns:a="http://schemas.openxmlformats.org/drawingml/2006/main">
+            <a:r>
+              <a:t>Study brings understanding. Practice tests and stabilises it. Practice does not manufacture faculties that were missing.</a:t>
             </a:r>
           </a:p>
         </p:txBody>
@@ -1623,37 +1531,28 @@
           <a:bodyPr xmlns:a="http://schemas.openxmlformats.org/drawingml/2006/main"/>
           <a:lstStyle xmlns:a="http://schemas.openxmlformats.org/drawingml/2006/main"/>
           <a:p xmlns:a="http://schemas.openxmlformats.org/drawingml/2006/main">
-            <a:pPr marL="0" indent="0" algn="l">
-              <a:spcBef>
-                <a:spcPts val="0"/>
-              </a:spcBef>
-              <a:spcAft>
-                <a:spcPts val="0"/>
-              </a:spcAft>
-              <a:buNone/>
-            </a:pPr>
-            <a:r>
-              <a:t>This slide explains the name Madhyasth — and it cashes a cheque I wrote back on slide 6.</a:t>
-            </a:r>
-          </a:p>
-          <a:p xmlns:a="http://schemas.openxmlformats.org/drawingml/2006/main">
-            <a:r>
-              <a:t>Remember the third of the three terms: surrounded. Regulation is what surroundedness establishes. Because the formless reality stands between units, each is held at a definite distance from the others. Orderliness is self-regulation inherent in saturated units — not dispensed by a cosmic governor. That mediative regulation, which regulates and conserves every unit, gives the darshan its name.</a:t>
-            </a:r>
-          </a:p>
-          <a:p xmlns:a="http://schemas.openxmlformats.org/drawingml/2006/main">
-            <a:r>
-              <a:t>The account works at three levels, and it is worth naming them: Omnipresence is the sustaining condition; within an atom, the nucleus is the mediative organisation that regulates generative and degenerative activity and conserves relative powers; and at larger scales, order-specific conformance is the definite conduct you can actually observe.</a:t>
-            </a:r>
-          </a:p>
-          <a:p xmlns:a="http://schemas.openxmlformats.org/drawingml/2006/main">
-            <a:r>
-              <a:t>Conformance has order-specific modes. Material: structural or result conformance. Bio: seed-conformance. Animal: species-conformance, inherited from gestation. Human: *sanskar*-conformance — achieved through knowing, believing, recognising, and fulfilling, rather than inherited. That last one is why education and tradition matter so much here: they can reproduce confusion just as easily as they can support awakening.</a:t>
-            </a:r>
-          </a:p>
-          <a:p xmlns:a="http://schemas.openxmlformats.org/drawingml/2006/main">
-            <a:r>
-              <a:t>Material, bio, and animal regulation is definite. An animal body’s expressive limits do not introduce evaluative error. In human living, the sentient unit can judge wrongly when it mistakes the body for the self. Awakening aligns evaluation with coexistence. That is why justice becomes necessary at the human order.</a:t>
+            <a:r>
+              <a:t>Happiness, peace, contentment, and bliss are not passing moods, and they are not a fourth milestone after T1, T2, and T3.</a:t>
+            </a:r>
+          </a:p>
+          <a:p xmlns:a="http://schemas.openxmlformats.org/drawingml/2006/main">
+            <a:r>
+              <a:t>They name harmonies within the sentient unit. Happiness: harmony of hope and thought. Peace: thought and desire. Contentment: desire and resolve. Bliss: resolve and the core self.</a:t>
+            </a:r>
+          </a:p>
+          <a:p xmlns:a="http://schemas.openxmlformats.org/drawingml/2006/main">
+            <a:r>
+              <a:t>Now hold all four in view, because they are what the knowledge order is actually after. This is the answer to “what is a human life for?” in this system — and notice that only the first of the four is reachable by sensory living. Happiness, the harmony of hope and thought, an animal can have. Peace, contentment, and bliss it cannot even see.</a:t>
+            </a:r>
+          </a:p>
+          <a:p xmlns:a="http://schemas.openxmlformats.org/drawingml/2006/main">
+            <a:r>
+              <a:t>The living cycle is: reflection feeds projection, and projection feeds deeper reflection — that is what living means here. Continuous happiness is harmony evidenced in resolved living, not a sensory spike.</a:t>
+            </a:r>
+          </a:p>
+          <a:p xmlns:a="http://schemas.openxmlformats.org/drawingml/2006/main">
+            <a:r>
+              <a:t>The next two slides ask how a human being actually gets from the first harmony to the other three.</a:t>
             </a:r>
           </a:p>
         </p:txBody>
@@ -1818,27 +1717,42 @@
           <a:lstStyle xmlns:a="http://schemas.openxmlformats.org/drawingml/2006/main"/>
           <a:p xmlns:a="http://schemas.openxmlformats.org/drawingml/2006/main">
             <a:r>
-              <a:t>Human evaluation widens across six perspectives: pleasant, healthy, profit, justice, innateness or dharma as an evaluative lens, and truth. They move from sensation, body, and gain to relationship, orderliness, and coexistence.</a:t>
-            </a:r>
-          </a:p>
-          <a:p xmlns:a="http://schemas.openxmlformats.org/drawingml/2006/main">
-            <a:r>
-              <a:t>Justice is both one of the six and the principle of fulfilled relationship. Dharma here means fitting the wider pattern — discipline in thought, not only outer conduct. Truth means alignment with the whole, grounded in realisation, not in liking or gain.</a:t>
-            </a:r>
-          </a:p>
-          <a:p xmlns:a="http://schemas.openxmlformats.org/drawingml/2006/main">
-            <a:r>
-              <a:t>The graduated chain is: rule itself is justice; justice itself is dharma; dharma itself is truth; truth itself is coexistence.</a:t>
-            </a:r>
-          </a:p>
-          <a:p xmlns:a="http://schemas.openxmlformats.org/drawingml/2006/main">
-            <a:r>
-              <a:t>Pleasure, health, and profit are not condemned. They remain legitimate in their domain. Awakening changes the organising refuge: they are subordinated under justice, dharma, and truth — not abandoned.</a:t>
-            </a:r>
-          </a:p>
-          <a:p xmlns:a="http://schemas.openxmlformats.org/drawingml/2006/main">
-            <a:r>
-              <a:t>Keep this distinct from unit-innateness earlier. One word, two levels: what a unit cannot be separated from, versus how we evaluate thought and resolution.</a:t>
+              <a:t>Every sentient unit bears the same five faculties and the same ten activities. What differs is the medium and what the unit does with it.</a:t>
+            </a:r>
+          </a:p>
+          <a:p xmlns:a="http://schemas.openxmlformats.org/drawingml/2006/main">
+            <a:r>
+              <a:t>Take the animal case first, because it sets up the human one. An animal *jeevan* is complete — it has all five faculties. But its bodily medium is limited, so it acts for sensory satisfaction under species-conformance, and it reaches the first harmony and stops. Peace, contentment, and bliss are not failures on its part; they are simply not available through that body.</a:t>
+            </a:r>
+          </a:p>
+          <a:p xmlns:a="http://schemas.openxmlformats.org/drawingml/2006/main">
+            <a:r>
+              <a:t>Now the human case. The human body *can* express all ten activities — that is what the developed nervous system is for. And yet, by default, human *jeevan* goes on evaluating by exactly the same sensory criteria the animal used. The equipment changed; the habit did not. That is the fork this slide names, and it answers one practical question — what makes me happy?</a:t>
+            </a:r>
+          </a:p>
+          <a:p xmlns:a="http://schemas.openxmlformats.org/drawingml/2006/main">
+            <a:r>
+              <a:t>Under confusion, the body is mistaken for the self. Selection and evaluation organise around pleasure, health, and profit.</a:t>
+            </a:r>
+          </a:p>
+          <a:p xmlns:a="http://schemas.openxmlformats.org/drawingml/2006/main">
+            <a:r>
+              <a:t>Under awakening, clear knowing regulates sensory life. Knowing and believing guide recognition and fulfilment toward justice, innateness, truth, and coexistence.</a:t>
+            </a:r>
+          </a:p>
+          <a:p xmlns:a="http://schemas.openxmlformats.org/drawingml/2006/main">
+            <a:r>
+              <a:t>No faculty is missing, and sensation is not rejected. Confusion lets sensory criteria rule; awakening balances sensation with understanding, so understanding guides conduct.</a:t>
+            </a:r>
+          </a:p>
+          <a:p xmlns:a="http://schemas.openxmlformats.org/drawingml/2006/main">
+            <a:r>
+              <a:t>When the same fork is resolved in a person and sustained across a tradition, it shows as resolution, prosperity, fearlessness, and coexistence.</a:t>
+            </a:r>
+          </a:p>
+          <a:p xmlns:a="http://schemas.openxmlformats.org/drawingml/2006/main">
+            <a:r>
+              <a:t>And one thing awakening is *not*: it is not preferring the right things, and it is not having the right insight. The next slide is about why.</a:t>
             </a:r>
           </a:p>
         </p:txBody>
@@ -1907,32 +1821,38 @@
           <a:bodyPr xmlns:a="http://schemas.openxmlformats.org/drawingml/2006/main"/>
           <a:lstStyle xmlns:a="http://schemas.openxmlformats.org/drawingml/2006/main"/>
           <a:p xmlns:a="http://schemas.openxmlformats.org/drawingml/2006/main">
-            <a:pPr marL="0" indent="0" algn="l">
-              <a:spcBef>
-                <a:spcPts val="0"/>
-              </a:spcBef>
-              <a:spcAft>
-                <a:spcPts val="0"/>
-              </a:spcAft>
-              <a:buNone/>
-            </a:pPr>
-            <a:r>
-              <a:t>We turn now to knowing — how understanding widens, and how it happens in the sentient unit.</a:t>
-            </a:r>
-          </a:p>
-          <a:p xmlns:a="http://schemas.openxmlformats.org/drawingml/2006/main">
-            <a:r>
-              <a:t>On the left: what must be understood as mutual context widens. Form is real structure encountered in mutual facing. Capacities show as effects between units. Essential nature needs state, order, and context. Innateness is evidenced in whole-order fulfilment. Relationships are shared expectations weighed by justice, dharma, and truth. At the top is coexistence itself — not another observed detail, but the aim of knowing.</a:t>
-            </a:r>
-          </a:p>
-          <a:p xmlns:a="http://schemas.openxmlformats.org/drawingml/2006/main">
-            <a:r>
-              <a:t>On the right: how knowing happens within the sentient unit. Hope tastes and selects. Thought deliberates. Desire contemplates. Resolve clarifies and resolves. The core self realises — through truth. When each level is acted in alignment, it is felt as happiness, peace, contentment, and bliss.</a:t>
-            </a:r>
-          </a:p>
-          <a:p xmlns:a="http://schemas.openxmlformats.org/drawingml/2006/main">
-            <a:r>
-              <a:t>The ladders meet at the top: coexistence known and lived is felt as bliss. Human error belongs to confused evaluation, not to fuzziness in the reality reflected.</a:t>
+            <a:r>
+              <a:t>So: peace, contentment, bliss. How does a person actually get them?</a:t>
+            </a:r>
+          </a:p>
+          <a:p xmlns:a="http://schemas.openxmlformats.org/drawingml/2006/main">
+            <a:r>
+              <a:t>Let me put the shape of the answer first, because it is the hinge of this whole movement. Below the human order, fulfilment is definite — it needs no deciding. A molecule does not choose. A plant does not deliberate. Even the animal, which has a complete sentient unit, is carried by species-conformance to the fulfilment available through its body. Nothing there has to be *worked out*.</a:t>
+            </a:r>
+          </a:p>
+          <a:p xmlns:a="http://schemas.openxmlformats.org/drawingml/2006/main">
+            <a:r>
+              <a:t>The human order is the one place where complementarity has to be fulfilled *knowingly* — where the higher harmonies are on offer and nothing delivers them automatically. And here is the part people resist: understanding does not deliver them either. Study is necessary. It is not sufficient. You can recognise the higher faculties, grasp the whole account, hold it clearly — and still not have peace, contentment, or bliss, because those are harmonies of the unit in *activity*, and there is no activity in knowing about activity.</a:t>
+            </a:r>
+          </a:p>
+          <a:p xmlns:a="http://schemas.openxmlformats.org/drawingml/2006/main">
+            <a:r>
+              <a:t>What delivers them is performed action — specifically, action that fulfils relationships. Recognise the higher faculties; study until you understand; then act so that what you owe in each relationship is actually fulfilled. That third step is not optional decoration on the first two. It is where the harmony happens.</a:t>
+            </a:r>
+          </a:p>
+          <a:p xmlns:a="http://schemas.openxmlformats.org/drawingml/2006/main">
+            <a:r>
+              <a:t>That is why the text bothers with the anatomy of action at all. Every activity done with desire has five limbs: doer, cause, objective, result, and effect. Effect means the act's reach or consequence — not a separate ledger of destiny. Desire is the aspiration; karma is the doing, activity together with aspiration; result is the fruit. And the text's own criterion: desire, doing, and result must *balance* for the desire to be truly accomplished. Wanting without doing is not accomplishment. Doing that misses the result is not accomplishment either.</a:t>
+            </a:r>
+          </a:p>
+          <a:p xmlns:a="http://schemas.openxmlformats.org/drawingml/2006/main">
+            <a:r>
+              <a:t>So: understanding alone changes nothing. It is the doing that yields the fruit. Book knowledge is half the work — the other half is conduct that fulfils relationships.</a:t>
+            </a:r>
+          </a:p>
+          <a:p xmlns:a="http://schemas.openxmlformats.org/drawingml/2006/main">
+            <a:r>
+              <a:t>Hold this beside the earlier triad of effort, motion, and result. This is the desire-laden framing of the same activity ontology in sentient living. The next slides show how desire and doing get reorganised under justice, innateness, and truth.</a:t>
             </a:r>
           </a:p>
         </p:txBody>
@@ -2011,37 +1931,27 @@
               <a:buNone/>
             </a:pPr>
             <a:r>
-              <a:t>Before the closing summary, I owe you an accounting of what kind of thing each part of this has been.</a:t>
-            </a:r>
-          </a:p>
-          <a:p xmlns:a="http://schemas.openxmlformats.org/drawingml/2006/main">
-            <a:r>
-              <a:t>Different methods establish different things. They can support one another, but they are not interchangeable.</a:t>
-            </a:r>
-          </a:p>
-          <a:p xmlns:a="http://schemas.openxmlformats.org/drawingml/2006/main">
-            <a:r>
-              <a:t>Logical exposition can show internal coherence. It cannot by itself prove empirical fact.</a:t>
-            </a:r>
-          </a:p>
-          <a:p xmlns:a="http://schemas.openxmlformats.org/drawingml/2006/main">
-            <a:r>
-              <a:t>Study and self-examination can show intelligibility and first-person recognition. They cannot by themselves physically identify the sentient unit.</a:t>
-            </a:r>
-          </a:p>
-          <a:p xmlns:a="http://schemas.openxmlformats.org/drawingml/2006/main">
-            <a:r>
-              <a:t>Practice and conduct-evidence can show effects in work, behaviour, and mutual satisfaction. They cannot by themselves measure T1 or the unit–body interface.</a:t>
-            </a:r>
-          </a:p>
-          <a:p xmlns:a="http://schemas.openxmlformats.org/drawingml/2006/main">
-            <a:r>
-              <a:t>Realisation is this tradition’s claimed completion of knowing. It does not force agreement from other methods.</a:t>
-            </a:r>
-          </a:p>
-          <a:p xmlns:a="http://schemas.openxmlformats.org/drawingml/2006/main">
-            <a:r>
-              <a:t>Publicly measurable physical claims remain answerable to instrument-based science. No accepted measurement currently identifies T1, the unit–body interface, or post-body reassociation — the last of those being the claim I flagged on slide 16, that the sentient unit continues when a body ends and may later associate with another. Stating that plainly is part of responsible presentation.</a:t>
+              <a:t>This slide explains the name Madhyasth — and it cashes a cheque I wrote back on slide 6.</a:t>
+            </a:r>
+          </a:p>
+          <a:p xmlns:a="http://schemas.openxmlformats.org/drawingml/2006/main">
+            <a:r>
+              <a:t>Remember the third of the three terms: surrounded. Regulation is what surroundedness establishes. Because the formless reality stands between units, each is held at a definite distance from the others. Orderliness is self-regulation inherent in saturated units — not dispensed by a cosmic governor. That mediative regulation, which regulates and conserves every unit, gives the darshan its name.</a:t>
+            </a:r>
+          </a:p>
+          <a:p xmlns:a="http://schemas.openxmlformats.org/drawingml/2006/main">
+            <a:r>
+              <a:t>The account works at three levels, and it is worth naming them: Omnipresence is the sustaining condition; within an atom, the nucleus is the mediative organisation that regulates generative and degenerative activity and conserves relative powers; and at larger scales, order-specific conformance is the definite conduct you can actually observe.</a:t>
+            </a:r>
+          </a:p>
+          <a:p xmlns:a="http://schemas.openxmlformats.org/drawingml/2006/main">
+            <a:r>
+              <a:t>Conformance has order-specific modes. Material: structural or result conformance. Bio: seed-conformance. Animal: species-conformance, inherited from gestation. Human: *sanskar*-conformance — achieved through knowing, believing, recognising, and fulfilling, rather than inherited. That last one is why education and tradition matter so much here: they can reproduce confusion just as easily as they can support awakening.</a:t>
+            </a:r>
+          </a:p>
+          <a:p xmlns:a="http://schemas.openxmlformats.org/drawingml/2006/main">
+            <a:r>
+              <a:t>Material, bio, and animal regulation is definite. An animal body’s expressive limits do not introduce evaluative error. In human living, the sentient unit can judge wrongly when it mistakes the body for the self. Awakening aligns evaluation with coexistence. That is why justice becomes necessary at the human order.</a:t>
             </a:r>
           </a:p>
         </p:txBody>
@@ -2111,42 +2021,27 @@
           <a:lstStyle xmlns:a="http://schemas.openxmlformats.org/drawingml/2006/main"/>
           <a:p xmlns:a="http://schemas.openxmlformats.org/drawingml/2006/main">
             <a:r>
-              <a:t>Every sentient unit bears the same five faculties and the same ten activities. What differs is the medium and what the unit does with it.</a:t>
-            </a:r>
-          </a:p>
-          <a:p xmlns:a="http://schemas.openxmlformats.org/drawingml/2006/main">
-            <a:r>
-              <a:t>Take the animal case first, because it sets up the human one. An animal *jeevan* is complete — it has all five faculties. But its bodily medium is limited, so it acts for sensory satisfaction under species-conformance, and it reaches the first harmony and stops. Peace, contentment, and bliss are not failures on its part; they are simply not available through that body.</a:t>
-            </a:r>
-          </a:p>
-          <a:p xmlns:a="http://schemas.openxmlformats.org/drawingml/2006/main">
-            <a:r>
-              <a:t>Now the human case. The human body *can* express all ten activities — that is what the developed nervous system is for. And yet, by default, human *jeevan* goes on evaluating by exactly the same sensory criteria the animal used. The equipment changed; the habit did not. That is the fork this slide names, and it answers one practical question — what makes me happy?</a:t>
-            </a:r>
-          </a:p>
-          <a:p xmlns:a="http://schemas.openxmlformats.org/drawingml/2006/main">
-            <a:r>
-              <a:t>Under confusion, the body is mistaken for the self. Selection and evaluation organise around pleasure, health, and profit.</a:t>
-            </a:r>
-          </a:p>
-          <a:p xmlns:a="http://schemas.openxmlformats.org/drawingml/2006/main">
-            <a:r>
-              <a:t>Under awakening, clear knowing regulates sensory life. Knowing and believing guide recognition and fulfilment toward justice, innateness, truth, and coexistence.</a:t>
-            </a:r>
-          </a:p>
-          <a:p xmlns:a="http://schemas.openxmlformats.org/drawingml/2006/main">
-            <a:r>
-              <a:t>No faculty is missing, and sensation is not rejected. Confusion lets sensory criteria rule; awakening balances sensation with understanding, so understanding guides conduct.</a:t>
-            </a:r>
-          </a:p>
-          <a:p xmlns:a="http://schemas.openxmlformats.org/drawingml/2006/main">
-            <a:r>
-              <a:t>When the same fork is resolved in a person and sustained across a tradition, it shows as resolution, prosperity, fearlessness, and coexistence.</a:t>
-            </a:r>
-          </a:p>
-          <a:p xmlns:a="http://schemas.openxmlformats.org/drawingml/2006/main">
-            <a:r>
-              <a:t>And one thing awakening is *not*: it is not preferring the right things, and it is not having the right insight. The next slide is about why.</a:t>
+              <a:t>Human evaluation widens across six perspectives: pleasant, healthy, profit, justice, innateness or dharma as an evaluative lens, and truth. They move from sensation, body, and gain to relationship, orderliness, and coexistence.</a:t>
+            </a:r>
+          </a:p>
+          <a:p xmlns:a="http://schemas.openxmlformats.org/drawingml/2006/main">
+            <a:r>
+              <a:t>Justice is both one of the six and the principle of fulfilled relationship. Dharma here means fitting the wider pattern — discipline in thought, not only outer conduct. Truth means alignment with the whole, grounded in realisation, not in liking or gain.</a:t>
+            </a:r>
+          </a:p>
+          <a:p xmlns:a="http://schemas.openxmlformats.org/drawingml/2006/main">
+            <a:r>
+              <a:t>The graduated chain is: rule itself is justice; justice itself is dharma; dharma itself is truth; truth itself is coexistence.</a:t>
+            </a:r>
+          </a:p>
+          <a:p xmlns:a="http://schemas.openxmlformats.org/drawingml/2006/main">
+            <a:r>
+              <a:t>Pleasure, health, and profit are not condemned. They remain legitimate in their domain. Awakening changes the organising refuge: they are subordinated under justice, dharma, and truth — not abandoned.</a:t>
+            </a:r>
+          </a:p>
+          <a:p xmlns:a="http://schemas.openxmlformats.org/drawingml/2006/main">
+            <a:r>
+              <a:t>Keep this distinct from unit-innateness earlier. One word, two levels: what a unit cannot be separated from, versus how we evaluate thought and resolution.</a:t>
             </a:r>
           </a:p>
         </p:txBody>
@@ -2225,22 +2120,22 @@
               <a:buNone/>
             </a:pPr>
             <a:r>
-              <a:t>This is where the developmental drive comes to rest: realisation in coexistence.</a:t>
-            </a:r>
-          </a:p>
-          <a:p xmlns:a="http://schemas.openxmlformats.org/drawingml/2006/main">
-            <a:r>
-              <a:t>The drive settles when relationships across nature are fulfilled and made evident — not because the ground becomes a knower, but because the awakened sentient unit realises and evidences the coexistence in which it has always existed.</a:t>
-            </a:r>
-          </a:p>
-          <a:p xmlns:a="http://schemas.openxmlformats.org/drawingml/2006/main">
-            <a:r>
-              <a:t>Realisation is bliss. Truth itself is abundance — coexistence; realisation of abundance is bliss; bliss is the living of the sentient unit. What is realised is the ground the unit was always saturated in.</a:t>
-            </a:r>
-          </a:p>
-          <a:p xmlns:a="http://schemas.openxmlformats.org/drawingml/2006/main">
-            <a:r>
-              <a:t>Three roles stay distinct: the sentient unit remains the knower; existence as coexistence remains the known; knowledge becomes evident as authentic conduct. They become coherent without becoming identical. The individual knower is not dissolved into a single universal Self.</a:t>
+              <a:t>We turn now to knowing — how understanding widens, and how it happens in the sentient unit.</a:t>
+            </a:r>
+          </a:p>
+          <a:p xmlns:a="http://schemas.openxmlformats.org/drawingml/2006/main">
+            <a:r>
+              <a:t>On the left: what must be understood as mutual context widens. Form is real structure encountered in mutual facing. Capacities show as effects between units. Essential nature needs state, order, and context. Innateness is evidenced in whole-order fulfilment. Relationships are shared expectations weighed by justice, dharma, and truth. At the top is coexistence itself — not another observed detail, but the aim of knowing.</a:t>
+            </a:r>
+          </a:p>
+          <a:p xmlns:a="http://schemas.openxmlformats.org/drawingml/2006/main">
+            <a:r>
+              <a:t>On the right: how knowing happens within the sentient unit. Hope tastes and selects. Thought deliberates. Desire contemplates. Resolve clarifies and resolves. The core self realises — through truth. When each level is acted in alignment, it is felt as happiness, peace, contentment, and bliss.</a:t>
+            </a:r>
+          </a:p>
+          <a:p xmlns:a="http://schemas.openxmlformats.org/drawingml/2006/main">
+            <a:r>
+              <a:t>The ladders meet at the top: coexistence known and lived is felt as bliss. Human error belongs to confused evaluation, not to fuzziness in the reality reflected.</a:t>
             </a:r>
           </a:p>
         </p:txBody>
@@ -2319,32 +2214,22 @@
               <a:buNone/>
             </a:pPr>
             <a:r>
-              <a:t>The drive comes to rest in awakened human beings — effort settled, understanding proven in daily conduct, and carried as a tradition.</a:t>
-            </a:r>
-          </a:p>
-          <a:p xmlns:a="http://schemas.openxmlformats.org/drawingml/2006/main">
-            <a:r>
-              <a:t>Effort settled in realisation is T2. Understanding proven in conduct is T3.</a:t>
-            </a:r>
-          </a:p>
-          <a:p xmlns:a="http://schemas.openxmlformats.org/drawingml/2006/main">
-            <a:r>
-              <a:t>Four goals at four levels: resolution in every person; prosperity in every family; fearlessness — trust — in society; coexistence with all of nature.</a:t>
-            </a:r>
-          </a:p>
-          <a:p xmlns:a="http://schemas.openxmlformats.org/drawingml/2006/main">
-            <a:r>
-              <a:t>Five dimensions of continuity carry the tradition: education and formative culture; justice and preservation; health and restraint; production and work; exchange and storage.</a:t>
-            </a:r>
-          </a:p>
-          <a:p xmlns:a="http://schemas.openxmlformats.org/drawingml/2006/main">
-            <a:r>
-              <a:t>And here is where the other half of the composition slide returns. Families and societies are not a further compositional tier — you cannot get a humane society by stacking bodies the way you stack molecules. They are relational achievements: they persist humanely while relationships are recognised, values fulfilled, evaluation completed, and mutual satisfaction achieved. Fear, force, or extraction can hold a group together for a while; on this account they do not make it an orderly society.</a:t>
-            </a:r>
-          </a:p>
-          <a:p xmlns:a="http://schemas.openxmlformats.org/drawingml/2006/main">
-            <a:r>
-              <a:t>This is not an ideal bolted onto matter. On this account, the progression is designed to arrive here. Nature saturated in Omnipresence is bound for development until realisation. An awakened human tradition is what that progression delivers.</a:t>
+              <a:t>This is where the developmental drive comes to rest: realisation in coexistence.</a:t>
+            </a:r>
+          </a:p>
+          <a:p xmlns:a="http://schemas.openxmlformats.org/drawingml/2006/main">
+            <a:r>
+              <a:t>The drive settles when relationships across nature are fulfilled and made evident — not because the ground becomes a knower, but because the awakened sentient unit realises and evidences the coexistence in which it has always existed.</a:t>
+            </a:r>
+          </a:p>
+          <a:p xmlns:a="http://schemas.openxmlformats.org/drawingml/2006/main">
+            <a:r>
+              <a:t>Realisation is bliss. Truth itself is abundance — coexistence; realisation of abundance is bliss; bliss is the living of the sentient unit. What is realised is the ground the unit was always saturated in.</a:t>
+            </a:r>
+          </a:p>
+          <a:p xmlns:a="http://schemas.openxmlformats.org/drawingml/2006/main">
+            <a:r>
+              <a:t>Three roles stay distinct: the sentient unit remains the knower; existence as coexistence remains the known; knowledge becomes evident as authentic conduct. They become coherent without becoming identical. The individual knower is not dissolved into a single universal Self.</a:t>
             </a:r>
           </a:p>
         </p:txBody>
@@ -2423,42 +2308,32 @@
               <a:buNone/>
             </a:pPr>
             <a:r>
-              <a:t>Let us close the loop on the six questions.</a:t>
-            </a:r>
-          </a:p>
-          <a:p xmlns:a="http://schemas.openxmlformats.org/drawingml/2006/main">
-            <a:r>
-              <a:t>What is existence? Eternal coexistence: countless units saturated in all-pervasive Omnipresence.</a:t>
-            </a:r>
-          </a:p>
-          <a:p xmlns:a="http://schemas.openxmlformats.org/drawingml/2006/main">
-            <a:r>
-              <a:t>What exists? Root atomic units; composite units and bodies; body–sentient-unit joint forms; and relational human assemblies — all saturated in the ground.</a:t>
-            </a:r>
-          </a:p>
-          <a:p xmlns:a="http://schemas.openxmlformats.org/drawingml/2006/main">
-            <a:r>
-              <a:t>Does existence begin or end? No. Existence is perpetual. Configurations form, transform, and decompose.</a:t>
-            </a:r>
-          </a:p>
-          <a:p xmlns:a="http://schemas.openxmlformats.org/drawingml/2006/main">
-            <a:r>
-              <a:t>What is the self? The constitutionally complete sentient unit working through the body.</a:t>
-            </a:r>
-          </a:p>
-          <a:p xmlns:a="http://schemas.openxmlformats.org/drawingml/2006/main">
-            <a:r>
-              <a:t>Is the world real? Yes. Units, mutual relationships, and definite material fulfilment are real within perpetual coexistence.</a:t>
-            </a:r>
-          </a:p>
-          <a:p xmlns:a="http://schemas.openxmlformats.org/drawingml/2006/main">
-            <a:r>
-              <a:t>How is it known? Through logical exposition, study and self-examination, practice, realisation, and conduct-evidence — without conflating those with instrument measurement of T1. The lived test is evidence in humane conduct.</a:t>
-            </a:r>
-          </a:p>
-          <a:p xmlns:a="http://schemas.openxmlformats.org/drawingml/2006/main">
-            <a:r>
-              <a:t>If we continue later, the natural next step is comparison with other traditions and with science — including open problems this study names for Madhyasth Darshan itself. Thank you.</a:t>
+              <a:t>The drive comes to rest in awakened human beings — effort settled, understanding proven in daily conduct, and carried as a tradition.</a:t>
+            </a:r>
+          </a:p>
+          <a:p xmlns:a="http://schemas.openxmlformats.org/drawingml/2006/main">
+            <a:r>
+              <a:t>Effort settled in realisation is T2. Understanding proven in conduct is T3.</a:t>
+            </a:r>
+          </a:p>
+          <a:p xmlns:a="http://schemas.openxmlformats.org/drawingml/2006/main">
+            <a:r>
+              <a:t>Four goals at four levels: resolution in every person; prosperity in every family; fearlessness — trust — in society; coexistence with all of nature.</a:t>
+            </a:r>
+          </a:p>
+          <a:p xmlns:a="http://schemas.openxmlformats.org/drawingml/2006/main">
+            <a:r>
+              <a:t>Five dimensions of continuity carry the tradition: education and formative culture; justice and preservation; health and restraint; production and work; exchange and storage.</a:t>
+            </a:r>
+          </a:p>
+          <a:p xmlns:a="http://schemas.openxmlformats.org/drawingml/2006/main">
+            <a:r>
+              <a:t>And here is where the other half of the composition slide returns. Families and societies are not a further compositional tier — you cannot get a humane society by stacking bodies the way you stack molecules. They are relational achievements: they persist humanely while relationships are recognised, values fulfilled, evaluation completed, and mutual satisfaction achieved. Fear, force, or extraction can hold a group together for a while; on this account they do not make it an orderly society.</a:t>
+            </a:r>
+          </a:p>
+          <a:p xmlns:a="http://schemas.openxmlformats.org/drawingml/2006/main">
+            <a:r>
+              <a:t>This is not an ideal bolted onto matter. On this account, the progression is designed to arrive here. Nature saturated in Omnipresence is bound for development until realisation. An awakened human tradition is what that progression delivers.</a:t>
             </a:r>
           </a:p>
         </p:txBody>
@@ -2489,7 +2364,7 @@
 </file>
 
 <file path=ppt/notesSlides/notesSlide27.xml><?xml version="1.0" encoding="utf-8"?>
-<p:notes xmlns:a="http://schemas.openxmlformats.org/drawingml/2006/main" xmlns:p="http://schemas.openxmlformats.org/presentationml/2006/main" xmlns:r="http://schemas.openxmlformats.org/officeDocument/2006/relationships">
+<p:notes xmlns:p="http://schemas.openxmlformats.org/presentationml/2006/main">
   <p:cSld>
     <p:spTree>
       <p:nvGrpSpPr>
@@ -2498,21 +2373,16 @@
         <p:nvPr/>
       </p:nvGrpSpPr>
       <p:grpSpPr>
-        <a:xfrm>
-          <a:off x="0" y="0"/>
-          <a:ext cx="0" cy="0"/>
-          <a:chOff x="0" y="0"/>
-          <a:chExt cx="0" cy="0"/>
-        </a:xfrm>
+        <a:xfrm xmlns:a="http://schemas.openxmlformats.org/drawingml/2006/main"/>
       </p:grpSpPr>
       <p:sp>
         <p:nvSpPr>
           <p:cNvPr id="2" name="Slide Image Placeholder 1"/>
           <p:cNvSpPr>
-            <a:spLocks noGrp="1"/>
+            <a:spLocks xmlns:a="http://schemas.openxmlformats.org/drawingml/2006/main" noGrp="1"/>
           </p:cNvSpPr>
           <p:nvPr>
-            <p:ph type="sldImg" idx="2"/>
+            <p:ph type="sldImg" idx="0"/>
           </p:nvPr>
         </p:nvSpPr>
         <p:spPr/>
@@ -2521,39 +2391,58 @@
         <p:nvSpPr>
           <p:cNvPr id="3" name="Notes Placeholder 2"/>
           <p:cNvSpPr>
-            <a:spLocks noGrp="1"/>
+            <a:spLocks xmlns:a="http://schemas.openxmlformats.org/drawingml/2006/main" noGrp="1"/>
           </p:cNvSpPr>
           <p:nvPr>
-            <p:ph type="body" idx="3" sz="quarter"/>
+            <p:ph type="body" idx="1"/>
           </p:nvPr>
         </p:nvSpPr>
         <p:spPr/>
         <p:txBody>
-          <a:bodyPr/>
-          <a:lstStyle/>
-          <a:p>
-            <a:r>
-              <a:t>One consequence of the last slide deserves its own moment, because it answers the second of our opening questions.</a:t>
-            </a:r>
-          </a:p>
-          <a:p>
-            <a:r>
-              <a:t>If no division of a unit can put any fragment outside the ground, then nothing that exists can be annihilated. And nothing arises from non-being either. So existence does not begin and does not end. What begins and ends is composition — particular arrangements of units.</a:t>
-            </a:r>
-          </a:p>
-          <a:p>
-            <a:r>
-              <a:t>Notice carefully what that does and does not claim. A compound decomposes. A body dies. Those organisations genuinely end. What continues is their constituents, in other relations. Perpetuity belongs to coexistence, not to any particular configuration.</a:t>
-            </a:r>
-          </a:p>
-          <a:p>
-            <a:r>
-              <a:t>Second point, and this one matters for how you hear the rest of the session. The texts call Omnipresence the supreme cause, and that phrase invites a misreading. It is cause only in the sustaining sense — no activity exists apart from nature saturated in it. It starts no particular change. Composition, decomposition, development, conduct: all of that is the work of units acting on one another. So there is no creator in this account, and no ruler issuing instructions.</a:t>
-            </a:r>
-          </a:p>
-          <a:p>
-            <a:r>
-              <a:t>Third, time. Time here is not a container existing alongside the ground and the units. Time is the duration of activity, reckoned from recurrent activities — a rotation, a year. The ground does not transform, so it is not temporal in the way unit-activity is measured.</a:t>
+          <a:bodyPr xmlns:a="http://schemas.openxmlformats.org/drawingml/2006/main"/>
+          <a:lstStyle xmlns:a="http://schemas.openxmlformats.org/drawingml/2006/main"/>
+          <a:p xmlns:a="http://schemas.openxmlformats.org/drawingml/2006/main">
+            <a:pPr marL="0" indent="0" algn="l">
+              <a:spcBef>
+                <a:spcPts val="0"/>
+              </a:spcBef>
+              <a:spcAft>
+                <a:spcPts val="0"/>
+              </a:spcAft>
+              <a:buNone/>
+            </a:pPr>
+            <a:r>
+              <a:t>Before the closing summary, I owe you an accounting of what kind of thing each part of this has been.</a:t>
+            </a:r>
+          </a:p>
+          <a:p xmlns:a="http://schemas.openxmlformats.org/drawingml/2006/main">
+            <a:r>
+              <a:t>Different methods establish different things. They can support one another, but they are not interchangeable.</a:t>
+            </a:r>
+          </a:p>
+          <a:p xmlns:a="http://schemas.openxmlformats.org/drawingml/2006/main">
+            <a:r>
+              <a:t>Logical exposition can show internal coherence. It cannot by itself prove empirical fact.</a:t>
+            </a:r>
+          </a:p>
+          <a:p xmlns:a="http://schemas.openxmlformats.org/drawingml/2006/main">
+            <a:r>
+              <a:t>Study and self-examination can show intelligibility and first-person recognition. They cannot by themselves physically identify the sentient unit.</a:t>
+            </a:r>
+          </a:p>
+          <a:p xmlns:a="http://schemas.openxmlformats.org/drawingml/2006/main">
+            <a:r>
+              <a:t>Practice and conduct-evidence can show effects in work, behaviour, and mutual satisfaction. They cannot by themselves measure the sentience threshold or the unit–body interface.</a:t>
+            </a:r>
+          </a:p>
+          <a:p xmlns:a="http://schemas.openxmlformats.org/drawingml/2006/main">
+            <a:r>
+              <a:t>Realisation is this tradition’s claimed completion of knowing. It does not force agreement from other methods.</a:t>
+            </a:r>
+          </a:p>
+          <a:p xmlns:a="http://schemas.openxmlformats.org/drawingml/2006/main">
+            <a:r>
+              <a:t>Publicly measurable physical claims remain answerable to instrument-based science. No accepted measurement currently identifies the sentience threshold, the unit–body interface, or post-body reassociation — the last of those being the claim I flagged on slide 16, that the sentient unit continues when a body ends and may later associate with another. Stating that plainly is part of responsible presentation.</a:t>
             </a:r>
           </a:p>
         </p:txBody>
@@ -2562,24 +2451,29 @@
         <p:nvSpPr>
           <p:cNvPr id="4" name="Slide Number Placeholder 3"/>
           <p:cNvSpPr>
-            <a:spLocks noGrp="1"/>
+            <a:spLocks xmlns:a="http://schemas.openxmlformats.org/drawingml/2006/main" noGrp="1"/>
           </p:cNvSpPr>
           <p:nvPr>
-            <p:ph type="sldNum" idx="5" sz="quarter"/>
+            <p:ph type="sldNum" idx="5"/>
           </p:nvPr>
         </p:nvSpPr>
         <p:spPr/>
+        <p:txBody>
+          <a:bodyPr xmlns:a="http://schemas.openxmlformats.org/drawingml/2006/main"/>
+          <a:lstStyle xmlns:a="http://schemas.openxmlformats.org/drawingml/2006/main"/>
+          <a:p xmlns:a="http://schemas.openxmlformats.org/drawingml/2006/main"/>
+        </p:txBody>
       </p:sp>
     </p:spTree>
   </p:cSld>
   <p:clrMapOvr>
-    <a:masterClrMapping/>
+    <a:masterClrMapping xmlns:a="http://schemas.openxmlformats.org/drawingml/2006/main"/>
   </p:clrMapOvr>
 </p:notes>
 </file>
 
 <file path=ppt/notesSlides/notesSlide28.xml><?xml version="1.0" encoding="utf-8"?>
-<p:notes xmlns:a="http://schemas.openxmlformats.org/drawingml/2006/main" xmlns:p="http://schemas.openxmlformats.org/presentationml/2006/main" xmlns:r="http://schemas.openxmlformats.org/officeDocument/2006/relationships">
+<p:notes xmlns:p="http://schemas.openxmlformats.org/presentationml/2006/main">
   <p:cSld>
     <p:spTree>
       <p:nvGrpSpPr>
@@ -2588,21 +2482,16 @@
         <p:nvPr/>
       </p:nvGrpSpPr>
       <p:grpSpPr>
-        <a:xfrm>
-          <a:off x="0" y="0"/>
-          <a:ext cx="0" cy="0"/>
-          <a:chOff x="0" y="0"/>
-          <a:chExt cx="0" cy="0"/>
-        </a:xfrm>
+        <a:xfrm xmlns:a="http://schemas.openxmlformats.org/drawingml/2006/main"/>
       </p:grpSpPr>
       <p:sp>
         <p:nvSpPr>
           <p:cNvPr id="2" name="Slide Image Placeholder 1"/>
           <p:cNvSpPr>
-            <a:spLocks noGrp="1"/>
+            <a:spLocks xmlns:a="http://schemas.openxmlformats.org/drawingml/2006/main" noGrp="1"/>
           </p:cNvSpPr>
           <p:nvPr>
-            <p:ph type="sldImg" idx="2"/>
+            <p:ph type="sldImg" idx="0"/>
           </p:nvPr>
         </p:nvSpPr>
         <p:spPr/>
@@ -2611,54 +2500,63 @@
         <p:nvSpPr>
           <p:cNvPr id="3" name="Notes Placeholder 2"/>
           <p:cNvSpPr>
-            <a:spLocks noGrp="1"/>
+            <a:spLocks xmlns:a="http://schemas.openxmlformats.org/drawingml/2006/main" noGrp="1"/>
           </p:cNvSpPr>
           <p:nvPr>
-            <p:ph type="body" idx="3" sz="quarter"/>
+            <p:ph type="body" idx="1"/>
           </p:nvPr>
         </p:nvSpPr>
         <p:spPr/>
         <p:txBody>
-          <a:bodyPr/>
-          <a:lstStyle/>
-          <a:p>
-            <a:r>
-              <a:t>So far the relation I have described runs between each unit and the ground. There is a second relation, and without it nothing else in this account works — not value, not relationship, not justice, and not the drive we are about to follow.</a:t>
-            </a:r>
-          </a:p>
-          <a:p>
-            <a:r>
-              <a:t>Here is where it comes from. Existence is countless units, each with definite limits, in one pervasive reality. That fact — bounded plurality — is itself what makes recognition possible. The text puts it almost casually: “a provision for one unit to recognise another got manifest in existence.” Because there are many bounded things in one ground, each one stands in definite relation to the others.</a:t>
-            </a:r>
-          </a:p>
-          <a:p>
-            <a:r>
-              <a:t>So complementarity is *given* in coexistence. Not created by us. Not agreed between parties. Not a value we project onto a neutral world. It is a feature of what exists.</a:t>
-            </a:r>
-          </a:p>
-          <a:p>
-            <a:r>
-              <a:t>Three things follow, and they are the three cards.</a:t>
-            </a:r>
-          </a:p>
-          <a:p>
-            <a:r>
-              <a:t>Recognition first. A unit recognises another by responding according to definite constitution, distance, force, and relation. No cognition is involved — please do not hear "recognition" as a mental act. Heat is accepted and redistributed by matter. Particles hold definite distance in an atom. Atoms combine in definite ways and not others. That is recognition in the insentient orders, and the texts name the equipment for it: capacity, ability, receptivity.</a:t>
-            </a:r>
-          </a:p>
-          <a:p>
-            <a:r>
-              <a:t>Complementarity second. Nothing in nature exists in isolation, and each unit is a whole along with its environment. Now the consequence people find surprising: essentiality in every order is what value *is*, in the broad sense — the usefulness through which a unit is complementary to others. That means value is ontological here. It is not assigned by an observer, and it is not a human invention layered on top of physics.</a:t>
-            </a:r>
-          </a:p>
-          <a:p>
-            <a:r>
-              <a:t>Fulfilment third. Fulfilment is the participation that follows recognition, according to constitution and order. Below the human order it is definite — it happens. At the human order it must be achieved, through knowing and believing. Which is precisely why, at the human order alone, it can fail.</a:t>
-            </a:r>
-          </a:p>
-          <a:p>
-            <a:r>
-              <a:t>And now the sentence I want you to carry through the rest of the session, because everything from here specifies it: the completeness drive is the drive to fulfil this complementarity. When we get to the composing line, the texts call it a natural inclination toward coexistence. When we get to the sentience threshold, it is hungry atoms and overfull atoms completing each other. When we get to justice, it is complementarity fulfilled knowingly between human beings. Same thing, three registers.</a:t>
+          <a:bodyPr xmlns:a="http://schemas.openxmlformats.org/drawingml/2006/main"/>
+          <a:lstStyle xmlns:a="http://schemas.openxmlformats.org/drawingml/2006/main"/>
+          <a:p xmlns:a="http://schemas.openxmlformats.org/drawingml/2006/main">
+            <a:pPr marL="0" indent="0" algn="l">
+              <a:spcBef>
+                <a:spcPts val="0"/>
+              </a:spcBef>
+              <a:spcAft>
+                <a:spcPts val="0"/>
+              </a:spcAft>
+              <a:buNone/>
+            </a:pPr>
+            <a:r>
+              <a:t>Let us close the loop on the six questions.</a:t>
+            </a:r>
+          </a:p>
+          <a:p xmlns:a="http://schemas.openxmlformats.org/drawingml/2006/main">
+            <a:r>
+              <a:t>What is existence? Eternal coexistence: countless units saturated in all-pervasive Omnipresence.</a:t>
+            </a:r>
+          </a:p>
+          <a:p xmlns:a="http://schemas.openxmlformats.org/drawingml/2006/main">
+            <a:r>
+              <a:t>What exists? Root atomic units; composite units and bodies; body–sentient-unit joint forms; and relational human assemblies — all saturated in the ground.</a:t>
+            </a:r>
+          </a:p>
+          <a:p xmlns:a="http://schemas.openxmlformats.org/drawingml/2006/main">
+            <a:r>
+              <a:t>Does existence begin or end? No. Existence is perpetual. Configurations form, transform, and decompose.</a:t>
+            </a:r>
+          </a:p>
+          <a:p xmlns:a="http://schemas.openxmlformats.org/drawingml/2006/main">
+            <a:r>
+              <a:t>What is the self? The constitutionally complete sentient unit working through the body.</a:t>
+            </a:r>
+          </a:p>
+          <a:p xmlns:a="http://schemas.openxmlformats.org/drawingml/2006/main">
+            <a:r>
+              <a:t>Is the world real? Yes. Units, mutual relationships, and definite material fulfilment are real within perpetual coexistence.</a:t>
+            </a:r>
+          </a:p>
+          <a:p xmlns:a="http://schemas.openxmlformats.org/drawingml/2006/main">
+            <a:r>
+              <a:t>How is it known? Through logical exposition, study and self-examination, practice, realisation, and conduct-evidence — without conflating those with instrument measurement of the sentience threshold. The lived test is evidence in humane conduct.</a:t>
+            </a:r>
+          </a:p>
+          <a:p xmlns:a="http://schemas.openxmlformats.org/drawingml/2006/main">
+            <a:r>
+              <a:t>If we continue later, the natural next step is comparison with other traditions and with science — including open problems this study names for Madhyasth Darshan itself. Thank you.</a:t>
             </a:r>
           </a:p>
         </p:txBody>
@@ -2667,18 +2565,23 @@
         <p:nvSpPr>
           <p:cNvPr id="4" name="Slide Number Placeholder 3"/>
           <p:cNvSpPr>
-            <a:spLocks noGrp="1"/>
+            <a:spLocks xmlns:a="http://schemas.openxmlformats.org/drawingml/2006/main" noGrp="1"/>
           </p:cNvSpPr>
           <p:nvPr>
-            <p:ph type="sldNum" idx="5" sz="quarter"/>
+            <p:ph type="sldNum" idx="5"/>
           </p:nvPr>
         </p:nvSpPr>
         <p:spPr/>
+        <p:txBody>
+          <a:bodyPr xmlns:a="http://schemas.openxmlformats.org/drawingml/2006/main"/>
+          <a:lstStyle xmlns:a="http://schemas.openxmlformats.org/drawingml/2006/main"/>
+          <a:p xmlns:a="http://schemas.openxmlformats.org/drawingml/2006/main"/>
+        </p:txBody>
       </p:sp>
     </p:spTree>
   </p:cSld>
   <p:clrMapOvr>
-    <a:masterClrMapping/>
+    <a:masterClrMapping xmlns:a="http://schemas.openxmlformats.org/drawingml/2006/main"/>
   </p:clrMapOvr>
 </p:notes>
 </file>
@@ -3178,47 +3081,28 @@
           <a:bodyPr xmlns:a="http://schemas.openxmlformats.org/drawingml/2006/main"/>
           <a:lstStyle xmlns:a="http://schemas.openxmlformats.org/drawingml/2006/main"/>
           <a:p xmlns:a="http://schemas.openxmlformats.org/drawingml/2006/main">
-            <a:pPr marL="0" indent="0" algn="l">
-              <a:spcBef>
-                <a:spcPts val="0"/>
-              </a:spcBef>
-              <a:spcAft>
-                <a:spcPts val="0"/>
-              </a:spcAft>
-              <a:buNone/>
-            </a:pPr>
-            <a:r>
-              <a:t>What is every unit? Four inseparable aspects — not a static checklist pasted onto things, but how a definite bearer shows up in the world.</a:t>
-            </a:r>
-          </a:p>
-          <a:p xmlns:a="http://schemas.openxmlformats.org/drawingml/2006/main">
-            <a:r>
-              <a:t>Form is real boundary and configuration. Take the peepal tree on the slide: one bounded living form with trunk, branches, leaves, and roots.</a:t>
-            </a:r>
-          </a:p>
-          <a:p xmlns:a="http://schemas.openxmlformats.org/drawingml/2006/main">
-            <a:r>
-              <a:t>Properties — capacities and relative effects. In the peepal: nutrition, growth, repair, seed production, degeneration under definite conditions.</a:t>
-            </a:r>
-          </a:p>
-          <a:p xmlns:a="http://schemas.openxmlformats.org/drawingml/2006/main">
-            <a:r>
-              <a:t>Essential nature is usefulness in context: vitalising while the living organisation holds; devitalising when it breaks down.</a:t>
-            </a:r>
-          </a:p>
-          <a:p xmlns:a="http://schemas.openxmlformats.org/drawingml/2006/main">
-            <a:r>
-              <a:t>Innateness — dharma in this technical sense — is what cannot be separated from the unit, plus order-specific fulfilment. For the peepal: existence plus growth. Seed-conformance is how it conducts itself, not an extra label piled on top.</a:t>
-            </a:r>
-          </a:p>
-          <a:p xmlns:a="http://schemas.openxmlformats.org/drawingml/2006/main">
-            <a:r>
-              <a:t>Form is real; what another unit encounters is its definite presentation in mutual facing. In non-sentient nature these aspects are definite. Misreading arises mainly in human living, when the sentient unit mistakes the body for the self.</a:t>
-            </a:r>
-          </a:p>
-          <a:p xmlns:a="http://schemas.openxmlformats.org/drawingml/2006/main">
-            <a:r>
-              <a:t>And notice: the tree as a composite can die while its material constituents persist. Persistence of existence is not persistence of one configuration.</a:t>
+            <a:r>
+              <a:t>One consequence of the last slide deserves its own moment, because it answers the second of our opening questions.</a:t>
+            </a:r>
+          </a:p>
+          <a:p xmlns:a="http://schemas.openxmlformats.org/drawingml/2006/main">
+            <a:r>
+              <a:t>If no division of a unit can put any fragment outside the ground, then nothing that exists can be annihilated. And nothing arises from non-being either. So existence does not begin and does not end. What begins and ends is composition — particular arrangements of units.</a:t>
+            </a:r>
+          </a:p>
+          <a:p xmlns:a="http://schemas.openxmlformats.org/drawingml/2006/main">
+            <a:r>
+              <a:t>Notice carefully what that does and does not claim. A compound decomposes. A body dies. Those organisations genuinely end. What continues is their constituents, in other relations. Perpetuity belongs to coexistence, not to any particular configuration.</a:t>
+            </a:r>
+          </a:p>
+          <a:p xmlns:a="http://schemas.openxmlformats.org/drawingml/2006/main">
+            <a:r>
+              <a:t>Second point, and this one matters for how you hear the rest of the session. The texts call Omnipresence the supreme cause, and that phrase invites a misreading. It is cause only in the sustaining sense — no activity exists apart from nature saturated in it. It starts no particular change. Composition, decomposition, development, conduct: all of that is the work of units acting on one another. So there is no creator in this account, and no ruler issuing instructions.</a:t>
+            </a:r>
+          </a:p>
+          <a:p xmlns:a="http://schemas.openxmlformats.org/drawingml/2006/main">
+            <a:r>
+              <a:t>Third, time. Time here is not a container existing alongside the ground and the units. Time is the duration of activity, reckoned from recurrent activities — a rotation, a year. The ground does not transform, so it is not temporal in the way unit-activity is measured.</a:t>
             </a:r>
           </a:p>
         </p:txBody>
@@ -3287,37 +3171,43 @@
           <a:bodyPr xmlns:a="http://schemas.openxmlformats.org/drawingml/2006/main"/>
           <a:lstStyle xmlns:a="http://schemas.openxmlformats.org/drawingml/2006/main"/>
           <a:p xmlns:a="http://schemas.openxmlformats.org/drawingml/2006/main">
-            <a:pPr marL="0" indent="0" algn="l">
-              <a:spcBef>
-                <a:spcPts val="0"/>
-              </a:spcBef>
-              <a:spcAft>
-                <a:spcPts val="0"/>
-              </a:spcAft>
-              <a:buNone/>
-            </a:pPr>
-            <a:r>
-              <a:t>The complementarity we just established becomes evident through relationships among units — this slide is what it looks like in practice.</a:t>
-            </a:r>
-          </a:p>
-          <a:p xmlns:a="http://schemas.openxmlformats.org/drawingml/2006/main">
-            <a:r>
-              <a:t>In the material, plant, and animal orders its expression is definite: recognition happens, fulfilment happens. At the human order alone it has to be recognised, evaluated, and fulfilled — so at the human order alone it can be got wrong, and it is got wrong when the body is mistaken for the self.</a:t>
-            </a:r>
-          </a:p>
-          <a:p xmlns:a="http://schemas.openxmlformats.org/drawingml/2006/main">
-            <a:r>
-              <a:t>Two kinds of mutuality matter. A relationship is mutuality whose expectations are definite in the completeness of the bond — parent and child. An association or contact is mutuality where expectations are voluntary — neighbours who share a wall.</a:t>
-            </a:r>
-          </a:p>
-          <a:p xmlns:a="http://schemas.openxmlformats.org/drawingml/2006/main">
-            <a:r>
-              <a:t>The slide names five value families: object, *jeevan*, human, established, and civic — the last is *shishta-mulya* in the source. Object values are two, utility and art, so the same list is often counted as six types: utility, art, *jeevan*, human, established, and civic. Established values are the ones that become evident when human relationships are recognised and fulfilled — trust, respect, affection, care, and so on. Civic values are how all of that is expressed in social participation.</a:t>
-            </a:r>
-          </a:p>
-          <a:p xmlns:a="http://schemas.openxmlformats.org/drawingml/2006/main">
-            <a:r>
-              <a:t>At the human order the path runs: knowing, then believing, then recognising, then fulfilling. Awakening does not invent new faculties. It aligns this chain with coexistence.</a:t>
+            <a:r>
+              <a:t>So far the relation I have described runs between each unit and the ground. There is a second relation, and without it nothing else in this account works — not value, not relationship, not justice, and not the drive we are about to follow.</a:t>
+            </a:r>
+          </a:p>
+          <a:p xmlns:a="http://schemas.openxmlformats.org/drawingml/2006/main">
+            <a:r>
+              <a:t>Here is where it comes from. Existence is countless units, each with definite limits, in one pervasive reality. That fact — bounded plurality — is itself what makes recognition possible. The text puts it almost casually: “a provision for one unit to recognise another got manifest in existence.” Because there are many bounded things in one ground, each one stands in definite relation to the others.</a:t>
+            </a:r>
+          </a:p>
+          <a:p xmlns:a="http://schemas.openxmlformats.org/drawingml/2006/main">
+            <a:r>
+              <a:t>So complementarity is *given* in coexistence. Not created by us. Not agreed between parties. Not a value we project onto a neutral world. It is a feature of what exists.</a:t>
+            </a:r>
+          </a:p>
+          <a:p xmlns:a="http://schemas.openxmlformats.org/drawingml/2006/main">
+            <a:r>
+              <a:t>Three things follow, and they are the three cards.</a:t>
+            </a:r>
+          </a:p>
+          <a:p xmlns:a="http://schemas.openxmlformats.org/drawingml/2006/main">
+            <a:r>
+              <a:t>Recognition first. A unit recognises another by responding according to definite constitution, distance, force, and relation. No cognition is involved — please do not hear "recognition" as a mental act. Heat is accepted and redistributed by matter. Particles hold definite distance in an atom. Atoms combine in definite ways and not others. That is recognition in the insentient orders, and the texts name the equipment for it: capacity, ability, receptivity.</a:t>
+            </a:r>
+          </a:p>
+          <a:p xmlns:a="http://schemas.openxmlformats.org/drawingml/2006/main">
+            <a:r>
+              <a:t>Complementarity second. Nothing in nature exists in isolation, and each unit is a whole along with its environment. Now the consequence people find surprising: essentiality in every order is what value *is*, in the broad sense — the usefulness through which a unit is complementary to others. That means value is ontological here. It is not assigned by an observer, and it is not a human invention layered on top of physics.</a:t>
+            </a:r>
+          </a:p>
+          <a:p xmlns:a="http://schemas.openxmlformats.org/drawingml/2006/main">
+            <a:r>
+              <a:t>Fulfilment third. Fulfilment is the participation that follows recognition, according to constitution and order. Below the human order it is definite — it happens. At the human order it must be achieved, through knowing and believing. Which is precisely why, at the human order alone, it can fail.</a:t>
+            </a:r>
+          </a:p>
+          <a:p xmlns:a="http://schemas.openxmlformats.org/drawingml/2006/main">
+            <a:r>
+              <a:t>And now the sentence I want you to carry through the rest of the session, because everything from here specifies it: the completeness drive is the drive to fulfil this complementarity. When we get to the composing line, the texts call it a natural inclination toward coexistence. When we get to the sentience threshold, it is hungry atoms and overfull atoms completing each other. When we get to justice, it is complementarity fulfilled knowingly between human beings. Same thing, three registers.</a:t>
             </a:r>
           </a:p>
         </p:txBody>
@@ -3396,27 +3286,37 @@
               <a:buNone/>
             </a:pPr>
             <a:r>
-              <a:t>Units organise into four stable orders: material; bio or living-plant order; animal; and knowledge — the human order.</a:t>
-            </a:r>
-          </a:p>
-          <a:p xmlns:a="http://schemas.openxmlformats.org/drawingml/2006/main">
-            <a:r>
-              <a:t>Read the table downward. Innateness is cumulative. Matter has existence. The bio order adds growth. The animal order adds hope to live. The human order adds happiness. Higher orders include the lower ones.</a:t>
-            </a:r>
-          </a:p>
-          <a:p xmlns:a="http://schemas.openxmlformats.org/drawingml/2006/main">
-            <a:r>
-              <a:t>The pivotal boundary is between plant life and animal life. Material and bio orders are non-sentient. Hope to live is where sentience enters. The sentient unit is present in animal and human joint forms.</a:t>
-            </a:r>
-          </a:p>
-          <a:p xmlns:a="http://schemas.openxmlformats.org/drawingml/2006/main">
-            <a:r>
-              <a:t>In animals, bodily and brain development limits how much of that unit’s range can be expressed. In humans, the bodily medium can support the full range, but confusion can still misdirect evaluation. Neither body produces sentience. Please do not collapse either case into “mind emerging from matter alone.”</a:t>
-            </a:r>
-          </a:p>
-          <a:p xmlns:a="http://schemas.openxmlformats.org/drawingml/2006/main">
-            <a:r>
-              <a:t>We have now stated what exists and how it is ordered. Next: how development proceeds.</a:t>
+              <a:t>What is every unit? Four inseparable aspects — not a static checklist pasted onto things, but how a definite bearer shows up in the world.</a:t>
+            </a:r>
+          </a:p>
+          <a:p xmlns:a="http://schemas.openxmlformats.org/drawingml/2006/main">
+            <a:r>
+              <a:t>Form is real boundary and configuration. Take the peepal tree on the slide: one bounded living form with trunk, branches, leaves, and roots.</a:t>
+            </a:r>
+          </a:p>
+          <a:p xmlns:a="http://schemas.openxmlformats.org/drawingml/2006/main">
+            <a:r>
+              <a:t>Properties — capacities and relative effects. In the peepal: nutrition, growth, repair, seed production, degeneration under definite conditions.</a:t>
+            </a:r>
+          </a:p>
+          <a:p xmlns:a="http://schemas.openxmlformats.org/drawingml/2006/main">
+            <a:r>
+              <a:t>Essential nature is usefulness in context: vitalising while the living organisation holds; devitalising when it breaks down.</a:t>
+            </a:r>
+          </a:p>
+          <a:p xmlns:a="http://schemas.openxmlformats.org/drawingml/2006/main">
+            <a:r>
+              <a:t>Innateness — dharma in this technical sense — is what cannot be separated from the unit, plus order-specific fulfilment. For the peepal: existence plus growth. Seed-conformance is how it conducts itself, not an extra label piled on top.</a:t>
+            </a:r>
+          </a:p>
+          <a:p xmlns:a="http://schemas.openxmlformats.org/drawingml/2006/main">
+            <a:r>
+              <a:t>Form is real; what another unit encounters is its definite presentation in mutual facing. In non-sentient nature these aspects are definite. Misreading arises mainly in human living, when the sentient unit mistakes the body for the self.</a:t>
+            </a:r>
+          </a:p>
+          <a:p xmlns:a="http://schemas.openxmlformats.org/drawingml/2006/main">
+            <a:r>
+              <a:t>And notice: the tree as a composite can die while its material constituents persist. Persistence of existence is not persistence of one configuration.</a:t>
             </a:r>
           </a:p>
         </p:txBody>
@@ -3491,7 +3391,7 @@
   </p:cSld>
   <p:clrMap bg1="lt1" tx1="dk1" bg2="dk2" tx2="lt2" accent1="accent1" accent2="accent2" accent3="accent3" accent4="accent4" accent5="accent5" accent6="accent6" hlink="hlink" folHlink="folHlink"/>
   <p:sldLayoutIdLst>
-    <p:sldLayoutId xmlns:r="http://schemas.openxmlformats.org/officeDocument/2006/relationships" id="2147483649" r:id="Rfbe447850c1b4458"/>
+    <p:sldLayoutId xmlns:r="http://schemas.openxmlformats.org/officeDocument/2006/relationships" id="2147483649" r:id="Rc8c5790afddb4223"/>
   </p:sldLayoutIdLst>
   <p:hf sldNum="0" hdr="0" ftr="0" dt="0"/>
   <p:txStyles>
@@ -9141,7 +9041,7 @@
                   <a:srgbClr val="5F6B82"/>
                 </a:solidFill>
               </a:rPr>
-              <a:t>Atomic: some developing atoms reach T1; T2/T3 concern awakened jeevan.</a:t>
+              <a:t>Atomic: some developing atoms reach sentience; T2/T3 concern awakened jeevan.</a:t>
             </a:r>
           </a:p>
         </p:txBody>
@@ -9429,7 +9329,7 @@
                 <a:ea typeface="Calibri"/>
                 <a:cs typeface="Calibri"/>
               </a:rPr>
-              <a:t>§1.10 · WHY COMPOSITION IS NOT DEVELOPMENT</a:t>
+              <a:t>§1.5–§1.6 · TWO PATHS, ONE JOINT FORM</a:t>
             </a:r>
           </a:p>
         </p:txBody>
@@ -9485,7 +9385,7 @@
                 <a:ea typeface="Cambria"/>
                 <a:cs typeface="Cambria"/>
               </a:rPr>
-              <a:t>Composition Never Exceeds Its Constituents</a:t>
+              <a:t>Two Paths Meet in the Animal Order</a:t>
             </a:r>
           </a:p>
         </p:txBody>
@@ -9532,6 +9432,17 @@
               </a:spcAft>
               <a:buNone/>
             </a:pPr>
+            <a:r>
+              <a:rPr sz="1300" b="1" i="0" u="none" cap="none">
+                <a:solidFill>
+                  <a:srgbClr val="5A6377"/>
+                </a:solidFill>
+                <a:latin typeface="Calibri"/>
+                <a:ea typeface="Calibri"/>
+                <a:cs typeface="Calibri"/>
+              </a:rPr>
+              <a:t>The completeness drive unfolds along two parallel paths.</a:t>
+            </a:r>
             <a:r>
               <a:rPr sz="1300" b="0" i="0" u="none" cap="none">
                 <a:solidFill>
@@ -9541,7 +9452,7 @@
                 <a:ea typeface="Calibri"/>
                 <a:cs typeface="Calibri"/>
               </a:rPr>
-              <a:t>Complementarity drives the composing line: the texts call it a natural inclination toward coexistence, and it is what leads particles into atoms, atoms into molecules, molecules into cells and bodies. But whatever a thing is constituted of, it remains of the order of that constituent — however vast the formation.</a:t>
+              <a:t> Rachna manifests material and biological formations; atomic development reaches constitutional completeness as sentient jeevan.</a:t>
             </a:r>
           </a:p>
         </p:txBody>
@@ -9653,7 +9564,7 @@
                 <a:ea typeface="Cambria"/>
                 <a:cs typeface="Cambria"/>
               </a:rPr>
-              <a:t>Mixture</a:t>
+              <a:t>Compositional path (rachna)</a:t>
             </a:r>
           </a:p>
         </p:txBody>
@@ -9709,7 +9620,7 @@
                 <a:ea typeface="Calibri"/>
                 <a:cs typeface="Calibri"/>
               </a:rPr>
-              <a:t>Components stay side by side and each maintains its own conduct — no new unit is formed.</a:t>
+              <a:t>Atoms and molecules form material order; chemical and pranic-cell compositions manifest biological order. Both are insentient.</a:t>
             </a:r>
           </a:p>
         </p:txBody>
@@ -9821,7 +9732,7 @@
                 <a:ea typeface="Cambria"/>
                 <a:cs typeface="Cambria"/>
               </a:rPr>
-              <a:t>Compound</a:t>
+              <a:t>Atomic path (gathan)</a:t>
             </a:r>
           </a:p>
         </p:txBody>
@@ -9877,7 +9788,7 @@
                 <a:ea typeface="Calibri"/>
                 <a:cs typeface="Calibri"/>
               </a:rPr>
-              <a:t>Definite proportion yields a new bounded unit. Its real form and its guna, svabhav, and dharma are evidenced in the new unit's mutuality.</a:t>
+              <a:t>A developing atom integrates its required particle constitution. At completeness, the texts classify it as sentient jeevan.</a:t>
             </a:r>
           </a:p>
         </p:txBody>
@@ -9933,7 +9844,7 @@
                 <a:ea typeface="Calibri"/>
                 <a:cs typeface="Calibri"/>
               </a:rPr>
-              <a:t>Objects made from soil remain soil; a body built from pranic cells remains of the order of the pranic cell; the Earth entire is of the order of its atoms, molecules, and cells. Change of composition is development or decline within an order, never passage beyond it.</a:t>
+              <a:t>The paths meet in animal order. Body lineages develop while jeevan’s expression widens; the human body can evidence all ten activities.</a:t>
             </a:r>
           </a:p>
         </p:txBody>
@@ -10038,7 +9949,7 @@
                 <a:ea typeface="Calibri"/>
                 <a:cs typeface="Calibri"/>
               </a:rPr>
-              <a:t>Particles &amp; atoms</a:t>
+              <a:t>Biological body</a:t>
             </a:r>
           </a:p>
         </p:txBody>
@@ -10060,6 +9971,167 @@
         <p:spPr>
           <a:xfrm xmlns:a="http://schemas.openxmlformats.org/drawingml/2006/main">
             <a:off x="2331720" y="3977640"/>
+            <a:ext cx="320040" cy="502920"/>
+          </a:xfrm>
+          <a:prstGeom xmlns:a="http://schemas.openxmlformats.org/drawingml/2006/main" prst="rect">
+            <a:avLst/>
+          </a:prstGeom>
+          <a:noFill xmlns:a="http://schemas.openxmlformats.org/drawingml/2006/main"/>
+          <a:ln xmlns:a="http://schemas.openxmlformats.org/drawingml/2006/main">
+            <a:noFill/>
+          </a:ln>
+        </p:spPr>
+        <p:txBody>
+          <a:bodyPr xmlns:a="http://schemas.openxmlformats.org/drawingml/2006/main" spcFirstLastPara="1" wrap="square" lIns="91425" tIns="45700" rIns="91425" bIns="45700" anchor="ctr">
+            <a:noAutofit/>
+          </a:bodyPr>
+          <a:lstStyle xmlns:a="http://schemas.openxmlformats.org/drawingml/2006/main"/>
+          <a:p xmlns:a="http://schemas.openxmlformats.org/drawingml/2006/main">
+            <a:pPr marL="0" indent="0" algn="ctr">
+              <a:spcBef>
+                <a:spcPts val="0"/>
+              </a:spcBef>
+              <a:spcAft>
+                <a:spcPts val="0"/>
+              </a:spcAft>
+              <a:buNone/>
+            </a:pPr>
+            <a:r>
+              <a:rPr sz="1600" b="1" i="0" u="none" cap="none">
+                <a:solidFill>
+                  <a:srgbClr val="C9821E"/>
+                </a:solidFill>
+                <a:latin typeface="Calibri"/>
+                <a:ea typeface="Calibri"/>
+                <a:cs typeface="Calibri"/>
+              </a:rPr>
+              <a:t>+</a:t>
+            </a:r>
+          </a:p>
+        </p:txBody>
+      </p:sp>
+      <p:sp>
+        <p:nvSpPr>
+          <p:cNvPr id="389" name="Google Shape;389;p16">
+            <a:extLst xmlns:a="http://schemas.openxmlformats.org/drawingml/2006/main">
+              <a:ext uri="{FF2B5EF4-FFF2-40B4-BE49-F238E27FC236}">
+                <a16:creationId xmlns:a16="http://schemas.microsoft.com/office/drawing/2014/main" id="{B468CC50-22BB-4266-A019-2EA79D2E3722}"/>
+              </a:ext>
+            </a:extLst>
+          </p:cNvPr>
+          <p:cNvSpPr>
+            <a:spLocks xmlns:a="http://schemas.openxmlformats.org/drawingml/2006/main" noGrp="1"/>
+          </p:cNvSpPr>
+          <p:nvPr/>
+        </p:nvSpPr>
+        <p:spPr>
+          <a:xfrm xmlns:a="http://schemas.openxmlformats.org/drawingml/2006/main">
+            <a:off x="2651760" y="3977640"/>
+            <a:ext cx="1691640" cy="502920"/>
+          </a:xfrm>
+          <a:prstGeom xmlns:a="http://schemas.openxmlformats.org/drawingml/2006/main" prst="roundRect">
+            <a:avLst>
+              <a:gd name="adj" fmla="val 16364"/>
+            </a:avLst>
+          </a:prstGeom>
+          <a:solidFill xmlns:a="http://schemas.openxmlformats.org/drawingml/2006/main">
+            <a:srgbClr val="1E2447"/>
+          </a:solidFill>
+          <a:ln xmlns:a="http://schemas.openxmlformats.org/drawingml/2006/main">
+            <a:noFill/>
+          </a:ln>
+        </p:spPr>
+        <p:txBody>
+          <a:bodyPr xmlns:a="http://schemas.openxmlformats.org/drawingml/2006/main" spcFirstLastPara="1" wrap="square" lIns="91425" tIns="91425" rIns="91425" bIns="91425" anchor="ctr">
+            <a:noAutofit/>
+          </a:bodyPr>
+          <a:lstStyle xmlns:a="http://schemas.openxmlformats.org/drawingml/2006/main"/>
+          <a:p xmlns:a="http://schemas.openxmlformats.org/drawingml/2006/main">
+            <a:pPr marL="0" indent="0" algn="l">
+              <a:spcBef>
+                <a:spcPts val="0"/>
+              </a:spcBef>
+              <a:spcAft>
+                <a:spcPts val="0"/>
+              </a:spcAft>
+              <a:buNone/>
+            </a:pPr>
+          </a:p>
+        </p:txBody>
+      </p:sp>
+      <p:sp>
+        <p:nvSpPr>
+          <p:cNvPr id="390" name="Google Shape;390;p16">
+            <a:extLst xmlns:a="http://schemas.openxmlformats.org/drawingml/2006/main">
+              <a:ext uri="{FF2B5EF4-FFF2-40B4-BE49-F238E27FC236}">
+                <a16:creationId xmlns:a16="http://schemas.microsoft.com/office/drawing/2014/main" id="{84AD2557-9213-4732-B37B-FE0F4371A016}"/>
+              </a:ext>
+            </a:extLst>
+          </p:cNvPr>
+          <p:cNvSpPr>
+            <a:spLocks xmlns:a="http://schemas.openxmlformats.org/drawingml/2006/main" noGrp="1"/>
+          </p:cNvSpPr>
+          <p:nvPr/>
+        </p:nvSpPr>
+        <p:spPr>
+          <a:xfrm xmlns:a="http://schemas.openxmlformats.org/drawingml/2006/main">
+            <a:off x="2651760" y="3977640"/>
+            <a:ext cx="1691640" cy="502920"/>
+          </a:xfrm>
+          <a:prstGeom xmlns:a="http://schemas.openxmlformats.org/drawingml/2006/main" prst="rect">
+            <a:avLst/>
+          </a:prstGeom>
+          <a:noFill xmlns:a="http://schemas.openxmlformats.org/drawingml/2006/main"/>
+          <a:ln xmlns:a="http://schemas.openxmlformats.org/drawingml/2006/main">
+            <a:noFill/>
+          </a:ln>
+        </p:spPr>
+        <p:txBody>
+          <a:bodyPr xmlns:a="http://schemas.openxmlformats.org/drawingml/2006/main" spcFirstLastPara="1" wrap="square" lIns="91425" tIns="45700" rIns="91425" bIns="45700" anchor="ctr">
+            <a:noAutofit/>
+          </a:bodyPr>
+          <a:lstStyle xmlns:a="http://schemas.openxmlformats.org/drawingml/2006/main"/>
+          <a:p xmlns:a="http://schemas.openxmlformats.org/drawingml/2006/main">
+            <a:pPr marL="0" indent="0" algn="ctr">
+              <a:spcBef>
+                <a:spcPts val="0"/>
+              </a:spcBef>
+              <a:spcAft>
+                <a:spcPts val="0"/>
+              </a:spcAft>
+              <a:buNone/>
+            </a:pPr>
+            <a:r>
+              <a:rPr sz="1250" b="1" i="0" u="none" cap="none">
+                <a:solidFill>
+                  <a:srgbClr val="FFFFFF"/>
+                </a:solidFill>
+                <a:latin typeface="Calibri"/>
+                <a:ea typeface="Calibri"/>
+                <a:cs typeface="Calibri"/>
+              </a:rPr>
+              <a:t>Sentient jeevan</a:t>
+            </a:r>
+          </a:p>
+        </p:txBody>
+      </p:sp>
+      <p:sp>
+        <p:nvSpPr>
+          <p:cNvPr id="391" name="Google Shape;391;p16">
+            <a:extLst xmlns:a="http://schemas.openxmlformats.org/drawingml/2006/main">
+              <a:ext uri="{FF2B5EF4-FFF2-40B4-BE49-F238E27FC236}">
+                <a16:creationId xmlns:a16="http://schemas.microsoft.com/office/drawing/2014/main" id="{89D7FE30-7CBB-40BF-B52C-6DBBCAF63FFF}"/>
+              </a:ext>
+            </a:extLst>
+          </p:cNvPr>
+          <p:cNvSpPr>
+            <a:spLocks xmlns:a="http://schemas.openxmlformats.org/drawingml/2006/main" noGrp="1"/>
+          </p:cNvSpPr>
+          <p:nvPr/>
+        </p:nvSpPr>
+        <p:spPr>
+          <a:xfrm xmlns:a="http://schemas.openxmlformats.org/drawingml/2006/main">
+            <a:off x="4343400" y="3977640"/>
             <a:ext cx="320040" cy="502920"/>
           </a:xfrm>
           <a:prstGeom xmlns:a="http://schemas.openxmlformats.org/drawingml/2006/main" prst="rect">
@@ -10101,21 +10173,21 @@
       </p:sp>
       <p:sp>
         <p:nvSpPr>
-          <p:cNvPr id="389" name="Google Shape;389;p16">
-            <a:extLst xmlns:a="http://schemas.openxmlformats.org/drawingml/2006/main">
-              <a:ext uri="{FF2B5EF4-FFF2-40B4-BE49-F238E27FC236}">
-                <a16:creationId xmlns:a16="http://schemas.microsoft.com/office/drawing/2014/main" id="{B468CC50-22BB-4266-A019-2EA79D2E3722}"/>
-              </a:ext>
-            </a:extLst>
-          </p:cNvPr>
-          <p:cNvSpPr>
-            <a:spLocks xmlns:a="http://schemas.openxmlformats.org/drawingml/2006/main" noGrp="1"/>
-          </p:cNvSpPr>
-          <p:nvPr/>
-        </p:nvSpPr>
-        <p:spPr>
-          <a:xfrm xmlns:a="http://schemas.openxmlformats.org/drawingml/2006/main">
-            <a:off x="2651760" y="3977640"/>
+          <p:cNvPr id="392" name="Google Shape;392;p16">
+            <a:extLst xmlns:a="http://schemas.openxmlformats.org/drawingml/2006/main">
+              <a:ext uri="{FF2B5EF4-FFF2-40B4-BE49-F238E27FC236}">
+                <a16:creationId xmlns:a16="http://schemas.microsoft.com/office/drawing/2014/main" id="{3302AF51-FAF2-4ECA-A54F-4AEFF4317013}"/>
+              </a:ext>
+            </a:extLst>
+          </p:cNvPr>
+          <p:cNvSpPr>
+            <a:spLocks xmlns:a="http://schemas.openxmlformats.org/drawingml/2006/main" noGrp="1"/>
+          </p:cNvSpPr>
+          <p:nvPr/>
+        </p:nvSpPr>
+        <p:spPr>
+          <a:xfrm xmlns:a="http://schemas.openxmlformats.org/drawingml/2006/main">
+            <a:off x="4663440" y="3977640"/>
             <a:ext cx="1691640" cy="502920"/>
           </a:xfrm>
           <a:prstGeom xmlns:a="http://schemas.openxmlformats.org/drawingml/2006/main" prst="roundRect">
@@ -10150,21 +10222,21 @@
       </p:sp>
       <p:sp>
         <p:nvSpPr>
-          <p:cNvPr id="390" name="Google Shape;390;p16">
-            <a:extLst xmlns:a="http://schemas.openxmlformats.org/drawingml/2006/main">
-              <a:ext uri="{FF2B5EF4-FFF2-40B4-BE49-F238E27FC236}">
-                <a16:creationId xmlns:a16="http://schemas.microsoft.com/office/drawing/2014/main" id="{84AD2557-9213-4732-B37B-FE0F4371A016}"/>
-              </a:ext>
-            </a:extLst>
-          </p:cNvPr>
-          <p:cNvSpPr>
-            <a:spLocks xmlns:a="http://schemas.openxmlformats.org/drawingml/2006/main" noGrp="1"/>
-          </p:cNvSpPr>
-          <p:nvPr/>
-        </p:nvSpPr>
-        <p:spPr>
-          <a:xfrm xmlns:a="http://schemas.openxmlformats.org/drawingml/2006/main">
-            <a:off x="2651760" y="3977640"/>
+          <p:cNvPr id="393" name="Google Shape;393;p16">
+            <a:extLst xmlns:a="http://schemas.openxmlformats.org/drawingml/2006/main">
+              <a:ext uri="{FF2B5EF4-FFF2-40B4-BE49-F238E27FC236}">
+                <a16:creationId xmlns:a16="http://schemas.microsoft.com/office/drawing/2014/main" id="{4774C513-D57A-4D9C-9224-483EB9B04BF9}"/>
+              </a:ext>
+            </a:extLst>
+          </p:cNvPr>
+          <p:cNvSpPr>
+            <a:spLocks xmlns:a="http://schemas.openxmlformats.org/drawingml/2006/main" noGrp="1"/>
+          </p:cNvSpPr>
+          <p:nvPr/>
+        </p:nvSpPr>
+        <p:spPr>
+          <a:xfrm xmlns:a="http://schemas.openxmlformats.org/drawingml/2006/main">
+            <a:off x="4663440" y="3977640"/>
             <a:ext cx="1691640" cy="502920"/>
           </a:xfrm>
           <a:prstGeom xmlns:a="http://schemas.openxmlformats.org/drawingml/2006/main" prst="rect">
@@ -10199,28 +10271,28 @@
                 <a:ea typeface="Calibri"/>
                 <a:cs typeface="Calibri"/>
               </a:rPr>
-              <a:t>Molecules</a:t>
-            </a:r>
-          </a:p>
-        </p:txBody>
-      </p:sp>
-      <p:sp>
-        <p:nvSpPr>
-          <p:cNvPr id="391" name="Google Shape;391;p16">
-            <a:extLst xmlns:a="http://schemas.openxmlformats.org/drawingml/2006/main">
-              <a:ext uri="{FF2B5EF4-FFF2-40B4-BE49-F238E27FC236}">
-                <a16:creationId xmlns:a16="http://schemas.microsoft.com/office/drawing/2014/main" id="{89D7FE30-7CBB-40BF-B52C-6DBBCAF63FFF}"/>
-              </a:ext>
-            </a:extLst>
-          </p:cNvPr>
-          <p:cNvSpPr>
-            <a:spLocks xmlns:a="http://schemas.openxmlformats.org/drawingml/2006/main" noGrp="1"/>
-          </p:cNvSpPr>
-          <p:nvPr/>
-        </p:nvSpPr>
-        <p:spPr>
-          <a:xfrm xmlns:a="http://schemas.openxmlformats.org/drawingml/2006/main">
-            <a:off x="4343400" y="3977640"/>
+              <a:t>Animal order</a:t>
+            </a:r>
+          </a:p>
+        </p:txBody>
+      </p:sp>
+      <p:sp>
+        <p:nvSpPr>
+          <p:cNvPr id="394" name="Google Shape;394;p16">
+            <a:extLst xmlns:a="http://schemas.openxmlformats.org/drawingml/2006/main">
+              <a:ext uri="{FF2B5EF4-FFF2-40B4-BE49-F238E27FC236}">
+                <a16:creationId xmlns:a16="http://schemas.microsoft.com/office/drawing/2014/main" id="{82350748-5E36-4F6A-A071-97DA1C996930}"/>
+              </a:ext>
+            </a:extLst>
+          </p:cNvPr>
+          <p:cNvSpPr>
+            <a:spLocks xmlns:a="http://schemas.openxmlformats.org/drawingml/2006/main" noGrp="1"/>
+          </p:cNvSpPr>
+          <p:nvPr/>
+        </p:nvSpPr>
+        <p:spPr>
+          <a:xfrm xmlns:a="http://schemas.openxmlformats.org/drawingml/2006/main">
+            <a:off x="6355080" y="3977640"/>
             <a:ext cx="320040" cy="502920"/>
           </a:xfrm>
           <a:prstGeom xmlns:a="http://schemas.openxmlformats.org/drawingml/2006/main" prst="rect">
@@ -10262,21 +10334,21 @@
       </p:sp>
       <p:sp>
         <p:nvSpPr>
-          <p:cNvPr id="392" name="Google Shape;392;p16">
-            <a:extLst xmlns:a="http://schemas.openxmlformats.org/drawingml/2006/main">
-              <a:ext uri="{FF2B5EF4-FFF2-40B4-BE49-F238E27FC236}">
-                <a16:creationId xmlns:a16="http://schemas.microsoft.com/office/drawing/2014/main" id="{3302AF51-FAF2-4ECA-A54F-4AEFF4317013}"/>
-              </a:ext>
-            </a:extLst>
-          </p:cNvPr>
-          <p:cNvSpPr>
-            <a:spLocks xmlns:a="http://schemas.openxmlformats.org/drawingml/2006/main" noGrp="1"/>
-          </p:cNvSpPr>
-          <p:nvPr/>
-        </p:nvSpPr>
-        <p:spPr>
-          <a:xfrm xmlns:a="http://schemas.openxmlformats.org/drawingml/2006/main">
-            <a:off x="4663440" y="3977640"/>
+          <p:cNvPr id="395" name="Google Shape;395;p16">
+            <a:extLst xmlns:a="http://schemas.openxmlformats.org/drawingml/2006/main">
+              <a:ext uri="{FF2B5EF4-FFF2-40B4-BE49-F238E27FC236}">
+                <a16:creationId xmlns:a16="http://schemas.microsoft.com/office/drawing/2014/main" id="{13B9CA69-1149-4B06-8953-A5B2B9029404}"/>
+              </a:ext>
+            </a:extLst>
+          </p:cNvPr>
+          <p:cNvSpPr>
+            <a:spLocks xmlns:a="http://schemas.openxmlformats.org/drawingml/2006/main" noGrp="1"/>
+          </p:cNvSpPr>
+          <p:nvPr/>
+        </p:nvSpPr>
+        <p:spPr>
+          <a:xfrm xmlns:a="http://schemas.openxmlformats.org/drawingml/2006/main">
+            <a:off x="6675120" y="3977640"/>
             <a:ext cx="1691640" cy="502920"/>
           </a:xfrm>
           <a:prstGeom xmlns:a="http://schemas.openxmlformats.org/drawingml/2006/main" prst="roundRect">
@@ -10311,21 +10383,21 @@
       </p:sp>
       <p:sp>
         <p:nvSpPr>
-          <p:cNvPr id="393" name="Google Shape;393;p16">
-            <a:extLst xmlns:a="http://schemas.openxmlformats.org/drawingml/2006/main">
-              <a:ext uri="{FF2B5EF4-FFF2-40B4-BE49-F238E27FC236}">
-                <a16:creationId xmlns:a16="http://schemas.microsoft.com/office/drawing/2014/main" id="{4774C513-D57A-4D9C-9224-483EB9B04BF9}"/>
-              </a:ext>
-            </a:extLst>
-          </p:cNvPr>
-          <p:cNvSpPr>
-            <a:spLocks xmlns:a="http://schemas.openxmlformats.org/drawingml/2006/main" noGrp="1"/>
-          </p:cNvSpPr>
-          <p:nvPr/>
-        </p:nvSpPr>
-        <p:spPr>
-          <a:xfrm xmlns:a="http://schemas.openxmlformats.org/drawingml/2006/main">
-            <a:off x="4663440" y="3977640"/>
+          <p:cNvPr id="396" name="Google Shape;396;p16">
+            <a:extLst xmlns:a="http://schemas.openxmlformats.org/drawingml/2006/main">
+              <a:ext uri="{FF2B5EF4-FFF2-40B4-BE49-F238E27FC236}">
+                <a16:creationId xmlns:a16="http://schemas.microsoft.com/office/drawing/2014/main" id="{30F2C252-C9A4-4D4B-96F6-0D00D394FC80}"/>
+              </a:ext>
+            </a:extLst>
+          </p:cNvPr>
+          <p:cNvSpPr>
+            <a:spLocks xmlns:a="http://schemas.openxmlformats.org/drawingml/2006/main" noGrp="1"/>
+          </p:cNvSpPr>
+          <p:nvPr/>
+        </p:nvSpPr>
+        <p:spPr>
+          <a:xfrm xmlns:a="http://schemas.openxmlformats.org/drawingml/2006/main">
+            <a:off x="6675120" y="3977640"/>
             <a:ext cx="1691640" cy="502920"/>
           </a:xfrm>
           <a:prstGeom xmlns:a="http://schemas.openxmlformats.org/drawingml/2006/main" prst="rect">
@@ -10360,168 +10432,7 @@
                 <a:ea typeface="Calibri"/>
                 <a:cs typeface="Calibri"/>
               </a:rPr>
-              <a:t>Cells &amp; bodies</a:t>
-            </a:r>
-          </a:p>
-        </p:txBody>
-      </p:sp>
-      <p:sp>
-        <p:nvSpPr>
-          <p:cNvPr id="394" name="Google Shape;394;p16">
-            <a:extLst xmlns:a="http://schemas.openxmlformats.org/drawingml/2006/main">
-              <a:ext uri="{FF2B5EF4-FFF2-40B4-BE49-F238E27FC236}">
-                <a16:creationId xmlns:a16="http://schemas.microsoft.com/office/drawing/2014/main" id="{82350748-5E36-4F6A-A071-97DA1C996930}"/>
-              </a:ext>
-            </a:extLst>
-          </p:cNvPr>
-          <p:cNvSpPr>
-            <a:spLocks xmlns:a="http://schemas.openxmlformats.org/drawingml/2006/main" noGrp="1"/>
-          </p:cNvSpPr>
-          <p:nvPr/>
-        </p:nvSpPr>
-        <p:spPr>
-          <a:xfrm xmlns:a="http://schemas.openxmlformats.org/drawingml/2006/main">
-            <a:off x="6355080" y="3977640"/>
-            <a:ext cx="320040" cy="502920"/>
-          </a:xfrm>
-          <a:prstGeom xmlns:a="http://schemas.openxmlformats.org/drawingml/2006/main" prst="rect">
-            <a:avLst/>
-          </a:prstGeom>
-          <a:noFill xmlns:a="http://schemas.openxmlformats.org/drawingml/2006/main"/>
-          <a:ln xmlns:a="http://schemas.openxmlformats.org/drawingml/2006/main">
-            <a:noFill/>
-          </a:ln>
-        </p:spPr>
-        <p:txBody>
-          <a:bodyPr xmlns:a="http://schemas.openxmlformats.org/drawingml/2006/main" spcFirstLastPara="1" wrap="square" lIns="91425" tIns="45700" rIns="91425" bIns="45700" anchor="ctr">
-            <a:noAutofit/>
-          </a:bodyPr>
-          <a:lstStyle xmlns:a="http://schemas.openxmlformats.org/drawingml/2006/main"/>
-          <a:p xmlns:a="http://schemas.openxmlformats.org/drawingml/2006/main">
-            <a:pPr marL="0" indent="0" algn="ctr">
-              <a:spcBef>
-                <a:spcPts val="0"/>
-              </a:spcBef>
-              <a:spcAft>
-                <a:spcPts val="0"/>
-              </a:spcAft>
-              <a:buNone/>
-            </a:pPr>
-            <a:r>
-              <a:rPr sz="1600" b="1" i="0" u="none" cap="none">
-                <a:solidFill>
-                  <a:srgbClr val="C9821E"/>
-                </a:solidFill>
-                <a:latin typeface="Calibri"/>
-                <a:ea typeface="Calibri"/>
-                <a:cs typeface="Calibri"/>
-              </a:rPr>
-              <a:t>≠</a:t>
-            </a:r>
-          </a:p>
-        </p:txBody>
-      </p:sp>
-      <p:sp>
-        <p:nvSpPr>
-          <p:cNvPr id="395" name="Google Shape;395;p16">
-            <a:extLst xmlns:a="http://schemas.openxmlformats.org/drawingml/2006/main">
-              <a:ext uri="{FF2B5EF4-FFF2-40B4-BE49-F238E27FC236}">
-                <a16:creationId xmlns:a16="http://schemas.microsoft.com/office/drawing/2014/main" id="{13B9CA69-1149-4B06-8953-A5B2B9029404}"/>
-              </a:ext>
-            </a:extLst>
-          </p:cNvPr>
-          <p:cNvSpPr>
-            <a:spLocks xmlns:a="http://schemas.openxmlformats.org/drawingml/2006/main" noGrp="1"/>
-          </p:cNvSpPr>
-          <p:nvPr/>
-        </p:nvSpPr>
-        <p:spPr>
-          <a:xfrm xmlns:a="http://schemas.openxmlformats.org/drawingml/2006/main">
-            <a:off x="6675120" y="3977640"/>
-            <a:ext cx="1691640" cy="502920"/>
-          </a:xfrm>
-          <a:prstGeom xmlns:a="http://schemas.openxmlformats.org/drawingml/2006/main" prst="roundRect">
-            <a:avLst>
-              <a:gd name="adj" fmla="val 16364"/>
-            </a:avLst>
-          </a:prstGeom>
-          <a:solidFill xmlns:a="http://schemas.openxmlformats.org/drawingml/2006/main">
-            <a:srgbClr val="1E2447"/>
-          </a:solidFill>
-          <a:ln xmlns:a="http://schemas.openxmlformats.org/drawingml/2006/main">
-            <a:noFill/>
-          </a:ln>
-        </p:spPr>
-        <p:txBody>
-          <a:bodyPr xmlns:a="http://schemas.openxmlformats.org/drawingml/2006/main" spcFirstLastPara="1" wrap="square" lIns="91425" tIns="91425" rIns="91425" bIns="91425" anchor="ctr">
-            <a:noAutofit/>
-          </a:bodyPr>
-          <a:lstStyle xmlns:a="http://schemas.openxmlformats.org/drawingml/2006/main"/>
-          <a:p xmlns:a="http://schemas.openxmlformats.org/drawingml/2006/main">
-            <a:pPr marL="0" indent="0" algn="l">
-              <a:spcBef>
-                <a:spcPts val="0"/>
-              </a:spcBef>
-              <a:spcAft>
-                <a:spcPts val="0"/>
-              </a:spcAft>
-              <a:buNone/>
-            </a:pPr>
-          </a:p>
-        </p:txBody>
-      </p:sp>
-      <p:sp>
-        <p:nvSpPr>
-          <p:cNvPr id="396" name="Google Shape;396;p16">
-            <a:extLst xmlns:a="http://schemas.openxmlformats.org/drawingml/2006/main">
-              <a:ext uri="{FF2B5EF4-FFF2-40B4-BE49-F238E27FC236}">
-                <a16:creationId xmlns:a16="http://schemas.microsoft.com/office/drawing/2014/main" id="{30F2C252-C9A4-4D4B-96F6-0D00D394FC80}"/>
-              </a:ext>
-            </a:extLst>
-          </p:cNvPr>
-          <p:cNvSpPr>
-            <a:spLocks xmlns:a="http://schemas.openxmlformats.org/drawingml/2006/main" noGrp="1"/>
-          </p:cNvSpPr>
-          <p:nvPr/>
-        </p:nvSpPr>
-        <p:spPr>
-          <a:xfrm xmlns:a="http://schemas.openxmlformats.org/drawingml/2006/main">
-            <a:off x="6675120" y="3977640"/>
-            <a:ext cx="1691640" cy="502920"/>
-          </a:xfrm>
-          <a:prstGeom xmlns:a="http://schemas.openxmlformats.org/drawingml/2006/main" prst="rect">
-            <a:avLst/>
-          </a:prstGeom>
-          <a:noFill xmlns:a="http://schemas.openxmlformats.org/drawingml/2006/main"/>
-          <a:ln xmlns:a="http://schemas.openxmlformats.org/drawingml/2006/main">
-            <a:noFill/>
-          </a:ln>
-        </p:spPr>
-        <p:txBody>
-          <a:bodyPr xmlns:a="http://schemas.openxmlformats.org/drawingml/2006/main" spcFirstLastPara="1" wrap="square" lIns="91425" tIns="45700" rIns="91425" bIns="45700" anchor="ctr">
-            <a:noAutofit/>
-          </a:bodyPr>
-          <a:lstStyle xmlns:a="http://schemas.openxmlformats.org/drawingml/2006/main"/>
-          <a:p xmlns:a="http://schemas.openxmlformats.org/drawingml/2006/main">
-            <a:pPr marL="0" indent="0" algn="ctr">
-              <a:spcBef>
-                <a:spcPts val="0"/>
-              </a:spcBef>
-              <a:spcAft>
-                <a:spcPts val="0"/>
-              </a:spcAft>
-              <a:buNone/>
-            </a:pPr>
-            <a:r>
-              <a:rPr sz="1250" b="1" i="0" u="none" cap="none">
-                <a:solidFill>
-                  <a:srgbClr val="FFFFFF"/>
-                </a:solidFill>
-                <a:latin typeface="Calibri"/>
-                <a:ea typeface="Calibri"/>
-                <a:cs typeface="Calibri"/>
-              </a:rPr>
-              <a:t>T1 · completeness</a:t>
+              <a:t>Human / knowledge order</a:t>
             </a:r>
           </a:p>
         </p:txBody>
@@ -10577,7 +10488,7 @@
                 <a:ea typeface="Calibri"/>
                 <a:cs typeface="Calibri"/>
               </a:rPr>
-              <a:t>However far composition goes, it stays within its constituents’ order. Constitutional completeness is reached only in the atom (§1.6).</a:t>
+              <a:t>Once the human medium is capable, further development is awakening in jeevan.</a:t>
             </a:r>
           </a:p>
         </p:txBody>
@@ -10633,7 +10544,7 @@
                 <a:ea typeface="Calibri"/>
                 <a:cs typeface="Calibri"/>
               </a:rPr>
-              <a:t>SB pp. 14, 260, 262, 264–265  ·  MVD p. 42 (mixture &amp; compound)  ·  JV p. 67 (inclination toward coexistence)</a:t>
+              <a:t>MVD pp. 13, 26, 79–80  ·  SB pp. 55, 76–77  ·  Study §§1.5–1.6, 1.9</a:t>
             </a:r>
           </a:p>
         </p:txBody>
@@ -14228,7 +14139,7 @@
                 <a:ea typeface="Cambria"/>
                 <a:cs typeface="Cambria"/>
               </a:rPr>
-              <a:t>T1 — The Irreversible Sentience Threshold</a:t>
+              <a:t>Sentience — The Constitutional Threshold</a:t>
             </a:r>
           </a:p>
         </p:txBody>
@@ -14284,51 +14195,18 @@
                 <a:ea typeface="Calibri"/>
                 <a:cs typeface="Calibri"/>
               </a:rPr>
-              <a:t>Constitutional completeness at the atomic level, </a:t>
-            </a:r>
-            <a:r>
-              <a:rPr sz="1250" b="0" i="0" u="none" cap="none">
+              <a:t>According to the primary texts, sentience appears when one developing atom reaches constitutional completeness.</a:t>
+            </a:r>
+            <a:r>
+              <a:rPr sz="1300" b="0" i="0" u="none" cap="none">
                 <a:solidFill>
-                  <a:srgbClr val="5A6377"/>
+                  <a:srgbClr val="1E2447"/>
                 </a:solidFill>
                 <a:latin typeface="Calibri"/>
                 <a:ea typeface="Calibri"/>
                 <a:cs typeface="Calibri"/>
               </a:rPr>
-              <a:t>not neural complexity, molecular size, or elevation along the order chain. </a:t>
-            </a:r>
-            <a:r>
-              <a:rPr sz="1250" b="0" i="0" u="none" cap="none">
-                <a:solidFill>
-                  <a:srgbClr val="5A6377"/>
-                </a:solidFill>
-                <a:latin typeface="Calibri"/>
-                <a:ea typeface="Calibri"/>
-                <a:cs typeface="Calibri"/>
-              </a:rPr>
-              <a:t>Complementarity does the work here too: </a:t>
-            </a:r>
-            <a:r>
-              <a:rPr sz="1250" b="0" i="0" u="none" cap="none">
-                <a:solidFill>
-                  <a:srgbClr val="5A6377"/>
-                </a:solidFill>
-                <a:latin typeface="Calibri"/>
-                <a:ea typeface="Calibri"/>
-                <a:cs typeface="Calibri"/>
-              </a:rPr>
-              <a:t>a constitution-oriented developing atom takes in particles — hungry atoms and overfull atoms completing each other — within a suitable environment; </a:t>
-            </a:r>
-            <a:r>
-              <a:rPr sz="1250" b="0" i="0" u="none" cap="none">
-                <a:solidFill>
-                  <a:srgbClr val="5A6377"/>
-                </a:solidFill>
-                <a:latin typeface="Calibri"/>
-                <a:ea typeface="Calibri"/>
-                <a:cs typeface="Calibri"/>
-              </a:rPr>
-              <a:t>once the required particles are in place, it closes. This is an ontological account; no accepted empirical procedure currently identifies the threshold.</a:t>
+              <a:t> Hungry and overfull atoms exchange particles until the required count is integrated. At closure, particle count stops changing while qualitative activity continues; the texts call that stable unit sentient jeevan. This is a stated criterion, not an accepted physical measurement or causal explanation of why closure is sentience.</a:t>
             </a:r>
           </a:p>
         </p:txBody>
@@ -14440,7 +14318,7 @@
                 <a:ea typeface="Cambria"/>
                 <a:cs typeface="Cambria"/>
               </a:rPr>
-              <a:t>Before T1 — evolving atom</a:t>
+              <a:t>Before sentience — open constitution</a:t>
             </a:r>
           </a:p>
         </p:txBody>
@@ -14496,7 +14374,7 @@
                 <a:ea typeface="Calibri"/>
                 <a:cs typeface="Calibri"/>
               </a:rPr>
-              <a:t>Still bound by molecular weight and structure</a:t>
+              <a:t>Absorbs or expels particles; required count not yet complete</a:t>
             </a:r>
           </a:p>
           <a:p xmlns:a="http://schemas.openxmlformats.org/drawingml/2006/main">
@@ -14518,7 +14396,7 @@
                 <a:ea typeface="Calibri"/>
                 <a:cs typeface="Calibri"/>
               </a:rPr>
-              <a:t>Qualitative change comes only with quantitative change: atomic kind and capacity track particle number</a:t>
+              <a:t>Molecular and weight bondage continue</a:t>
             </a:r>
           </a:p>
           <a:p xmlns:a="http://schemas.openxmlformats.org/drawingml/2006/main">
@@ -14540,7 +14418,7 @@
                 <a:ea typeface="Calibri"/>
                 <a:cs typeface="Calibri"/>
               </a:rPr>
-              <a:t>Exhibits radiance and projection as an insentient unit</a:t>
+              <a:t>Kind, capacity, and qualitative change track particle count</a:t>
             </a:r>
           </a:p>
         </p:txBody>
@@ -14652,7 +14530,7 @@
                 <a:ea typeface="Cambria"/>
                 <a:cs typeface="Cambria"/>
               </a:rPr>
-              <a:t>After T1 — the completed atom</a:t>
+              <a:t>Sentience — constitution closes</a:t>
             </a:r>
           </a:p>
         </p:txBody>
@@ -14710,7 +14588,7 @@
                   <a:srgbClr val="5F6B82"/>
                 </a:solidFill>
               </a:rPr>
-              <a:t>Released from molecular and weight bondage; carried by hope</a:t>
+              <a:t>All particles required by that constitution are integrated</a:t>
             </a:r>
           </a:p>
           <a:p xmlns:a="http://schemas.openxmlformats.org/drawingml/2006/main">
@@ -14737,7 +14615,7 @@
                 <a:ea typeface="Calibri"/>
                 <a:cs typeface="Calibri"/>
               </a:rPr>
-              <a:t>No increase or decrease in particles: qualitative change without quantitative change</a:t>
+              <a:t>Particle count no longer increases or decreases</a:t>
             </a:r>
           </a:p>
           <a:p xmlns:a="http://schemas.openxmlformats.org/drawingml/2006/main">
@@ -14761,7 +14639,7 @@
                   <a:srgbClr val="5F6B82"/>
                 </a:solidFill>
               </a:rPr>
-              <a:t>Sentient jeevan shows a finer mode of recognition</a:t>
+              <a:t>Leaves molecular and weight bondage; qualitative activity continues as jeevan</a:t>
             </a:r>
           </a:p>
         </p:txBody>
@@ -14873,7 +14751,7 @@
                 <a:ea typeface="Calibri"/>
                 <a:cs typeface="Calibri"/>
               </a:rPr>
-              <a:t>T1 is irreversible: the constitution is closed, so qualitative activity continues while particles no longer change — and that separation is the criterion. The closed constitution is also MD’s ground for jeevan continuing beyond the body.</a:t>
+              <a:t>The transition to sentience is the texts’ claim: one atom’s constitution closes and is reclassified as sentient — not a body becoming conscious through greater complexity. The threshold remains unmeasured.</a:t>
             </a:r>
           </a:p>
         </p:txBody>
@@ -14929,7 +14807,7 @@
                 <a:ea typeface="Calibri"/>
                 <a:cs typeface="Calibri"/>
               </a:rPr>
-              <a:t>JV also describes later association with another body; no accepted procedure measures this (§6.2).  ·  SB pp. 52, 55, 59, 80–81, 86, 92  ·  MVD pp. 8, 91, 117</a:t>
+              <a:t>SB pp. 55, 58–59, 71, 86  ·  MVD pp. 8, 91  ·  KD 3.3  ·  No accepted procedure identifies this threshold or explains why closure is sentience (§6.2.1).</a:t>
             </a:r>
           </a:p>
         </p:txBody>
@@ -27605,7 +27483,7 @@
       </p:sp>
       <p:cxnSp>
         <p:nvCxnSpPr>
-          <p:cNvPr id="862" name="Google Shape;445;p18"/>
+          <p:cNvPr id="1047" name="Google Shape;445;p18"/>
           <p:cNvCxnSpPr/>
           <p:nvPr/>
         </p:nvCxnSpPr>
@@ -27686,7 +27564,7 @@
       </p:sp>
       <p:cxnSp>
         <p:nvCxnSpPr>
-          <p:cNvPr id="864" name="Google Shape;447;p18"/>
+          <p:cNvPr id="1049" name="Google Shape;447;p18"/>
           <p:cNvCxnSpPr/>
           <p:nvPr/>
         </p:nvCxnSpPr>
@@ -31181,7 +31059,7 @@
                           <a:ea typeface="Calibri"/>
                           <a:cs typeface="Calibri"/>
                         </a:rPr>
-                        <a:t>measurement of T1 or the jeevan–body interface</a:t>
+                        <a:t>measurement of sentience or the jeevan–body interface</a:t>
                       </a:r>
                     </a:p>
                   </a:txBody>
@@ -31475,7 +31353,7 @@
                 <a:ea typeface="Calibri"/>
                 <a:cs typeface="Calibri"/>
               </a:rPr>
-              <a:t>No accepted measurement procedure currently identifies T1, the jeevan–body interface, or post-body reassociation. These remain open to instrument-based scientific inquiry.</a:t>
+              <a:t>No accepted measurement currently identifies the sentience threshold, the jeevan–body interface, or post-body reassociation. These remain open to instrument-based scientific inquiry.</a:t>
             </a:r>
           </a:p>
         </p:txBody>
@@ -32976,7 +32854,7 @@
           <p:nvPr/>
         </p:nvPicPr>
         <p:blipFill rotWithShape="1">
-          <a:blip xmlns:r="http://schemas.openxmlformats.org/officeDocument/2006/relationships" xmlns:a="http://schemas.openxmlformats.org/drawingml/2006/main" r:embed="R88075c53ad06497a">
+          <a:blip xmlns:r="http://schemas.openxmlformats.org/officeDocument/2006/relationships" xmlns:a="http://schemas.openxmlformats.org/drawingml/2006/main" r:embed="Rb9d2cd783c36492d">
             <a:alphaModFix/>
           </a:blip>
           <a:srcRect xmlns:a="http://schemas.openxmlformats.org/drawingml/2006/main" l="0" t="0" r="0" b="0"/>
@@ -33118,7 +32996,7 @@
           <p:nvPr/>
         </p:nvPicPr>
         <p:blipFill rotWithShape="1">
-          <a:blip xmlns:r="http://schemas.openxmlformats.org/officeDocument/2006/relationships" xmlns:a="http://schemas.openxmlformats.org/drawingml/2006/main" r:embed="R88075c53ad06497a">
+          <a:blip xmlns:r="http://schemas.openxmlformats.org/officeDocument/2006/relationships" xmlns:a="http://schemas.openxmlformats.org/drawingml/2006/main" r:embed="Rb9d2cd783c36492d">
             <a:alphaModFix/>
           </a:blip>
           <a:srcRect xmlns:a="http://schemas.openxmlformats.org/drawingml/2006/main" l="0" t="0" r="0" b="0"/>
@@ -33260,7 +33138,7 @@
           <p:nvPr/>
         </p:nvPicPr>
         <p:blipFill rotWithShape="1">
-          <a:blip xmlns:r="http://schemas.openxmlformats.org/officeDocument/2006/relationships" xmlns:a="http://schemas.openxmlformats.org/drawingml/2006/main" r:embed="R88075c53ad06497a">
+          <a:blip xmlns:r="http://schemas.openxmlformats.org/officeDocument/2006/relationships" xmlns:a="http://schemas.openxmlformats.org/drawingml/2006/main" r:embed="Rb9d2cd783c36492d">
             <a:alphaModFix/>
           </a:blip>
           <a:srcRect xmlns:a="http://schemas.openxmlformats.org/drawingml/2006/main" l="0" t="0" r="0" b="0"/>
@@ -33402,7 +33280,7 @@
           <p:nvPr/>
         </p:nvPicPr>
         <p:blipFill rotWithShape="1">
-          <a:blip xmlns:r="http://schemas.openxmlformats.org/officeDocument/2006/relationships" xmlns:a="http://schemas.openxmlformats.org/drawingml/2006/main" r:embed="R88075c53ad06497a">
+          <a:blip xmlns:r="http://schemas.openxmlformats.org/officeDocument/2006/relationships" xmlns:a="http://schemas.openxmlformats.org/drawingml/2006/main" r:embed="Rb9d2cd783c36492d">
             <a:alphaModFix/>
           </a:blip>
           <a:srcRect xmlns:a="http://schemas.openxmlformats.org/drawingml/2006/main" l="0" t="0" r="0" b="0"/>
@@ -33544,7 +33422,7 @@
           <p:nvPr/>
         </p:nvPicPr>
         <p:blipFill rotWithShape="1">
-          <a:blip xmlns:r="http://schemas.openxmlformats.org/officeDocument/2006/relationships" xmlns:a="http://schemas.openxmlformats.org/drawingml/2006/main" r:embed="R88075c53ad06497a">
+          <a:blip xmlns:r="http://schemas.openxmlformats.org/officeDocument/2006/relationships" xmlns:a="http://schemas.openxmlformats.org/drawingml/2006/main" r:embed="Rb9d2cd783c36492d">
             <a:alphaModFix/>
           </a:blip>
           <a:srcRect xmlns:a="http://schemas.openxmlformats.org/drawingml/2006/main" l="0" t="0" r="0" b="0"/>
@@ -33686,7 +33564,7 @@
           <p:nvPr/>
         </p:nvPicPr>
         <p:blipFill rotWithShape="1">
-          <a:blip xmlns:r="http://schemas.openxmlformats.org/officeDocument/2006/relationships" xmlns:a="http://schemas.openxmlformats.org/drawingml/2006/main" r:embed="R88075c53ad06497a">
+          <a:blip xmlns:r="http://schemas.openxmlformats.org/officeDocument/2006/relationships" xmlns:a="http://schemas.openxmlformats.org/drawingml/2006/main" r:embed="Rb9d2cd783c36492d">
             <a:alphaModFix/>
           </a:blip>
           <a:srcRect xmlns:a="http://schemas.openxmlformats.org/drawingml/2006/main" l="0" t="0" r="0" b="0"/>
@@ -34237,7 +34115,7 @@
           <p:nvPr/>
         </p:nvPicPr>
         <p:blipFill>
-          <a:blip xmlns:r="http://schemas.openxmlformats.org/officeDocument/2006/relationships" xmlns:a="http://schemas.openxmlformats.org/drawingml/2006/main" r:embed="Rcf6635e90225442b"/>
+          <a:blip xmlns:r="http://schemas.openxmlformats.org/officeDocument/2006/relationships" xmlns:a="http://schemas.openxmlformats.org/drawingml/2006/main" r:embed="R5463d652c32345ac"/>
           <a:stretch xmlns:a="http://schemas.openxmlformats.org/drawingml/2006/main"/>
         </p:blipFill>
         <p:spPr>
@@ -36152,7 +36030,7 @@
           <p:nvPr/>
         </p:nvPicPr>
         <p:blipFill rotWithShape="1">
-          <a:blip xmlns:r="http://schemas.openxmlformats.org/officeDocument/2006/relationships" xmlns:a="http://schemas.openxmlformats.org/drawingml/2006/main" r:embed="Rd188bf943b454c22">
+          <a:blip xmlns:r="http://schemas.openxmlformats.org/officeDocument/2006/relationships" xmlns:a="http://schemas.openxmlformats.org/drawingml/2006/main" r:embed="R9038ac16d5854b72">
             <a:alphaModFix/>
           </a:blip>
           <a:srcRect xmlns:a="http://schemas.openxmlformats.org/drawingml/2006/main" l="0" t="0" r="0" b="0"/>
@@ -36395,7 +36273,7 @@
           <p:nvPr/>
         </p:nvPicPr>
         <p:blipFill rotWithShape="1">
-          <a:blip xmlns:r="http://schemas.openxmlformats.org/officeDocument/2006/relationships" xmlns:a="http://schemas.openxmlformats.org/drawingml/2006/main" r:embed="Rf96316b55e144a25">
+          <a:blip xmlns:r="http://schemas.openxmlformats.org/officeDocument/2006/relationships" xmlns:a="http://schemas.openxmlformats.org/drawingml/2006/main" r:embed="R6f47f4044c304646">
             <a:alphaModFix/>
           </a:blip>
           <a:srcRect xmlns:a="http://schemas.openxmlformats.org/drawingml/2006/main" l="0" t="0" r="0" b="0"/>
@@ -36638,7 +36516,7 @@
           <p:nvPr/>
         </p:nvPicPr>
         <p:blipFill rotWithShape="1">
-          <a:blip xmlns:r="http://schemas.openxmlformats.org/officeDocument/2006/relationships" xmlns:a="http://schemas.openxmlformats.org/drawingml/2006/main" r:embed="Rc382a912f15544a8">
+          <a:blip xmlns:r="http://schemas.openxmlformats.org/officeDocument/2006/relationships" xmlns:a="http://schemas.openxmlformats.org/drawingml/2006/main" r:embed="Rd2c9bbdc8e494723">
             <a:alphaModFix/>
           </a:blip>
           <a:srcRect xmlns:a="http://schemas.openxmlformats.org/drawingml/2006/main" l="0" t="0" r="0" b="0"/>
@@ -37281,7 +37159,7 @@
           <p:nvPr/>
         </p:nvPicPr>
         <p:blipFill rotWithShape="1">
-          <a:blip xmlns:r="http://schemas.openxmlformats.org/officeDocument/2006/relationships" xmlns:a="http://schemas.openxmlformats.org/drawingml/2006/main" r:embed="Rd188bf943b454c22">
+          <a:blip xmlns:r="http://schemas.openxmlformats.org/officeDocument/2006/relationships" xmlns:a="http://schemas.openxmlformats.org/drawingml/2006/main" r:embed="R1611995c1b154a01">
             <a:alphaModFix/>
           </a:blip>
           <a:srcRect xmlns:a="http://schemas.openxmlformats.org/drawingml/2006/main" l="0" t="0" r="0" b="0"/>
@@ -37524,7 +37402,7 @@
           <p:nvPr/>
         </p:nvPicPr>
         <p:blipFill rotWithShape="1">
-          <a:blip xmlns:r="http://schemas.openxmlformats.org/officeDocument/2006/relationships" xmlns:a="http://schemas.openxmlformats.org/drawingml/2006/main" r:embed="Rf96316b55e144a25">
+          <a:blip xmlns:r="http://schemas.openxmlformats.org/officeDocument/2006/relationships" xmlns:a="http://schemas.openxmlformats.org/drawingml/2006/main" r:embed="R4d2f2983afac4a53">
             <a:alphaModFix/>
           </a:blip>
           <a:srcRect xmlns:a="http://schemas.openxmlformats.org/drawingml/2006/main" l="0" t="0" r="0" b="0"/>
@@ -37767,7 +37645,7 @@
           <p:nvPr/>
         </p:nvPicPr>
         <p:blipFill rotWithShape="1">
-          <a:blip xmlns:r="http://schemas.openxmlformats.org/officeDocument/2006/relationships" xmlns:a="http://schemas.openxmlformats.org/drawingml/2006/main" r:embed="Rc382a912f15544a8">
+          <a:blip xmlns:r="http://schemas.openxmlformats.org/officeDocument/2006/relationships" xmlns:a="http://schemas.openxmlformats.org/drawingml/2006/main" r:embed="R4186f21325884578">
             <a:alphaModFix/>
           </a:blip>
           <a:srcRect xmlns:a="http://schemas.openxmlformats.org/drawingml/2006/main" l="0" t="0" r="0" b="0"/>
@@ -38410,7 +38288,7 @@
           <p:nvPr/>
         </p:nvPicPr>
         <p:blipFill rotWithShape="1">
-          <a:blip xmlns:r="http://schemas.openxmlformats.org/officeDocument/2006/relationships" xmlns:a="http://schemas.openxmlformats.org/drawingml/2006/main" r:embed="Rd188bf943b454c22">
+          <a:blip xmlns:r="http://schemas.openxmlformats.org/officeDocument/2006/relationships" xmlns:a="http://schemas.openxmlformats.org/drawingml/2006/main" r:embed="R68ffc5f379384abb">
             <a:alphaModFix/>
           </a:blip>
           <a:srcRect xmlns:a="http://schemas.openxmlformats.org/drawingml/2006/main" l="0" t="0" r="0" b="0"/>
@@ -38653,7 +38531,7 @@
           <p:nvPr/>
         </p:nvPicPr>
         <p:blipFill rotWithShape="1">
-          <a:blip xmlns:r="http://schemas.openxmlformats.org/officeDocument/2006/relationships" xmlns:a="http://schemas.openxmlformats.org/drawingml/2006/main" r:embed="Rf96316b55e144a25">
+          <a:blip xmlns:r="http://schemas.openxmlformats.org/officeDocument/2006/relationships" xmlns:a="http://schemas.openxmlformats.org/drawingml/2006/main" r:embed="R3d33b8c3422e4c96">
             <a:alphaModFix/>
           </a:blip>
           <a:srcRect xmlns:a="http://schemas.openxmlformats.org/drawingml/2006/main" l="0" t="0" r="0" b="0"/>
@@ -38896,7 +38774,7 @@
           <p:nvPr/>
         </p:nvPicPr>
         <p:blipFill rotWithShape="1">
-          <a:blip xmlns:r="http://schemas.openxmlformats.org/officeDocument/2006/relationships" xmlns:a="http://schemas.openxmlformats.org/drawingml/2006/main" r:embed="Rc382a912f15544a8">
+          <a:blip xmlns:r="http://schemas.openxmlformats.org/officeDocument/2006/relationships" xmlns:a="http://schemas.openxmlformats.org/drawingml/2006/main" r:embed="Ra51fbd2159f84837">
             <a:alphaModFix/>
           </a:blip>
           <a:srcRect xmlns:a="http://schemas.openxmlformats.org/drawingml/2006/main" l="0" t="0" r="0" b="0"/>
@@ -39078,7 +38956,29 @@
                 <a:ea typeface="Calibri"/>
                 <a:cs typeface="Calibri"/>
               </a:rPr>
-              <a:t>The completeness drive is the drive to fulfil this complementarity: composition is the natural inclination toward coexistence, T1 is hungry and overfull atoms completing each other, and justice is the human form of the same thing. — SB pp. 49–50, 53, 57, 62; MVD pp. 32, 62; JV pp. 43, 67, 69</a:t>
+              <a:t>The completeness drive is the drive to fulfil this complementarity: composition is the natural inclination toward coexistence, </a:t>
+            </a:r>
+            <a:r>
+              <a:rPr sz="950" b="0" i="1" u="none" cap="none">
+                <a:solidFill>
+                  <a:srgbClr val="5A6377"/>
+                </a:solidFill>
+                <a:latin typeface="Calibri"/>
+                <a:ea typeface="Calibri"/>
+                <a:cs typeface="Calibri"/>
+              </a:rPr>
+              <a:t>the sentience threshold is hungry and overfull atoms completing each other</a:t>
+            </a:r>
+            <a:r>
+              <a:rPr sz="950" b="0" i="1" u="none" cap="none">
+                <a:solidFill>
+                  <a:srgbClr val="5A6377"/>
+                </a:solidFill>
+                <a:latin typeface="Calibri"/>
+                <a:ea typeface="Calibri"/>
+                <a:cs typeface="Calibri"/>
+              </a:rPr>
+              <a:t>, and justice is the human form of the same thing. — SB pp. 49–50, 53, 57, 62; MVD pp. 32, 62; JV pp. 43, 67, 69</a:t>
             </a:r>
           </a:p>
         </p:txBody>

</xml_diff>

<commit_message>
Clarify activity and action in ontology study
</commit_message>
<xml_diff>
--- a/Studies/The-Ontology-of-Coexistence/The-Ontology-of-Existence-Madhyasth-Darshan.pptx
+++ b/Studies/The-Ontology-of-Coexistence/The-Ontology-of-Existence-Madhyasth-Darshan.pptx
@@ -2,40 +2,40 @@
 <file path=ppt/presentation.xml><?xml version="1.0" encoding="utf-8"?>
 <p:presentation xmlns:p="http://schemas.openxmlformats.org/presentationml/2006/main">
   <p:sldMasterIdLst>
-    <p:sldMasterId xmlns:r="http://schemas.openxmlformats.org/officeDocument/2006/relationships" id="2147483648" r:id="R36c3b345eaf24a80"/>
+    <p:sldMasterId xmlns:r="http://schemas.openxmlformats.org/officeDocument/2006/relationships" id="2147483648" r:id="Rb763969d7a354eb0"/>
   </p:sldMasterIdLst>
   <p:notesMasterIdLst>
-    <p:notesMasterId xmlns:r="http://schemas.openxmlformats.org/officeDocument/2006/relationships" r:id="Re7e183d1d8474863"/>
+    <p:notesMasterId xmlns:r="http://schemas.openxmlformats.org/officeDocument/2006/relationships" r:id="Re089755d6eee4c05"/>
   </p:notesMasterIdLst>
   <p:sldIdLst>
-    <p:sldId xmlns:r="http://schemas.openxmlformats.org/officeDocument/2006/relationships" id="256" r:id="R8e93baf735ab49dd"/>
-    <p:sldId xmlns:r="http://schemas.openxmlformats.org/officeDocument/2006/relationships" id="257" r:id="Re923161173384642"/>
-    <p:sldId xmlns:r="http://schemas.openxmlformats.org/officeDocument/2006/relationships" id="258" r:id="R823ebfb2a7264c5e"/>
-    <p:sldId xmlns:r="http://schemas.openxmlformats.org/officeDocument/2006/relationships" id="259" r:id="R96fdd392b00a4c4d"/>
-    <p:sldId xmlns:r="http://schemas.openxmlformats.org/officeDocument/2006/relationships" id="260" r:id="R924fc04ecd654954"/>
-    <p:sldId xmlns:r="http://schemas.openxmlformats.org/officeDocument/2006/relationships" id="261" r:id="Ra3d054b6923044d9"/>
-    <p:sldId xmlns:r="http://schemas.openxmlformats.org/officeDocument/2006/relationships" id="262" r:id="R90942b1331e149c6"/>
-    <p:sldId xmlns:r="http://schemas.openxmlformats.org/officeDocument/2006/relationships" id="263" r:id="Rae2e1f1948994179"/>
-    <p:sldId xmlns:r="http://schemas.openxmlformats.org/officeDocument/2006/relationships" id="264" r:id="Rb4fe29ff578c4c1a"/>
-    <p:sldId xmlns:r="http://schemas.openxmlformats.org/officeDocument/2006/relationships" id="265" r:id="R1c04e7d829af497b"/>
-    <p:sldId xmlns:r="http://schemas.openxmlformats.org/officeDocument/2006/relationships" id="266" r:id="R012590733b8f4f48"/>
-    <p:sldId xmlns:r="http://schemas.openxmlformats.org/officeDocument/2006/relationships" id="267" r:id="Rf7c429f9714f40ea"/>
-    <p:sldId xmlns:r="http://schemas.openxmlformats.org/officeDocument/2006/relationships" id="268" r:id="R4f0c63996a9847c3"/>
-    <p:sldId xmlns:r="http://schemas.openxmlformats.org/officeDocument/2006/relationships" id="269" r:id="R216a1fd1a9a8498a"/>
-    <p:sldId xmlns:r="http://schemas.openxmlformats.org/officeDocument/2006/relationships" id="270" r:id="R9b907f3063a247d3"/>
-    <p:sldId xmlns:r="http://schemas.openxmlformats.org/officeDocument/2006/relationships" id="271" r:id="Re111fb24de434fbf"/>
-    <p:sldId xmlns:r="http://schemas.openxmlformats.org/officeDocument/2006/relationships" id="272" r:id="R8e75b285dc994036"/>
-    <p:sldId xmlns:r="http://schemas.openxmlformats.org/officeDocument/2006/relationships" id="273" r:id="Rc051ce4dc9a04231"/>
-    <p:sldId xmlns:r="http://schemas.openxmlformats.org/officeDocument/2006/relationships" id="274" r:id="Re2809ee22f4c4d87"/>
-    <p:sldId xmlns:r="http://schemas.openxmlformats.org/officeDocument/2006/relationships" id="275" r:id="R9569ed22d2b84ead"/>
-    <p:sldId xmlns:r="http://schemas.openxmlformats.org/officeDocument/2006/relationships" id="276" r:id="Rd303ce6447bb4871"/>
-    <p:sldId xmlns:r="http://schemas.openxmlformats.org/officeDocument/2006/relationships" id="277" r:id="R60743571f4c343c2"/>
-    <p:sldId xmlns:r="http://schemas.openxmlformats.org/officeDocument/2006/relationships" id="278" r:id="Rb892ce7f38a84cb0"/>
-    <p:sldId xmlns:r="http://schemas.openxmlformats.org/officeDocument/2006/relationships" id="279" r:id="R73658b09b77d4348"/>
-    <p:sldId xmlns:r="http://schemas.openxmlformats.org/officeDocument/2006/relationships" id="280" r:id="Rdd2eee1401504460"/>
-    <p:sldId xmlns:r="http://schemas.openxmlformats.org/officeDocument/2006/relationships" id="281" r:id="R163cbc1424cf4090"/>
-    <p:sldId xmlns:r="http://schemas.openxmlformats.org/officeDocument/2006/relationships" id="282" r:id="R264b946c389c4d0f"/>
-    <p:sldId xmlns:r="http://schemas.openxmlformats.org/officeDocument/2006/relationships" id="283" r:id="R997e15c41f9e467e"/>
+    <p:sldId xmlns:r="http://schemas.openxmlformats.org/officeDocument/2006/relationships" id="256" r:id="Rcf1a2b7213d4431e"/>
+    <p:sldId xmlns:r="http://schemas.openxmlformats.org/officeDocument/2006/relationships" id="257" r:id="R694c89ade17f41b8"/>
+    <p:sldId xmlns:r="http://schemas.openxmlformats.org/officeDocument/2006/relationships" id="258" r:id="R00eb5efb8c5f4e44"/>
+    <p:sldId xmlns:r="http://schemas.openxmlformats.org/officeDocument/2006/relationships" id="259" r:id="Rd90f309206424460"/>
+    <p:sldId xmlns:r="http://schemas.openxmlformats.org/officeDocument/2006/relationships" id="260" r:id="Raf2baeef531a4f5e"/>
+    <p:sldId xmlns:r="http://schemas.openxmlformats.org/officeDocument/2006/relationships" id="261" r:id="R698bb10d3d0c4344"/>
+    <p:sldId xmlns:r="http://schemas.openxmlformats.org/officeDocument/2006/relationships" id="262" r:id="R93cb00fbbfea4ae6"/>
+    <p:sldId xmlns:r="http://schemas.openxmlformats.org/officeDocument/2006/relationships" id="263" r:id="R47e7378bd44348b4"/>
+    <p:sldId xmlns:r="http://schemas.openxmlformats.org/officeDocument/2006/relationships" id="264" r:id="R23b69067c47a47fe"/>
+    <p:sldId xmlns:r="http://schemas.openxmlformats.org/officeDocument/2006/relationships" id="265" r:id="R46a5a279f5014553"/>
+    <p:sldId xmlns:r="http://schemas.openxmlformats.org/officeDocument/2006/relationships" id="266" r:id="R7c87f677a3b74689"/>
+    <p:sldId xmlns:r="http://schemas.openxmlformats.org/officeDocument/2006/relationships" id="267" r:id="Rbf1d92438c834905"/>
+    <p:sldId xmlns:r="http://schemas.openxmlformats.org/officeDocument/2006/relationships" id="268" r:id="Ra974545b42484d04"/>
+    <p:sldId xmlns:r="http://schemas.openxmlformats.org/officeDocument/2006/relationships" id="269" r:id="Re4bd29b4c7a04a69"/>
+    <p:sldId xmlns:r="http://schemas.openxmlformats.org/officeDocument/2006/relationships" id="270" r:id="R369076999c8e4178"/>
+    <p:sldId xmlns:r="http://schemas.openxmlformats.org/officeDocument/2006/relationships" id="271" r:id="R45e80e95324f49ac"/>
+    <p:sldId xmlns:r="http://schemas.openxmlformats.org/officeDocument/2006/relationships" id="272" r:id="Rba502ed2c6e44fee"/>
+    <p:sldId xmlns:r="http://schemas.openxmlformats.org/officeDocument/2006/relationships" id="273" r:id="R811c3c5282334a91"/>
+    <p:sldId xmlns:r="http://schemas.openxmlformats.org/officeDocument/2006/relationships" id="274" r:id="Rd62664e70b01459e"/>
+    <p:sldId xmlns:r="http://schemas.openxmlformats.org/officeDocument/2006/relationships" id="275" r:id="R3fce05a135364de6"/>
+    <p:sldId xmlns:r="http://schemas.openxmlformats.org/officeDocument/2006/relationships" id="276" r:id="R341dd9382d6f4162"/>
+    <p:sldId xmlns:r="http://schemas.openxmlformats.org/officeDocument/2006/relationships" id="277" r:id="Rac0e4792baf942b1"/>
+    <p:sldId xmlns:r="http://schemas.openxmlformats.org/officeDocument/2006/relationships" id="278" r:id="R8b0e403157ef46e5"/>
+    <p:sldId xmlns:r="http://schemas.openxmlformats.org/officeDocument/2006/relationships" id="279" r:id="R66b512dca57841c8"/>
+    <p:sldId xmlns:r="http://schemas.openxmlformats.org/officeDocument/2006/relationships" id="280" r:id="Rdd31d43a6bb1483d"/>
+    <p:sldId xmlns:r="http://schemas.openxmlformats.org/officeDocument/2006/relationships" id="281" r:id="R71b6723b939b4fe7"/>
+    <p:sldId xmlns:r="http://schemas.openxmlformats.org/officeDocument/2006/relationships" id="282" r:id="R406d5014727442d4"/>
+    <p:sldId xmlns:r="http://schemas.openxmlformats.org/officeDocument/2006/relationships" id="283" r:id="R8057b9684d574773"/>
   </p:sldIdLst>
   <p:sldSz cx="9144000" cy="5143500"/>
   <p:notesSz cx="6858000" cy="9144000"/>
@@ -453,7 +453,7 @@
 </file>
 
 <file path=ppt/notesSlides/notesSlide1.xml><?xml version="1.0" encoding="utf-8"?>
-<p:notes xmlns:p="http://schemas.openxmlformats.org/presentationml/2006/main">
+<p:notes xmlns:a="http://schemas.openxmlformats.org/drawingml/2006/main" xmlns:p="http://schemas.openxmlformats.org/presentationml/2006/main">
   <p:cSld>
     <p:spTree>
       <p:nvGrpSpPr>
@@ -462,13 +462,13 @@
         <p:nvPr/>
       </p:nvGrpSpPr>
       <p:grpSpPr>
-        <a:xfrm xmlns:a="http://schemas.openxmlformats.org/drawingml/2006/main"/>
+        <a:xfrm/>
       </p:grpSpPr>
       <p:sp>
         <p:nvSpPr>
           <p:cNvPr id="2" name="Slide Image Placeholder 1"/>
           <p:cNvSpPr>
-            <a:spLocks xmlns:a="http://schemas.openxmlformats.org/drawingml/2006/main" noGrp="1"/>
+            <a:spLocks noGrp="1"/>
           </p:cNvSpPr>
           <p:nvPr>
             <p:ph type="sldImg" idx="0"/>
@@ -480,7 +480,7 @@
         <p:nvSpPr>
           <p:cNvPr id="3" name="Notes Placeholder 2"/>
           <p:cNvSpPr>
-            <a:spLocks xmlns:a="http://schemas.openxmlformats.org/drawingml/2006/main" noGrp="1"/>
+            <a:spLocks noGrp="1"/>
           </p:cNvSpPr>
           <p:nvPr>
             <p:ph type="body" idx="1"/>
@@ -488,38 +488,29 @@
         </p:nvSpPr>
         <p:spPr/>
         <p:txBody>
-          <a:bodyPr xmlns:a="http://schemas.openxmlformats.org/drawingml/2006/main"/>
-          <a:lstStyle xmlns:a="http://schemas.openxmlformats.org/drawingml/2006/main"/>
-          <a:p xmlns:a="http://schemas.openxmlformats.org/drawingml/2006/main">
-            <a:pPr marL="0" indent="0" algn="l">
-              <a:spcBef>
-                <a:spcPts val="0"/>
-              </a:spcBef>
-              <a:spcAft>
-                <a:spcPts val="0"/>
-              </a:spcAft>
-              <a:buNone/>
-            </a:pPr>
+          <a:bodyPr/>
+          <a:lstStyle/>
+          <a:p>
             <a:r>
               <a:t>Welcome, and thank you for joining.</a:t>
             </a:r>
           </a:p>
-          <a:p xmlns:a="http://schemas.openxmlformats.org/drawingml/2006/main">
+          <a:p>
             <a:r>
               <a:t>You do not need any prior familiarity with Madhyasth Darshan, or with formal philosophy, to follow this session. I will use ordinary English first, and introduce source terms only when they help. Our aim is not persuasion or devotion. It is to examine one coherent account of reality — testing its definitions and internal consistency.</a:t>
             </a:r>
           </a:p>
-          <a:p xmlns:a="http://schemas.openxmlformats.org/drawingml/2006/main">
+          <a:p>
             <a:r>
               <a:t>Madhyasth Darshan — also called Co-existentialism — was propounded by Shri A. Nagraj. The name points to a thesis we will unpack later: order in nature is mediative and inherent, not imposed by an external governor.</a:t>
             </a:r>
           </a:p>
-          <a:p xmlns:a="http://schemas.openxmlformats.org/drawingml/2006/main">
+          <a:p>
             <a:r>
               <a:t>Here is the one claim to hold for the whole talk: existence is coexistence. Reality is the ever-present togetherness of a formless, all-pervasive ground and countless real, bounded units of nature, each saturated in that ground. Everything else — sentience, values, justice, society — unfolds from this picture.</a:t>
             </a:r>
           </a:p>
-          <a:p xmlns:a="http://schemas.openxmlformats.org/drawingml/2006/main">
+          <a:p>
             <a:r>
               <a:t>One word about vocabulary. The published translations often print “Omnipotence” for the ground; the slides and I will say Omnipresence. Same reality, different English label — you will see the translation's word only inside quotations.</a:t>
             </a:r>
@@ -530,7 +521,7 @@
         <p:nvSpPr>
           <p:cNvPr id="4" name="Slide Number Placeholder 3"/>
           <p:cNvSpPr>
-            <a:spLocks xmlns:a="http://schemas.openxmlformats.org/drawingml/2006/main" noGrp="1"/>
+            <a:spLocks noGrp="1"/>
           </p:cNvSpPr>
           <p:nvPr>
             <p:ph type="sldNum" idx="5"/>
@@ -538,21 +529,21 @@
         </p:nvSpPr>
         <p:spPr/>
         <p:txBody>
-          <a:bodyPr xmlns:a="http://schemas.openxmlformats.org/drawingml/2006/main"/>
-          <a:lstStyle xmlns:a="http://schemas.openxmlformats.org/drawingml/2006/main"/>
-          <a:p xmlns:a="http://schemas.openxmlformats.org/drawingml/2006/main"/>
+          <a:bodyPr/>
+          <a:lstStyle/>
+          <a:p/>
         </p:txBody>
       </p:sp>
     </p:spTree>
   </p:cSld>
   <p:clrMapOvr>
-    <a:masterClrMapping xmlns:a="http://schemas.openxmlformats.org/drawingml/2006/main"/>
+    <a:masterClrMapping/>
   </p:clrMapOvr>
 </p:notes>
 </file>
 
 <file path=ppt/notesSlides/notesSlide10.xml><?xml version="1.0" encoding="utf-8"?>
-<p:notes xmlns:p="http://schemas.openxmlformats.org/presentationml/2006/main">
+<p:notes xmlns:a="http://schemas.openxmlformats.org/drawingml/2006/main" xmlns:p="http://schemas.openxmlformats.org/presentationml/2006/main">
   <p:cSld>
     <p:spTree>
       <p:nvGrpSpPr>
@@ -561,13 +552,13 @@
         <p:nvPr/>
       </p:nvGrpSpPr>
       <p:grpSpPr>
-        <a:xfrm xmlns:a="http://schemas.openxmlformats.org/drawingml/2006/main"/>
+        <a:xfrm/>
       </p:grpSpPr>
       <p:sp>
         <p:nvSpPr>
           <p:cNvPr id="2" name="Slide Image Placeholder 1"/>
           <p:cNvSpPr>
-            <a:spLocks xmlns:a="http://schemas.openxmlformats.org/drawingml/2006/main" noGrp="1"/>
+            <a:spLocks noGrp="1"/>
           </p:cNvSpPr>
           <p:nvPr>
             <p:ph type="sldImg" idx="0"/>
@@ -579,7 +570,7 @@
         <p:nvSpPr>
           <p:cNvPr id="3" name="Notes Placeholder 2"/>
           <p:cNvSpPr>
-            <a:spLocks xmlns:a="http://schemas.openxmlformats.org/drawingml/2006/main" noGrp="1"/>
+            <a:spLocks noGrp="1"/>
           </p:cNvSpPr>
           <p:nvPr>
             <p:ph type="body" idx="1"/>
@@ -587,38 +578,29 @@
         </p:nvSpPr>
         <p:spPr/>
         <p:txBody>
-          <a:bodyPr xmlns:a="http://schemas.openxmlformats.org/drawingml/2006/main"/>
-          <a:lstStyle xmlns:a="http://schemas.openxmlformats.org/drawingml/2006/main"/>
-          <a:p xmlns:a="http://schemas.openxmlformats.org/drawingml/2006/main">
-            <a:pPr marL="0" indent="0" algn="l">
-              <a:spcBef>
-                <a:spcPts val="0"/>
-              </a:spcBef>
-              <a:spcAft>
-                <a:spcPts val="0"/>
-              </a:spcAft>
-              <a:buNone/>
-            </a:pPr>
+          <a:bodyPr/>
+          <a:lstStyle/>
+          <a:p>
             <a:r>
               <a:t>The complementarity we just established becomes evident through relationships among units — this slide is what it looks like in practice.</a:t>
             </a:r>
           </a:p>
-          <a:p xmlns:a="http://schemas.openxmlformats.org/drawingml/2006/main">
+          <a:p>
             <a:r>
               <a:t>In the material, plant, and animal orders its expression is definite: recognition happens, fulfilment happens. At the human order alone it has to be recognised, evaluated, and fulfilled — so at the human order alone it can be got wrong, and it is got wrong when the body is mistaken for the self.</a:t>
             </a:r>
           </a:p>
-          <a:p xmlns:a="http://schemas.openxmlformats.org/drawingml/2006/main">
+          <a:p>
             <a:r>
               <a:t>Two kinds of mutuality matter. A relationship is mutuality whose expectations are definite in the completeness of the bond — parent and child. An association or contact is mutuality where expectations are voluntary — neighbours who share a wall.</a:t>
             </a:r>
           </a:p>
-          <a:p xmlns:a="http://schemas.openxmlformats.org/drawingml/2006/main">
+          <a:p>
             <a:r>
               <a:t>The slide names five value families: object, *jeevan*, human, established, and civic — the last is *shishta-mulya* in the source. Object values are two, utility and art, so the same list is often counted as six types: utility, art, *jeevan*, human, established, and civic. Established values are the ones that become evident when human relationships are recognised and fulfilled — trust, respect, affection, care, and so on. Civic values are how all of that is expressed in social participation.</a:t>
             </a:r>
           </a:p>
-          <a:p xmlns:a="http://schemas.openxmlformats.org/drawingml/2006/main">
+          <a:p>
             <a:r>
               <a:t>At the human order the path runs: knowing, then believing, then recognising, then fulfilling. Awakening does not invent new faculties. It aligns this chain with coexistence.</a:t>
             </a:r>
@@ -629,7 +611,7 @@
         <p:nvSpPr>
           <p:cNvPr id="4" name="Slide Number Placeholder 3"/>
           <p:cNvSpPr>
-            <a:spLocks xmlns:a="http://schemas.openxmlformats.org/drawingml/2006/main" noGrp="1"/>
+            <a:spLocks noGrp="1"/>
           </p:cNvSpPr>
           <p:nvPr>
             <p:ph type="sldNum" idx="5"/>
@@ -637,21 +619,21 @@
         </p:nvSpPr>
         <p:spPr/>
         <p:txBody>
-          <a:bodyPr xmlns:a="http://schemas.openxmlformats.org/drawingml/2006/main"/>
-          <a:lstStyle xmlns:a="http://schemas.openxmlformats.org/drawingml/2006/main"/>
-          <a:p xmlns:a="http://schemas.openxmlformats.org/drawingml/2006/main"/>
+          <a:bodyPr/>
+          <a:lstStyle/>
+          <a:p/>
         </p:txBody>
       </p:sp>
     </p:spTree>
   </p:cSld>
   <p:clrMapOvr>
-    <a:masterClrMapping xmlns:a="http://schemas.openxmlformats.org/drawingml/2006/main"/>
+    <a:masterClrMapping/>
   </p:clrMapOvr>
 </p:notes>
 </file>
 
 <file path=ppt/notesSlides/notesSlide11.xml><?xml version="1.0" encoding="utf-8"?>
-<p:notes xmlns:p="http://schemas.openxmlformats.org/presentationml/2006/main">
+<p:notes xmlns:a="http://schemas.openxmlformats.org/drawingml/2006/main" xmlns:p="http://schemas.openxmlformats.org/presentationml/2006/main">
   <p:cSld>
     <p:spTree>
       <p:nvGrpSpPr>
@@ -660,13 +642,13 @@
         <p:nvPr/>
       </p:nvGrpSpPr>
       <p:grpSpPr>
-        <a:xfrm xmlns:a="http://schemas.openxmlformats.org/drawingml/2006/main"/>
+        <a:xfrm/>
       </p:grpSpPr>
       <p:sp>
         <p:nvSpPr>
           <p:cNvPr id="2" name="Slide Image Placeholder 1"/>
           <p:cNvSpPr>
-            <a:spLocks xmlns:a="http://schemas.openxmlformats.org/drawingml/2006/main" noGrp="1"/>
+            <a:spLocks noGrp="1"/>
           </p:cNvSpPr>
           <p:nvPr>
             <p:ph type="sldImg" idx="0"/>
@@ -678,7 +660,7 @@
         <p:nvSpPr>
           <p:cNvPr id="3" name="Notes Placeholder 2"/>
           <p:cNvSpPr>
-            <a:spLocks xmlns:a="http://schemas.openxmlformats.org/drawingml/2006/main" noGrp="1"/>
+            <a:spLocks noGrp="1"/>
           </p:cNvSpPr>
           <p:nvPr>
             <p:ph type="body" idx="1"/>
@@ -686,38 +668,29 @@
         </p:nvSpPr>
         <p:spPr/>
         <p:txBody>
-          <a:bodyPr xmlns:a="http://schemas.openxmlformats.org/drawingml/2006/main"/>
-          <a:lstStyle xmlns:a="http://schemas.openxmlformats.org/drawingml/2006/main"/>
-          <a:p xmlns:a="http://schemas.openxmlformats.org/drawingml/2006/main">
-            <a:pPr marL="0" indent="0" algn="l">
-              <a:spcBef>
-                <a:spcPts val="0"/>
-              </a:spcBef>
-              <a:spcAft>
-                <a:spcPts val="0"/>
-              </a:spcAft>
-              <a:buNone/>
-            </a:pPr>
+          <a:bodyPr/>
+          <a:lstStyle/>
+          <a:p>
             <a:r>
               <a:t>Units organise into four stable orders: material; bio or living-plant order; animal; and knowledge — the human order.</a:t>
             </a:r>
           </a:p>
-          <a:p xmlns:a="http://schemas.openxmlformats.org/drawingml/2006/main">
+          <a:p>
             <a:r>
               <a:t>Read the table downward. Innateness is cumulative. Matter has existence. The bio order adds growth. The animal order adds hope to live. The human order adds happiness. Higher orders include the lower ones.</a:t>
             </a:r>
           </a:p>
-          <a:p xmlns:a="http://schemas.openxmlformats.org/drawingml/2006/main">
+          <a:p>
             <a:r>
               <a:t>The pivotal boundary is between plant life and animal life. Material and bio orders are non-sentient. Hope to live is where sentience enters. The sentient unit is present in animal and human joint forms.</a:t>
             </a:r>
           </a:p>
-          <a:p xmlns:a="http://schemas.openxmlformats.org/drawingml/2006/main">
+          <a:p>
             <a:r>
               <a:t>In animals, bodily and brain development limits how much of that unit’s range can be expressed. In humans, the bodily medium can support the full range, but confusion can still misdirect evaluation. Neither body produces sentience. Please do not collapse either case into “mind emerging from matter alone.”</a:t>
             </a:r>
           </a:p>
-          <a:p xmlns:a="http://schemas.openxmlformats.org/drawingml/2006/main">
+          <a:p>
             <a:r>
               <a:t>We have now stated what exists and how it is ordered. Next: how development proceeds.</a:t>
             </a:r>
@@ -728,7 +701,7 @@
         <p:nvSpPr>
           <p:cNvPr id="4" name="Slide Number Placeholder 3"/>
           <p:cNvSpPr>
-            <a:spLocks xmlns:a="http://schemas.openxmlformats.org/drawingml/2006/main" noGrp="1"/>
+            <a:spLocks noGrp="1"/>
           </p:cNvSpPr>
           <p:nvPr>
             <p:ph type="sldNum" idx="5"/>
@@ -736,21 +709,21 @@
         </p:nvSpPr>
         <p:spPr/>
         <p:txBody>
-          <a:bodyPr xmlns:a="http://schemas.openxmlformats.org/drawingml/2006/main"/>
-          <a:lstStyle xmlns:a="http://schemas.openxmlformats.org/drawingml/2006/main"/>
-          <a:p xmlns:a="http://schemas.openxmlformats.org/drawingml/2006/main"/>
+          <a:bodyPr/>
+          <a:lstStyle/>
+          <a:p/>
         </p:txBody>
       </p:sp>
     </p:spTree>
   </p:cSld>
   <p:clrMapOvr>
-    <a:masterClrMapping xmlns:a="http://schemas.openxmlformats.org/drawingml/2006/main"/>
+    <a:masterClrMapping/>
   </p:clrMapOvr>
 </p:notes>
 </file>
 
 <file path=ppt/notesSlides/notesSlide12.xml><?xml version="1.0" encoding="utf-8"?>
-<p:notes xmlns:p="http://schemas.openxmlformats.org/presentationml/2006/main">
+<p:notes xmlns:a="http://schemas.openxmlformats.org/drawingml/2006/main" xmlns:p="http://schemas.openxmlformats.org/presentationml/2006/main">
   <p:cSld>
     <p:spTree>
       <p:nvGrpSpPr>
@@ -759,13 +732,13 @@
         <p:nvPr/>
       </p:nvGrpSpPr>
       <p:grpSpPr>
-        <a:xfrm xmlns:a="http://schemas.openxmlformats.org/drawingml/2006/main"/>
+        <a:xfrm/>
       </p:grpSpPr>
       <p:sp>
         <p:nvSpPr>
           <p:cNvPr id="2" name="Slide Image Placeholder 1"/>
           <p:cNvSpPr>
-            <a:spLocks xmlns:a="http://schemas.openxmlformats.org/drawingml/2006/main" noGrp="1"/>
+            <a:spLocks noGrp="1"/>
           </p:cNvSpPr>
           <p:nvPr>
             <p:ph type="sldImg" idx="0"/>
@@ -777,7 +750,7 @@
         <p:nvSpPr>
           <p:cNvPr id="3" name="Notes Placeholder 2"/>
           <p:cNvSpPr>
-            <a:spLocks xmlns:a="http://schemas.openxmlformats.org/drawingml/2006/main" noGrp="1"/>
+            <a:spLocks noGrp="1"/>
           </p:cNvSpPr>
           <p:nvPr>
             <p:ph type="body" idx="1"/>
@@ -785,58 +758,49 @@
         </p:nvSpPr>
         <p:spPr/>
         <p:txBody>
-          <a:bodyPr xmlns:a="http://schemas.openxmlformats.org/drawingml/2006/main"/>
-          <a:lstStyle xmlns:a="http://schemas.openxmlformats.org/drawingml/2006/main"/>
-          <a:p xmlns:a="http://schemas.openxmlformats.org/drawingml/2006/main">
-            <a:pPr marL="0" indent="0" algn="l">
-              <a:spcBef>
-                <a:spcPts val="0"/>
-              </a:spcBef>
-              <a:spcAft>
-                <a:spcPts val="0"/>
-              </a:spcAft>
-              <a:buNone/>
-            </a:pPr>
+          <a:bodyPr/>
+          <a:lstStyle/>
+          <a:p>
             <a:r>
               <a:t>Start with the question the last three slides have been building toward: why does anything develop at all?</a:t>
             </a:r>
           </a:p>
-          <a:p xmlns:a="http://schemas.openxmlformats.org/drawingml/2006/main">
+          <a:p>
             <a:r>
               <a:t>The answer the texts give is the completeness drive. Nature saturated in state-complete Omnipresence is oriented toward development and awakening, until realisation. “Oriented” is doing careful work there — it names a direction inherent in the order of coexistence, not a guarantee that every unit travels the whole way.</a:t>
             </a:r>
           </a:p>
-          <a:p xmlns:a="http://schemas.openxmlformats.org/drawingml/2006/main">
+          <a:p>
             <a:r>
               <a:t>And here is the connection back to slide 8, which is the one I most want to land: that drive is the drive to fulfil complementarity. Complementarity is given; fulfilling it is what development *is*. Everything in this movement, and everything in the movement after it, is a specification of that one sentence.</a:t>
             </a:r>
           </a:p>
-          <a:p xmlns:a="http://schemas.openxmlformats.org/drawingml/2006/main">
+          <a:p>
             <a:r>
               <a:t>That drive proceeds along two distinct lines, and Madhyasth Darshan insists they must not be collapsed.</a:t>
             </a:r>
           </a:p>
-          <a:p xmlns:a="http://schemas.openxmlformats.org/drawingml/2006/main">
+          <a:p>
             <a:r>
               <a:t>Compositional progression joins particles, atoms, molecules, cells, and bodies into larger configurations. Separately, development in an atom can reach constitutional completeness as a sentient unit. These lines meet in living joint forms, but they remain distinct.</a:t>
             </a:r>
           </a:p>
-          <a:p xmlns:a="http://schemas.openxmlformats.org/drawingml/2006/main">
+          <a:p>
             <a:r>
               <a:t>Across both, activity is one inseparable triad: effort, motion, and result — three aspects of one activity, not three sequential steps. When sodium and chlorine approach, the approach is effort and motion together; the stable salt crystal is the result.</a:t>
             </a:r>
           </a:p>
-          <a:p xmlns:a="http://schemas.openxmlformats.org/drawingml/2006/main">
+          <a:p>
             <a:r>
               <a:t>The texts compress the engine this way: saturation is forcefulness; forcefulness is basic impulsion; impulsion is activity; activity is effort-motion-result; and that is development.</a:t>
             </a:r>
           </a:p>
-          <a:p xmlns:a="http://schemas.openxmlformats.org/drawingml/2006/main">
+          <a:p>
             <a:r>
               <a:t>Each term has a goal: restfulness of effort, destination of motion, immortality of result. Development pervades nature; awakening occurs in the sentient. Non-sentient units participate by composing bodies and environments without each individually completing the drive.</a:t>
             </a:r>
           </a:p>
-          <a:p xmlns:a="http://schemas.openxmlformats.org/drawingml/2006/main">
+          <a:p>
             <a:r>
               <a:t>The next slide follows both paths through their convergence in animal and human living.</a:t>
             </a:r>
@@ -847,7 +811,7 @@
         <p:nvSpPr>
           <p:cNvPr id="4" name="Slide Number Placeholder 3"/>
           <p:cNvSpPr>
-            <a:spLocks xmlns:a="http://schemas.openxmlformats.org/drawingml/2006/main" noGrp="1"/>
+            <a:spLocks noGrp="1"/>
           </p:cNvSpPr>
           <p:nvPr>
             <p:ph type="sldNum" idx="5"/>
@@ -855,21 +819,21 @@
         </p:nvSpPr>
         <p:spPr/>
         <p:txBody>
-          <a:bodyPr xmlns:a="http://schemas.openxmlformats.org/drawingml/2006/main"/>
-          <a:lstStyle xmlns:a="http://schemas.openxmlformats.org/drawingml/2006/main"/>
-          <a:p xmlns:a="http://schemas.openxmlformats.org/drawingml/2006/main"/>
+          <a:bodyPr/>
+          <a:lstStyle/>
+          <a:p/>
         </p:txBody>
       </p:sp>
     </p:spTree>
   </p:cSld>
   <p:clrMapOvr>
-    <a:masterClrMapping xmlns:a="http://schemas.openxmlformats.org/drawingml/2006/main"/>
+    <a:masterClrMapping/>
   </p:clrMapOvr>
 </p:notes>
 </file>
 
 <file path=ppt/notesSlides/notesSlide13.xml><?xml version="1.0" encoding="utf-8"?>
-<p:notes xmlns:p="http://schemas.openxmlformats.org/presentationml/2006/main">
+<p:notes xmlns:a="http://schemas.openxmlformats.org/drawingml/2006/main" xmlns:p="http://schemas.openxmlformats.org/presentationml/2006/main">
   <p:cSld>
     <p:spTree>
       <p:nvGrpSpPr>
@@ -878,13 +842,13 @@
         <p:nvPr/>
       </p:nvGrpSpPr>
       <p:grpSpPr>
-        <a:xfrm xmlns:a="http://schemas.openxmlformats.org/drawingml/2006/main"/>
+        <a:xfrm/>
       </p:grpSpPr>
       <p:sp>
         <p:nvSpPr>
           <p:cNvPr id="2" name="Slide Image Placeholder 1"/>
           <p:cNvSpPr>
-            <a:spLocks xmlns:a="http://schemas.openxmlformats.org/drawingml/2006/main" noGrp="1"/>
+            <a:spLocks noGrp="1"/>
           </p:cNvSpPr>
           <p:nvPr>
             <p:ph type="sldImg" idx="0"/>
@@ -896,7 +860,7 @@
         <p:nvSpPr>
           <p:cNvPr id="3" name="Notes Placeholder 2"/>
           <p:cNvSpPr>
-            <a:spLocks xmlns:a="http://schemas.openxmlformats.org/drawingml/2006/main" noGrp="1"/>
+            <a:spLocks noGrp="1"/>
           </p:cNvSpPr>
           <p:nvPr>
             <p:ph type="body" idx="1"/>
@@ -904,43 +868,34 @@
         </p:nvSpPr>
         <p:spPr/>
         <p:txBody>
-          <a:bodyPr xmlns:a="http://schemas.openxmlformats.org/drawingml/2006/main"/>
-          <a:lstStyle xmlns:a="http://schemas.openxmlformats.org/drawingml/2006/main"/>
-          <a:p xmlns:a="http://schemas.openxmlformats.org/drawingml/2006/main">
-            <a:pPr marL="0" indent="0" algn="l">
-              <a:spcBef>
-                <a:spcPts val="0"/>
-              </a:spcBef>
-              <a:spcAft>
-                <a:spcPts val="0"/>
-              </a:spcAft>
-              <a:buNone/>
-            </a:pPr>
+          <a:bodyPr/>
+          <a:lstStyle/>
+          <a:p>
             <a:r>
               <a:t>The completeness drive unfolds along two parallel paths.</a:t>
             </a:r>
           </a:p>
-          <a:p xmlns:a="http://schemas.openxmlformats.org/drawingml/2006/main">
+          <a:p>
             <a:r>
               <a:t>The first is the compositional path, *rachna*. Atoms and molecules form material-order structures. Under appropriate chemical and environmental conditions, pranic cells and biological formations appear. This is the material-to-biological order change, and both orders remain insentient.</a:t>
             </a:r>
           </a:p>
-          <a:p xmlns:a="http://schemas.openxmlformats.org/drawingml/2006/main">
+          <a:p>
             <a:r>
               <a:t>The second is the atomic path, *gathan*. A developing atom integrates the particle constitution required for completeness. At constitutional completeness, the texts classify that atom as sentient *jeevan*.</a:t>
             </a:r>
           </a:p>
-          <a:p xmlns:a="http://schemas.openxmlformats.org/drawingml/2006/main">
+          <a:p>
             <a:r>
               <a:t>The two paths meet in the animal order as a joint form: a biological body plus sentient *jeevan*. One does not manufacture the other; they work together.</a:t>
             </a:r>
           </a:p>
-          <a:p xmlns:a="http://schemas.openxmlformats.org/drawingml/2006/main">
+          <a:p>
             <a:r>
               <a:t>Development then continues along both aspects of the joint form. Bodily lineages develop through species-conforming biological organisation, while *jeevan*’s expression widens through those bodily media. In the animal order that expression remains limited by the body.</a:t>
             </a:r>
           </a:p>
-          <a:p xmlns:a="http://schemas.openxmlformats.org/drawingml/2006/main">
+          <a:p>
             <a:r>
               <a:t>The human body, in the knowledge order, is described as capable of evidencing all ten activities of *jeevan*. That does not mean the body owns those activities. It means the bodily medium is adequate for their expression. Once that capacity is present, the remaining development is awakening in *jeevan*, evidenced through understanding and conduct.</a:t>
             </a:r>
@@ -951,7 +906,7 @@
         <p:nvSpPr>
           <p:cNvPr id="4" name="Slide Number Placeholder 3"/>
           <p:cNvSpPr>
-            <a:spLocks xmlns:a="http://schemas.openxmlformats.org/drawingml/2006/main" noGrp="1"/>
+            <a:spLocks noGrp="1"/>
           </p:cNvSpPr>
           <p:nvPr>
             <p:ph type="sldNum" idx="5"/>
@@ -959,21 +914,21 @@
         </p:nvSpPr>
         <p:spPr/>
         <p:txBody>
-          <a:bodyPr xmlns:a="http://schemas.openxmlformats.org/drawingml/2006/main"/>
-          <a:lstStyle xmlns:a="http://schemas.openxmlformats.org/drawingml/2006/main"/>
-          <a:p xmlns:a="http://schemas.openxmlformats.org/drawingml/2006/main"/>
+          <a:bodyPr/>
+          <a:lstStyle/>
+          <a:p/>
         </p:txBody>
       </p:sp>
     </p:spTree>
   </p:cSld>
   <p:clrMapOvr>
-    <a:masterClrMapping xmlns:a="http://schemas.openxmlformats.org/drawingml/2006/main"/>
+    <a:masterClrMapping/>
   </p:clrMapOvr>
 </p:notes>
 </file>
 
 <file path=ppt/notesSlides/notesSlide14.xml><?xml version="1.0" encoding="utf-8"?>
-<p:notes xmlns:p="http://schemas.openxmlformats.org/presentationml/2006/main">
+<p:notes xmlns:a="http://schemas.openxmlformats.org/drawingml/2006/main" xmlns:p="http://schemas.openxmlformats.org/presentationml/2006/main">
   <p:cSld>
     <p:spTree>
       <p:nvGrpSpPr>
@@ -982,13 +937,13 @@
         <p:nvPr/>
       </p:nvGrpSpPr>
       <p:grpSpPr>
-        <a:xfrm xmlns:a="http://schemas.openxmlformats.org/drawingml/2006/main"/>
+        <a:xfrm/>
       </p:grpSpPr>
       <p:sp>
         <p:nvSpPr>
           <p:cNvPr id="2" name="Slide Image Placeholder 1"/>
           <p:cNvSpPr>
-            <a:spLocks xmlns:a="http://schemas.openxmlformats.org/drawingml/2006/main" noGrp="1"/>
+            <a:spLocks noGrp="1"/>
           </p:cNvSpPr>
           <p:nvPr>
             <p:ph type="sldImg" idx="0"/>
@@ -1000,7 +955,7 @@
         <p:nvSpPr>
           <p:cNvPr id="3" name="Notes Placeholder 2"/>
           <p:cNvSpPr>
-            <a:spLocks xmlns:a="http://schemas.openxmlformats.org/drawingml/2006/main" noGrp="1"/>
+            <a:spLocks noGrp="1"/>
           </p:cNvSpPr>
           <p:nvPr>
             <p:ph type="body" idx="1"/>
@@ -1008,48 +963,39 @@
         </p:nvSpPr>
         <p:spPr/>
         <p:txBody>
-          <a:bodyPr xmlns:a="http://schemas.openxmlformats.org/drawingml/2006/main"/>
-          <a:lstStyle xmlns:a="http://schemas.openxmlformats.org/drawingml/2006/main"/>
-          <a:p xmlns:a="http://schemas.openxmlformats.org/drawingml/2006/main">
-            <a:pPr marL="0" indent="0" algn="l">
-              <a:spcBef>
-                <a:spcPts val="0"/>
-              </a:spcBef>
-              <a:spcAft>
-                <a:spcPts val="0"/>
-              </a:spcAft>
-              <a:buNone/>
-            </a:pPr>
+          <a:bodyPr/>
+          <a:lstStyle/>
+          <a:p>
             <a:r>
               <a:t>Now we name three milestones — T1, T2, and T3.</a:t>
             </a:r>
           </a:p>
-          <a:p xmlns:a="http://schemas.openxmlformats.org/drawingml/2006/main">
+          <a:p>
             <a:r>
               <a:t>T1 is constitutional completeness: the immortality of result. A developing atom becomes a sentient unit — jeevan. Status shifts from physicochemical to what the texts call delusional — meaning the body is mistaken for the self. That is a stage label, not a psychiatric diagnosis.</a:t>
             </a:r>
           </a:p>
-          <a:p xmlns:a="http://schemas.openxmlformats.org/drawingml/2006/main">
+          <a:p>
             <a:r>
               <a:t>T2 is activity completeness: restfulness of effort. Inner seeking settles into direct realisation and resolution. Status shifts toward awakened understanding.</a:t>
             </a:r>
           </a:p>
-          <a:p xmlns:a="http://schemas.openxmlformats.org/drawingml/2006/main">
+          <a:p>
             <a:r>
               <a:t>T3 is conduct completeness: destination of motion. Understanding becomes authentic conduct — living proof.</a:t>
             </a:r>
           </a:p>
-          <a:p xmlns:a="http://schemas.openxmlformats.org/drawingml/2006/main">
+          <a:p>
             <a:r>
               <a:t>Keep T2 and T3 apart. T2 is internal settlement. T3 is outer destination in conduct. And do not confuse T2’s restfulness with the ease of non-sentient natural complementarity.</a:t>
             </a:r>
           </a:p>
-          <a:p xmlns:a="http://schemas.openxmlformats.org/drawingml/2006/main">
+          <a:p>
             <a:r>
               <a:t>T1 is completeness of an atom’s constitution. T2 and T3 are not further material stages; they name completeness of activity and conduct in the awakened sentient unit. In one line: the saturated realises the ground it is saturated in.</a:t>
             </a:r>
           </a:p>
-          <a:p xmlns:a="http://schemas.openxmlformats.org/drawingml/2006/main">
+          <a:p>
             <a:r>
               <a:t>One naming point, since I have just used the words. Physicochemical, delusional, deific, divine — the band across the top of this slide — are what the texts call the four **planes**. A plane is the developmental standing a thing has reached. It is not a kind of thing, and it is not the same as an order of nature. The next slide sorts that out properly.</a:t>
             </a:r>
@@ -1060,7 +1006,7 @@
         <p:nvSpPr>
           <p:cNvPr id="4" name="Slide Number Placeholder 3"/>
           <p:cNvSpPr>
-            <a:spLocks xmlns:a="http://schemas.openxmlformats.org/drawingml/2006/main" noGrp="1"/>
+            <a:spLocks noGrp="1"/>
           </p:cNvSpPr>
           <p:nvPr>
             <p:ph type="sldNum" idx="5"/>
@@ -1068,21 +1014,21 @@
         </p:nvSpPr>
         <p:spPr/>
         <p:txBody>
-          <a:bodyPr xmlns:a="http://schemas.openxmlformats.org/drawingml/2006/main"/>
-          <a:lstStyle xmlns:a="http://schemas.openxmlformats.org/drawingml/2006/main"/>
-          <a:p xmlns:a="http://schemas.openxmlformats.org/drawingml/2006/main"/>
+          <a:bodyPr/>
+          <a:lstStyle/>
+          <a:p/>
         </p:txBody>
       </p:sp>
     </p:spTree>
   </p:cSld>
   <p:clrMapOvr>
-    <a:masterClrMapping xmlns:a="http://schemas.openxmlformats.org/drawingml/2006/main"/>
+    <a:masterClrMapping/>
   </p:clrMapOvr>
 </p:notes>
 </file>
 
 <file path=ppt/notesSlides/notesSlide15.xml><?xml version="1.0" encoding="utf-8"?>
-<p:notes xmlns:p="http://schemas.openxmlformats.org/presentationml/2006/main">
+<p:notes xmlns:a="http://schemas.openxmlformats.org/drawingml/2006/main" xmlns:p="http://schemas.openxmlformats.org/presentationml/2006/main">
   <p:cSld>
     <p:spTree>
       <p:nvGrpSpPr>
@@ -1091,13 +1037,13 @@
         <p:nvPr/>
       </p:nvGrpSpPr>
       <p:grpSpPr>
-        <a:xfrm xmlns:a="http://schemas.openxmlformats.org/drawingml/2006/main"/>
+        <a:xfrm/>
       </p:grpSpPr>
       <p:sp>
         <p:nvSpPr>
           <p:cNvPr id="2" name="Slide Image Placeholder 1"/>
           <p:cNvSpPr>
-            <a:spLocks xmlns:a="http://schemas.openxmlformats.org/drawingml/2006/main" noGrp="1"/>
+            <a:spLocks noGrp="1"/>
           </p:cNvSpPr>
           <p:nvPr>
             <p:ph type="sldImg" idx="0"/>
@@ -1109,7 +1055,7 @@
         <p:nvSpPr>
           <p:cNvPr id="3" name="Notes Placeholder 2"/>
           <p:cNvSpPr>
-            <a:spLocks xmlns:a="http://schemas.openxmlformats.org/drawingml/2006/main" noGrp="1"/>
+            <a:spLocks noGrp="1"/>
           </p:cNvSpPr>
           <p:nvPr>
             <p:ph type="body" idx="1"/>
@@ -1117,48 +1063,39 @@
         </p:nvSpPr>
         <p:spPr/>
         <p:txBody>
-          <a:bodyPr xmlns:a="http://schemas.openxmlformats.org/drawingml/2006/main"/>
-          <a:lstStyle xmlns:a="http://schemas.openxmlformats.org/drawingml/2006/main"/>
-          <a:p xmlns:a="http://schemas.openxmlformats.org/drawingml/2006/main">
-            <a:pPr marL="0" indent="0" algn="l">
-              <a:spcBef>
-                <a:spcPts val="0"/>
-              </a:spcBef>
-              <a:spcAft>
-                <a:spcPts val="0"/>
-              </a:spcAft>
-              <a:buNone/>
-            </a:pPr>
+          <a:bodyPr/>
+          <a:lstStyle/>
+          <a:p>
             <a:r>
               <a:t>Let me consolidate, because this tradition uses four different vocabularies for what is fundamentally one thing, and mixing them up is the commonest way to get lost in it.</a:t>
             </a:r>
           </a:p>
-          <a:p xmlns:a="http://schemas.openxmlformats.org/drawingml/2006/main">
+          <a:p>
             <a:r>
               <a:t>There is one drive: nature saturated in state-complete Omnipresence, oriented toward development and awakening until realisation. Everything on this table is a way of describing where something stands in that drive.</a:t>
             </a:r>
           </a:p>
-          <a:p xmlns:a="http://schemas.openxmlformats.org/drawingml/2006/main">
+          <a:p>
             <a:r>
               <a:t>**Orders** — material, bio, animal, knowledge — say what *kind* of thing a unit is: its organisation, its essential nature, its innateness. Four orders.</a:t>
             </a:r>
           </a:p>
-          <a:p xmlns:a="http://schemas.openxmlformats.org/drawingml/2006/main">
+          <a:p>
             <a:r>
               <a:t>**Progressions** — existential, way of existence, development, awakening — say how the drive *moves*. The first names the definite sequence in which the orders become manifest; the second, the conformance by which each order keeps its conduct; the third, physicochemical and atomic development up to T1; the fourth, qualitative development inside a complete sentient unit toward T2 and T3.</a:t>
             </a:r>
           </a:p>
-          <a:p xmlns:a="http://schemas.openxmlformats.org/drawingml/2006/main">
+          <a:p>
             <a:r>
               <a:t>**Planes** — physicochemical, delusional, deific, divine — say how *far* something has come. These are the four we just saw across the top of the last slide. Before T1; T1 only; T2; T3.</a:t>
             </a:r>
           </a:p>
-          <a:p xmlns:a="http://schemas.openxmlformats.org/drawingml/2006/main">
+          <a:p>
             <a:r>
               <a:t>**Human types** — animalistic, demonic, humane or discerning, deific, divine — say how a human *life is oriented*. Five of them, and they classify modes of consciousness and conduct. Not biological species. Not social classes. Not castes.</a:t>
             </a:r>
           </a:p>
-          <a:p xmlns:a="http://schemas.openxmlformats.org/drawingml/2006/main">
+          <a:p>
             <a:r>
               <a:t>The one caution worth stating out loud: an order is not a plane. The knowledge order spans more than one plane — most human beings are in the knowledge order and on the delusional plane at the same time, and there is nothing insulting in that; it just means realisation has not happened yet. T1 separates physicochemical from sentient standing. T2 and T3 are completeness within an awakened sentient unit, and no fifth plane is added beyond them.</a:t>
             </a:r>
@@ -1169,7 +1106,7 @@
         <p:nvSpPr>
           <p:cNvPr id="4" name="Slide Number Placeholder 3"/>
           <p:cNvSpPr>
-            <a:spLocks xmlns:a="http://schemas.openxmlformats.org/drawingml/2006/main" noGrp="1"/>
+            <a:spLocks noGrp="1"/>
           </p:cNvSpPr>
           <p:nvPr>
             <p:ph type="sldNum" idx="5"/>
@@ -1177,21 +1114,21 @@
         </p:nvSpPr>
         <p:spPr/>
         <p:txBody>
-          <a:bodyPr xmlns:a="http://schemas.openxmlformats.org/drawingml/2006/main"/>
-          <a:lstStyle xmlns:a="http://schemas.openxmlformats.org/drawingml/2006/main"/>
-          <a:p xmlns:a="http://schemas.openxmlformats.org/drawingml/2006/main"/>
+          <a:bodyPr/>
+          <a:lstStyle/>
+          <a:p/>
         </p:txBody>
       </p:sp>
     </p:spTree>
   </p:cSld>
   <p:clrMapOvr>
-    <a:masterClrMapping xmlns:a="http://schemas.openxmlformats.org/drawingml/2006/main"/>
+    <a:masterClrMapping/>
   </p:clrMapOvr>
 </p:notes>
 </file>
 
 <file path=ppt/notesSlides/notesSlide16.xml><?xml version="1.0" encoding="utf-8"?>
-<p:notes xmlns:p="http://schemas.openxmlformats.org/presentationml/2006/main">
+<p:notes xmlns:a="http://schemas.openxmlformats.org/drawingml/2006/main" xmlns:p="http://schemas.openxmlformats.org/presentationml/2006/main">
   <p:cSld>
     <p:spTree>
       <p:nvGrpSpPr>
@@ -1200,13 +1137,13 @@
         <p:nvPr/>
       </p:nvGrpSpPr>
       <p:grpSpPr>
-        <a:xfrm xmlns:a="http://schemas.openxmlformats.org/drawingml/2006/main"/>
+        <a:xfrm/>
       </p:grpSpPr>
       <p:sp>
         <p:nvSpPr>
           <p:cNvPr id="2" name="Slide Image Placeholder 1"/>
           <p:cNvSpPr>
-            <a:spLocks xmlns:a="http://schemas.openxmlformats.org/drawingml/2006/main" noGrp="1"/>
+            <a:spLocks noGrp="1"/>
           </p:cNvSpPr>
           <p:nvPr>
             <p:ph type="sldImg" idx="0"/>
@@ -1218,7 +1155,7 @@
         <p:nvSpPr>
           <p:cNvPr id="3" name="Notes Placeholder 2"/>
           <p:cNvSpPr>
-            <a:spLocks xmlns:a="http://schemas.openxmlformats.org/drawingml/2006/main" noGrp="1"/>
+            <a:spLocks noGrp="1"/>
           </p:cNvSpPr>
           <p:nvPr>
             <p:ph type="body" idx="1"/>
@@ -1226,43 +1163,34 @@
         </p:nvSpPr>
         <p:spPr/>
         <p:txBody>
-          <a:bodyPr xmlns:a="http://schemas.openxmlformats.org/drawingml/2006/main"/>
-          <a:lstStyle xmlns:a="http://schemas.openxmlformats.org/drawingml/2006/main"/>
-          <a:p xmlns:a="http://schemas.openxmlformats.org/drawingml/2006/main">
-            <a:pPr marL="0" indent="0" algn="l">
-              <a:spcBef>
-                <a:spcPts val="0"/>
-              </a:spcBef>
-              <a:spcAft>
-                <a:spcPts val="0"/>
-              </a:spcAft>
-              <a:buNone/>
-            </a:pPr>
+          <a:bodyPr/>
+          <a:lstStyle/>
+          <a:p>
             <a:r>
               <a:t>This is the claimed sentience threshold. The technical transitions slide names it T1; here the audience-facing question is how the texts say sentience enters.</a:t>
             </a:r>
           </a:p>
-          <a:p xmlns:a="http://schemas.openxmlformats.org/drawingml/2006/main">
+          <a:p>
             <a:r>
               <a:t>According to the primary texts, sentience appears when one developing atom reaches constitutional completeness — not through neural complexity, molecular size, or the material-to-biological order change.</a:t>
             </a:r>
           </a:p>
-          <a:p xmlns:a="http://schemas.openxmlformats.org/drawingml/2006/main">
+          <a:p>
             <a:r>
               <a:t>The described process begins with particle exchange. Hungry atoms can incorporate particles; overfull or undigested atoms seek to expel them. Under suitable mutuality, a developing atom integrates the full count required by its constitution. When that requirement is satisfied, the constitution closes and particle count no longer increases or decreases.</a:t>
             </a:r>
           </a:p>
-          <a:p xmlns:a="http://schemas.openxmlformats.org/drawingml/2006/main">
+          <a:p>
             <a:r>
               <a:t>The slide shows the before and after. Before sentience, the constitution remains open: particles are absorbed or expelled, molecular and weight bondage continue, and kind, capacity, and qualitative change track particle count. At the sentience threshold, all required particles are integrated. The count becomes fixed, molecular and weight bondage end, and qualitative activity continues. The texts classify that closed unit as sentient *jeevan*.</a:t>
             </a:r>
           </a:p>
-          <a:p xmlns:a="http://schemas.openxmlformats.org/drawingml/2006/main">
+          <a:p>
             <a:r>
               <a:t>That separation of qualitative from quantitative change is the stated criterion. MVD adds the visible signs of release from the molecular group, liberation from molecular- and weight-bondage, and establishment in hope-bondage.</a:t>
             </a:r>
           </a:p>
-          <a:p xmlns:a="http://schemas.openxmlformats.org/drawingml/2006/main">
+          <a:p>
             <a:r>
               <a:t>The transition to sentience is therefore a claim of reclassification at atomic closure: one atom becomes *jeevan*; a body does not become conscious by becoming more complex. The texts give a process and a criterion, but not an accepted physical measurement of this threshold or a causal explanation of why closure is sentience. We will return to that open bridge under method and evidence.</a:t>
             </a:r>
@@ -1273,7 +1201,7 @@
         <p:nvSpPr>
           <p:cNvPr id="4" name="Slide Number Placeholder 3"/>
           <p:cNvSpPr>
-            <a:spLocks xmlns:a="http://schemas.openxmlformats.org/drawingml/2006/main" noGrp="1"/>
+            <a:spLocks noGrp="1"/>
           </p:cNvSpPr>
           <p:nvPr>
             <p:ph type="sldNum" idx="5"/>
@@ -1281,21 +1209,21 @@
         </p:nvSpPr>
         <p:spPr/>
         <p:txBody>
-          <a:bodyPr xmlns:a="http://schemas.openxmlformats.org/drawingml/2006/main"/>
-          <a:lstStyle xmlns:a="http://schemas.openxmlformats.org/drawingml/2006/main"/>
-          <a:p xmlns:a="http://schemas.openxmlformats.org/drawingml/2006/main"/>
+          <a:bodyPr/>
+          <a:lstStyle/>
+          <a:p/>
         </p:txBody>
       </p:sp>
     </p:spTree>
   </p:cSld>
   <p:clrMapOvr>
-    <a:masterClrMapping xmlns:a="http://schemas.openxmlformats.org/drawingml/2006/main"/>
+    <a:masterClrMapping/>
   </p:clrMapOvr>
 </p:notes>
 </file>
 
 <file path=ppt/notesSlides/notesSlide17.xml><?xml version="1.0" encoding="utf-8"?>
-<p:notes xmlns:p="http://schemas.openxmlformats.org/presentationml/2006/main">
+<p:notes xmlns:a="http://schemas.openxmlformats.org/drawingml/2006/main" xmlns:p="http://schemas.openxmlformats.org/presentationml/2006/main">
   <p:cSld>
     <p:spTree>
       <p:nvGrpSpPr>
@@ -1304,13 +1232,13 @@
         <p:nvPr/>
       </p:nvGrpSpPr>
       <p:grpSpPr>
-        <a:xfrm xmlns:a="http://schemas.openxmlformats.org/drawingml/2006/main"/>
+        <a:xfrm/>
       </p:grpSpPr>
       <p:sp>
         <p:nvSpPr>
           <p:cNvPr id="2" name="Slide Image Placeholder 1"/>
           <p:cNvSpPr>
-            <a:spLocks xmlns:a="http://schemas.openxmlformats.org/drawingml/2006/main" noGrp="1"/>
+            <a:spLocks noGrp="1"/>
           </p:cNvSpPr>
           <p:nvPr>
             <p:ph type="sldImg" idx="0"/>
@@ -1322,7 +1250,7 @@
         <p:nvSpPr>
           <p:cNvPr id="3" name="Notes Placeholder 2"/>
           <p:cNvSpPr>
-            <a:spLocks xmlns:a="http://schemas.openxmlformats.org/drawingml/2006/main" noGrp="1"/>
+            <a:spLocks noGrp="1"/>
           </p:cNvSpPr>
           <p:nvPr>
             <p:ph type="body" idx="1"/>
@@ -1330,38 +1258,29 @@
         </p:nvSpPr>
         <p:spPr/>
         <p:txBody>
-          <a:bodyPr xmlns:a="http://schemas.openxmlformats.org/drawingml/2006/main"/>
-          <a:lstStyle xmlns:a="http://schemas.openxmlformats.org/drawingml/2006/main"/>
-          <a:p xmlns:a="http://schemas.openxmlformats.org/drawingml/2006/main">
-            <a:pPr marL="0" indent="0" algn="l">
-              <a:spcBef>
-                <a:spcPts val="0"/>
-              </a:spcBef>
-              <a:spcAft>
-                <a:spcPts val="0"/>
-              </a:spcAft>
-              <a:buNone/>
-            </a:pPr>
+          <a:bodyPr/>
+          <a:lstStyle/>
+          <a:p>
             <a:r>
               <a:t>We now turn to human living — movement three.</a:t>
             </a:r>
           </a:p>
-          <a:p xmlns:a="http://schemas.openxmlformats.org/drawingml/2006/main">
+          <a:p>
             <a:r>
               <a:t>Animal and human living is a joint form. The sentient unit brings the full set of faculties and activities. The body supplies the species-specific medium.</a:t>
             </a:r>
           </a:p>
-          <a:p xmlns:a="http://schemas.openxmlformats.org/drawingml/2006/main">
+          <a:p>
             <a:r>
               <a:t>On one side: the body — living composition, sense organs, brain, physical expression; decomposable. On the other: the sentient unit — constitutionally complete; faculties inherent; continuing when the joint form ends.</a:t>
             </a:r>
           </a:p>
-          <a:p xmlns:a="http://schemas.openxmlformats.org/drawingml/2006/main">
+          <a:p>
             <a:r>
               <a:t>Animal bodily development limits expression. The human medium can support the full range, while mistaking the body for the self can still misdirect evaluation.</a:t>
             </a:r>
           </a:p>
-          <a:p xmlns:a="http://schemas.openxmlformats.org/drawingml/2006/main">
+          <a:p>
             <a:r>
               <a:t>The body gates expression. The sentient unit is seer, doer, and enjoyer through the body. Animal limitation belongs to the medium. Human mis-evaluation belongs to that confusion. The body does not produce sentience, and those two problems are not the same problem.</a:t>
             </a:r>
@@ -1372,7 +1291,7 @@
         <p:nvSpPr>
           <p:cNvPr id="4" name="Slide Number Placeholder 3"/>
           <p:cNvSpPr>
-            <a:spLocks xmlns:a="http://schemas.openxmlformats.org/drawingml/2006/main" noGrp="1"/>
+            <a:spLocks noGrp="1"/>
           </p:cNvSpPr>
           <p:nvPr>
             <p:ph type="sldNum" idx="5"/>
@@ -1380,21 +1299,21 @@
         </p:nvSpPr>
         <p:spPr/>
         <p:txBody>
-          <a:bodyPr xmlns:a="http://schemas.openxmlformats.org/drawingml/2006/main"/>
-          <a:lstStyle xmlns:a="http://schemas.openxmlformats.org/drawingml/2006/main"/>
-          <a:p xmlns:a="http://schemas.openxmlformats.org/drawingml/2006/main"/>
+          <a:bodyPr/>
+          <a:lstStyle/>
+          <a:p/>
         </p:txBody>
       </p:sp>
     </p:spTree>
   </p:cSld>
   <p:clrMapOvr>
-    <a:masterClrMapping xmlns:a="http://schemas.openxmlformats.org/drawingml/2006/main"/>
+    <a:masterClrMapping/>
   </p:clrMapOvr>
 </p:notes>
 </file>
 
 <file path=ppt/notesSlides/notesSlide18.xml><?xml version="1.0" encoding="utf-8"?>
-<p:notes xmlns:p="http://schemas.openxmlformats.org/presentationml/2006/main">
+<p:notes xmlns:a="http://schemas.openxmlformats.org/drawingml/2006/main" xmlns:p="http://schemas.openxmlformats.org/presentationml/2006/main">
   <p:cSld>
     <p:spTree>
       <p:nvGrpSpPr>
@@ -1403,13 +1322,13 @@
         <p:nvPr/>
       </p:nvGrpSpPr>
       <p:grpSpPr>
-        <a:xfrm xmlns:a="http://schemas.openxmlformats.org/drawingml/2006/main"/>
+        <a:xfrm/>
       </p:grpSpPr>
       <p:sp>
         <p:nvSpPr>
           <p:cNvPr id="2" name="Slide Image Placeholder 1"/>
           <p:cNvSpPr>
-            <a:spLocks xmlns:a="http://schemas.openxmlformats.org/drawingml/2006/main" noGrp="1"/>
+            <a:spLocks noGrp="1"/>
           </p:cNvSpPr>
           <p:nvPr>
             <p:ph type="sldImg" idx="0"/>
@@ -1421,7 +1340,7 @@
         <p:nvSpPr>
           <p:cNvPr id="3" name="Notes Placeholder 2"/>
           <p:cNvSpPr>
-            <a:spLocks xmlns:a="http://schemas.openxmlformats.org/drawingml/2006/main" noGrp="1"/>
+            <a:spLocks noGrp="1"/>
           </p:cNvSpPr>
           <p:nvPr>
             <p:ph type="body" idx="1"/>
@@ -1429,38 +1348,29 @@
         </p:nvSpPr>
         <p:spPr/>
         <p:txBody>
-          <a:bodyPr xmlns:a="http://schemas.openxmlformats.org/drawingml/2006/main"/>
-          <a:lstStyle xmlns:a="http://schemas.openxmlformats.org/drawingml/2006/main"/>
-          <a:p xmlns:a="http://schemas.openxmlformats.org/drawingml/2006/main">
-            <a:pPr marL="0" indent="0" algn="l">
-              <a:spcBef>
-                <a:spcPts val="0"/>
-              </a:spcBef>
-              <a:spcAft>
-                <a:spcPts val="0"/>
-              </a:spcAft>
-              <a:buNone/>
-            </a:pPr>
+          <a:bodyPr/>
+          <a:lstStyle/>
+          <a:p>
             <a:r>
               <a:t>The sentient unit — jeevan — is a constitutionally complete atom.</a:t>
             </a:r>
           </a:p>
-          <a:p xmlns:a="http://schemas.openxmlformats.org/drawingml/2006/main">
+          <a:p>
             <a:r>
               <a:t>Structurally, the centre is the core self. Around it: resolve, desire, thought, and hope — the texts’ buddhi, chitta, vritti, and mun.</a:t>
             </a:r>
           </a:p>
-          <a:p xmlns:a="http://schemas.openxmlformats.org/drawingml/2006/main">
+          <a:p>
             <a:r>
               <a:t>Each works outward and inward. Hope selects and tastes. Thought analyses and deliberates. Desire visualises and contemplates. Resolve resolves and receives clear understanding. The core self authenticates and realises.</a:t>
             </a:r>
           </a:p>
-          <a:p xmlns:a="http://schemas.openxmlformats.org/drawingml/2006/main">
+          <a:p>
             <a:r>
               <a:t>All five faculties and ten activities belong to the sentient unit. Presence is not the same as expression or effective organisation. Animal bodies limit expression. Humans have the medium for the full range, yet under body-confusion only part of that range may be effectively organised.</a:t>
             </a:r>
           </a:p>
-          <a:p xmlns:a="http://schemas.openxmlformats.org/drawingml/2006/main">
+          <a:p>
             <a:r>
               <a:t>Study brings understanding. Practice tests and stabilises it. Practice does not manufacture faculties that were missing.</a:t>
             </a:r>
@@ -1471,7 +1381,7 @@
         <p:nvSpPr>
           <p:cNvPr id="4" name="Slide Number Placeholder 3"/>
           <p:cNvSpPr>
-            <a:spLocks xmlns:a="http://schemas.openxmlformats.org/drawingml/2006/main" noGrp="1"/>
+            <a:spLocks noGrp="1"/>
           </p:cNvSpPr>
           <p:nvPr>
             <p:ph type="sldNum" idx="5"/>
@@ -1479,21 +1389,21 @@
         </p:nvSpPr>
         <p:spPr/>
         <p:txBody>
-          <a:bodyPr xmlns:a="http://schemas.openxmlformats.org/drawingml/2006/main"/>
-          <a:lstStyle xmlns:a="http://schemas.openxmlformats.org/drawingml/2006/main"/>
-          <a:p xmlns:a="http://schemas.openxmlformats.org/drawingml/2006/main"/>
+          <a:bodyPr/>
+          <a:lstStyle/>
+          <a:p/>
         </p:txBody>
       </p:sp>
     </p:spTree>
   </p:cSld>
   <p:clrMapOvr>
-    <a:masterClrMapping xmlns:a="http://schemas.openxmlformats.org/drawingml/2006/main"/>
+    <a:masterClrMapping/>
   </p:clrMapOvr>
 </p:notes>
 </file>
 
 <file path=ppt/notesSlides/notesSlide19.xml><?xml version="1.0" encoding="utf-8"?>
-<p:notes xmlns:p="http://schemas.openxmlformats.org/presentationml/2006/main">
+<p:notes xmlns:a="http://schemas.openxmlformats.org/drawingml/2006/main" xmlns:p="http://schemas.openxmlformats.org/presentationml/2006/main">
   <p:cSld>
     <p:spTree>
       <p:nvGrpSpPr>
@@ -1502,13 +1412,13 @@
         <p:nvPr/>
       </p:nvGrpSpPr>
       <p:grpSpPr>
-        <a:xfrm xmlns:a="http://schemas.openxmlformats.org/drawingml/2006/main"/>
+        <a:xfrm/>
       </p:grpSpPr>
       <p:sp>
         <p:nvSpPr>
           <p:cNvPr id="2" name="Slide Image Placeholder 1"/>
           <p:cNvSpPr>
-            <a:spLocks xmlns:a="http://schemas.openxmlformats.org/drawingml/2006/main" noGrp="1"/>
+            <a:spLocks noGrp="1"/>
           </p:cNvSpPr>
           <p:nvPr>
             <p:ph type="sldImg" idx="0"/>
@@ -1520,7 +1430,7 @@
         <p:nvSpPr>
           <p:cNvPr id="3" name="Notes Placeholder 2"/>
           <p:cNvSpPr>
-            <a:spLocks xmlns:a="http://schemas.openxmlformats.org/drawingml/2006/main" noGrp="1"/>
+            <a:spLocks noGrp="1"/>
           </p:cNvSpPr>
           <p:nvPr>
             <p:ph type="body" idx="1"/>
@@ -1528,29 +1438,29 @@
         </p:nvSpPr>
         <p:spPr/>
         <p:txBody>
-          <a:bodyPr xmlns:a="http://schemas.openxmlformats.org/drawingml/2006/main"/>
-          <a:lstStyle xmlns:a="http://schemas.openxmlformats.org/drawingml/2006/main"/>
-          <a:p xmlns:a="http://schemas.openxmlformats.org/drawingml/2006/main">
+          <a:bodyPr/>
+          <a:lstStyle/>
+          <a:p>
             <a:r>
               <a:t>Happiness, peace, contentment, and bliss are not passing moods, and they are not a fourth milestone after T1, T2, and T3.</a:t>
             </a:r>
           </a:p>
-          <a:p xmlns:a="http://schemas.openxmlformats.org/drawingml/2006/main">
+          <a:p>
             <a:r>
               <a:t>They name harmonies within the sentient unit. Happiness: harmony of hope and thought. Peace: thought and desire. Contentment: desire and resolve. Bliss: resolve and the core self.</a:t>
             </a:r>
           </a:p>
-          <a:p xmlns:a="http://schemas.openxmlformats.org/drawingml/2006/main">
+          <a:p>
             <a:r>
               <a:t>Now hold all four in view, because they are what the knowledge order is actually after. This is the answer to “what is a human life for?” in this system — and notice that only the first of the four is reachable by sensory living. Happiness, the harmony of hope and thought, an animal can have. Peace, contentment, and bliss it cannot even see.</a:t>
             </a:r>
           </a:p>
-          <a:p xmlns:a="http://schemas.openxmlformats.org/drawingml/2006/main">
+          <a:p>
             <a:r>
               <a:t>The living cycle is: reflection feeds projection, and projection feeds deeper reflection — that is what living means here. Continuous happiness is harmony evidenced in resolved living, not a sensory spike.</a:t>
             </a:r>
           </a:p>
-          <a:p xmlns:a="http://schemas.openxmlformats.org/drawingml/2006/main">
+          <a:p>
             <a:r>
               <a:t>The next two slides ask how a human being actually gets from the first harmony to the other three.</a:t>
             </a:r>
@@ -1561,7 +1471,7 @@
         <p:nvSpPr>
           <p:cNvPr id="4" name="Slide Number Placeholder 3"/>
           <p:cNvSpPr>
-            <a:spLocks xmlns:a="http://schemas.openxmlformats.org/drawingml/2006/main" noGrp="1"/>
+            <a:spLocks noGrp="1"/>
           </p:cNvSpPr>
           <p:nvPr>
             <p:ph type="sldNum" idx="5"/>
@@ -1569,21 +1479,21 @@
         </p:nvSpPr>
         <p:spPr/>
         <p:txBody>
-          <a:bodyPr xmlns:a="http://schemas.openxmlformats.org/drawingml/2006/main"/>
-          <a:lstStyle xmlns:a="http://schemas.openxmlformats.org/drawingml/2006/main"/>
-          <a:p xmlns:a="http://schemas.openxmlformats.org/drawingml/2006/main"/>
+          <a:bodyPr/>
+          <a:lstStyle/>
+          <a:p/>
         </p:txBody>
       </p:sp>
     </p:spTree>
   </p:cSld>
   <p:clrMapOvr>
-    <a:masterClrMapping xmlns:a="http://schemas.openxmlformats.org/drawingml/2006/main"/>
+    <a:masterClrMapping/>
   </p:clrMapOvr>
 </p:notes>
 </file>
 
 <file path=ppt/notesSlides/notesSlide2.xml><?xml version="1.0" encoding="utf-8"?>
-<p:notes xmlns:p="http://schemas.openxmlformats.org/presentationml/2006/main">
+<p:notes xmlns:a="http://schemas.openxmlformats.org/drawingml/2006/main" xmlns:p="http://schemas.openxmlformats.org/presentationml/2006/main">
   <p:cSld>
     <p:spTree>
       <p:nvGrpSpPr>
@@ -1592,13 +1502,13 @@
         <p:nvPr/>
       </p:nvGrpSpPr>
       <p:grpSpPr>
-        <a:xfrm xmlns:a="http://schemas.openxmlformats.org/drawingml/2006/main"/>
+        <a:xfrm/>
       </p:grpSpPr>
       <p:sp>
         <p:nvSpPr>
           <p:cNvPr id="2" name="Slide Image Placeholder 1"/>
           <p:cNvSpPr>
-            <a:spLocks xmlns:a="http://schemas.openxmlformats.org/drawingml/2006/main" noGrp="1"/>
+            <a:spLocks noGrp="1"/>
           </p:cNvSpPr>
           <p:nvPr>
             <p:ph type="sldImg" idx="0"/>
@@ -1610,7 +1520,7 @@
         <p:nvSpPr>
           <p:cNvPr id="3" name="Notes Placeholder 2"/>
           <p:cNvSpPr>
-            <a:spLocks xmlns:a="http://schemas.openxmlformats.org/drawingml/2006/main" noGrp="1"/>
+            <a:spLocks noGrp="1"/>
           </p:cNvSpPr>
           <p:nvPr>
             <p:ph type="body" idx="1"/>
@@ -1618,34 +1528,34 @@
         </p:nvSpPr>
         <p:spPr/>
         <p:txBody>
-          <a:bodyPr xmlns:a="http://schemas.openxmlformats.org/drawingml/2006/main"/>
-          <a:lstStyle xmlns:a="http://schemas.openxmlformats.org/drawingml/2006/main"/>
-          <a:p xmlns:a="http://schemas.openxmlformats.org/drawingml/2006/main">
+          <a:bodyPr/>
+          <a:lstStyle/>
+          <a:p>
             <a:r>
               <a:t>Before the details, here is the map of the argument. One claim — existence is coexistence — moves through three parts.</a:t>
             </a:r>
           </a:p>
-          <a:p xmlns:a="http://schemas.openxmlformats.org/drawingml/2006/main">
+          <a:p>
             <a:r>
               <a:t>First: what is real, and how it is ordered. There is an all-pervasive ground and countable units, and two bonds — each unit to the ground, and each unit to the others. The second of those is complementarity, and it is given rather than made: because there are many bounded things in one ground, each stands in definite relation to the rest. Each unit has a definite form, capacities, a way of participating, and an inseparable innateness, and these show up in mutual relations across four orders of nature. Because no unit can be separated from the ground, existence itself neither begins nor ends.</a:t>
             </a:r>
           </a:p>
-          <a:p xmlns:a="http://schemas.openxmlformats.org/drawingml/2006/main">
+          <a:p>
             <a:r>
               <a:t>Second: how development proceeds along two lines that must not be collapsed. And the reason it proceeds at all — the drive is to fulfil that complementarity. One line builds larger configurations — particles, molecules, cells, bodies — but never exceeds the order of the things it is built from. The other is development in an atom that can become a complete sentient unit. Across both, activity is effort, motion, and result together — not three separate steps.</a:t>
             </a:r>
           </a:p>
-          <a:p xmlns:a="http://schemas.openxmlformats.org/drawingml/2006/main">
+          <a:p>
             <a:r>
               <a:t>Third: how sentient living becomes awakened conduct — the human as a joint form of body and sentient unit, the faculties of that sentient unit, the four harmonies it can reach, and why the higher three are reached only through action actually performed: evaluation, realisation, and participation in humane order.</a:t>
             </a:r>
           </a:p>
-          <a:p xmlns:a="http://schemas.openxmlformats.org/drawingml/2006/main">
+          <a:p>
             <a:r>
               <a:t>Please keep one distinction early: the body line and the sentient-unit line meet in animal and human living, but they are not the same process. That blocks the most common confusion — treating the body as the producer of the knower.</a:t>
             </a:r>
           </a:p>
-          <a:p xmlns:a="http://schemas.openxmlformats.org/drawingml/2006/main">
+          <a:p>
             <a:r>
               <a:t>Each movement is marked in the small line at the top of its opening slide, so you can always tell where we are.</a:t>
             </a:r>
@@ -1656,7 +1566,7 @@
         <p:nvSpPr>
           <p:cNvPr id="4" name="Slide Number Placeholder 3"/>
           <p:cNvSpPr>
-            <a:spLocks xmlns:a="http://schemas.openxmlformats.org/drawingml/2006/main" noGrp="1"/>
+            <a:spLocks noGrp="1"/>
           </p:cNvSpPr>
           <p:nvPr>
             <p:ph type="sldNum" idx="5"/>
@@ -1664,21 +1574,21 @@
         </p:nvSpPr>
         <p:spPr/>
         <p:txBody>
-          <a:bodyPr xmlns:a="http://schemas.openxmlformats.org/drawingml/2006/main"/>
-          <a:lstStyle xmlns:a="http://schemas.openxmlformats.org/drawingml/2006/main"/>
-          <a:p xmlns:a="http://schemas.openxmlformats.org/drawingml/2006/main"/>
+          <a:bodyPr/>
+          <a:lstStyle/>
+          <a:p/>
         </p:txBody>
       </p:sp>
     </p:spTree>
   </p:cSld>
   <p:clrMapOvr>
-    <a:masterClrMapping xmlns:a="http://schemas.openxmlformats.org/drawingml/2006/main"/>
+    <a:masterClrMapping/>
   </p:clrMapOvr>
 </p:notes>
 </file>
 
 <file path=ppt/notesSlides/notesSlide20.xml><?xml version="1.0" encoding="utf-8"?>
-<p:notes xmlns:p="http://schemas.openxmlformats.org/presentationml/2006/main">
+<p:notes xmlns:a="http://schemas.openxmlformats.org/drawingml/2006/main" xmlns:p="http://schemas.openxmlformats.org/presentationml/2006/main">
   <p:cSld>
     <p:spTree>
       <p:nvGrpSpPr>
@@ -1687,13 +1597,13 @@
         <p:nvPr/>
       </p:nvGrpSpPr>
       <p:grpSpPr>
-        <a:xfrm xmlns:a="http://schemas.openxmlformats.org/drawingml/2006/main"/>
+        <a:xfrm/>
       </p:grpSpPr>
       <p:sp>
         <p:nvSpPr>
           <p:cNvPr id="2" name="Slide Image Placeholder 1"/>
           <p:cNvSpPr>
-            <a:spLocks xmlns:a="http://schemas.openxmlformats.org/drawingml/2006/main" noGrp="1"/>
+            <a:spLocks noGrp="1"/>
           </p:cNvSpPr>
           <p:nvPr>
             <p:ph type="sldImg" idx="0"/>
@@ -1705,7 +1615,7 @@
         <p:nvSpPr>
           <p:cNvPr id="3" name="Notes Placeholder 2"/>
           <p:cNvSpPr>
-            <a:spLocks xmlns:a="http://schemas.openxmlformats.org/drawingml/2006/main" noGrp="1"/>
+            <a:spLocks noGrp="1"/>
           </p:cNvSpPr>
           <p:nvPr>
             <p:ph type="body" idx="1"/>
@@ -1713,44 +1623,44 @@
         </p:nvSpPr>
         <p:spPr/>
         <p:txBody>
-          <a:bodyPr xmlns:a="http://schemas.openxmlformats.org/drawingml/2006/main"/>
-          <a:lstStyle xmlns:a="http://schemas.openxmlformats.org/drawingml/2006/main"/>
-          <a:p xmlns:a="http://schemas.openxmlformats.org/drawingml/2006/main">
+          <a:bodyPr/>
+          <a:lstStyle/>
+          <a:p>
             <a:r>
               <a:t>Every sentient unit bears the same five faculties and the same ten activities. What differs is the medium and what the unit does with it.</a:t>
             </a:r>
           </a:p>
-          <a:p xmlns:a="http://schemas.openxmlformats.org/drawingml/2006/main">
-            <a:r>
-              <a:t>Take the animal case first, because it sets up the human one. An animal *jeevan* is complete — it has all five faculties. But its bodily medium is limited, so it acts for sensory satisfaction under species-conformance, and it reaches the first harmony and stops. Peace, contentment, and bliss are not failures on its part; they are simply not available through that body.</a:t>
-            </a:r>
-          </a:p>
-          <a:p xmlns:a="http://schemas.openxmlformats.org/drawingml/2006/main">
+          <a:p>
+            <a:r>
+              <a:t>Take the animal case first, because it sets up the human one. An animal *jeevan* is complete — it has all five faculties. But its bodily medium is limited, so its activity remains within sensory satisfaction under species-conformance, and it reaches the first harmony and stops. Peace, contentment, and bliss are not failures on its part; they are simply not available through that body.</a:t>
+            </a:r>
+          </a:p>
+          <a:p>
             <a:r>
               <a:t>Now the human case. The human body *can* express all ten activities — that is what the developed nervous system is for. And yet, by default, human *jeevan* goes on evaluating by exactly the same sensory criteria the animal used. The equipment changed; the habit did not. That is the fork this slide names, and it answers one practical question — what makes me happy?</a:t>
             </a:r>
           </a:p>
-          <a:p xmlns:a="http://schemas.openxmlformats.org/drawingml/2006/main">
+          <a:p>
             <a:r>
               <a:t>Under confusion, the body is mistaken for the self. Selection and evaluation organise around pleasure, health, and profit.</a:t>
             </a:r>
           </a:p>
-          <a:p xmlns:a="http://schemas.openxmlformats.org/drawingml/2006/main">
+          <a:p>
             <a:r>
               <a:t>Under awakening, clear knowing regulates sensory life. Knowing and believing guide recognition and fulfilment toward justice, innateness, truth, and coexistence.</a:t>
             </a:r>
           </a:p>
-          <a:p xmlns:a="http://schemas.openxmlformats.org/drawingml/2006/main">
+          <a:p>
             <a:r>
               <a:t>No faculty is missing, and sensation is not rejected. Confusion lets sensory criteria rule; awakening balances sensation with understanding, so understanding guides conduct.</a:t>
             </a:r>
           </a:p>
-          <a:p xmlns:a="http://schemas.openxmlformats.org/drawingml/2006/main">
+          <a:p>
             <a:r>
               <a:t>When the same fork is resolved in a person and sustained across a tradition, it shows as resolution, prosperity, fearlessness, and coexistence.</a:t>
             </a:r>
           </a:p>
-          <a:p xmlns:a="http://schemas.openxmlformats.org/drawingml/2006/main">
+          <a:p>
             <a:r>
               <a:t>And one thing awakening is *not*: it is not preferring the right things, and it is not having the right insight. The next slide is about why.</a:t>
             </a:r>
@@ -1761,7 +1671,7 @@
         <p:nvSpPr>
           <p:cNvPr id="4" name="Slide Number Placeholder 3"/>
           <p:cNvSpPr>
-            <a:spLocks xmlns:a="http://schemas.openxmlformats.org/drawingml/2006/main" noGrp="1"/>
+            <a:spLocks noGrp="1"/>
           </p:cNvSpPr>
           <p:nvPr>
             <p:ph type="sldNum" idx="5"/>
@@ -1769,21 +1679,21 @@
         </p:nvSpPr>
         <p:spPr/>
         <p:txBody>
-          <a:bodyPr xmlns:a="http://schemas.openxmlformats.org/drawingml/2006/main"/>
-          <a:lstStyle xmlns:a="http://schemas.openxmlformats.org/drawingml/2006/main"/>
-          <a:p xmlns:a="http://schemas.openxmlformats.org/drawingml/2006/main"/>
+          <a:bodyPr/>
+          <a:lstStyle/>
+          <a:p/>
         </p:txBody>
       </p:sp>
     </p:spTree>
   </p:cSld>
   <p:clrMapOvr>
-    <a:masterClrMapping xmlns:a="http://schemas.openxmlformats.org/drawingml/2006/main"/>
+    <a:masterClrMapping/>
   </p:clrMapOvr>
 </p:notes>
 </file>
 
 <file path=ppt/notesSlides/notesSlide21.xml><?xml version="1.0" encoding="utf-8"?>
-<p:notes xmlns:p="http://schemas.openxmlformats.org/presentationml/2006/main">
+<p:notes xmlns:a="http://schemas.openxmlformats.org/drawingml/2006/main" xmlns:p="http://schemas.openxmlformats.org/presentationml/2006/main">
   <p:cSld>
     <p:spTree>
       <p:nvGrpSpPr>
@@ -1792,13 +1702,13 @@
         <p:nvPr/>
       </p:nvGrpSpPr>
       <p:grpSpPr>
-        <a:xfrm xmlns:a="http://schemas.openxmlformats.org/drawingml/2006/main"/>
+        <a:xfrm/>
       </p:grpSpPr>
       <p:sp>
         <p:nvSpPr>
           <p:cNvPr id="2" name="Slide Image Placeholder 1"/>
           <p:cNvSpPr>
-            <a:spLocks xmlns:a="http://schemas.openxmlformats.org/drawingml/2006/main" noGrp="1"/>
+            <a:spLocks noGrp="1"/>
           </p:cNvSpPr>
           <p:nvPr>
             <p:ph type="sldImg" idx="0"/>
@@ -1810,7 +1720,7 @@
         <p:nvSpPr>
           <p:cNvPr id="3" name="Notes Placeholder 2"/>
           <p:cNvSpPr>
-            <a:spLocks xmlns:a="http://schemas.openxmlformats.org/drawingml/2006/main" noGrp="1"/>
+            <a:spLocks noGrp="1"/>
           </p:cNvSpPr>
           <p:nvPr>
             <p:ph type="body" idx="1"/>
@@ -1818,41 +1728,41 @@
         </p:nvSpPr>
         <p:spPr/>
         <p:txBody>
-          <a:bodyPr xmlns:a="http://schemas.openxmlformats.org/drawingml/2006/main"/>
-          <a:lstStyle xmlns:a="http://schemas.openxmlformats.org/drawingml/2006/main"/>
-          <a:p xmlns:a="http://schemas.openxmlformats.org/drawingml/2006/main">
+          <a:bodyPr/>
+          <a:lstStyle/>
+          <a:p>
             <a:r>
               <a:t>So: peace, contentment, bliss. How does a person actually get them?</a:t>
             </a:r>
           </a:p>
-          <a:p xmlns:a="http://schemas.openxmlformats.org/drawingml/2006/main">
+          <a:p>
             <a:r>
               <a:t>Let me put the shape of the answer first, because it is the hinge of this whole movement. Below the human order, fulfilment is definite — it needs no deciding. A molecule does not choose. A plant does not deliberate. Even the animal, which has a complete sentient unit, is carried by species-conformance to the fulfilment available through its body. Nothing there has to be *worked out*.</a:t>
             </a:r>
           </a:p>
-          <a:p xmlns:a="http://schemas.openxmlformats.org/drawingml/2006/main">
+          <a:p>
             <a:r>
               <a:t>The human order is the one place where complementarity has to be fulfilled *knowingly* — where the higher harmonies are on offer and nothing delivers them automatically. And here is the part people resist: understanding does not deliver them either. Study is necessary. It is not sufficient. You can recognise the higher faculties, grasp the whole account, hold it clearly — and still not have peace, contentment, or bliss, because those are harmonies of the unit in *activity*, and there is no activity in knowing about activity.</a:t>
             </a:r>
           </a:p>
-          <a:p xmlns:a="http://schemas.openxmlformats.org/drawingml/2006/main">
+          <a:p>
             <a:r>
               <a:t>What delivers them is performed action — specifically, action that fulfils relationships. Recognise the higher faculties; study until you understand; then act so that what you owe in each relationship is actually fulfilled. That third step is not optional decoration on the first two. It is where the harmony happens.</a:t>
             </a:r>
           </a:p>
-          <a:p xmlns:a="http://schemas.openxmlformats.org/drawingml/2006/main">
-            <a:r>
-              <a:t>That is why the text bothers with the anatomy of action at all. Every activity done with desire has five limbs: doer, cause, objective, result, and effect. Effect means the act's reach or consequence — not a separate ledger of destiny. Desire is the aspiration; karma is the doing, activity together with aspiration; result is the fruit. And the text's own criterion: desire, doing, and result must *balance* for the desire to be truly accomplished. Wanting without doing is not accomplishment. Doing that misses the result is not accomplishment either.</a:t>
-            </a:r>
-          </a:p>
-          <a:p xmlns:a="http://schemas.openxmlformats.org/drawingml/2006/main">
+          <a:p>
+            <a:r>
+              <a:t>That is why the text bothers with the anatomy of action at all. *Kriyā* names activity throughout nature; it is not thereby *karma*. Human activity joined to aspiration has five limbs: doer, cause, objective, result, and effect. Effect means the act's reach or consequence — not a separate ledger of destiny. Desire is the aspiration; karma is the doing, activity together with aspiration; result is the fruit. And the text's own criterion: desire, doing, and result must *balance* for the desire to be truly accomplished. Wanting without doing is not accomplishment. Doing that misses the result is not accomplishment either.</a:t>
+            </a:r>
+          </a:p>
+          <a:p>
             <a:r>
               <a:t>So: understanding alone changes nothing. It is the doing that yields the fruit. Book knowledge is half the work — the other half is conduct that fulfils relationships.</a:t>
             </a:r>
           </a:p>
-          <a:p xmlns:a="http://schemas.openxmlformats.org/drawingml/2006/main">
-            <a:r>
-              <a:t>Hold this beside the earlier triad of effort, motion, and result. This is the desire-laden framing of the same activity ontology in sentient living. The next slides show how desire and doing get reorganised under justice, innateness, and truth.</a:t>
+          <a:p>
+            <a:r>
+              <a:t>Hold this beside the earlier triad of effort, motion, and result. This is the desire-laden human framing of the same activity ontology. The next slides show how desire and doing get reorganised under justice, innateness, and truth.</a:t>
             </a:r>
           </a:p>
         </p:txBody>
@@ -1861,7 +1771,7 @@
         <p:nvSpPr>
           <p:cNvPr id="4" name="Slide Number Placeholder 3"/>
           <p:cNvSpPr>
-            <a:spLocks xmlns:a="http://schemas.openxmlformats.org/drawingml/2006/main" noGrp="1"/>
+            <a:spLocks noGrp="1"/>
           </p:cNvSpPr>
           <p:nvPr>
             <p:ph type="sldNum" idx="5"/>
@@ -1869,21 +1779,21 @@
         </p:nvSpPr>
         <p:spPr/>
         <p:txBody>
-          <a:bodyPr xmlns:a="http://schemas.openxmlformats.org/drawingml/2006/main"/>
-          <a:lstStyle xmlns:a="http://schemas.openxmlformats.org/drawingml/2006/main"/>
-          <a:p xmlns:a="http://schemas.openxmlformats.org/drawingml/2006/main"/>
+          <a:bodyPr/>
+          <a:lstStyle/>
+          <a:p/>
         </p:txBody>
       </p:sp>
     </p:spTree>
   </p:cSld>
   <p:clrMapOvr>
-    <a:masterClrMapping xmlns:a="http://schemas.openxmlformats.org/drawingml/2006/main"/>
+    <a:masterClrMapping/>
   </p:clrMapOvr>
 </p:notes>
 </file>
 
 <file path=ppt/notesSlides/notesSlide22.xml><?xml version="1.0" encoding="utf-8"?>
-<p:notes xmlns:p="http://schemas.openxmlformats.org/presentationml/2006/main">
+<p:notes xmlns:a="http://schemas.openxmlformats.org/drawingml/2006/main" xmlns:p="http://schemas.openxmlformats.org/presentationml/2006/main">
   <p:cSld>
     <p:spTree>
       <p:nvGrpSpPr>
@@ -1892,13 +1802,13 @@
         <p:nvPr/>
       </p:nvGrpSpPr>
       <p:grpSpPr>
-        <a:xfrm xmlns:a="http://schemas.openxmlformats.org/drawingml/2006/main"/>
+        <a:xfrm/>
       </p:grpSpPr>
       <p:sp>
         <p:nvSpPr>
           <p:cNvPr id="2" name="Slide Image Placeholder 1"/>
           <p:cNvSpPr>
-            <a:spLocks xmlns:a="http://schemas.openxmlformats.org/drawingml/2006/main" noGrp="1"/>
+            <a:spLocks noGrp="1"/>
           </p:cNvSpPr>
           <p:nvPr>
             <p:ph type="sldImg" idx="0"/>
@@ -1910,7 +1820,7 @@
         <p:nvSpPr>
           <p:cNvPr id="3" name="Notes Placeholder 2"/>
           <p:cNvSpPr>
-            <a:spLocks xmlns:a="http://schemas.openxmlformats.org/drawingml/2006/main" noGrp="1"/>
+            <a:spLocks noGrp="1"/>
           </p:cNvSpPr>
           <p:nvPr>
             <p:ph type="body" idx="1"/>
@@ -1918,38 +1828,29 @@
         </p:nvSpPr>
         <p:spPr/>
         <p:txBody>
-          <a:bodyPr xmlns:a="http://schemas.openxmlformats.org/drawingml/2006/main"/>
-          <a:lstStyle xmlns:a="http://schemas.openxmlformats.org/drawingml/2006/main"/>
-          <a:p xmlns:a="http://schemas.openxmlformats.org/drawingml/2006/main">
-            <a:pPr marL="0" indent="0" algn="l">
-              <a:spcBef>
-                <a:spcPts val="0"/>
-              </a:spcBef>
-              <a:spcAft>
-                <a:spcPts val="0"/>
-              </a:spcAft>
-              <a:buNone/>
-            </a:pPr>
+          <a:bodyPr/>
+          <a:lstStyle/>
+          <a:p>
             <a:r>
               <a:t>This slide explains the name Madhyasth — and it cashes a cheque I wrote back on slide 6.</a:t>
             </a:r>
           </a:p>
-          <a:p xmlns:a="http://schemas.openxmlformats.org/drawingml/2006/main">
+          <a:p>
             <a:r>
               <a:t>Remember the third of the three terms: surrounded. Regulation is what surroundedness establishes. Because the formless reality stands between units, each is held at a definite distance from the others. Orderliness is self-regulation inherent in saturated units — not dispensed by a cosmic governor. That mediative regulation, which regulates and conserves every unit, gives the darshan its name.</a:t>
             </a:r>
           </a:p>
-          <a:p xmlns:a="http://schemas.openxmlformats.org/drawingml/2006/main">
+          <a:p>
             <a:r>
               <a:t>The account works at three levels, and it is worth naming them: Omnipresence is the sustaining condition; within an atom, the nucleus is the mediative organisation that regulates generative and degenerative activity and conserves relative powers; and at larger scales, order-specific conformance is the definite conduct you can actually observe.</a:t>
             </a:r>
           </a:p>
-          <a:p xmlns:a="http://schemas.openxmlformats.org/drawingml/2006/main">
+          <a:p>
             <a:r>
               <a:t>Conformance has order-specific modes. Material: structural or result conformance. Bio: seed-conformance. Animal: species-conformance, inherited from gestation. Human: *sanskar*-conformance — achieved through knowing, believing, recognising, and fulfilling, rather than inherited. That last one is why education and tradition matter so much here: they can reproduce confusion just as easily as they can support awakening.</a:t>
             </a:r>
           </a:p>
-          <a:p xmlns:a="http://schemas.openxmlformats.org/drawingml/2006/main">
+          <a:p>
             <a:r>
               <a:t>Material, bio, and animal regulation is definite. An animal body’s expressive limits do not introduce evaluative error. In human living, the sentient unit can judge wrongly when it mistakes the body for the self. Awakening aligns evaluation with coexistence. That is why justice becomes necessary at the human order.</a:t>
             </a:r>
@@ -1960,7 +1861,7 @@
         <p:nvSpPr>
           <p:cNvPr id="4" name="Slide Number Placeholder 3"/>
           <p:cNvSpPr>
-            <a:spLocks xmlns:a="http://schemas.openxmlformats.org/drawingml/2006/main" noGrp="1"/>
+            <a:spLocks noGrp="1"/>
           </p:cNvSpPr>
           <p:nvPr>
             <p:ph type="sldNum" idx="5"/>
@@ -1968,21 +1869,21 @@
         </p:nvSpPr>
         <p:spPr/>
         <p:txBody>
-          <a:bodyPr xmlns:a="http://schemas.openxmlformats.org/drawingml/2006/main"/>
-          <a:lstStyle xmlns:a="http://schemas.openxmlformats.org/drawingml/2006/main"/>
-          <a:p xmlns:a="http://schemas.openxmlformats.org/drawingml/2006/main"/>
+          <a:bodyPr/>
+          <a:lstStyle/>
+          <a:p/>
         </p:txBody>
       </p:sp>
     </p:spTree>
   </p:cSld>
   <p:clrMapOvr>
-    <a:masterClrMapping xmlns:a="http://schemas.openxmlformats.org/drawingml/2006/main"/>
+    <a:masterClrMapping/>
   </p:clrMapOvr>
 </p:notes>
 </file>
 
 <file path=ppt/notesSlides/notesSlide23.xml><?xml version="1.0" encoding="utf-8"?>
-<p:notes xmlns:p="http://schemas.openxmlformats.org/presentationml/2006/main">
+<p:notes xmlns:a="http://schemas.openxmlformats.org/drawingml/2006/main" xmlns:p="http://schemas.openxmlformats.org/presentationml/2006/main">
   <p:cSld>
     <p:spTree>
       <p:nvGrpSpPr>
@@ -1991,13 +1892,13 @@
         <p:nvPr/>
       </p:nvGrpSpPr>
       <p:grpSpPr>
-        <a:xfrm xmlns:a="http://schemas.openxmlformats.org/drawingml/2006/main"/>
+        <a:xfrm/>
       </p:grpSpPr>
       <p:sp>
         <p:nvSpPr>
           <p:cNvPr id="2" name="Slide Image Placeholder 1"/>
           <p:cNvSpPr>
-            <a:spLocks xmlns:a="http://schemas.openxmlformats.org/drawingml/2006/main" noGrp="1"/>
+            <a:spLocks noGrp="1"/>
           </p:cNvSpPr>
           <p:nvPr>
             <p:ph type="sldImg" idx="0"/>
@@ -2009,7 +1910,7 @@
         <p:nvSpPr>
           <p:cNvPr id="3" name="Notes Placeholder 2"/>
           <p:cNvSpPr>
-            <a:spLocks xmlns:a="http://schemas.openxmlformats.org/drawingml/2006/main" noGrp="1"/>
+            <a:spLocks noGrp="1"/>
           </p:cNvSpPr>
           <p:nvPr>
             <p:ph type="body" idx="1"/>
@@ -2017,29 +1918,29 @@
         </p:nvSpPr>
         <p:spPr/>
         <p:txBody>
-          <a:bodyPr xmlns:a="http://schemas.openxmlformats.org/drawingml/2006/main"/>
-          <a:lstStyle xmlns:a="http://schemas.openxmlformats.org/drawingml/2006/main"/>
-          <a:p xmlns:a="http://schemas.openxmlformats.org/drawingml/2006/main">
+          <a:bodyPr/>
+          <a:lstStyle/>
+          <a:p>
             <a:r>
               <a:t>Human evaluation widens across six perspectives: pleasant, healthy, profit, justice, innateness or dharma as an evaluative lens, and truth. They move from sensation, body, and gain to relationship, orderliness, and coexistence.</a:t>
             </a:r>
           </a:p>
-          <a:p xmlns:a="http://schemas.openxmlformats.org/drawingml/2006/main">
+          <a:p>
             <a:r>
               <a:t>Justice is both one of the six and the principle of fulfilled relationship. Dharma here means fitting the wider pattern — discipline in thought, not only outer conduct. Truth means alignment with the whole, grounded in realisation, not in liking or gain.</a:t>
             </a:r>
           </a:p>
-          <a:p xmlns:a="http://schemas.openxmlformats.org/drawingml/2006/main">
+          <a:p>
             <a:r>
               <a:t>The graduated chain is: rule itself is justice; justice itself is dharma; dharma itself is truth; truth itself is coexistence.</a:t>
             </a:r>
           </a:p>
-          <a:p xmlns:a="http://schemas.openxmlformats.org/drawingml/2006/main">
+          <a:p>
             <a:r>
               <a:t>Pleasure, health, and profit are not condemned. They remain legitimate in their domain. Awakening changes the organising refuge: they are subordinated under justice, dharma, and truth — not abandoned.</a:t>
             </a:r>
           </a:p>
-          <a:p xmlns:a="http://schemas.openxmlformats.org/drawingml/2006/main">
+          <a:p>
             <a:r>
               <a:t>Keep this distinct from unit-innateness earlier. One word, two levels: what a unit cannot be separated from, versus how we evaluate thought and resolution.</a:t>
             </a:r>
@@ -2050,7 +1951,7 @@
         <p:nvSpPr>
           <p:cNvPr id="4" name="Slide Number Placeholder 3"/>
           <p:cNvSpPr>
-            <a:spLocks xmlns:a="http://schemas.openxmlformats.org/drawingml/2006/main" noGrp="1"/>
+            <a:spLocks noGrp="1"/>
           </p:cNvSpPr>
           <p:nvPr>
             <p:ph type="sldNum" idx="5"/>
@@ -2058,21 +1959,21 @@
         </p:nvSpPr>
         <p:spPr/>
         <p:txBody>
-          <a:bodyPr xmlns:a="http://schemas.openxmlformats.org/drawingml/2006/main"/>
-          <a:lstStyle xmlns:a="http://schemas.openxmlformats.org/drawingml/2006/main"/>
-          <a:p xmlns:a="http://schemas.openxmlformats.org/drawingml/2006/main"/>
+          <a:bodyPr/>
+          <a:lstStyle/>
+          <a:p/>
         </p:txBody>
       </p:sp>
     </p:spTree>
   </p:cSld>
   <p:clrMapOvr>
-    <a:masterClrMapping xmlns:a="http://schemas.openxmlformats.org/drawingml/2006/main"/>
+    <a:masterClrMapping/>
   </p:clrMapOvr>
 </p:notes>
 </file>
 
 <file path=ppt/notesSlides/notesSlide24.xml><?xml version="1.0" encoding="utf-8"?>
-<p:notes xmlns:p="http://schemas.openxmlformats.org/presentationml/2006/main">
+<p:notes xmlns:a="http://schemas.openxmlformats.org/drawingml/2006/main" xmlns:p="http://schemas.openxmlformats.org/presentationml/2006/main">
   <p:cSld>
     <p:spTree>
       <p:nvGrpSpPr>
@@ -2081,13 +1982,13 @@
         <p:nvPr/>
       </p:nvGrpSpPr>
       <p:grpSpPr>
-        <a:xfrm xmlns:a="http://schemas.openxmlformats.org/drawingml/2006/main"/>
+        <a:xfrm/>
       </p:grpSpPr>
       <p:sp>
         <p:nvSpPr>
           <p:cNvPr id="2" name="Slide Image Placeholder 1"/>
           <p:cNvSpPr>
-            <a:spLocks xmlns:a="http://schemas.openxmlformats.org/drawingml/2006/main" noGrp="1"/>
+            <a:spLocks noGrp="1"/>
           </p:cNvSpPr>
           <p:nvPr>
             <p:ph type="sldImg" idx="0"/>
@@ -2099,7 +2000,7 @@
         <p:nvSpPr>
           <p:cNvPr id="3" name="Notes Placeholder 2"/>
           <p:cNvSpPr>
-            <a:spLocks xmlns:a="http://schemas.openxmlformats.org/drawingml/2006/main" noGrp="1"/>
+            <a:spLocks noGrp="1"/>
           </p:cNvSpPr>
           <p:nvPr>
             <p:ph type="body" idx="1"/>
@@ -2107,33 +2008,24 @@
         </p:nvSpPr>
         <p:spPr/>
         <p:txBody>
-          <a:bodyPr xmlns:a="http://schemas.openxmlformats.org/drawingml/2006/main"/>
-          <a:lstStyle xmlns:a="http://schemas.openxmlformats.org/drawingml/2006/main"/>
-          <a:p xmlns:a="http://schemas.openxmlformats.org/drawingml/2006/main">
-            <a:pPr marL="0" indent="0" algn="l">
-              <a:spcBef>
-                <a:spcPts val="0"/>
-              </a:spcBef>
-              <a:spcAft>
-                <a:spcPts val="0"/>
-              </a:spcAft>
-              <a:buNone/>
-            </a:pPr>
+          <a:bodyPr/>
+          <a:lstStyle/>
+          <a:p>
             <a:r>
               <a:t>We turn now to knowing — how understanding widens, and how it happens in the sentient unit.</a:t>
             </a:r>
           </a:p>
-          <a:p xmlns:a="http://schemas.openxmlformats.org/drawingml/2006/main">
+          <a:p>
             <a:r>
               <a:t>On the left: what must be understood as mutual context widens. Form is real structure encountered in mutual facing. Capacities show as effects between units. Essential nature needs state, order, and context. Innateness is evidenced in whole-order fulfilment. Relationships are shared expectations weighed by justice, dharma, and truth. At the top is coexistence itself — not another observed detail, but the aim of knowing.</a:t>
             </a:r>
           </a:p>
-          <a:p xmlns:a="http://schemas.openxmlformats.org/drawingml/2006/main">
+          <a:p>
             <a:r>
               <a:t>On the right: how knowing happens within the sentient unit. Hope tastes and selects. Thought deliberates. Desire contemplates. Resolve clarifies and resolves. The core self realises — through truth. When each level is acted in alignment, it is felt as happiness, peace, contentment, and bliss.</a:t>
             </a:r>
           </a:p>
-          <a:p xmlns:a="http://schemas.openxmlformats.org/drawingml/2006/main">
+          <a:p>
             <a:r>
               <a:t>The ladders meet at the top: coexistence known and lived is felt as bliss. Human error belongs to confused evaluation, not to fuzziness in the reality reflected.</a:t>
             </a:r>
@@ -2144,7 +2036,7 @@
         <p:nvSpPr>
           <p:cNvPr id="4" name="Slide Number Placeholder 3"/>
           <p:cNvSpPr>
-            <a:spLocks xmlns:a="http://schemas.openxmlformats.org/drawingml/2006/main" noGrp="1"/>
+            <a:spLocks noGrp="1"/>
           </p:cNvSpPr>
           <p:nvPr>
             <p:ph type="sldNum" idx="5"/>
@@ -2152,21 +2044,21 @@
         </p:nvSpPr>
         <p:spPr/>
         <p:txBody>
-          <a:bodyPr xmlns:a="http://schemas.openxmlformats.org/drawingml/2006/main"/>
-          <a:lstStyle xmlns:a="http://schemas.openxmlformats.org/drawingml/2006/main"/>
-          <a:p xmlns:a="http://schemas.openxmlformats.org/drawingml/2006/main"/>
+          <a:bodyPr/>
+          <a:lstStyle/>
+          <a:p/>
         </p:txBody>
       </p:sp>
     </p:spTree>
   </p:cSld>
   <p:clrMapOvr>
-    <a:masterClrMapping xmlns:a="http://schemas.openxmlformats.org/drawingml/2006/main"/>
+    <a:masterClrMapping/>
   </p:clrMapOvr>
 </p:notes>
 </file>
 
 <file path=ppt/notesSlides/notesSlide25.xml><?xml version="1.0" encoding="utf-8"?>
-<p:notes xmlns:p="http://schemas.openxmlformats.org/presentationml/2006/main">
+<p:notes xmlns:a="http://schemas.openxmlformats.org/drawingml/2006/main" xmlns:p="http://schemas.openxmlformats.org/presentationml/2006/main">
   <p:cSld>
     <p:spTree>
       <p:nvGrpSpPr>
@@ -2175,13 +2067,13 @@
         <p:nvPr/>
       </p:nvGrpSpPr>
       <p:grpSpPr>
-        <a:xfrm xmlns:a="http://schemas.openxmlformats.org/drawingml/2006/main"/>
+        <a:xfrm/>
       </p:grpSpPr>
       <p:sp>
         <p:nvSpPr>
           <p:cNvPr id="2" name="Slide Image Placeholder 1"/>
           <p:cNvSpPr>
-            <a:spLocks xmlns:a="http://schemas.openxmlformats.org/drawingml/2006/main" noGrp="1"/>
+            <a:spLocks noGrp="1"/>
           </p:cNvSpPr>
           <p:nvPr>
             <p:ph type="sldImg" idx="0"/>
@@ -2193,7 +2085,7 @@
         <p:nvSpPr>
           <p:cNvPr id="3" name="Notes Placeholder 2"/>
           <p:cNvSpPr>
-            <a:spLocks xmlns:a="http://schemas.openxmlformats.org/drawingml/2006/main" noGrp="1"/>
+            <a:spLocks noGrp="1"/>
           </p:cNvSpPr>
           <p:nvPr>
             <p:ph type="body" idx="1"/>
@@ -2201,33 +2093,24 @@
         </p:nvSpPr>
         <p:spPr/>
         <p:txBody>
-          <a:bodyPr xmlns:a="http://schemas.openxmlformats.org/drawingml/2006/main"/>
-          <a:lstStyle xmlns:a="http://schemas.openxmlformats.org/drawingml/2006/main"/>
-          <a:p xmlns:a="http://schemas.openxmlformats.org/drawingml/2006/main">
-            <a:pPr marL="0" indent="0" algn="l">
-              <a:spcBef>
-                <a:spcPts val="0"/>
-              </a:spcBef>
-              <a:spcAft>
-                <a:spcPts val="0"/>
-              </a:spcAft>
-              <a:buNone/>
-            </a:pPr>
+          <a:bodyPr/>
+          <a:lstStyle/>
+          <a:p>
             <a:r>
               <a:t>This is where the developmental drive comes to rest: realisation in coexistence.</a:t>
             </a:r>
           </a:p>
-          <a:p xmlns:a="http://schemas.openxmlformats.org/drawingml/2006/main">
+          <a:p>
             <a:r>
               <a:t>The drive settles when relationships across nature are fulfilled and made evident — not because the ground becomes a knower, but because the awakened sentient unit realises and evidences the coexistence in which it has always existed.</a:t>
             </a:r>
           </a:p>
-          <a:p xmlns:a="http://schemas.openxmlformats.org/drawingml/2006/main">
+          <a:p>
             <a:r>
               <a:t>Realisation is bliss. Truth itself is abundance — coexistence; realisation of abundance is bliss; bliss is the living of the sentient unit. What is realised is the ground the unit was always saturated in.</a:t>
             </a:r>
           </a:p>
-          <a:p xmlns:a="http://schemas.openxmlformats.org/drawingml/2006/main">
+          <a:p>
             <a:r>
               <a:t>Three roles stay distinct: the sentient unit remains the knower; existence as coexistence remains the known; knowledge becomes evident as authentic conduct. They become coherent without becoming identical. The individual knower is not dissolved into a single universal Self.</a:t>
             </a:r>
@@ -2238,7 +2121,7 @@
         <p:nvSpPr>
           <p:cNvPr id="4" name="Slide Number Placeholder 3"/>
           <p:cNvSpPr>
-            <a:spLocks xmlns:a="http://schemas.openxmlformats.org/drawingml/2006/main" noGrp="1"/>
+            <a:spLocks noGrp="1"/>
           </p:cNvSpPr>
           <p:nvPr>
             <p:ph type="sldNum" idx="5"/>
@@ -2246,21 +2129,21 @@
         </p:nvSpPr>
         <p:spPr/>
         <p:txBody>
-          <a:bodyPr xmlns:a="http://schemas.openxmlformats.org/drawingml/2006/main"/>
-          <a:lstStyle xmlns:a="http://schemas.openxmlformats.org/drawingml/2006/main"/>
-          <a:p xmlns:a="http://schemas.openxmlformats.org/drawingml/2006/main"/>
+          <a:bodyPr/>
+          <a:lstStyle/>
+          <a:p/>
         </p:txBody>
       </p:sp>
     </p:spTree>
   </p:cSld>
   <p:clrMapOvr>
-    <a:masterClrMapping xmlns:a="http://schemas.openxmlformats.org/drawingml/2006/main"/>
+    <a:masterClrMapping/>
   </p:clrMapOvr>
 </p:notes>
 </file>
 
 <file path=ppt/notesSlides/notesSlide26.xml><?xml version="1.0" encoding="utf-8"?>
-<p:notes xmlns:p="http://schemas.openxmlformats.org/presentationml/2006/main">
+<p:notes xmlns:a="http://schemas.openxmlformats.org/drawingml/2006/main" xmlns:p="http://schemas.openxmlformats.org/presentationml/2006/main">
   <p:cSld>
     <p:spTree>
       <p:nvGrpSpPr>
@@ -2269,13 +2152,13 @@
         <p:nvPr/>
       </p:nvGrpSpPr>
       <p:grpSpPr>
-        <a:xfrm xmlns:a="http://schemas.openxmlformats.org/drawingml/2006/main"/>
+        <a:xfrm/>
       </p:grpSpPr>
       <p:sp>
         <p:nvSpPr>
           <p:cNvPr id="2" name="Slide Image Placeholder 1"/>
           <p:cNvSpPr>
-            <a:spLocks xmlns:a="http://schemas.openxmlformats.org/drawingml/2006/main" noGrp="1"/>
+            <a:spLocks noGrp="1"/>
           </p:cNvSpPr>
           <p:nvPr>
             <p:ph type="sldImg" idx="0"/>
@@ -2287,7 +2170,7 @@
         <p:nvSpPr>
           <p:cNvPr id="3" name="Notes Placeholder 2"/>
           <p:cNvSpPr>
-            <a:spLocks xmlns:a="http://schemas.openxmlformats.org/drawingml/2006/main" noGrp="1"/>
+            <a:spLocks noGrp="1"/>
           </p:cNvSpPr>
           <p:nvPr>
             <p:ph type="body" idx="1"/>
@@ -2295,43 +2178,34 @@
         </p:nvSpPr>
         <p:spPr/>
         <p:txBody>
-          <a:bodyPr xmlns:a="http://schemas.openxmlformats.org/drawingml/2006/main"/>
-          <a:lstStyle xmlns:a="http://schemas.openxmlformats.org/drawingml/2006/main"/>
-          <a:p xmlns:a="http://schemas.openxmlformats.org/drawingml/2006/main">
-            <a:pPr marL="0" indent="0" algn="l">
-              <a:spcBef>
-                <a:spcPts val="0"/>
-              </a:spcBef>
-              <a:spcAft>
-                <a:spcPts val="0"/>
-              </a:spcAft>
-              <a:buNone/>
-            </a:pPr>
+          <a:bodyPr/>
+          <a:lstStyle/>
+          <a:p>
             <a:r>
               <a:t>The drive comes to rest in awakened human beings — effort settled, understanding proven in daily conduct, and carried as a tradition.</a:t>
             </a:r>
           </a:p>
-          <a:p xmlns:a="http://schemas.openxmlformats.org/drawingml/2006/main">
+          <a:p>
             <a:r>
               <a:t>Effort settled in realisation is T2. Understanding proven in conduct is T3.</a:t>
             </a:r>
           </a:p>
-          <a:p xmlns:a="http://schemas.openxmlformats.org/drawingml/2006/main">
+          <a:p>
             <a:r>
               <a:t>Four goals at four levels: resolution in every person; prosperity in every family; fearlessness — trust — in society; coexistence with all of nature.</a:t>
             </a:r>
           </a:p>
-          <a:p xmlns:a="http://schemas.openxmlformats.org/drawingml/2006/main">
+          <a:p>
             <a:r>
               <a:t>Five dimensions of continuity carry the tradition: education and formative culture; justice and preservation; health and restraint; production and work; exchange and storage.</a:t>
             </a:r>
           </a:p>
-          <a:p xmlns:a="http://schemas.openxmlformats.org/drawingml/2006/main">
+          <a:p>
             <a:r>
               <a:t>And here is where the other half of the composition slide returns. Families and societies are not a further compositional tier — you cannot get a humane society by stacking bodies the way you stack molecules. They are relational achievements: they persist humanely while relationships are recognised, values fulfilled, evaluation completed, and mutual satisfaction achieved. Fear, force, or extraction can hold a group together for a while; on this account they do not make it an orderly society.</a:t>
             </a:r>
           </a:p>
-          <a:p xmlns:a="http://schemas.openxmlformats.org/drawingml/2006/main">
+          <a:p>
             <a:r>
               <a:t>This is not an ideal bolted onto matter. On this account, the progression is designed to arrive here. Nature saturated in Omnipresence is bound for development until realisation. An awakened human tradition is what that progression delivers.</a:t>
             </a:r>
@@ -2342,7 +2216,7 @@
         <p:nvSpPr>
           <p:cNvPr id="4" name="Slide Number Placeholder 3"/>
           <p:cNvSpPr>
-            <a:spLocks xmlns:a="http://schemas.openxmlformats.org/drawingml/2006/main" noGrp="1"/>
+            <a:spLocks noGrp="1"/>
           </p:cNvSpPr>
           <p:nvPr>
             <p:ph type="sldNum" idx="5"/>
@@ -2350,21 +2224,21 @@
         </p:nvSpPr>
         <p:spPr/>
         <p:txBody>
-          <a:bodyPr xmlns:a="http://schemas.openxmlformats.org/drawingml/2006/main"/>
-          <a:lstStyle xmlns:a="http://schemas.openxmlformats.org/drawingml/2006/main"/>
-          <a:p xmlns:a="http://schemas.openxmlformats.org/drawingml/2006/main"/>
+          <a:bodyPr/>
+          <a:lstStyle/>
+          <a:p/>
         </p:txBody>
       </p:sp>
     </p:spTree>
   </p:cSld>
   <p:clrMapOvr>
-    <a:masterClrMapping xmlns:a="http://schemas.openxmlformats.org/drawingml/2006/main"/>
+    <a:masterClrMapping/>
   </p:clrMapOvr>
 </p:notes>
 </file>
 
 <file path=ppt/notesSlides/notesSlide27.xml><?xml version="1.0" encoding="utf-8"?>
-<p:notes xmlns:p="http://schemas.openxmlformats.org/presentationml/2006/main">
+<p:notes xmlns:a="http://schemas.openxmlformats.org/drawingml/2006/main" xmlns:p="http://schemas.openxmlformats.org/presentationml/2006/main">
   <p:cSld>
     <p:spTree>
       <p:nvGrpSpPr>
@@ -2373,13 +2247,13 @@
         <p:nvPr/>
       </p:nvGrpSpPr>
       <p:grpSpPr>
-        <a:xfrm xmlns:a="http://schemas.openxmlformats.org/drawingml/2006/main"/>
+        <a:xfrm/>
       </p:grpSpPr>
       <p:sp>
         <p:nvSpPr>
           <p:cNvPr id="2" name="Slide Image Placeholder 1"/>
           <p:cNvSpPr>
-            <a:spLocks xmlns:a="http://schemas.openxmlformats.org/drawingml/2006/main" noGrp="1"/>
+            <a:spLocks noGrp="1"/>
           </p:cNvSpPr>
           <p:nvPr>
             <p:ph type="sldImg" idx="0"/>
@@ -2391,7 +2265,7 @@
         <p:nvSpPr>
           <p:cNvPr id="3" name="Notes Placeholder 2"/>
           <p:cNvSpPr>
-            <a:spLocks xmlns:a="http://schemas.openxmlformats.org/drawingml/2006/main" noGrp="1"/>
+            <a:spLocks noGrp="1"/>
           </p:cNvSpPr>
           <p:nvPr>
             <p:ph type="body" idx="1"/>
@@ -2399,48 +2273,39 @@
         </p:nvSpPr>
         <p:spPr/>
         <p:txBody>
-          <a:bodyPr xmlns:a="http://schemas.openxmlformats.org/drawingml/2006/main"/>
-          <a:lstStyle xmlns:a="http://schemas.openxmlformats.org/drawingml/2006/main"/>
-          <a:p xmlns:a="http://schemas.openxmlformats.org/drawingml/2006/main">
-            <a:pPr marL="0" indent="0" algn="l">
-              <a:spcBef>
-                <a:spcPts val="0"/>
-              </a:spcBef>
-              <a:spcAft>
-                <a:spcPts val="0"/>
-              </a:spcAft>
-              <a:buNone/>
-            </a:pPr>
+          <a:bodyPr/>
+          <a:lstStyle/>
+          <a:p>
             <a:r>
               <a:t>Before the closing summary, I owe you an accounting of what kind of thing each part of this has been.</a:t>
             </a:r>
           </a:p>
-          <a:p xmlns:a="http://schemas.openxmlformats.org/drawingml/2006/main">
+          <a:p>
             <a:r>
               <a:t>Different methods establish different things. They can support one another, but they are not interchangeable.</a:t>
             </a:r>
           </a:p>
-          <a:p xmlns:a="http://schemas.openxmlformats.org/drawingml/2006/main">
+          <a:p>
             <a:r>
               <a:t>Logical exposition can show internal coherence. It cannot by itself prove empirical fact.</a:t>
             </a:r>
           </a:p>
-          <a:p xmlns:a="http://schemas.openxmlformats.org/drawingml/2006/main">
+          <a:p>
             <a:r>
               <a:t>Study and self-examination can show intelligibility and first-person recognition. They cannot by themselves physically identify the sentient unit.</a:t>
             </a:r>
           </a:p>
-          <a:p xmlns:a="http://schemas.openxmlformats.org/drawingml/2006/main">
+          <a:p>
             <a:r>
               <a:t>Practice and conduct-evidence can show effects in work, behaviour, and mutual satisfaction. They cannot by themselves measure the sentience threshold or the unit–body interface.</a:t>
             </a:r>
           </a:p>
-          <a:p xmlns:a="http://schemas.openxmlformats.org/drawingml/2006/main">
+          <a:p>
             <a:r>
               <a:t>Realisation is this tradition’s claimed completion of knowing. It does not force agreement from other methods.</a:t>
             </a:r>
           </a:p>
-          <a:p xmlns:a="http://schemas.openxmlformats.org/drawingml/2006/main">
+          <a:p>
             <a:r>
               <a:t>Publicly measurable physical claims remain answerable to instrument-based science. No accepted measurement currently identifies the sentience threshold, the unit–body interface, or post-body reassociation — the last of those being the claim I flagged on slide 16, that the sentient unit continues when a body ends and may later associate with another. Stating that plainly is part of responsible presentation.</a:t>
             </a:r>
@@ -2451,7 +2316,7 @@
         <p:nvSpPr>
           <p:cNvPr id="4" name="Slide Number Placeholder 3"/>
           <p:cNvSpPr>
-            <a:spLocks xmlns:a="http://schemas.openxmlformats.org/drawingml/2006/main" noGrp="1"/>
+            <a:spLocks noGrp="1"/>
           </p:cNvSpPr>
           <p:nvPr>
             <p:ph type="sldNum" idx="5"/>
@@ -2459,21 +2324,21 @@
         </p:nvSpPr>
         <p:spPr/>
         <p:txBody>
-          <a:bodyPr xmlns:a="http://schemas.openxmlformats.org/drawingml/2006/main"/>
-          <a:lstStyle xmlns:a="http://schemas.openxmlformats.org/drawingml/2006/main"/>
-          <a:p xmlns:a="http://schemas.openxmlformats.org/drawingml/2006/main"/>
+          <a:bodyPr/>
+          <a:lstStyle/>
+          <a:p/>
         </p:txBody>
       </p:sp>
     </p:spTree>
   </p:cSld>
   <p:clrMapOvr>
-    <a:masterClrMapping xmlns:a="http://schemas.openxmlformats.org/drawingml/2006/main"/>
+    <a:masterClrMapping/>
   </p:clrMapOvr>
 </p:notes>
 </file>
 
 <file path=ppt/notesSlides/notesSlide28.xml><?xml version="1.0" encoding="utf-8"?>
-<p:notes xmlns:p="http://schemas.openxmlformats.org/presentationml/2006/main">
+<p:notes xmlns:a="http://schemas.openxmlformats.org/drawingml/2006/main" xmlns:p="http://schemas.openxmlformats.org/presentationml/2006/main">
   <p:cSld>
     <p:spTree>
       <p:nvGrpSpPr>
@@ -2482,13 +2347,13 @@
         <p:nvPr/>
       </p:nvGrpSpPr>
       <p:grpSpPr>
-        <a:xfrm xmlns:a="http://schemas.openxmlformats.org/drawingml/2006/main"/>
+        <a:xfrm/>
       </p:grpSpPr>
       <p:sp>
         <p:nvSpPr>
           <p:cNvPr id="2" name="Slide Image Placeholder 1"/>
           <p:cNvSpPr>
-            <a:spLocks xmlns:a="http://schemas.openxmlformats.org/drawingml/2006/main" noGrp="1"/>
+            <a:spLocks noGrp="1"/>
           </p:cNvSpPr>
           <p:nvPr>
             <p:ph type="sldImg" idx="0"/>
@@ -2500,7 +2365,7 @@
         <p:nvSpPr>
           <p:cNvPr id="3" name="Notes Placeholder 2"/>
           <p:cNvSpPr>
-            <a:spLocks xmlns:a="http://schemas.openxmlformats.org/drawingml/2006/main" noGrp="1"/>
+            <a:spLocks noGrp="1"/>
           </p:cNvSpPr>
           <p:nvPr>
             <p:ph type="body" idx="1"/>
@@ -2508,53 +2373,44 @@
         </p:nvSpPr>
         <p:spPr/>
         <p:txBody>
-          <a:bodyPr xmlns:a="http://schemas.openxmlformats.org/drawingml/2006/main"/>
-          <a:lstStyle xmlns:a="http://schemas.openxmlformats.org/drawingml/2006/main"/>
-          <a:p xmlns:a="http://schemas.openxmlformats.org/drawingml/2006/main">
-            <a:pPr marL="0" indent="0" algn="l">
-              <a:spcBef>
-                <a:spcPts val="0"/>
-              </a:spcBef>
-              <a:spcAft>
-                <a:spcPts val="0"/>
-              </a:spcAft>
-              <a:buNone/>
-            </a:pPr>
+          <a:bodyPr/>
+          <a:lstStyle/>
+          <a:p>
             <a:r>
               <a:t>Let us close the loop on the six questions.</a:t>
             </a:r>
           </a:p>
-          <a:p xmlns:a="http://schemas.openxmlformats.org/drawingml/2006/main">
+          <a:p>
             <a:r>
               <a:t>What is existence? Eternal coexistence: countless units saturated in all-pervasive Omnipresence.</a:t>
             </a:r>
           </a:p>
-          <a:p xmlns:a="http://schemas.openxmlformats.org/drawingml/2006/main">
+          <a:p>
             <a:r>
               <a:t>What exists? Root atomic units; composite units and bodies; body–sentient-unit joint forms; and relational human assemblies — all saturated in the ground.</a:t>
             </a:r>
           </a:p>
-          <a:p xmlns:a="http://schemas.openxmlformats.org/drawingml/2006/main">
+          <a:p>
             <a:r>
               <a:t>Does existence begin or end? No. Existence is perpetual. Configurations form, transform, and decompose.</a:t>
             </a:r>
           </a:p>
-          <a:p xmlns:a="http://schemas.openxmlformats.org/drawingml/2006/main">
+          <a:p>
             <a:r>
               <a:t>What is the self? The constitutionally complete sentient unit working through the body.</a:t>
             </a:r>
           </a:p>
-          <a:p xmlns:a="http://schemas.openxmlformats.org/drawingml/2006/main">
+          <a:p>
             <a:r>
               <a:t>Is the world real? Yes. Units, mutual relationships, and definite material fulfilment are real within perpetual coexistence.</a:t>
             </a:r>
           </a:p>
-          <a:p xmlns:a="http://schemas.openxmlformats.org/drawingml/2006/main">
+          <a:p>
             <a:r>
               <a:t>How is it known? Through logical exposition, study and self-examination, practice, realisation, and conduct-evidence — without conflating those with instrument measurement of the sentience threshold. The lived test is evidence in humane conduct.</a:t>
             </a:r>
           </a:p>
-          <a:p xmlns:a="http://schemas.openxmlformats.org/drawingml/2006/main">
+          <a:p>
             <a:r>
               <a:t>If we continue later, the natural next step is comparison with other traditions and with science — including open problems this study names for Madhyasth Darshan itself. Thank you.</a:t>
             </a:r>
@@ -2565,7 +2421,7 @@
         <p:nvSpPr>
           <p:cNvPr id="4" name="Slide Number Placeholder 3"/>
           <p:cNvSpPr>
-            <a:spLocks xmlns:a="http://schemas.openxmlformats.org/drawingml/2006/main" noGrp="1"/>
+            <a:spLocks noGrp="1"/>
           </p:cNvSpPr>
           <p:nvPr>
             <p:ph type="sldNum" idx="5"/>
@@ -2573,21 +2429,21 @@
         </p:nvSpPr>
         <p:spPr/>
         <p:txBody>
-          <a:bodyPr xmlns:a="http://schemas.openxmlformats.org/drawingml/2006/main"/>
-          <a:lstStyle xmlns:a="http://schemas.openxmlformats.org/drawingml/2006/main"/>
-          <a:p xmlns:a="http://schemas.openxmlformats.org/drawingml/2006/main"/>
+          <a:bodyPr/>
+          <a:lstStyle/>
+          <a:p/>
         </p:txBody>
       </p:sp>
     </p:spTree>
   </p:cSld>
   <p:clrMapOvr>
-    <a:masterClrMapping xmlns:a="http://schemas.openxmlformats.org/drawingml/2006/main"/>
+    <a:masterClrMapping/>
   </p:clrMapOvr>
 </p:notes>
 </file>
 
 <file path=ppt/notesSlides/notesSlide3.xml><?xml version="1.0" encoding="utf-8"?>
-<p:notes xmlns:p="http://schemas.openxmlformats.org/presentationml/2006/main">
+<p:notes xmlns:a="http://schemas.openxmlformats.org/drawingml/2006/main" xmlns:p="http://schemas.openxmlformats.org/presentationml/2006/main">
   <p:cSld>
     <p:spTree>
       <p:nvGrpSpPr>
@@ -2596,13 +2452,13 @@
         <p:nvPr/>
       </p:nvGrpSpPr>
       <p:grpSpPr>
-        <a:xfrm xmlns:a="http://schemas.openxmlformats.org/drawingml/2006/main"/>
+        <a:xfrm/>
       </p:grpSpPr>
       <p:sp>
         <p:nvSpPr>
           <p:cNvPr id="2" name="Slide Image Placeholder 1"/>
           <p:cNvSpPr>
-            <a:spLocks xmlns:a="http://schemas.openxmlformats.org/drawingml/2006/main" noGrp="1"/>
+            <a:spLocks noGrp="1"/>
           </p:cNvSpPr>
           <p:nvPr>
             <p:ph type="sldImg" idx="0"/>
@@ -2614,7 +2470,7 @@
         <p:nvSpPr>
           <p:cNvPr id="3" name="Notes Placeholder 2"/>
           <p:cNvSpPr>
-            <a:spLocks xmlns:a="http://schemas.openxmlformats.org/drawingml/2006/main" noGrp="1"/>
+            <a:spLocks noGrp="1"/>
           </p:cNvSpPr>
           <p:nvPr>
             <p:ph type="body" idx="1"/>
@@ -2622,58 +2478,49 @@
         </p:nvSpPr>
         <p:spPr/>
         <p:txBody>
-          <a:bodyPr xmlns:a="http://schemas.openxmlformats.org/drawingml/2006/main"/>
-          <a:lstStyle xmlns:a="http://schemas.openxmlformats.org/drawingml/2006/main"/>
-          <a:p xmlns:a="http://schemas.openxmlformats.org/drawingml/2006/main">
-            <a:pPr marL="0" indent="0" algn="l">
-              <a:spcBef>
-                <a:spcPts val="0"/>
-              </a:spcBef>
-              <a:spcAft>
-                <a:spcPts val="0"/>
-              </a:spcAft>
-              <a:buNone/>
-            </a:pPr>
+          <a:bodyPr/>
+          <a:lstStyle/>
+          <a:p>
             <a:r>
               <a:t>Any serious account of reality has to face a small set of questions. Let us name them before we give this tradition’s answers.</a:t>
             </a:r>
           </a:p>
-          <a:p xmlns:a="http://schemas.openxmlformats.org/drawingml/2006/main">
+          <a:p>
             <a:r>
               <a:t>What is existence? Is there one fundamental reality, or many — and how are they related?</a:t>
             </a:r>
           </a:p>
-          <a:p xmlns:a="http://schemas.openxmlformats.org/drawingml/2006/main">
+          <a:p>
             <a:r>
               <a:t>What exists? What are the basic constituents, and what is each of them?</a:t>
             </a:r>
           </a:p>
-          <a:p xmlns:a="http://schemas.openxmlformats.org/drawingml/2006/main">
+          <a:p>
             <a:r>
               <a:t>Does what exists begin? Did reality originate at some time — or do only configurations begin and end?</a:t>
             </a:r>
           </a:p>
-          <a:p xmlns:a="http://schemas.openxmlformats.org/drawingml/2006/main">
+          <a:p>
             <a:r>
               <a:t>Does the self begin or end with the body?</a:t>
             </a:r>
           </a:p>
-          <a:p xmlns:a="http://schemas.openxmlformats.org/drawingml/2006/main">
+          <a:p>
             <a:r>
               <a:t>Is the plural world finally real, or only an appearance?</a:t>
             </a:r>
           </a:p>
-          <a:p xmlns:a="http://schemas.openxmlformats.org/drawingml/2006/main">
+          <a:p>
             <a:r>
               <a:t>And sixth: how can what exists be known — what must be understood, and at what scope?</a:t>
             </a:r>
           </a:p>
-          <a:p xmlns:a="http://schemas.openxmlformats.org/drawingml/2006/main">
+          <a:p>
             <a:r>
               <a:t>Different traditions answer these differently. Madhyasth Darshan does not answer them with six separate doctrines. One picture — coexistence — is meant to answer all six at once.</a:t>
             </a:r>
           </a:p>
-          <a:p xmlns:a="http://schemas.openxmlformats.org/drawingml/2006/main">
+          <a:p>
             <a:r>
               <a:t>We will return to this list at the end with the answers filled in. Along the way you will also see how knowing widens, where the developmental drive comes to rest, and how different kinds of evidence are kept distinct.</a:t>
             </a:r>
@@ -2684,7 +2531,7 @@
         <p:nvSpPr>
           <p:cNvPr id="4" name="Slide Number Placeholder 3"/>
           <p:cNvSpPr>
-            <a:spLocks xmlns:a="http://schemas.openxmlformats.org/drawingml/2006/main" noGrp="1"/>
+            <a:spLocks noGrp="1"/>
           </p:cNvSpPr>
           <p:nvPr>
             <p:ph type="sldNum" idx="5"/>
@@ -2692,21 +2539,21 @@
         </p:nvSpPr>
         <p:spPr/>
         <p:txBody>
-          <a:bodyPr xmlns:a="http://schemas.openxmlformats.org/drawingml/2006/main"/>
-          <a:lstStyle xmlns:a="http://schemas.openxmlformats.org/drawingml/2006/main"/>
-          <a:p xmlns:a="http://schemas.openxmlformats.org/drawingml/2006/main"/>
+          <a:bodyPr/>
+          <a:lstStyle/>
+          <a:p/>
         </p:txBody>
       </p:sp>
     </p:spTree>
   </p:cSld>
   <p:clrMapOvr>
-    <a:masterClrMapping xmlns:a="http://schemas.openxmlformats.org/drawingml/2006/main"/>
+    <a:masterClrMapping/>
   </p:clrMapOvr>
 </p:notes>
 </file>
 
 <file path=ppt/notesSlides/notesSlide4.xml><?xml version="1.0" encoding="utf-8"?>
-<p:notes xmlns:p="http://schemas.openxmlformats.org/presentationml/2006/main">
+<p:notes xmlns:a="http://schemas.openxmlformats.org/drawingml/2006/main" xmlns:p="http://schemas.openxmlformats.org/presentationml/2006/main">
   <p:cSld>
     <p:spTree>
       <p:nvGrpSpPr>
@@ -2715,13 +2562,13 @@
         <p:nvPr/>
       </p:nvGrpSpPr>
       <p:grpSpPr>
-        <a:xfrm xmlns:a="http://schemas.openxmlformats.org/drawingml/2006/main"/>
+        <a:xfrm/>
       </p:grpSpPr>
       <p:sp>
         <p:nvSpPr>
           <p:cNvPr id="2" name="Slide Image Placeholder 1"/>
           <p:cNvSpPr>
-            <a:spLocks xmlns:a="http://schemas.openxmlformats.org/drawingml/2006/main" noGrp="1"/>
+            <a:spLocks noGrp="1"/>
           </p:cNvSpPr>
           <p:nvPr>
             <p:ph type="sldImg" idx="0"/>
@@ -2733,7 +2580,7 @@
         <p:nvSpPr>
           <p:cNvPr id="3" name="Notes Placeholder 2"/>
           <p:cNvSpPr>
-            <a:spLocks xmlns:a="http://schemas.openxmlformats.org/drawingml/2006/main" noGrp="1"/>
+            <a:spLocks noGrp="1"/>
           </p:cNvSpPr>
           <p:nvPr>
             <p:ph type="body" idx="1"/>
@@ -2741,38 +2588,29 @@
         </p:nvSpPr>
         <p:spPr/>
         <p:txBody>
-          <a:bodyPr xmlns:a="http://schemas.openxmlformats.org/drawingml/2006/main"/>
-          <a:lstStyle xmlns:a="http://schemas.openxmlformats.org/drawingml/2006/main"/>
-          <a:p xmlns:a="http://schemas.openxmlformats.org/drawingml/2006/main">
-            <a:pPr marL="0" indent="0" algn="l">
-              <a:spcBef>
-                <a:spcPts val="0"/>
-              </a:spcBef>
-              <a:spcAft>
-                <a:spcPts val="0"/>
-              </a:spcAft>
-              <a:buNone/>
-            </a:pPr>
+          <a:bodyPr/>
+          <a:lstStyle/>
+          <a:p>
             <a:r>
               <a:t>This map is the organising picture for what follows. You do not need to memorise every node. Use it as a place to return when later slides feel dense.</a:t>
             </a:r>
           </a:p>
-          <a:p xmlns:a="http://schemas.openxmlformats.org/drawingml/2006/main">
+          <a:p>
             <a:r>
               <a:t>At the top: coexistence — the ground and countless units, inseparable without losing their distinction. Then, on the unit side: four aspects of every unit; relationships; four orders of nature; and two developmental lines.</a:t>
             </a:r>
           </a:p>
-          <a:p xmlns:a="http://schemas.openxmlformats.org/drawingml/2006/main">
+          <a:p>
             <a:r>
               <a:t>Notice the fork. Bodies belong to compositional building. The sentient unit is the result of a different line — development in an atom. The two meet in animal and human living.</a:t>
             </a:r>
           </a:p>
-          <a:p xmlns:a="http://schemas.openxmlformats.org/drawingml/2006/main">
+          <a:p>
             <a:r>
               <a:t>Later we will name three milestones on the sentient path: the arrival of sentience, then settlement of inner seeking, then authentic conduct. Those are not further material stages.</a:t>
             </a:r>
           </a:p>
-          <a:p xmlns:a="http://schemas.openxmlformats.org/drawingml/2006/main">
+          <a:p>
             <a:r>
               <a:t>Most of the deck is a zoom into one region of this map.</a:t>
             </a:r>
@@ -2783,7 +2621,7 @@
         <p:nvSpPr>
           <p:cNvPr id="4" name="Slide Number Placeholder 3"/>
           <p:cNvSpPr>
-            <a:spLocks xmlns:a="http://schemas.openxmlformats.org/drawingml/2006/main" noGrp="1"/>
+            <a:spLocks noGrp="1"/>
           </p:cNvSpPr>
           <p:nvPr>
             <p:ph type="sldNum" idx="5"/>
@@ -2791,21 +2629,21 @@
         </p:nvSpPr>
         <p:spPr/>
         <p:txBody>
-          <a:bodyPr xmlns:a="http://schemas.openxmlformats.org/drawingml/2006/main"/>
-          <a:lstStyle xmlns:a="http://schemas.openxmlformats.org/drawingml/2006/main"/>
-          <a:p xmlns:a="http://schemas.openxmlformats.org/drawingml/2006/main"/>
+          <a:bodyPr/>
+          <a:lstStyle/>
+          <a:p/>
         </p:txBody>
       </p:sp>
     </p:spTree>
   </p:cSld>
   <p:clrMapOvr>
-    <a:masterClrMapping xmlns:a="http://schemas.openxmlformats.org/drawingml/2006/main"/>
+    <a:masterClrMapping/>
   </p:clrMapOvr>
 </p:notes>
 </file>
 
 <file path=ppt/notesSlides/notesSlide5.xml><?xml version="1.0" encoding="utf-8"?>
-<p:notes xmlns:p="http://schemas.openxmlformats.org/presentationml/2006/main">
+<p:notes xmlns:a="http://schemas.openxmlformats.org/drawingml/2006/main" xmlns:p="http://schemas.openxmlformats.org/presentationml/2006/main">
   <p:cSld>
     <p:spTree>
       <p:nvGrpSpPr>
@@ -2814,13 +2652,13 @@
         <p:nvPr/>
       </p:nvGrpSpPr>
       <p:grpSpPr>
-        <a:xfrm xmlns:a="http://schemas.openxmlformats.org/drawingml/2006/main"/>
+        <a:xfrm/>
       </p:grpSpPr>
       <p:sp>
         <p:nvSpPr>
           <p:cNvPr id="2" name="Slide Image Placeholder 1"/>
           <p:cNvSpPr>
-            <a:spLocks xmlns:a="http://schemas.openxmlformats.org/drawingml/2006/main" noGrp="1"/>
+            <a:spLocks noGrp="1"/>
           </p:cNvSpPr>
           <p:nvPr>
             <p:ph type="sldImg" idx="0"/>
@@ -2832,7 +2670,7 @@
         <p:nvSpPr>
           <p:cNvPr id="3" name="Notes Placeholder 2"/>
           <p:cNvSpPr>
-            <a:spLocks xmlns:a="http://schemas.openxmlformats.org/drawingml/2006/main" noGrp="1"/>
+            <a:spLocks noGrp="1"/>
           </p:cNvSpPr>
           <p:nvPr>
             <p:ph type="body" idx="1"/>
@@ -2840,53 +2678,44 @@
         </p:nvSpPr>
         <p:spPr/>
         <p:txBody>
-          <a:bodyPr xmlns:a="http://schemas.openxmlformats.org/drawingml/2006/main"/>
-          <a:lstStyle xmlns:a="http://schemas.openxmlformats.org/drawingml/2006/main"/>
-          <a:p xmlns:a="http://schemas.openxmlformats.org/drawingml/2006/main">
-            <a:pPr marL="0" indent="0" algn="l">
-              <a:spcBef>
-                <a:spcPts val="0"/>
-              </a:spcBef>
-              <a:spcAft>
-                <a:spcPts val="0"/>
-              </a:spcAft>
-              <a:buNone/>
-            </a:pPr>
+          <a:bodyPr/>
+          <a:lstStyle/>
+          <a:p>
             <a:r>
               <a:t>We now enter the foundations — what this account says exists.</a:t>
             </a:r>
           </a:p>
-          <a:p xmlns:a="http://schemas.openxmlformats.org/drawingml/2006/main">
+          <a:p>
             <a:r>
               <a:t>Existence has two inseparable aspects.</a:t>
             </a:r>
           </a:p>
-          <a:p xmlns:a="http://schemas.openxmlformats.org/drawingml/2006/main">
+          <a:p>
             <a:r>
               <a:t>First, the ground — Omnipresence. Formless, all-pervasive, transparent, permeating, non-transforming, immeasurable. Actionless energy: it acts not at all, yet every unit is energised and regulated in it. There is no place where it is absent.</a:t>
             </a:r>
           </a:p>
-          <a:p xmlns:a="http://schemas.openxmlformats.org/drawingml/2006/main">
+          <a:p>
             <a:r>
               <a:t>Hold on to two of those words, because the next slide is built on them. *Transparent* and *permeating*. The texts say transparence, permeability, and pervasiveness taken together are what show the ground to be one indivisible reality. Permeating is the strong one: the ground does not merely surround a unit from outside, it passes through it. That will matter in about ninety seconds.</a:t>
             </a:r>
           </a:p>
-          <a:p xmlns:a="http://schemas.openxmlformats.org/drawingml/2006/main">
+          <a:p>
             <a:r>
               <a:t>Second, units of nature. Formful, active, countable. Each is bounded and saturated in the ground. Each has form, capacities, a way of participating, and an inseparable innateness — we will walk those four shortly.</a:t>
             </a:r>
           </a:p>
-          <a:p xmlns:a="http://schemas.openxmlformats.org/drawingml/2006/main">
+          <a:p>
             <a:r>
               <a:t>Do not collapse levels. At the root, nature is analysed as atomic units — a centre with orbiting parts. Compounds and bodies are composite units. Body and sentient unit together are a joint form. Families and societies are relational assemblies.</a:t>
             </a:r>
           </a:p>
-          <a:p xmlns:a="http://schemas.openxmlformats.org/drawingml/2006/main">
+          <a:p>
             <a:r>
               <a:t>These two poles were never separate. Separation of a unit from the saturated whole never happens. The ground does not change. Nature saturated in it is dynamic. Therefore all change is unit-activity.</a:t>
             </a:r>
           </a:p>
-          <a:p xmlns:a="http://schemas.openxmlformats.org/drawingml/2006/main">
+          <a:p>
             <a:r>
               <a:t>One naming caution. The texts list many English names for the ground — including Knowledge and Consciousness. Those names do not mean a mind that knows. Active knowing belongs to the sentient unit, never to the ground.</a:t>
             </a:r>
@@ -2897,7 +2726,7 @@
         <p:nvSpPr>
           <p:cNvPr id="4" name="Slide Number Placeholder 3"/>
           <p:cNvSpPr>
-            <a:spLocks xmlns:a="http://schemas.openxmlformats.org/drawingml/2006/main" noGrp="1"/>
+            <a:spLocks noGrp="1"/>
           </p:cNvSpPr>
           <p:nvPr>
             <p:ph type="sldNum" idx="5"/>
@@ -2905,21 +2734,21 @@
         </p:nvSpPr>
         <p:spPr/>
         <p:txBody>
-          <a:bodyPr xmlns:a="http://schemas.openxmlformats.org/drawingml/2006/main"/>
-          <a:lstStyle xmlns:a="http://schemas.openxmlformats.org/drawingml/2006/main"/>
-          <a:p xmlns:a="http://schemas.openxmlformats.org/drawingml/2006/main"/>
+          <a:bodyPr/>
+          <a:lstStyle/>
+          <a:p/>
         </p:txBody>
       </p:sp>
     </p:spTree>
   </p:cSld>
   <p:clrMapOvr>
-    <a:masterClrMapping xmlns:a="http://schemas.openxmlformats.org/drawingml/2006/main"/>
+    <a:masterClrMapping/>
   </p:clrMapOvr>
 </p:notes>
 </file>
 
 <file path=ppt/notesSlides/notesSlide6.xml><?xml version="1.0" encoding="utf-8"?>
-<p:notes xmlns:p="http://schemas.openxmlformats.org/presentationml/2006/main">
+<p:notes xmlns:a="http://schemas.openxmlformats.org/drawingml/2006/main" xmlns:p="http://schemas.openxmlformats.org/presentationml/2006/main">
   <p:cSld>
     <p:spTree>
       <p:nvGrpSpPr>
@@ -2928,13 +2757,13 @@
         <p:nvPr/>
       </p:nvGrpSpPr>
       <p:grpSpPr>
-        <a:xfrm xmlns:a="http://schemas.openxmlformats.org/drawingml/2006/main"/>
+        <a:xfrm/>
       </p:grpSpPr>
       <p:sp>
         <p:nvSpPr>
           <p:cNvPr id="2" name="Slide Image Placeholder 1"/>
           <p:cNvSpPr>
-            <a:spLocks xmlns:a="http://schemas.openxmlformats.org/drawingml/2006/main" noGrp="1"/>
+            <a:spLocks noGrp="1"/>
           </p:cNvSpPr>
           <p:nvPr>
             <p:ph type="sldImg" idx="0"/>
@@ -2946,7 +2775,7 @@
         <p:nvSpPr>
           <p:cNvPr id="3" name="Notes Placeholder 2"/>
           <p:cNvSpPr>
-            <a:spLocks xmlns:a="http://schemas.openxmlformats.org/drawingml/2006/main" noGrp="1"/>
+            <a:spLocks noGrp="1"/>
           </p:cNvSpPr>
           <p:nvPr>
             <p:ph type="body" idx="1"/>
@@ -2954,63 +2783,54 @@
         </p:nvSpPr>
         <p:spPr/>
         <p:txBody>
-          <a:bodyPr xmlns:a="http://schemas.openxmlformats.org/drawingml/2006/main"/>
-          <a:lstStyle xmlns:a="http://schemas.openxmlformats.org/drawingml/2006/main"/>
-          <a:p xmlns:a="http://schemas.openxmlformats.org/drawingml/2006/main">
-            <a:pPr marL="0" indent="0" algn="l">
-              <a:spcBef>
-                <a:spcPts val="0"/>
-              </a:spcBef>
-              <a:spcAft>
-                <a:spcPts val="0"/>
-              </a:spcAft>
-              <a:buNone/>
-            </a:pPr>
+          <a:bodyPr/>
+          <a:lstStyle/>
+          <a:p>
             <a:r>
               <a:t>How are ground and units related? The texts have one word for it: saturation. Every formful unit is soaked, submerged, and surrounded in Omnipresence.</a:t>
             </a:r>
           </a:p>
-          <a:p xmlns:a="http://schemas.openxmlformats.org/drawingml/2006/main">
+          <a:p>
             <a:r>
               <a:t>Now, why is that true rather than merely asserted? Because the ground is permeating — the word from the last slide. Take a unit and divide it. Divide the fragments. Divide those. However far you go, every fragment is still soaked, still submerged, still surrounded. There is no cut you can make that leaves a piece standing outside the ground.</a:t>
             </a:r>
           </a:p>
-          <a:p xmlns:a="http://schemas.openxmlformats.org/drawingml/2006/main">
+          <a:p>
             <a:r>
               <a:t>Two things follow immediately, and they are worth stating slowly.</a:t>
             </a:r>
           </a:p>
-          <a:p xmlns:a="http://schemas.openxmlformats.org/drawingml/2006/main">
+          <a:p>
             <a:r>
               <a:t>One: a unit cannot be annihilated. To annihilate it you would need a fragment separated from what it is saturated in, and no division produces that.</a:t>
             </a:r>
           </a:p>
-          <a:p xmlns:a="http://schemas.openxmlformats.org/drawingml/2006/main">
+          <a:p>
             <a:r>
               <a:t>Two: saturation is a condition, not an event. There is no moment at which units existed on their own and were later joined to the ground. If someone asks you *when* saturation happened, the answer is that the question does not apply.</a:t>
             </a:r>
           </a:p>
-          <a:p xmlns:a="http://schemas.openxmlformats.org/drawingml/2006/main">
+          <a:p>
             <a:r>
               <a:t>Here is the part I want you to notice, because it is easy to read past. Soaked, submerged, surrounded are not three words for one relation. Each carries its own entailment, and the three cards on the slide follow them in order.</a:t>
             </a:r>
           </a:p>
-          <a:p xmlns:a="http://schemas.openxmlformats.org/drawingml/2006/main">
+          <a:p>
             <a:r>
               <a:t>Soaked gives forcefulness. Being soaked *is* forcefulness — the unit is the bearer of definite relative power. On the force side of the same bond, the texts call this basic impulsion.</a:t>
             </a:r>
           </a:p>
-          <a:p xmlns:a="http://schemas.openxmlformats.org/drawingml/2006/main">
+          <a:p>
             <a:r>
               <a:t>Submerged gives energy-fullness. The ground is on every side of the unit, so the unit is never devoid of the energy evident in its activity. The texts state the relation as a bare identity: unit-ness plus energy-fullness is activeness. And activity is never one thing at a time — always effort, motion, and result together.</a:t>
             </a:r>
           </a:p>
-          <a:p xmlns:a="http://schemas.openxmlformats.org/drawingml/2006/main">
+          <a:p>
             <a:r>
               <a:t>Surrounded gives regulation. Because the formless reality stands between units, each is held at a definite distance from the others. That is where law and orderliness come from — not from a statute issued from outside. We will come back to this on slide 22.</a:t>
             </a:r>
           </a:p>
-          <a:p xmlns:a="http://schemas.openxmlformats.org/drawingml/2006/main">
+          <a:p>
             <a:r>
               <a:t>Recognition and participation in orderliness follow from the same bond, and slide 8 takes them up in their own right. And please hear the caution: this is a claim about what existence is like, not a proposed laboratory transfer mechanism. Nor does saturation destine any unit to become sentient.</a:t>
             </a:r>
@@ -3021,7 +2841,7 @@
         <p:nvSpPr>
           <p:cNvPr id="4" name="Slide Number Placeholder 3"/>
           <p:cNvSpPr>
-            <a:spLocks xmlns:a="http://schemas.openxmlformats.org/drawingml/2006/main" noGrp="1"/>
+            <a:spLocks noGrp="1"/>
           </p:cNvSpPr>
           <p:nvPr>
             <p:ph type="sldNum" idx="5"/>
@@ -3029,21 +2849,21 @@
         </p:nvSpPr>
         <p:spPr/>
         <p:txBody>
-          <a:bodyPr xmlns:a="http://schemas.openxmlformats.org/drawingml/2006/main"/>
-          <a:lstStyle xmlns:a="http://schemas.openxmlformats.org/drawingml/2006/main"/>
-          <a:p xmlns:a="http://schemas.openxmlformats.org/drawingml/2006/main"/>
+          <a:bodyPr/>
+          <a:lstStyle/>
+          <a:p/>
         </p:txBody>
       </p:sp>
     </p:spTree>
   </p:cSld>
   <p:clrMapOvr>
-    <a:masterClrMapping xmlns:a="http://schemas.openxmlformats.org/drawingml/2006/main"/>
+    <a:masterClrMapping/>
   </p:clrMapOvr>
 </p:notes>
 </file>
 
 <file path=ppt/notesSlides/notesSlide7.xml><?xml version="1.0" encoding="utf-8"?>
-<p:notes xmlns:p="http://schemas.openxmlformats.org/presentationml/2006/main">
+<p:notes xmlns:a="http://schemas.openxmlformats.org/drawingml/2006/main" xmlns:p="http://schemas.openxmlformats.org/presentationml/2006/main">
   <p:cSld>
     <p:spTree>
       <p:nvGrpSpPr>
@@ -3052,13 +2872,13 @@
         <p:nvPr/>
       </p:nvGrpSpPr>
       <p:grpSpPr>
-        <a:xfrm xmlns:a="http://schemas.openxmlformats.org/drawingml/2006/main"/>
+        <a:xfrm/>
       </p:grpSpPr>
       <p:sp>
         <p:nvSpPr>
           <p:cNvPr id="2" name="Slide Image Placeholder 1"/>
           <p:cNvSpPr>
-            <a:spLocks xmlns:a="http://schemas.openxmlformats.org/drawingml/2006/main" noGrp="1"/>
+            <a:spLocks noGrp="1"/>
           </p:cNvSpPr>
           <p:nvPr>
             <p:ph type="sldImg" idx="0"/>
@@ -3070,7 +2890,7 @@
         <p:nvSpPr>
           <p:cNvPr id="3" name="Notes Placeholder 2"/>
           <p:cNvSpPr>
-            <a:spLocks xmlns:a="http://schemas.openxmlformats.org/drawingml/2006/main" noGrp="1"/>
+            <a:spLocks noGrp="1"/>
           </p:cNvSpPr>
           <p:nvPr>
             <p:ph type="body" idx="1"/>
@@ -3078,29 +2898,29 @@
         </p:nvSpPr>
         <p:spPr/>
         <p:txBody>
-          <a:bodyPr xmlns:a="http://schemas.openxmlformats.org/drawingml/2006/main"/>
-          <a:lstStyle xmlns:a="http://schemas.openxmlformats.org/drawingml/2006/main"/>
-          <a:p xmlns:a="http://schemas.openxmlformats.org/drawingml/2006/main">
+          <a:bodyPr/>
+          <a:lstStyle/>
+          <a:p>
             <a:r>
               <a:t>One consequence of the last slide deserves its own moment, because it answers the second of our opening questions.</a:t>
             </a:r>
           </a:p>
-          <a:p xmlns:a="http://schemas.openxmlformats.org/drawingml/2006/main">
+          <a:p>
             <a:r>
               <a:t>If no division of a unit can put any fragment outside the ground, then nothing that exists can be annihilated. And nothing arises from non-being either. So existence does not begin and does not end. What begins and ends is composition — particular arrangements of units.</a:t>
             </a:r>
           </a:p>
-          <a:p xmlns:a="http://schemas.openxmlformats.org/drawingml/2006/main">
+          <a:p>
             <a:r>
               <a:t>Notice carefully what that does and does not claim. A compound decomposes. A body dies. Those organisations genuinely end. What continues is their constituents, in other relations. Perpetuity belongs to coexistence, not to any particular configuration.</a:t>
             </a:r>
           </a:p>
-          <a:p xmlns:a="http://schemas.openxmlformats.org/drawingml/2006/main">
-            <a:r>
-              <a:t>Second point, and this one matters for how you hear the rest of the session. The texts call Omnipresence the supreme cause, and that phrase invites a misreading. It is cause only in the sustaining sense — no activity exists apart from nature saturated in it. It starts no particular change. Composition, decomposition, development, conduct: all of that is the work of units acting on one another. So there is no creator in this account, and no ruler issuing instructions.</a:t>
-            </a:r>
-          </a:p>
-          <a:p xmlns:a="http://schemas.openxmlformats.org/drawingml/2006/main">
+          <a:p>
+            <a:r>
+              <a:t>Second point, and this one matters for how you hear the rest of the session. The texts call Omnipresence the supreme cause, and that phrase invites a misreading. It is cause only in the sustaining sense — no activity exists apart from nature saturated in it. It starts no particular change. Composition, decomposition, and development occur as unit-activity in mutuality. Karma and humane conduct belong to the human joint form. So there is no creator in this account, and no ruler issuing instructions.</a:t>
+            </a:r>
+          </a:p>
+          <a:p>
             <a:r>
               <a:t>Third, time. Time here is not a container existing alongside the ground and the units. Time is the duration of activity, reckoned from recurrent activities — a rotation, a year. The ground does not transform, so it is not temporal in the way unit-activity is measured.</a:t>
             </a:r>
@@ -3111,7 +2931,7 @@
         <p:nvSpPr>
           <p:cNvPr id="4" name="Slide Number Placeholder 3"/>
           <p:cNvSpPr>
-            <a:spLocks xmlns:a="http://schemas.openxmlformats.org/drawingml/2006/main" noGrp="1"/>
+            <a:spLocks noGrp="1"/>
           </p:cNvSpPr>
           <p:nvPr>
             <p:ph type="sldNum" idx="5"/>
@@ -3119,21 +2939,21 @@
         </p:nvSpPr>
         <p:spPr/>
         <p:txBody>
-          <a:bodyPr xmlns:a="http://schemas.openxmlformats.org/drawingml/2006/main"/>
-          <a:lstStyle xmlns:a="http://schemas.openxmlformats.org/drawingml/2006/main"/>
-          <a:p xmlns:a="http://schemas.openxmlformats.org/drawingml/2006/main"/>
+          <a:bodyPr/>
+          <a:lstStyle/>
+          <a:p/>
         </p:txBody>
       </p:sp>
     </p:spTree>
   </p:cSld>
   <p:clrMapOvr>
-    <a:masterClrMapping xmlns:a="http://schemas.openxmlformats.org/drawingml/2006/main"/>
+    <a:masterClrMapping/>
   </p:clrMapOvr>
 </p:notes>
 </file>
 
 <file path=ppt/notesSlides/notesSlide8.xml><?xml version="1.0" encoding="utf-8"?>
-<p:notes xmlns:p="http://schemas.openxmlformats.org/presentationml/2006/main">
+<p:notes xmlns:a="http://schemas.openxmlformats.org/drawingml/2006/main" xmlns:p="http://schemas.openxmlformats.org/presentationml/2006/main">
   <p:cSld>
     <p:spTree>
       <p:nvGrpSpPr>
@@ -3142,13 +2962,13 @@
         <p:nvPr/>
       </p:nvGrpSpPr>
       <p:grpSpPr>
-        <a:xfrm xmlns:a="http://schemas.openxmlformats.org/drawingml/2006/main"/>
+        <a:xfrm/>
       </p:grpSpPr>
       <p:sp>
         <p:nvSpPr>
           <p:cNvPr id="2" name="Slide Image Placeholder 1"/>
           <p:cNvSpPr>
-            <a:spLocks xmlns:a="http://schemas.openxmlformats.org/drawingml/2006/main" noGrp="1"/>
+            <a:spLocks noGrp="1"/>
           </p:cNvSpPr>
           <p:nvPr>
             <p:ph type="sldImg" idx="0"/>
@@ -3160,7 +2980,7 @@
         <p:nvSpPr>
           <p:cNvPr id="3" name="Notes Placeholder 2"/>
           <p:cNvSpPr>
-            <a:spLocks xmlns:a="http://schemas.openxmlformats.org/drawingml/2006/main" noGrp="1"/>
+            <a:spLocks noGrp="1"/>
           </p:cNvSpPr>
           <p:nvPr>
             <p:ph type="body" idx="1"/>
@@ -3168,44 +2988,44 @@
         </p:nvSpPr>
         <p:spPr/>
         <p:txBody>
-          <a:bodyPr xmlns:a="http://schemas.openxmlformats.org/drawingml/2006/main"/>
-          <a:lstStyle xmlns:a="http://schemas.openxmlformats.org/drawingml/2006/main"/>
-          <a:p xmlns:a="http://schemas.openxmlformats.org/drawingml/2006/main">
+          <a:bodyPr/>
+          <a:lstStyle/>
+          <a:p>
             <a:r>
               <a:t>So far the relation I have described runs between each unit and the ground. There is a second relation, and without it nothing else in this account works — not value, not relationship, not justice, and not the drive we are about to follow.</a:t>
             </a:r>
           </a:p>
-          <a:p xmlns:a="http://schemas.openxmlformats.org/drawingml/2006/main">
+          <a:p>
             <a:r>
               <a:t>Here is where it comes from. Existence is countless units, each with definite limits, in one pervasive reality. That fact — bounded plurality — is itself what makes recognition possible. The text puts it almost casually: “a provision for one unit to recognise another got manifest in existence.” Because there are many bounded things in one ground, each one stands in definite relation to the others.</a:t>
             </a:r>
           </a:p>
-          <a:p xmlns:a="http://schemas.openxmlformats.org/drawingml/2006/main">
+          <a:p>
             <a:r>
               <a:t>So complementarity is *given* in coexistence. Not created by us. Not agreed between parties. Not a value we project onto a neutral world. It is a feature of what exists.</a:t>
             </a:r>
           </a:p>
-          <a:p xmlns:a="http://schemas.openxmlformats.org/drawingml/2006/main">
+          <a:p>
             <a:r>
               <a:t>Three things follow, and they are the three cards.</a:t>
             </a:r>
           </a:p>
-          <a:p xmlns:a="http://schemas.openxmlformats.org/drawingml/2006/main">
+          <a:p>
             <a:r>
               <a:t>Recognition first. A unit recognises another by responding according to definite constitution, distance, force, and relation. No cognition is involved — please do not hear "recognition" as a mental act. Heat is accepted and redistributed by matter. Particles hold definite distance in an atom. Atoms combine in definite ways and not others. That is recognition in the insentient orders, and the texts name the equipment for it: capacity, ability, receptivity.</a:t>
             </a:r>
           </a:p>
-          <a:p xmlns:a="http://schemas.openxmlformats.org/drawingml/2006/main">
+          <a:p>
             <a:r>
               <a:t>Complementarity second. Nothing in nature exists in isolation, and each unit is a whole along with its environment. Now the consequence people find surprising: essentiality in every order is what value *is*, in the broad sense — the usefulness through which a unit is complementary to others. That means value is ontological here. It is not assigned by an observer, and it is not a human invention layered on top of physics.</a:t>
             </a:r>
           </a:p>
-          <a:p xmlns:a="http://schemas.openxmlformats.org/drawingml/2006/main">
+          <a:p>
             <a:r>
               <a:t>Fulfilment third. Fulfilment is the participation that follows recognition, according to constitution and order. Below the human order it is definite — it happens. At the human order it must be achieved, through knowing and believing. Which is precisely why, at the human order alone, it can fail.</a:t>
             </a:r>
           </a:p>
-          <a:p xmlns:a="http://schemas.openxmlformats.org/drawingml/2006/main">
+          <a:p>
             <a:r>
               <a:t>And now the sentence I want you to carry through the rest of the session, because everything from here specifies it: the completeness drive is the drive to fulfil this complementarity. When we get to the composing line, the texts call it a natural inclination toward coexistence. When we get to the sentience threshold, it is hungry atoms and overfull atoms completing each other. When we get to justice, it is complementarity fulfilled knowingly between human beings. Same thing, three registers.</a:t>
             </a:r>
@@ -3216,7 +3036,7 @@
         <p:nvSpPr>
           <p:cNvPr id="4" name="Slide Number Placeholder 3"/>
           <p:cNvSpPr>
-            <a:spLocks xmlns:a="http://schemas.openxmlformats.org/drawingml/2006/main" noGrp="1"/>
+            <a:spLocks noGrp="1"/>
           </p:cNvSpPr>
           <p:nvPr>
             <p:ph type="sldNum" idx="5"/>
@@ -3224,21 +3044,21 @@
         </p:nvSpPr>
         <p:spPr/>
         <p:txBody>
-          <a:bodyPr xmlns:a="http://schemas.openxmlformats.org/drawingml/2006/main"/>
-          <a:lstStyle xmlns:a="http://schemas.openxmlformats.org/drawingml/2006/main"/>
-          <a:p xmlns:a="http://schemas.openxmlformats.org/drawingml/2006/main"/>
+          <a:bodyPr/>
+          <a:lstStyle/>
+          <a:p/>
         </p:txBody>
       </p:sp>
     </p:spTree>
   </p:cSld>
   <p:clrMapOvr>
-    <a:masterClrMapping xmlns:a="http://schemas.openxmlformats.org/drawingml/2006/main"/>
+    <a:masterClrMapping/>
   </p:clrMapOvr>
 </p:notes>
 </file>
 
 <file path=ppt/notesSlides/notesSlide9.xml><?xml version="1.0" encoding="utf-8"?>
-<p:notes xmlns:p="http://schemas.openxmlformats.org/presentationml/2006/main">
+<p:notes xmlns:a="http://schemas.openxmlformats.org/drawingml/2006/main" xmlns:p="http://schemas.openxmlformats.org/presentationml/2006/main">
   <p:cSld>
     <p:spTree>
       <p:nvGrpSpPr>
@@ -3247,13 +3067,13 @@
         <p:nvPr/>
       </p:nvGrpSpPr>
       <p:grpSpPr>
-        <a:xfrm xmlns:a="http://schemas.openxmlformats.org/drawingml/2006/main"/>
+        <a:xfrm/>
       </p:grpSpPr>
       <p:sp>
         <p:nvSpPr>
           <p:cNvPr id="2" name="Slide Image Placeholder 1"/>
           <p:cNvSpPr>
-            <a:spLocks xmlns:a="http://schemas.openxmlformats.org/drawingml/2006/main" noGrp="1"/>
+            <a:spLocks noGrp="1"/>
           </p:cNvSpPr>
           <p:nvPr>
             <p:ph type="sldImg" idx="0"/>
@@ -3265,7 +3085,7 @@
         <p:nvSpPr>
           <p:cNvPr id="3" name="Notes Placeholder 2"/>
           <p:cNvSpPr>
-            <a:spLocks xmlns:a="http://schemas.openxmlformats.org/drawingml/2006/main" noGrp="1"/>
+            <a:spLocks noGrp="1"/>
           </p:cNvSpPr>
           <p:nvPr>
             <p:ph type="body" idx="1"/>
@@ -3273,48 +3093,39 @@
         </p:nvSpPr>
         <p:spPr/>
         <p:txBody>
-          <a:bodyPr xmlns:a="http://schemas.openxmlformats.org/drawingml/2006/main"/>
-          <a:lstStyle xmlns:a="http://schemas.openxmlformats.org/drawingml/2006/main"/>
-          <a:p xmlns:a="http://schemas.openxmlformats.org/drawingml/2006/main">
-            <a:pPr marL="0" indent="0" algn="l">
-              <a:spcBef>
-                <a:spcPts val="0"/>
-              </a:spcBef>
-              <a:spcAft>
-                <a:spcPts val="0"/>
-              </a:spcAft>
-              <a:buNone/>
-            </a:pPr>
+          <a:bodyPr/>
+          <a:lstStyle/>
+          <a:p>
             <a:r>
               <a:t>What is every unit? Four inseparable aspects — not a static checklist pasted onto things, but how a definite bearer shows up in the world.</a:t>
             </a:r>
           </a:p>
-          <a:p xmlns:a="http://schemas.openxmlformats.org/drawingml/2006/main">
+          <a:p>
             <a:r>
               <a:t>Form is real boundary and configuration. Take the peepal tree on the slide: one bounded living form with trunk, branches, leaves, and roots.</a:t>
             </a:r>
           </a:p>
-          <a:p xmlns:a="http://schemas.openxmlformats.org/drawingml/2006/main">
+          <a:p>
             <a:r>
               <a:t>Properties — capacities and relative effects. In the peepal: nutrition, growth, repair, seed production, degeneration under definite conditions.</a:t>
             </a:r>
           </a:p>
-          <a:p xmlns:a="http://schemas.openxmlformats.org/drawingml/2006/main">
+          <a:p>
             <a:r>
               <a:t>Essential nature is usefulness in context: vitalising while the living organisation holds; devitalising when it breaks down.</a:t>
             </a:r>
           </a:p>
-          <a:p xmlns:a="http://schemas.openxmlformats.org/drawingml/2006/main">
+          <a:p>
             <a:r>
               <a:t>Innateness — dharma in this technical sense — is what cannot be separated from the unit, plus order-specific fulfilment. For the peepal: existence plus growth. Seed-conformance is how it conducts itself, not an extra label piled on top.</a:t>
             </a:r>
           </a:p>
-          <a:p xmlns:a="http://schemas.openxmlformats.org/drawingml/2006/main">
+          <a:p>
             <a:r>
               <a:t>Form is real; what another unit encounters is its definite presentation in mutual facing. In non-sentient nature these aspects are definite. Misreading arises mainly in human living, when the sentient unit mistakes the body for the self.</a:t>
             </a:r>
           </a:p>
-          <a:p xmlns:a="http://schemas.openxmlformats.org/drawingml/2006/main">
+          <a:p>
             <a:r>
               <a:t>And notice: the tree as a composite can die while its material constituents persist. Persistence of existence is not persistence of one configuration.</a:t>
             </a:r>
@@ -3325,7 +3136,7 @@
         <p:nvSpPr>
           <p:cNvPr id="4" name="Slide Number Placeholder 3"/>
           <p:cNvSpPr>
-            <a:spLocks xmlns:a="http://schemas.openxmlformats.org/drawingml/2006/main" noGrp="1"/>
+            <a:spLocks noGrp="1"/>
           </p:cNvSpPr>
           <p:nvPr>
             <p:ph type="sldNum" idx="5"/>
@@ -3333,15 +3144,15 @@
         </p:nvSpPr>
         <p:spPr/>
         <p:txBody>
-          <a:bodyPr xmlns:a="http://schemas.openxmlformats.org/drawingml/2006/main"/>
-          <a:lstStyle xmlns:a="http://schemas.openxmlformats.org/drawingml/2006/main"/>
-          <a:p xmlns:a="http://schemas.openxmlformats.org/drawingml/2006/main"/>
+          <a:bodyPr/>
+          <a:lstStyle/>
+          <a:p/>
         </p:txBody>
       </p:sp>
     </p:spTree>
   </p:cSld>
   <p:clrMapOvr>
-    <a:masterClrMapping xmlns:a="http://schemas.openxmlformats.org/drawingml/2006/main"/>
+    <a:masterClrMapping/>
   </p:clrMapOvr>
 </p:notes>
 </file>
@@ -3391,7 +3202,7 @@
   </p:cSld>
   <p:clrMap bg1="lt1" tx1="dk1" bg2="dk2" tx2="lt2" accent1="accent1" accent2="accent2" accent3="accent3" accent4="accent4" accent5="accent5" accent6="accent6" hlink="hlink" folHlink="folHlink"/>
   <p:sldLayoutIdLst>
-    <p:sldLayoutId xmlns:r="http://schemas.openxmlformats.org/officeDocument/2006/relationships" id="2147483649" r:id="Rc8c5790afddb4223"/>
+    <p:sldLayoutId xmlns:r="http://schemas.openxmlformats.org/officeDocument/2006/relationships" id="2147483649" r:id="R2110124672a94979"/>
   </p:sldLayoutIdLst>
   <p:hf sldNum="0" hdr="0" ftr="0" dt="0"/>
   <p:txStyles>
@@ -20547,7 +20358,7 @@
                 <a:ea typeface="Calibri"/>
                 <a:cs typeface="Calibri"/>
               </a:rPr>
-              <a:t>Every jeevan bears the same five faculties and ten activities. An animal jeevan, limited by its bodily medium, acts for sensory satisfaction and reaches only the first harmony. Human jeevan has a body that can express all ten — yet by default it evaluates on the same sensory criteria.</a:t>
+              <a:t>Every jeevan bears the same five faculties and ten activities. In animal living, bodily limits keep jeevan's activity within sensory satisfaction and the first harmony. The human body can express all ten — yet by default human evaluation uses the same sensory criteria.</a:t>
             </a:r>
           </a:p>
         </p:txBody>
@@ -21983,7 +21794,7 @@
                 <a:ea typeface="Calibri"/>
                 <a:cs typeface="Calibri"/>
               </a:rPr>
-              <a:t>Below the human order fulfilment is definite and needs no deciding. In animal living, jeevan acts for sensory satisfaction under species-conformance; peace, contentment, and bliss are not in view. The human order is where complementarity has to be fulfilled knowingly — and study alone does not fulfil it. Book knowledge is half the work; the other half is conduct that fulfils relationships.</a:t>
+              <a:t>Below the human order, fulfilment is definite and needs no deciding. Animal jeevan's activity remains within sensory satisfaction under species-conformance; peace, contentment, and bliss are not in view. The human order is where complementarity must be fulfilled knowingly — study alone does not fulfil it. Book knowledge is half the work; the other half is conduct that fulfils relationships.</a:t>
             </a:r>
             <a:r>
               <a:rPr sz="1250" b="0" i="0" u="none" cap="none">
@@ -22410,7 +22221,7 @@
                 <a:ea typeface="Calibri"/>
                 <a:cs typeface="Calibri"/>
               </a:rPr>
-              <a:t>activity + aspiration = karma</a:t>
+              <a:t>human kriyā + aspiration = karma</a:t>
             </a:r>
           </a:p>
         </p:txBody>
@@ -27483,7 +27294,7 @@
       </p:sp>
       <p:cxnSp>
         <p:nvCxnSpPr>
-          <p:cNvPr id="1047" name="Google Shape;445;p18"/>
+          <p:cNvPr id="1158" name="Google Shape;445;p18"/>
           <p:cNvCxnSpPr/>
           <p:nvPr/>
         </p:nvCxnSpPr>
@@ -27564,7 +27375,7 @@
       </p:sp>
       <p:cxnSp>
         <p:nvCxnSpPr>
-          <p:cNvPr id="1049" name="Google Shape;447;p18"/>
+          <p:cNvPr id="1160" name="Google Shape;447;p18"/>
           <p:cNvCxnSpPr/>
           <p:nvPr/>
         </p:nvCxnSpPr>
@@ -32854,7 +32665,7 @@
           <p:nvPr/>
         </p:nvPicPr>
         <p:blipFill rotWithShape="1">
-          <a:blip xmlns:r="http://schemas.openxmlformats.org/officeDocument/2006/relationships" xmlns:a="http://schemas.openxmlformats.org/drawingml/2006/main" r:embed="Rb9d2cd783c36492d">
+          <a:blip xmlns:r="http://schemas.openxmlformats.org/officeDocument/2006/relationships" xmlns:a="http://schemas.openxmlformats.org/drawingml/2006/main" r:embed="R07d244b533a54820">
             <a:alphaModFix/>
           </a:blip>
           <a:srcRect xmlns:a="http://schemas.openxmlformats.org/drawingml/2006/main" l="0" t="0" r="0" b="0"/>
@@ -32996,7 +32807,7 @@
           <p:nvPr/>
         </p:nvPicPr>
         <p:blipFill rotWithShape="1">
-          <a:blip xmlns:r="http://schemas.openxmlformats.org/officeDocument/2006/relationships" xmlns:a="http://schemas.openxmlformats.org/drawingml/2006/main" r:embed="Rb9d2cd783c36492d">
+          <a:blip xmlns:r="http://schemas.openxmlformats.org/officeDocument/2006/relationships" xmlns:a="http://schemas.openxmlformats.org/drawingml/2006/main" r:embed="R07d244b533a54820">
             <a:alphaModFix/>
           </a:blip>
           <a:srcRect xmlns:a="http://schemas.openxmlformats.org/drawingml/2006/main" l="0" t="0" r="0" b="0"/>
@@ -33138,7 +32949,7 @@
           <p:nvPr/>
         </p:nvPicPr>
         <p:blipFill rotWithShape="1">
-          <a:blip xmlns:r="http://schemas.openxmlformats.org/officeDocument/2006/relationships" xmlns:a="http://schemas.openxmlformats.org/drawingml/2006/main" r:embed="Rb9d2cd783c36492d">
+          <a:blip xmlns:r="http://schemas.openxmlformats.org/officeDocument/2006/relationships" xmlns:a="http://schemas.openxmlformats.org/drawingml/2006/main" r:embed="R07d244b533a54820">
             <a:alphaModFix/>
           </a:blip>
           <a:srcRect xmlns:a="http://schemas.openxmlformats.org/drawingml/2006/main" l="0" t="0" r="0" b="0"/>
@@ -33280,7 +33091,7 @@
           <p:nvPr/>
         </p:nvPicPr>
         <p:blipFill rotWithShape="1">
-          <a:blip xmlns:r="http://schemas.openxmlformats.org/officeDocument/2006/relationships" xmlns:a="http://schemas.openxmlformats.org/drawingml/2006/main" r:embed="Rb9d2cd783c36492d">
+          <a:blip xmlns:r="http://schemas.openxmlformats.org/officeDocument/2006/relationships" xmlns:a="http://schemas.openxmlformats.org/drawingml/2006/main" r:embed="R07d244b533a54820">
             <a:alphaModFix/>
           </a:blip>
           <a:srcRect xmlns:a="http://schemas.openxmlformats.org/drawingml/2006/main" l="0" t="0" r="0" b="0"/>
@@ -33422,7 +33233,7 @@
           <p:nvPr/>
         </p:nvPicPr>
         <p:blipFill rotWithShape="1">
-          <a:blip xmlns:r="http://schemas.openxmlformats.org/officeDocument/2006/relationships" xmlns:a="http://schemas.openxmlformats.org/drawingml/2006/main" r:embed="Rb9d2cd783c36492d">
+          <a:blip xmlns:r="http://schemas.openxmlformats.org/officeDocument/2006/relationships" xmlns:a="http://schemas.openxmlformats.org/drawingml/2006/main" r:embed="R07d244b533a54820">
             <a:alphaModFix/>
           </a:blip>
           <a:srcRect xmlns:a="http://schemas.openxmlformats.org/drawingml/2006/main" l="0" t="0" r="0" b="0"/>
@@ -33564,7 +33375,7 @@
           <p:nvPr/>
         </p:nvPicPr>
         <p:blipFill rotWithShape="1">
-          <a:blip xmlns:r="http://schemas.openxmlformats.org/officeDocument/2006/relationships" xmlns:a="http://schemas.openxmlformats.org/drawingml/2006/main" r:embed="Rb9d2cd783c36492d">
+          <a:blip xmlns:r="http://schemas.openxmlformats.org/officeDocument/2006/relationships" xmlns:a="http://schemas.openxmlformats.org/drawingml/2006/main" r:embed="R07d244b533a54820">
             <a:alphaModFix/>
           </a:blip>
           <a:srcRect xmlns:a="http://schemas.openxmlformats.org/drawingml/2006/main" l="0" t="0" r="0" b="0"/>
@@ -34115,7 +33926,7 @@
           <p:nvPr/>
         </p:nvPicPr>
         <p:blipFill>
-          <a:blip xmlns:r="http://schemas.openxmlformats.org/officeDocument/2006/relationships" xmlns:a="http://schemas.openxmlformats.org/drawingml/2006/main" r:embed="R5463d652c32345ac"/>
+          <a:blip xmlns:r="http://schemas.openxmlformats.org/officeDocument/2006/relationships" xmlns:a="http://schemas.openxmlformats.org/drawingml/2006/main" r:embed="Raa476ea641584eaa"/>
           <a:stretch xmlns:a="http://schemas.openxmlformats.org/drawingml/2006/main"/>
         </p:blipFill>
         <p:spPr>
@@ -36030,7 +35841,7 @@
           <p:nvPr/>
         </p:nvPicPr>
         <p:blipFill rotWithShape="1">
-          <a:blip xmlns:r="http://schemas.openxmlformats.org/officeDocument/2006/relationships" xmlns:a="http://schemas.openxmlformats.org/drawingml/2006/main" r:embed="R9038ac16d5854b72">
+          <a:blip xmlns:r="http://schemas.openxmlformats.org/officeDocument/2006/relationships" xmlns:a="http://schemas.openxmlformats.org/drawingml/2006/main" r:embed="R568c85c70f744fe8">
             <a:alphaModFix/>
           </a:blip>
           <a:srcRect xmlns:a="http://schemas.openxmlformats.org/drawingml/2006/main" l="0" t="0" r="0" b="0"/>
@@ -36273,7 +36084,7 @@
           <p:nvPr/>
         </p:nvPicPr>
         <p:blipFill rotWithShape="1">
-          <a:blip xmlns:r="http://schemas.openxmlformats.org/officeDocument/2006/relationships" xmlns:a="http://schemas.openxmlformats.org/drawingml/2006/main" r:embed="R6f47f4044c304646">
+          <a:blip xmlns:r="http://schemas.openxmlformats.org/officeDocument/2006/relationships" xmlns:a="http://schemas.openxmlformats.org/drawingml/2006/main" r:embed="Rbeb856ebe720419c">
             <a:alphaModFix/>
           </a:blip>
           <a:srcRect xmlns:a="http://schemas.openxmlformats.org/drawingml/2006/main" l="0" t="0" r="0" b="0"/>
@@ -36516,7 +36327,7 @@
           <p:nvPr/>
         </p:nvPicPr>
         <p:blipFill rotWithShape="1">
-          <a:blip xmlns:r="http://schemas.openxmlformats.org/officeDocument/2006/relationships" xmlns:a="http://schemas.openxmlformats.org/drawingml/2006/main" r:embed="Rd2c9bbdc8e494723">
+          <a:blip xmlns:r="http://schemas.openxmlformats.org/officeDocument/2006/relationships" xmlns:a="http://schemas.openxmlformats.org/drawingml/2006/main" r:embed="Rbf65f7d724a94252">
             <a:alphaModFix/>
           </a:blip>
           <a:srcRect xmlns:a="http://schemas.openxmlformats.org/drawingml/2006/main" l="0" t="0" r="0" b="0"/>
@@ -37159,7 +36970,7 @@
           <p:nvPr/>
         </p:nvPicPr>
         <p:blipFill rotWithShape="1">
-          <a:blip xmlns:r="http://schemas.openxmlformats.org/officeDocument/2006/relationships" xmlns:a="http://schemas.openxmlformats.org/drawingml/2006/main" r:embed="R1611995c1b154a01">
+          <a:blip xmlns:r="http://schemas.openxmlformats.org/officeDocument/2006/relationships" xmlns:a="http://schemas.openxmlformats.org/drawingml/2006/main" r:embed="R526dd5ed2a5140a9">
             <a:alphaModFix/>
           </a:blip>
           <a:srcRect xmlns:a="http://schemas.openxmlformats.org/drawingml/2006/main" l="0" t="0" r="0" b="0"/>
@@ -37402,7 +37213,7 @@
           <p:nvPr/>
         </p:nvPicPr>
         <p:blipFill rotWithShape="1">
-          <a:blip xmlns:r="http://schemas.openxmlformats.org/officeDocument/2006/relationships" xmlns:a="http://schemas.openxmlformats.org/drawingml/2006/main" r:embed="R4d2f2983afac4a53">
+          <a:blip xmlns:r="http://schemas.openxmlformats.org/officeDocument/2006/relationships" xmlns:a="http://schemas.openxmlformats.org/drawingml/2006/main" r:embed="Ra44519b4fac24678">
             <a:alphaModFix/>
           </a:blip>
           <a:srcRect xmlns:a="http://schemas.openxmlformats.org/drawingml/2006/main" l="0" t="0" r="0" b="0"/>
@@ -37528,7 +37339,7 @@
                 <a:ea typeface="Calibri"/>
                 <a:cs typeface="Calibri"/>
               </a:rPr>
-              <a:t>Omnipresence is supreme cause only in the sustaining sense: no activity exists apart from nature saturated in it. It initiates no particular change — composition, decomposition, and conduct are the work of units. The ground is no creator and no ruler.</a:t>
+              <a:t>Omnipresence is supreme cause only in the sustaining sense: no activity exists apart from saturated nature. It initiates no change — composition, decomposition, and development occur as unit-activity. Karma belongs to humans. The ground is no creator or ruler.</a:t>
             </a:r>
           </a:p>
         </p:txBody>
@@ -37645,7 +37456,7 @@
           <p:nvPr/>
         </p:nvPicPr>
         <p:blipFill rotWithShape="1">
-          <a:blip xmlns:r="http://schemas.openxmlformats.org/officeDocument/2006/relationships" xmlns:a="http://schemas.openxmlformats.org/drawingml/2006/main" r:embed="R4186f21325884578">
+          <a:blip xmlns:r="http://schemas.openxmlformats.org/officeDocument/2006/relationships" xmlns:a="http://schemas.openxmlformats.org/drawingml/2006/main" r:embed="R835fd9b123634f6b">
             <a:alphaModFix/>
           </a:blip>
           <a:srcRect xmlns:a="http://schemas.openxmlformats.org/drawingml/2006/main" l="0" t="0" r="0" b="0"/>
@@ -38288,7 +38099,7 @@
           <p:nvPr/>
         </p:nvPicPr>
         <p:blipFill rotWithShape="1">
-          <a:blip xmlns:r="http://schemas.openxmlformats.org/officeDocument/2006/relationships" xmlns:a="http://schemas.openxmlformats.org/drawingml/2006/main" r:embed="R68ffc5f379384abb">
+          <a:blip xmlns:r="http://schemas.openxmlformats.org/officeDocument/2006/relationships" xmlns:a="http://schemas.openxmlformats.org/drawingml/2006/main" r:embed="Rb7a54a25afca4a24">
             <a:alphaModFix/>
           </a:blip>
           <a:srcRect xmlns:a="http://schemas.openxmlformats.org/drawingml/2006/main" l="0" t="0" r="0" b="0"/>
@@ -38531,7 +38342,7 @@
           <p:nvPr/>
         </p:nvPicPr>
         <p:blipFill rotWithShape="1">
-          <a:blip xmlns:r="http://schemas.openxmlformats.org/officeDocument/2006/relationships" xmlns:a="http://schemas.openxmlformats.org/drawingml/2006/main" r:embed="R3d33b8c3422e4c96">
+          <a:blip xmlns:r="http://schemas.openxmlformats.org/officeDocument/2006/relationships" xmlns:a="http://schemas.openxmlformats.org/drawingml/2006/main" r:embed="Rec4a061207d041be">
             <a:alphaModFix/>
           </a:blip>
           <a:srcRect xmlns:a="http://schemas.openxmlformats.org/drawingml/2006/main" l="0" t="0" r="0" b="0"/>
@@ -38774,7 +38585,7 @@
           <p:nvPr/>
         </p:nvPicPr>
         <p:blipFill rotWithShape="1">
-          <a:blip xmlns:r="http://schemas.openxmlformats.org/officeDocument/2006/relationships" xmlns:a="http://schemas.openxmlformats.org/drawingml/2006/main" r:embed="Ra51fbd2159f84837">
+          <a:blip xmlns:r="http://schemas.openxmlformats.org/officeDocument/2006/relationships" xmlns:a="http://schemas.openxmlformats.org/drawingml/2006/main" r:embed="R7cf61c14e8514020">
             <a:alphaModFix/>
           </a:blip>
           <a:srcRect xmlns:a="http://schemas.openxmlformats.org/drawingml/2006/main" l="0" t="0" r="0" b="0"/>

</xml_diff>

<commit_message>
Revise Ontology of Coexistence to the thirty-value canon and primary-text faculty terms.
Co-authored-by: Cursor <cursoragent@cursor.com>
</commit_message>
<xml_diff>
--- a/Studies/The-Ontology-of-Coexistence/The-Ontology-of-Existence-Madhyasth-Darshan.pptx
+++ b/Studies/The-Ontology-of-Coexistence/The-Ontology-of-Existence-Madhyasth-Darshan.pptx
@@ -597,7 +597,7 @@
           </a:p>
           <a:p>
             <a:r>
-              <a:t>The slide names five value families: object, *jeevan*, human, established, and civic — the last is *shishta-mulya* in the source. Object values are two, utility and art, so the same list is often counted as six types: utility, art, *jeevan*, human, established, and civic. Established values are the ones that become evident when human relationships are recognised and fulfilled — trust, respect, affection, care, and so on. Civic values are how all of that is expressed in social participation.</a:t>
+              <a:t>The slide names the thirty values: four *jeevan* values, six human values, nine established values, nine expressed values, and two object values. Established values become evident when human relationships are recognised and fulfilled — trust, respect, affection, care, and so on. Expressed values — *shishta-mulya* — are their corresponding powers in motion. The English translation of MVD renders those as civic values; they are relationship-expression, not a separate family of right-use of body, mind, and wealth.</a:t>
             </a:r>
           </a:p>
           <a:p>
@@ -1272,7 +1272,7 @@
           </a:p>
           <a:p>
             <a:r>
-              <a:t>On one side: the body — living composition, sense organs, brain, physical expression; decomposable. On the other: the sentient unit — constitutionally complete; faculties inherent; continuing when the joint form ends.</a:t>
+              <a:t>On one side: the body — living composition, sense organs, the brain (*medhas*), physical expression; decomposable. The brain receives and translates signals; it is the medium, not the knower. On the other: the sentient unit — constitutionally complete; faculties inherent; continuing when the joint form ends.</a:t>
             </a:r>
           </a:p>
           <a:p>
@@ -1362,7 +1362,12 @@
           </a:p>
           <a:p>
             <a:r>
-              <a:t>Each works outward and inward. Hope selects and tastes. Thought analyses and deliberates. Desire visualises and contemplates. Resolve resolves and receives clear understanding. The core self authenticates and realises.</a:t>
+              <a:t>Each works outward and inward. Hope selects and tastes. Thought analyses and deliberates. Desire visualises and contemplates — and directly apprehends. Resolve resolves and comprehends. The core self authenticates and realises.</a:t>
+            </a:r>
+          </a:p>
+          <a:p>
+            <a:r>
+              <a:t>Guidance can descend from the core self through the faculties — higher-conformance — or sensory drive can push inward from the body — lower-conformance. Cognisance regulates sensitivity when the higher direction holds.</a:t>
             </a:r>
           </a:p>
           <a:p>
@@ -2022,7 +2027,7 @@
           </a:p>
           <a:p>
             <a:r>
-              <a:t>On the right: how knowing happens within the sentient unit. Hope tastes and selects. Thought deliberates. Desire contemplates. Resolve clarifies and resolves. The core self realises — through truth. When each level is acted in alignment, it is felt as happiness, peace, contentment, and bliss.</a:t>
+              <a:t>On the right: how knowing happens within the sentient unit. Hope tastes and selects. Thought deliberates. Desire contemplates and directly apprehends. Resolve comprehends and resolves. The core self realises — through truth. When each level is acted in alignment, it is felt as happiness, peace, contentment, and bliss.</a:t>
             </a:r>
           </a:p>
           <a:p>
@@ -3017,7 +3022,7 @@
           </a:p>
           <a:p>
             <a:r>
-              <a:t>Complementarity second. Nothing in nature exists in isolation, and each unit is a whole along with its environment. Now the consequence people find surprising: essentiality in every order is what value *is*, in the broad sense — the usefulness through which a unit is complementary to others. That means value is ontological here. It is not assigned by an observer, and it is not a human invention layered on top of physics.</a:t>
+              <a:t>Complementarity second. Nothing in nature exists in isolation, and each unit is a whole along with its environment. Now the consequence people find surprising: value, in the universal sense, is essentiality and participation in orderliness — the definite conduct through which a unit complements others. Usefulness is that essentiality as it appears in objects; it is not the whole of value. Value is ontological here. It is not assigned by an observer, and it is not a human invention layered on top of physics.</a:t>
             </a:r>
           </a:p>
           <a:p>
@@ -3128,6 +3133,11 @@
           <a:p>
             <a:r>
               <a:t>And notice: the tree as a composite can die while its material constituents persist. Persistence of existence is not persistence of one configuration.</a:t>
+            </a:r>
+          </a:p>
+          <a:p>
+            <a:r>
+              <a:t>The same unit is known in three complementary aspects, not three worlds. Inherent truth is what the unit is. Positional truth is how it stands among others. Existential truth is that it exists in Omnipresence.</a:t>
             </a:r>
           </a:p>
         </p:txBody>
@@ -5517,7 +5527,7 @@
                 <a:ea typeface="Calibri"/>
                 <a:cs typeface="Calibri"/>
               </a:rPr>
-              <a:t>Five value families: object, jeevan, human, established, and civic (shishta). Object values are two — utility and art — so the same list is counted as six types: utility, art, jeevan, human, established, and civic.</a:t>
+              <a:t>Thirty values: four jeevan, six human, nine established, nine expressed (shishta), and two object values. Established values are paired with expressed values in conduct.</a:t>
             </a:r>
           </a:p>
         </p:txBody>
@@ -6161,7 +6171,7 @@
                 <a:ea typeface="Calibri"/>
                 <a:cs typeface="Calibri"/>
               </a:rPr>
-              <a:t>Human evaluation may err; understanding aligns knowing → believing → recognising → fulfilling. Established values arise as relationships are fulfilled; civic values express them socially.</a:t>
+              <a:t>Human evaluation may err; understanding aligns knowing → believing → recognising → fulfilling. Established values arise as relationships are fulfilled; expressed values carry them in conduct.</a:t>
             </a:r>
           </a:p>
         </p:txBody>
@@ -6217,7 +6227,7 @@
                 <a:ea typeface="Calibri"/>
                 <a:cs typeface="Calibri"/>
               </a:rPr>
-              <a:t>MVD pp. 61–62, 27  ·  SB pp. 50, 53, 61  ·  JV p. 69</a:t>
+              <a:t>MVD pp. 61–62, 27  ·  SB pp. 50, 53, 61  ·  JV p. 69  ·  Paribhasha pp. 151, 154</a:t>
             </a:r>
           </a:p>
         </p:txBody>
@@ -17211,7 +17221,7 @@
                           <a:ea typeface="Calibri"/>
                           <a:cs typeface="Calibri"/>
                         </a:rPr>
-                        <a:t>enlightenment</a:t>
+                        <a:t>comprehension</a:t>
                       </a:r>
                     </a:p>
                   </a:txBody>
@@ -26694,7 +26704,7 @@
                 <a:ea typeface="Calibri"/>
                 <a:cs typeface="Calibri"/>
               </a:rPr>
-              <a:t>enlightenment of existence, jeevan, conduct · resolve</a:t>
+              <a:t>comprehension of existence, jeevan, conduct · resolve</a:t>
             </a:r>
           </a:p>
         </p:txBody>
@@ -26817,7 +26827,7 @@
                 <a:ea typeface="Calibri"/>
                 <a:cs typeface="Calibri"/>
               </a:rPr>
-              <a:t>contemplation &amp; visualisation · direct recognition</a:t>
+              <a:t>contemplation &amp; visualisation · direct apprehension</a:t>
             </a:r>
           </a:p>
         </p:txBody>
@@ -38468,7 +38478,7 @@
                 <a:ea typeface="Calibri"/>
                 <a:cs typeface="Calibri"/>
               </a:rPr>
-              <a:t>Nothing exists in isolation, and each unit is a whole along with its environment. Essentiality in every order is value in the broad sense — the usefulness through which a unit is complementary to others. Value is ontological, not assigned by an observer.</a:t>
+              <a:t>Nothing exists in isolation, and each unit is a whole along with its environment. Value is essentiality and participation in orderliness — the definite conduct through which a unit complements others. Usefulness is that essentiality in objects, not the whole of value.</a:t>
             </a:r>
           </a:p>
         </p:txBody>

</xml_diff>

<commit_message>
Clarify light, manifestness and sentient expression in ontology
</commit_message>
<xml_diff>
--- a/Studies/The-Ontology-of-Coexistence/The-Ontology-of-Existence-Madhyasth-Darshan.pptx
+++ b/Studies/The-Ontology-of-Coexistence/The-Ontology-of-Existence-Madhyasth-Darshan.pptx
@@ -2,41 +2,41 @@
 <file path=ppt/presentation.xml><?xml version="1.0" encoding="utf-8"?>
 <p:presentation xmlns:p="http://schemas.openxmlformats.org/presentationml/2006/main">
   <p:sldMasterIdLst>
-    <p:sldMasterId xmlns:r="http://schemas.openxmlformats.org/officeDocument/2006/relationships" id="2147483648" r:id="R26dc17f0a4c54b14"/>
+    <p:sldMasterId xmlns:r="http://schemas.openxmlformats.org/officeDocument/2006/relationships" id="2147483648" r:id="R388e00381139496b"/>
   </p:sldMasterIdLst>
   <p:notesMasterIdLst>
-    <p:notesMasterId xmlns:r="http://schemas.openxmlformats.org/officeDocument/2006/relationships" r:id="R6c7f3daab4c941d6"/>
+    <p:notesMasterId xmlns:r="http://schemas.openxmlformats.org/officeDocument/2006/relationships" r:id="Re4f21cfc0aca4d45"/>
   </p:notesMasterIdLst>
   <p:sldIdLst>
-    <p:sldId xmlns:r="http://schemas.openxmlformats.org/officeDocument/2006/relationships" id="256" r:id="R7ed1c79b43014523"/>
-    <p:sldId xmlns:r="http://schemas.openxmlformats.org/officeDocument/2006/relationships" id="257" r:id="Rcba9d247f22b4b21"/>
-    <p:sldId xmlns:r="http://schemas.openxmlformats.org/officeDocument/2006/relationships" id="258" r:id="R6b38263f39d3477e"/>
-    <p:sldId xmlns:r="http://schemas.openxmlformats.org/officeDocument/2006/relationships" id="259" r:id="Ree9b4a731909464d"/>
-    <p:sldId xmlns:r="http://schemas.openxmlformats.org/officeDocument/2006/relationships" id="260" r:id="R299d79bc952a4939"/>
-    <p:sldId xmlns:r="http://schemas.openxmlformats.org/officeDocument/2006/relationships" id="261" r:id="R51a1d96d47b44615"/>
-    <p:sldId xmlns:r="http://schemas.openxmlformats.org/officeDocument/2006/relationships" id="262" r:id="R85bceaaaee3843d2"/>
-    <p:sldId xmlns:r="http://schemas.openxmlformats.org/officeDocument/2006/relationships" id="263" r:id="R65946d05a8dc4f3e"/>
-    <p:sldId xmlns:r="http://schemas.openxmlformats.org/officeDocument/2006/relationships" id="264" r:id="R4d1a08f09a6c4e76"/>
-    <p:sldId xmlns:r="http://schemas.openxmlformats.org/officeDocument/2006/relationships" id="265" r:id="R5ba004cab7994c63"/>
-    <p:sldId xmlns:r="http://schemas.openxmlformats.org/officeDocument/2006/relationships" id="266" r:id="R8391730f4b874e80"/>
-    <p:sldId xmlns:r="http://schemas.openxmlformats.org/officeDocument/2006/relationships" id="267" r:id="R5ab992cd4e5940cd"/>
-    <p:sldId xmlns:r="http://schemas.openxmlformats.org/officeDocument/2006/relationships" id="268" r:id="Raccf362c0bcc4c6e"/>
-    <p:sldId xmlns:r="http://schemas.openxmlformats.org/officeDocument/2006/relationships" id="269" r:id="R424ce8a1734a4239"/>
-    <p:sldId xmlns:r="http://schemas.openxmlformats.org/officeDocument/2006/relationships" id="270" r:id="R0c1a2f4361d9443a"/>
-    <p:sldId xmlns:r="http://schemas.openxmlformats.org/officeDocument/2006/relationships" id="271" r:id="Re3f0f0b1026e445f"/>
-    <p:sldId xmlns:r="http://schemas.openxmlformats.org/officeDocument/2006/relationships" id="272" r:id="Rbbcb622c63404a38"/>
-    <p:sldId xmlns:r="http://schemas.openxmlformats.org/officeDocument/2006/relationships" id="273" r:id="R027eea7240ba4142"/>
-    <p:sldId xmlns:r="http://schemas.openxmlformats.org/officeDocument/2006/relationships" id="274" r:id="Rf14e5bb44c114e69"/>
-    <p:sldId xmlns:r="http://schemas.openxmlformats.org/officeDocument/2006/relationships" id="275" r:id="R56242c4337144b9b"/>
-    <p:sldId xmlns:r="http://schemas.openxmlformats.org/officeDocument/2006/relationships" id="276" r:id="Re9ce0dceb55244b3"/>
-    <p:sldId xmlns:r="http://schemas.openxmlformats.org/officeDocument/2006/relationships" id="277" r:id="R945e1b7c84dc4650"/>
-    <p:sldId xmlns:r="http://schemas.openxmlformats.org/officeDocument/2006/relationships" id="278" r:id="Rb0e41dbafe7c43db"/>
-    <p:sldId xmlns:r="http://schemas.openxmlformats.org/officeDocument/2006/relationships" id="279" r:id="R5a320b00137c4da8"/>
-    <p:sldId xmlns:r="http://schemas.openxmlformats.org/officeDocument/2006/relationships" id="280" r:id="Rb4d2d8452d0b451b"/>
-    <p:sldId xmlns:r="http://schemas.openxmlformats.org/officeDocument/2006/relationships" id="281" r:id="R6623d7210841434d"/>
-    <p:sldId xmlns:r="http://schemas.openxmlformats.org/officeDocument/2006/relationships" id="282" r:id="R77fdabaaf91e4ac8"/>
-    <p:sldId xmlns:r="http://schemas.openxmlformats.org/officeDocument/2006/relationships" id="283" r:id="R72fa459b228f47ce"/>
-    <p:sldId xmlns:r="http://schemas.openxmlformats.org/officeDocument/2006/relationships" id="284" r:id="R8e9f99cc3cb94cd7"/>
+    <p:sldId xmlns:r="http://schemas.openxmlformats.org/officeDocument/2006/relationships" id="256" r:id="R41e9a533ec364630"/>
+    <p:sldId xmlns:r="http://schemas.openxmlformats.org/officeDocument/2006/relationships" id="257" r:id="Rd034aae41c354bb3"/>
+    <p:sldId xmlns:r="http://schemas.openxmlformats.org/officeDocument/2006/relationships" id="258" r:id="R38addf1f4b3e4b90"/>
+    <p:sldId xmlns:r="http://schemas.openxmlformats.org/officeDocument/2006/relationships" id="259" r:id="Rd446b5a533c747a0"/>
+    <p:sldId xmlns:r="http://schemas.openxmlformats.org/officeDocument/2006/relationships" id="260" r:id="Rd97751e356094ccd"/>
+    <p:sldId xmlns:r="http://schemas.openxmlformats.org/officeDocument/2006/relationships" id="261" r:id="R99c4675820df4525"/>
+    <p:sldId xmlns:r="http://schemas.openxmlformats.org/officeDocument/2006/relationships" id="262" r:id="R6be27b6a3cda4022"/>
+    <p:sldId xmlns:r="http://schemas.openxmlformats.org/officeDocument/2006/relationships" id="263" r:id="R318dc95f784d44b2"/>
+    <p:sldId xmlns:r="http://schemas.openxmlformats.org/officeDocument/2006/relationships" id="264" r:id="Rcd9382cc06474fa3"/>
+    <p:sldId xmlns:r="http://schemas.openxmlformats.org/officeDocument/2006/relationships" id="265" r:id="Rb41dd1b3c3644845"/>
+    <p:sldId xmlns:r="http://schemas.openxmlformats.org/officeDocument/2006/relationships" id="266" r:id="Rdb6b97e371e34923"/>
+    <p:sldId xmlns:r="http://schemas.openxmlformats.org/officeDocument/2006/relationships" id="267" r:id="R48709f4e5a5341fe"/>
+    <p:sldId xmlns:r="http://schemas.openxmlformats.org/officeDocument/2006/relationships" id="268" r:id="R47feca93d8a34b26"/>
+    <p:sldId xmlns:r="http://schemas.openxmlformats.org/officeDocument/2006/relationships" id="269" r:id="Rece2015381aa477e"/>
+    <p:sldId xmlns:r="http://schemas.openxmlformats.org/officeDocument/2006/relationships" id="270" r:id="R41973db7630746b6"/>
+    <p:sldId xmlns:r="http://schemas.openxmlformats.org/officeDocument/2006/relationships" id="271" r:id="R80af74615ee443a9"/>
+    <p:sldId xmlns:r="http://schemas.openxmlformats.org/officeDocument/2006/relationships" id="272" r:id="R10185a9b24a940e1"/>
+    <p:sldId xmlns:r="http://schemas.openxmlformats.org/officeDocument/2006/relationships" id="273" r:id="R752431d326714fc3"/>
+    <p:sldId xmlns:r="http://schemas.openxmlformats.org/officeDocument/2006/relationships" id="274" r:id="R87ad913278b442f3"/>
+    <p:sldId xmlns:r="http://schemas.openxmlformats.org/officeDocument/2006/relationships" id="275" r:id="Rdd81a705775d40f9"/>
+    <p:sldId xmlns:r="http://schemas.openxmlformats.org/officeDocument/2006/relationships" id="276" r:id="Rfd7adb97ba334329"/>
+    <p:sldId xmlns:r="http://schemas.openxmlformats.org/officeDocument/2006/relationships" id="277" r:id="Rc880ecfc00ec4133"/>
+    <p:sldId xmlns:r="http://schemas.openxmlformats.org/officeDocument/2006/relationships" id="278" r:id="R65f6b9533ce14d9d"/>
+    <p:sldId xmlns:r="http://schemas.openxmlformats.org/officeDocument/2006/relationships" id="279" r:id="R71e70a94617d46b6"/>
+    <p:sldId xmlns:r="http://schemas.openxmlformats.org/officeDocument/2006/relationships" id="280" r:id="R57fb06dbf93c4733"/>
+    <p:sldId xmlns:r="http://schemas.openxmlformats.org/officeDocument/2006/relationships" id="281" r:id="Re4dda241596c419a"/>
+    <p:sldId xmlns:r="http://schemas.openxmlformats.org/officeDocument/2006/relationships" id="282" r:id="Rd335dd17123d41f7"/>
+    <p:sldId xmlns:r="http://schemas.openxmlformats.org/officeDocument/2006/relationships" id="283" r:id="R113f93d5b7a04046"/>
+    <p:sldId xmlns:r="http://schemas.openxmlformats.org/officeDocument/2006/relationships" id="284" r:id="R32e1694d411e4a07"/>
   </p:sldIdLst>
   <p:sldSz cx="9144000" cy="5143500"/>
   <p:notesSz cx="6858000" cy="9144000"/>
@@ -2183,7 +2183,7 @@
           <a:lstStyle xmlns:a="http://schemas.openxmlformats.org/drawingml/2006/main"/>
           <a:p xmlns:a="http://schemas.openxmlformats.org/drawingml/2006/main">
             <a:r>
-              <a:t>Presentation, communication and expression have a scope throughout nature. Every unit makes its characteristic contribution evident according to its state, activity and order. In human living, the same vocabulary also describes the purposeful expression of understanding.</a:t>
+              <a:t>Every unit is prakashman, manifest through its form, properties, essential nature and dharma. Presentation, communication and expression describe this participation throughout nature. In sentient jeevan, manifestness includes its active faculties and the capacities it expresses through the body. Humans already communicate and express their capacities during awakening progression. With awakening, these activities carry realised understanding into meaningful presentation, communication and conduct. The three definitions here describe that fuller human fulfilment.</a:t>
             </a:r>
           </a:p>
           <a:p xmlns:a="http://schemas.openxmlformats.org/drawingml/2006/main">
@@ -2208,7 +2208,7 @@
           </a:p>
           <a:p xmlns:a="http://schemas.openxmlformats.org/drawingml/2006/main">
             <a:r>
-              <a:t>These activities overlap and work together. In awakened human living they involve jeevan through the body, carrying understanding into conduct and the humane tradition.</a:t>
+              <a:t>These are connected, overlapping aspects of sentient manifestation. Their fulfilment in awakened human living carries realised understanding through the body into conduct and the humane tradition.</a:t>
             </a:r>
           </a:p>
         </p:txBody>
@@ -2783,7 +2783,7 @@
           </a:p>
           <a:p xmlns:a="http://schemas.openxmlformats.org/drawingml/2006/main">
             <a:r>
-              <a:t>First, the ground — Omnipresence. Formless, all-pervasive, transparent, permeating, non-transforming, immeasurable. Actionless energy: it acts not at all, yet every unit is energised and regulated in it. There is no place where it is absent.</a:t>
+              <a:t>First, the ground — Omnipresence. Formless, all-pervasive, transparent, permeating, non-transforming, immeasurable. Actionless energy: it acts not at all, yet every unit is energised and regulated in it. There is no place where it is absent. The same pervasive reality is also named jyoti, light; realisation in it is described as enduring prakash.</a:t>
             </a:r>
           </a:p>
           <a:p xmlns:a="http://schemas.openxmlformats.org/drawingml/2006/main">
@@ -2893,7 +2893,7 @@
           </a:p>
           <a:p xmlns:a="http://schemas.openxmlformats.org/drawingml/2006/main">
             <a:r>
-              <a:t>These are connected aspects of one saturation. Energy becomes evident in activity, recognition in mutuality, and regulation in definite conduct. The unit is also manifest to others: the texts connect its manifestness with being force-endowed in Omnipresence.</a:t>
+              <a:t>These are connected aspects of one saturation. Energy becomes evident in activity, recognition in mutuality, and regulation in definite conduct. The ground is named jyoti, light; each unit saturated in it is prakashman, manifest. The texts explicitly connect this manifestness with satta permeating the unit and its being endowed with force. Manifestness belongs to all units, including sentient jeevan.</a:t>
             </a:r>
           </a:p>
           <a:p xmlns:a="http://schemas.openxmlformats.org/drawingml/2006/main">
@@ -3088,7 +3088,7 @@
           </a:p>
           <a:p xmlns:a="http://schemas.openxmlformats.org/drawingml/2006/main">
             <a:r>
-              <a:t>The whole unit is manifest, or prakashman, with all four aspects. Imaging is central to prakash. This is a claim about how units are manifest to one another; completed human understanding also requires knowing their relations and fulfilment. An image alone does not deliver that understanding. Animal recognition of essential nature becomes evident in friendliness and opposition; human living brings the exchange of values and evaluation of dharma.</a:t>
+              <a:t>The whole unit is manifest, or prakashman, with all four aspects, grounded in its saturation in satta. In the context of mutuality, prakash names a unit’s imaging. This describes how units are manifest to one another within the wider account of light and manifestness; completed human understanding also requires knowing their relations and fulfilment. An image alone does not deliver that understanding. Animal recognition of essential nature becomes evident in friendliness and opposition; human living brings the exchange of values and evaluation of dharma.</a:t>
             </a:r>
           </a:p>
           <a:p xmlns:a="http://schemas.openxmlformats.org/drawingml/2006/main">
@@ -3268,7 +3268,7 @@
   </p:cSld>
   <p:clrMap bg1="lt1" tx1="dk1" bg2="dk2" tx2="lt2" accent1="accent1" accent2="accent2" accent3="accent3" accent4="accent4" accent5="accent5" accent6="accent6" hlink="hlink" folHlink="folHlink"/>
   <p:sldLayoutIdLst>
-    <p:sldLayoutId xmlns:r="http://schemas.openxmlformats.org/officeDocument/2006/relationships" id="2147483649" r:id="Rf687c78d599f45fd"/>
+    <p:sldLayoutId xmlns:r="http://schemas.openxmlformats.org/officeDocument/2006/relationships" id="2147483649" r:id="Rccf15baee49a48d0"/>
   </p:sldLayoutIdLst>
   <p:hf sldNum="0" hdr="0" ftr="0" dt="0"/>
   <p:txStyles>
@@ -27669,7 +27669,7 @@
       </p:sp>
       <p:cxnSp>
         <p:nvCxnSpPr>
-          <p:cNvPr id="1306" name="Google Shape;445;p18"/>
+          <p:cNvPr id="1343" name="Google Shape;445;p18"/>
           <p:cNvCxnSpPr/>
           <p:nvPr/>
         </p:nvCxnSpPr>
@@ -27750,7 +27750,7 @@
       </p:sp>
       <p:cxnSp>
         <p:nvCxnSpPr>
-          <p:cNvPr id="1308" name="Google Shape;447;p18"/>
+          <p:cNvPr id="1345" name="Google Shape;447;p18"/>
           <p:cNvCxnSpPr/>
           <p:nvPr/>
         </p:nvCxnSpPr>
@@ -29329,7 +29329,7 @@
                 <a:ea typeface="Calibri"/>
                 <a:cs typeface="Calibri"/>
               </a:rPr>
-              <a:t>Every unit presents, communicates and expresses its form, properties, nature and dharma. In human living, these take the fuller forms below, serving understanding and all-round resolution.</a:t>
+              <a:t>Jeevan’s sentient capacities become manifest through the body. Humans express and communicate them during awakening progression; in full awakening, these activities carry realised understanding into conduct.</a:t>
             </a:r>
           </a:p>
         </p:txBody>
@@ -29446,7 +29446,7 @@
           <p:nvPr/>
         </p:nvPicPr>
         <p:blipFill rotWithShape="1">
-          <a:blip xmlns:r="http://schemas.openxmlformats.org/officeDocument/2006/relationships" xmlns:a="http://schemas.openxmlformats.org/drawingml/2006/main" r:embed="R97e3d4b47c7949c2">
+          <a:blip xmlns:r="http://schemas.openxmlformats.org/officeDocument/2006/relationships" xmlns:a="http://schemas.openxmlformats.org/drawingml/2006/main" r:embed="Rbeef1ba50dab4717">
             <a:alphaModFix/>
           </a:blip>
           <a:srcRect xmlns:a="http://schemas.openxmlformats.org/drawingml/2006/main" l="0" t="0" r="0" b="0"/>
@@ -29689,7 +29689,7 @@
           <p:nvPr/>
         </p:nvPicPr>
         <p:blipFill rotWithShape="1">
-          <a:blip xmlns:r="http://schemas.openxmlformats.org/officeDocument/2006/relationships" xmlns:a="http://schemas.openxmlformats.org/drawingml/2006/main" r:embed="R4db1bd9577594744">
+          <a:blip xmlns:r="http://schemas.openxmlformats.org/officeDocument/2006/relationships" xmlns:a="http://schemas.openxmlformats.org/drawingml/2006/main" r:embed="Rac6e0b5be9014e0d">
             <a:alphaModFix/>
           </a:blip>
           <a:srcRect xmlns:a="http://schemas.openxmlformats.org/drawingml/2006/main" l="0" t="0" r="0" b="0"/>
@@ -29932,7 +29932,7 @@
           <p:nvPr/>
         </p:nvPicPr>
         <p:blipFill rotWithShape="1">
-          <a:blip xmlns:r="http://schemas.openxmlformats.org/officeDocument/2006/relationships" xmlns:a="http://schemas.openxmlformats.org/drawingml/2006/main" r:embed="R64164c1fe10b4f23">
+          <a:blip xmlns:r="http://schemas.openxmlformats.org/officeDocument/2006/relationships" xmlns:a="http://schemas.openxmlformats.org/drawingml/2006/main" r:embed="Re775de770ff140c8">
             <a:alphaModFix/>
           </a:blip>
           <a:srcRect xmlns:a="http://schemas.openxmlformats.org/drawingml/2006/main" l="0" t="0" r="0" b="0"/>
@@ -30115,7 +30115,18 @@
                 <a:cs typeface="Calibri"/>
               </a:rPr>
               <a:t>Kala: skilful expression. Kala-mulya: beauty and convenience supporting an object’s usefulness.
-PS pp. 22, 56, 119, 206  ·  SB p. 179  ·  MVD pp. 109–110</a:t>
+PS pp. 22, 56, 119, 206  ·  </a:t>
+            </a:r>
+            <a:r>
+              <a:rPr sz="950" b="0" i="1" u="none" cap="none">
+                <a:solidFill>
+                  <a:srgbClr val="5A6377"/>
+                </a:solidFill>
+                <a:latin typeface="Calibri"/>
+                <a:ea typeface="Calibri"/>
+                <a:cs typeface="Calibri"/>
+              </a:rPr>
+              <a:t>SB pp. 52, 63, 66, 179  ·  MVD pp. 109–110, 328</a:t>
             </a:r>
           </a:p>
         </p:txBody>
@@ -34236,7 +34247,7 @@
           <p:nvPr/>
         </p:nvPicPr>
         <p:blipFill rotWithShape="1">
-          <a:blip xmlns:r="http://schemas.openxmlformats.org/officeDocument/2006/relationships" xmlns:a="http://schemas.openxmlformats.org/drawingml/2006/main" r:embed="R51b41a5c0f524c43">
+          <a:blip xmlns:r="http://schemas.openxmlformats.org/officeDocument/2006/relationships" xmlns:a="http://schemas.openxmlformats.org/drawingml/2006/main" r:embed="Rab090c9d22c0488e">
             <a:alphaModFix/>
           </a:blip>
           <a:srcRect xmlns:a="http://schemas.openxmlformats.org/drawingml/2006/main" l="0" t="0" r="0" b="0"/>
@@ -34378,7 +34389,7 @@
           <p:nvPr/>
         </p:nvPicPr>
         <p:blipFill rotWithShape="1">
-          <a:blip xmlns:r="http://schemas.openxmlformats.org/officeDocument/2006/relationships" xmlns:a="http://schemas.openxmlformats.org/drawingml/2006/main" r:embed="R51b41a5c0f524c43">
+          <a:blip xmlns:r="http://schemas.openxmlformats.org/officeDocument/2006/relationships" xmlns:a="http://schemas.openxmlformats.org/drawingml/2006/main" r:embed="Rab090c9d22c0488e">
             <a:alphaModFix/>
           </a:blip>
           <a:srcRect xmlns:a="http://schemas.openxmlformats.org/drawingml/2006/main" l="0" t="0" r="0" b="0"/>
@@ -34520,7 +34531,7 @@
           <p:nvPr/>
         </p:nvPicPr>
         <p:blipFill rotWithShape="1">
-          <a:blip xmlns:r="http://schemas.openxmlformats.org/officeDocument/2006/relationships" xmlns:a="http://schemas.openxmlformats.org/drawingml/2006/main" r:embed="R51b41a5c0f524c43">
+          <a:blip xmlns:r="http://schemas.openxmlformats.org/officeDocument/2006/relationships" xmlns:a="http://schemas.openxmlformats.org/drawingml/2006/main" r:embed="Rab090c9d22c0488e">
             <a:alphaModFix/>
           </a:blip>
           <a:srcRect xmlns:a="http://schemas.openxmlformats.org/drawingml/2006/main" l="0" t="0" r="0" b="0"/>
@@ -34662,7 +34673,7 @@
           <p:nvPr/>
         </p:nvPicPr>
         <p:blipFill rotWithShape="1">
-          <a:blip xmlns:r="http://schemas.openxmlformats.org/officeDocument/2006/relationships" xmlns:a="http://schemas.openxmlformats.org/drawingml/2006/main" r:embed="R51b41a5c0f524c43">
+          <a:blip xmlns:r="http://schemas.openxmlformats.org/officeDocument/2006/relationships" xmlns:a="http://schemas.openxmlformats.org/drawingml/2006/main" r:embed="Rab090c9d22c0488e">
             <a:alphaModFix/>
           </a:blip>
           <a:srcRect xmlns:a="http://schemas.openxmlformats.org/drawingml/2006/main" l="0" t="0" r="0" b="0"/>
@@ -34804,7 +34815,7 @@
           <p:nvPr/>
         </p:nvPicPr>
         <p:blipFill rotWithShape="1">
-          <a:blip xmlns:r="http://schemas.openxmlformats.org/officeDocument/2006/relationships" xmlns:a="http://schemas.openxmlformats.org/drawingml/2006/main" r:embed="R51b41a5c0f524c43">
+          <a:blip xmlns:r="http://schemas.openxmlformats.org/officeDocument/2006/relationships" xmlns:a="http://schemas.openxmlformats.org/drawingml/2006/main" r:embed="Rab090c9d22c0488e">
             <a:alphaModFix/>
           </a:blip>
           <a:srcRect xmlns:a="http://schemas.openxmlformats.org/drawingml/2006/main" l="0" t="0" r="0" b="0"/>
@@ -34946,7 +34957,7 @@
           <p:nvPr/>
         </p:nvPicPr>
         <p:blipFill rotWithShape="1">
-          <a:blip xmlns:r="http://schemas.openxmlformats.org/officeDocument/2006/relationships" xmlns:a="http://schemas.openxmlformats.org/drawingml/2006/main" r:embed="R51b41a5c0f524c43">
+          <a:blip xmlns:r="http://schemas.openxmlformats.org/officeDocument/2006/relationships" xmlns:a="http://schemas.openxmlformats.org/drawingml/2006/main" r:embed="Rab090c9d22c0488e">
             <a:alphaModFix/>
           </a:blip>
           <a:srcRect xmlns:a="http://schemas.openxmlformats.org/drawingml/2006/main" l="0" t="0" r="0" b="0"/>
@@ -35497,7 +35508,7 @@
           <p:nvPr/>
         </p:nvPicPr>
         <p:blipFill>
-          <a:blip xmlns:r="http://schemas.openxmlformats.org/officeDocument/2006/relationships" xmlns:a="http://schemas.openxmlformats.org/drawingml/2006/main" r:embed="R558b14c063f948b5"/>
+          <a:blip xmlns:r="http://schemas.openxmlformats.org/officeDocument/2006/relationships" xmlns:a="http://schemas.openxmlformats.org/drawingml/2006/main" r:embed="R6f640c4b95674b2d"/>
           <a:stretch xmlns:a="http://schemas.openxmlformats.org/drawingml/2006/main"/>
         </p:blipFill>
         <p:spPr>
@@ -35871,7 +35882,7 @@
                 <a:ea typeface="Calibri"/>
                 <a:cs typeface="Calibri"/>
               </a:rPr>
-              <a:t>Formless, all-pervasive, non-transforming and actionless. It permeates every unit and is transparent in mutuality, where units are imaged and recognised. Every unit is energised and regulated in it. It has no absent place.</a:t>
+              <a:t>Formless, all-pervasive, non-transforming and actionless. Also named jyoti (light), it permeates every unit and is transparent in mutuality. Saturated units are active and manifest (prakashman). It has no absent place.</a:t>
             </a:r>
           </a:p>
           <a:p xmlns:a="http://schemas.openxmlformats.org/drawingml/2006/main">
@@ -36951,7 +36962,29 @@
                 <a:ea typeface="Calibri"/>
                 <a:cs typeface="Calibri"/>
               </a:rPr>
-              <a:t>SB pp. 46, 48, 248–252  ·  MVD pp. 11, 32, 34  ·  PS p. 114  ·  JV p. 18</a:t>
+              <a:t>SB pp. 46, 48, 248–252  ·  MVD pp. 11, 32, 34  ·  </a:t>
+            </a:r>
+            <a:r>
+              <a:rPr sz="950" b="0" i="1" u="none" cap="none">
+                <a:solidFill>
+                  <a:srgbClr val="5A6377"/>
+                </a:solidFill>
+                <a:latin typeface="Calibri"/>
+                <a:ea typeface="Calibri"/>
+                <a:cs typeface="Calibri"/>
+              </a:rPr>
+              <a:t>PS pp. 114, 137</a:t>
+            </a:r>
+            <a:r>
+              <a:rPr sz="950" b="0" i="1" u="none" cap="none">
+                <a:solidFill>
+                  <a:srgbClr val="5A6377"/>
+                </a:solidFill>
+                <a:latin typeface="Calibri"/>
+                <a:ea typeface="Calibri"/>
+                <a:cs typeface="Calibri"/>
+              </a:rPr>
+              <a:t>  ·  JV p. 18</a:t>
             </a:r>
           </a:p>
         </p:txBody>
@@ -37412,7 +37445,7 @@
           <p:nvPr/>
         </p:nvPicPr>
         <p:blipFill rotWithShape="1">
-          <a:blip xmlns:r="http://schemas.openxmlformats.org/officeDocument/2006/relationships" xmlns:a="http://schemas.openxmlformats.org/drawingml/2006/main" r:embed="Rbbb04681cfd84f0b">
+          <a:blip xmlns:r="http://schemas.openxmlformats.org/officeDocument/2006/relationships" xmlns:a="http://schemas.openxmlformats.org/drawingml/2006/main" r:embed="R60478028fed94430">
             <a:alphaModFix/>
           </a:blip>
           <a:srcRect xmlns:a="http://schemas.openxmlformats.org/drawingml/2006/main" l="0" t="0" r="0" b="0"/>
@@ -37538,7 +37571,7 @@
                 <a:ea typeface="Calibri"/>
                 <a:cs typeface="Calibri"/>
               </a:rPr>
-              <a:t>The unit is endowed with energy and has definite relative power. This force-endowment is the root of its manifestness: its being evident to other units.</a:t>
+              <a:t>Permeation by satta grounds force-endowment and manifestness (prakashmanata). Each unit is energy-endowed, with definite relative powers.</a:t>
             </a:r>
           </a:p>
         </p:txBody>
@@ -37655,7 +37688,7 @@
           <p:nvPr/>
         </p:nvPicPr>
         <p:blipFill rotWithShape="1">
-          <a:blip xmlns:r="http://schemas.openxmlformats.org/officeDocument/2006/relationships" xmlns:a="http://schemas.openxmlformats.org/drawingml/2006/main" r:embed="R687d71b4b1e3451a">
+          <a:blip xmlns:r="http://schemas.openxmlformats.org/officeDocument/2006/relationships" xmlns:a="http://schemas.openxmlformats.org/drawingml/2006/main" r:embed="R77bb050624ca48bf">
             <a:alphaModFix/>
           </a:blip>
           <a:srcRect xmlns:a="http://schemas.openxmlformats.org/drawingml/2006/main" l="0" t="0" r="0" b="0"/>
@@ -37781,7 +37814,7 @@
                 <a:ea typeface="Calibri"/>
                 <a:cs typeface="Calibri"/>
               </a:rPr>
-              <a:t>Units are active in one pervasive reality and become manifest to one another through imaging. Energy-endowment and activity belong together.</a:t>
+              <a:t>Units remain active in the pervasive ground. Their images in mutual facing provide a basis of recognition. Energy-endowment and activity belong together.</a:t>
             </a:r>
           </a:p>
         </p:txBody>
@@ -37898,7 +37931,7 @@
           <p:nvPr/>
         </p:nvPicPr>
         <p:blipFill rotWithShape="1">
-          <a:blip xmlns:r="http://schemas.openxmlformats.org/officeDocument/2006/relationships" xmlns:a="http://schemas.openxmlformats.org/drawingml/2006/main" r:embed="Rba1a994c2da04f18">
+          <a:blip xmlns:r="http://schemas.openxmlformats.org/officeDocument/2006/relationships" xmlns:a="http://schemas.openxmlformats.org/drawingml/2006/main" r:embed="R730f6d8c24c74730">
             <a:alphaModFix/>
           </a:blip>
           <a:srcRect xmlns:a="http://schemas.openxmlformats.org/drawingml/2006/main" l="0" t="0" r="0" b="0"/>
@@ -38080,7 +38113,29 @@
                 <a:ea typeface="Calibri"/>
                 <a:cs typeface="Calibri"/>
               </a:rPr>
-              <a:t>These descriptions overlap. Imaging and recognition continue on slide 7.  ·  SB pp. 57, 69, 79, 248  ·  MVD pp. 32–33, 40  ·  PS pp. 114, 121</a:t>
+              <a:t>These descriptions overlap. Imaging and recognition continue on slide 7.  ·  SB pp. 57, 69, 79, 248  ·  </a:t>
+            </a:r>
+            <a:r>
+              <a:rPr sz="950" b="0" i="1" u="none" cap="none">
+                <a:solidFill>
+                  <a:srgbClr val="5A6377"/>
+                </a:solidFill>
+                <a:latin typeface="Calibri"/>
+                <a:ea typeface="Calibri"/>
+                <a:cs typeface="Calibri"/>
+              </a:rPr>
+              <a:t>AVD PDF pp. 115–116</a:t>
+            </a:r>
+            <a:r>
+              <a:rPr sz="950" b="0" i="1" u="none" cap="none">
+                <a:solidFill>
+                  <a:srgbClr val="5A6377"/>
+                </a:solidFill>
+                <a:latin typeface="Calibri"/>
+                <a:ea typeface="Calibri"/>
+                <a:cs typeface="Calibri"/>
+              </a:rPr>
+              <a:t>  ·  PS pp. 114, 121</a:t>
             </a:r>
           </a:p>
         </p:txBody>
@@ -38552,7 +38607,7 @@
           <p:nvPr/>
         </p:nvPicPr>
         <p:blipFill rotWithShape="1">
-          <a:blip xmlns:r="http://schemas.openxmlformats.org/officeDocument/2006/relationships" xmlns:a="http://schemas.openxmlformats.org/drawingml/2006/main" r:embed="Rd0b6f088f5b14d05">
+          <a:blip xmlns:r="http://schemas.openxmlformats.org/officeDocument/2006/relationships" xmlns:a="http://schemas.openxmlformats.org/drawingml/2006/main" r:embed="R83aca33a03a146e1">
             <a:alphaModFix/>
           </a:blip>
           <a:srcRect xmlns:a="http://schemas.openxmlformats.org/drawingml/2006/main" l="0" t="0" r="0" b="0"/>
@@ -38795,7 +38850,7 @@
           <p:nvPr/>
         </p:nvPicPr>
         <p:blipFill rotWithShape="1">
-          <a:blip xmlns:r="http://schemas.openxmlformats.org/officeDocument/2006/relationships" xmlns:a="http://schemas.openxmlformats.org/drawingml/2006/main" r:embed="Rb734a8a987d44910">
+          <a:blip xmlns:r="http://schemas.openxmlformats.org/officeDocument/2006/relationships" xmlns:a="http://schemas.openxmlformats.org/drawingml/2006/main" r:embed="R667e578a5fb349ff">
             <a:alphaModFix/>
           </a:blip>
           <a:srcRect xmlns:a="http://schemas.openxmlformats.org/drawingml/2006/main" l="0" t="0" r="0" b="0"/>
@@ -39038,7 +39093,7 @@
           <p:nvPr/>
         </p:nvPicPr>
         <p:blipFill rotWithShape="1">
-          <a:blip xmlns:r="http://schemas.openxmlformats.org/officeDocument/2006/relationships" xmlns:a="http://schemas.openxmlformats.org/drawingml/2006/main" r:embed="R69647d449b9046b5">
+          <a:blip xmlns:r="http://schemas.openxmlformats.org/officeDocument/2006/relationships" xmlns:a="http://schemas.openxmlformats.org/drawingml/2006/main" r:embed="R3af91f88232c4d55">
             <a:alphaModFix/>
           </a:blip>
           <a:srcRect xmlns:a="http://schemas.openxmlformats.org/drawingml/2006/main" l="0" t="0" r="0" b="0"/>
@@ -40873,7 +40928,7 @@
                 <a:ea typeface="Calibri"/>
                 <a:cs typeface="Calibri"/>
               </a:rPr>
-              <a:t>The whole unit is manifest (prakashman) with all four aspects. Imaging (pratibimban) is central to prakash. An image provides a basis of recognition; understanding the unit also requires its relations and fulfilment. The tree can die while its material constituents persist.</a:t>
+              <a:t>The whole unit is manifest (prakashman) with all four aspects through saturation in satta. In the imaging context, prakash names the unit’s being imaged. An image supports recognition; human understanding also requires relations and fulfilment. The tree can die while its material constituents persist.</a:t>
             </a:r>
           </a:p>
         </p:txBody>
@@ -41401,7 +41456,7 @@
           <p:nvPr/>
         </p:nvPicPr>
         <p:blipFill rotWithShape="1">
-          <a:blip xmlns:r="http://schemas.openxmlformats.org/officeDocument/2006/relationships" xmlns:a="http://schemas.openxmlformats.org/drawingml/2006/main" r:embed="R82996ebfd5974aa0">
+          <a:blip xmlns:r="http://schemas.openxmlformats.org/officeDocument/2006/relationships" xmlns:a="http://schemas.openxmlformats.org/drawingml/2006/main" r:embed="R4309ea82831a4909">
             <a:alphaModFix/>
           </a:blip>
           <a:srcRect xmlns:a="http://schemas.openxmlformats.org/drawingml/2006/main" l="0" t="0" r="0" b="0"/>
@@ -41644,7 +41699,7 @@
           <p:nvPr/>
         </p:nvPicPr>
         <p:blipFill rotWithShape="1">
-          <a:blip xmlns:r="http://schemas.openxmlformats.org/officeDocument/2006/relationships" xmlns:a="http://schemas.openxmlformats.org/drawingml/2006/main" r:embed="Rb8e14d41b2b94826">
+          <a:blip xmlns:r="http://schemas.openxmlformats.org/officeDocument/2006/relationships" xmlns:a="http://schemas.openxmlformats.org/drawingml/2006/main" r:embed="R652459c6135e4133">
             <a:alphaModFix/>
           </a:blip>
           <a:srcRect xmlns:a="http://schemas.openxmlformats.org/drawingml/2006/main" l="0" t="0" r="0" b="0"/>
@@ -41887,7 +41942,7 @@
           <p:nvPr/>
         </p:nvPicPr>
         <p:blipFill rotWithShape="1">
-          <a:blip xmlns:r="http://schemas.openxmlformats.org/officeDocument/2006/relationships" xmlns:a="http://schemas.openxmlformats.org/drawingml/2006/main" r:embed="R077af4fd903d498a">
+          <a:blip xmlns:r="http://schemas.openxmlformats.org/officeDocument/2006/relationships" xmlns:a="http://schemas.openxmlformats.org/drawingml/2006/main" r:embed="R258b4be7ee2948e0">
             <a:alphaModFix/>
           </a:blip>
           <a:srcRect xmlns:a="http://schemas.openxmlformats.org/drawingml/2006/main" l="0" t="0" r="0" b="0"/>

</xml_diff>

<commit_message>
Use Prakash for satta in ontology study and teaching material
</commit_message>
<xml_diff>
--- a/Studies/The-Ontology-of-Coexistence/The-Ontology-of-Existence-Madhyasth-Darshan.pptx
+++ b/Studies/The-Ontology-of-Coexistence/The-Ontology-of-Existence-Madhyasth-Darshan.pptx
@@ -2,41 +2,41 @@
 <file path=ppt/presentation.xml><?xml version="1.0" encoding="utf-8"?>
 <p:presentation xmlns:p="http://schemas.openxmlformats.org/presentationml/2006/main">
   <p:sldMasterIdLst>
-    <p:sldMasterId xmlns:r="http://schemas.openxmlformats.org/officeDocument/2006/relationships" id="2147483648" r:id="R388e00381139496b"/>
+    <p:sldMasterId xmlns:r="http://schemas.openxmlformats.org/officeDocument/2006/relationships" id="2147483648" r:id="Rc60c548412b845a9"/>
   </p:sldMasterIdLst>
   <p:notesMasterIdLst>
-    <p:notesMasterId xmlns:r="http://schemas.openxmlformats.org/officeDocument/2006/relationships" r:id="Re4f21cfc0aca4d45"/>
+    <p:notesMasterId xmlns:r="http://schemas.openxmlformats.org/officeDocument/2006/relationships" r:id="R61833166a92d4d9a"/>
   </p:notesMasterIdLst>
   <p:sldIdLst>
-    <p:sldId xmlns:r="http://schemas.openxmlformats.org/officeDocument/2006/relationships" id="256" r:id="R41e9a533ec364630"/>
-    <p:sldId xmlns:r="http://schemas.openxmlformats.org/officeDocument/2006/relationships" id="257" r:id="Rd034aae41c354bb3"/>
-    <p:sldId xmlns:r="http://schemas.openxmlformats.org/officeDocument/2006/relationships" id="258" r:id="R38addf1f4b3e4b90"/>
-    <p:sldId xmlns:r="http://schemas.openxmlformats.org/officeDocument/2006/relationships" id="259" r:id="Rd446b5a533c747a0"/>
-    <p:sldId xmlns:r="http://schemas.openxmlformats.org/officeDocument/2006/relationships" id="260" r:id="Rd97751e356094ccd"/>
-    <p:sldId xmlns:r="http://schemas.openxmlformats.org/officeDocument/2006/relationships" id="261" r:id="R99c4675820df4525"/>
-    <p:sldId xmlns:r="http://schemas.openxmlformats.org/officeDocument/2006/relationships" id="262" r:id="R6be27b6a3cda4022"/>
-    <p:sldId xmlns:r="http://schemas.openxmlformats.org/officeDocument/2006/relationships" id="263" r:id="R318dc95f784d44b2"/>
-    <p:sldId xmlns:r="http://schemas.openxmlformats.org/officeDocument/2006/relationships" id="264" r:id="Rcd9382cc06474fa3"/>
-    <p:sldId xmlns:r="http://schemas.openxmlformats.org/officeDocument/2006/relationships" id="265" r:id="Rb41dd1b3c3644845"/>
-    <p:sldId xmlns:r="http://schemas.openxmlformats.org/officeDocument/2006/relationships" id="266" r:id="Rdb6b97e371e34923"/>
-    <p:sldId xmlns:r="http://schemas.openxmlformats.org/officeDocument/2006/relationships" id="267" r:id="R48709f4e5a5341fe"/>
-    <p:sldId xmlns:r="http://schemas.openxmlformats.org/officeDocument/2006/relationships" id="268" r:id="R47feca93d8a34b26"/>
-    <p:sldId xmlns:r="http://schemas.openxmlformats.org/officeDocument/2006/relationships" id="269" r:id="Rece2015381aa477e"/>
-    <p:sldId xmlns:r="http://schemas.openxmlformats.org/officeDocument/2006/relationships" id="270" r:id="R41973db7630746b6"/>
-    <p:sldId xmlns:r="http://schemas.openxmlformats.org/officeDocument/2006/relationships" id="271" r:id="R80af74615ee443a9"/>
-    <p:sldId xmlns:r="http://schemas.openxmlformats.org/officeDocument/2006/relationships" id="272" r:id="R10185a9b24a940e1"/>
-    <p:sldId xmlns:r="http://schemas.openxmlformats.org/officeDocument/2006/relationships" id="273" r:id="R752431d326714fc3"/>
-    <p:sldId xmlns:r="http://schemas.openxmlformats.org/officeDocument/2006/relationships" id="274" r:id="R87ad913278b442f3"/>
-    <p:sldId xmlns:r="http://schemas.openxmlformats.org/officeDocument/2006/relationships" id="275" r:id="Rdd81a705775d40f9"/>
-    <p:sldId xmlns:r="http://schemas.openxmlformats.org/officeDocument/2006/relationships" id="276" r:id="Rfd7adb97ba334329"/>
-    <p:sldId xmlns:r="http://schemas.openxmlformats.org/officeDocument/2006/relationships" id="277" r:id="Rc880ecfc00ec4133"/>
-    <p:sldId xmlns:r="http://schemas.openxmlformats.org/officeDocument/2006/relationships" id="278" r:id="R65f6b9533ce14d9d"/>
-    <p:sldId xmlns:r="http://schemas.openxmlformats.org/officeDocument/2006/relationships" id="279" r:id="R71e70a94617d46b6"/>
-    <p:sldId xmlns:r="http://schemas.openxmlformats.org/officeDocument/2006/relationships" id="280" r:id="R57fb06dbf93c4733"/>
-    <p:sldId xmlns:r="http://schemas.openxmlformats.org/officeDocument/2006/relationships" id="281" r:id="Re4dda241596c419a"/>
-    <p:sldId xmlns:r="http://schemas.openxmlformats.org/officeDocument/2006/relationships" id="282" r:id="Rd335dd17123d41f7"/>
-    <p:sldId xmlns:r="http://schemas.openxmlformats.org/officeDocument/2006/relationships" id="283" r:id="R113f93d5b7a04046"/>
-    <p:sldId xmlns:r="http://schemas.openxmlformats.org/officeDocument/2006/relationships" id="284" r:id="R32e1694d411e4a07"/>
+    <p:sldId xmlns:r="http://schemas.openxmlformats.org/officeDocument/2006/relationships" id="256" r:id="Rf3701083f24e4753"/>
+    <p:sldId xmlns:r="http://schemas.openxmlformats.org/officeDocument/2006/relationships" id="257" r:id="Rcc33e57f9c91499f"/>
+    <p:sldId xmlns:r="http://schemas.openxmlformats.org/officeDocument/2006/relationships" id="258" r:id="R5e7945a87e754aaf"/>
+    <p:sldId xmlns:r="http://schemas.openxmlformats.org/officeDocument/2006/relationships" id="259" r:id="Rbf2afbce72eb4847"/>
+    <p:sldId xmlns:r="http://schemas.openxmlformats.org/officeDocument/2006/relationships" id="260" r:id="Rc5e2b6117e864e4d"/>
+    <p:sldId xmlns:r="http://schemas.openxmlformats.org/officeDocument/2006/relationships" id="261" r:id="R31388e7c88ae458e"/>
+    <p:sldId xmlns:r="http://schemas.openxmlformats.org/officeDocument/2006/relationships" id="262" r:id="Rc3f8382af9d04675"/>
+    <p:sldId xmlns:r="http://schemas.openxmlformats.org/officeDocument/2006/relationships" id="263" r:id="R4bbf6b4c092b4946"/>
+    <p:sldId xmlns:r="http://schemas.openxmlformats.org/officeDocument/2006/relationships" id="264" r:id="R856b00ff4e984d96"/>
+    <p:sldId xmlns:r="http://schemas.openxmlformats.org/officeDocument/2006/relationships" id="265" r:id="Rde11a7c9d2fd40c0"/>
+    <p:sldId xmlns:r="http://schemas.openxmlformats.org/officeDocument/2006/relationships" id="266" r:id="R5f8f4ede99794f81"/>
+    <p:sldId xmlns:r="http://schemas.openxmlformats.org/officeDocument/2006/relationships" id="267" r:id="R315a1d78f69d4ff6"/>
+    <p:sldId xmlns:r="http://schemas.openxmlformats.org/officeDocument/2006/relationships" id="268" r:id="R8997fde8edcf4278"/>
+    <p:sldId xmlns:r="http://schemas.openxmlformats.org/officeDocument/2006/relationships" id="269" r:id="R2a1b0b014d284b7b"/>
+    <p:sldId xmlns:r="http://schemas.openxmlformats.org/officeDocument/2006/relationships" id="270" r:id="Rcd7a7d85698d479b"/>
+    <p:sldId xmlns:r="http://schemas.openxmlformats.org/officeDocument/2006/relationships" id="271" r:id="R4b66368af6a44210"/>
+    <p:sldId xmlns:r="http://schemas.openxmlformats.org/officeDocument/2006/relationships" id="272" r:id="Rdeefed849069497e"/>
+    <p:sldId xmlns:r="http://schemas.openxmlformats.org/officeDocument/2006/relationships" id="273" r:id="Rf80df657513444b3"/>
+    <p:sldId xmlns:r="http://schemas.openxmlformats.org/officeDocument/2006/relationships" id="274" r:id="Ref9242009dc648bc"/>
+    <p:sldId xmlns:r="http://schemas.openxmlformats.org/officeDocument/2006/relationships" id="275" r:id="Rb98bc0b0866241c3"/>
+    <p:sldId xmlns:r="http://schemas.openxmlformats.org/officeDocument/2006/relationships" id="276" r:id="R8133054df5014c12"/>
+    <p:sldId xmlns:r="http://schemas.openxmlformats.org/officeDocument/2006/relationships" id="277" r:id="R6121794f99254638"/>
+    <p:sldId xmlns:r="http://schemas.openxmlformats.org/officeDocument/2006/relationships" id="278" r:id="R1ba55feaa796431e"/>
+    <p:sldId xmlns:r="http://schemas.openxmlformats.org/officeDocument/2006/relationships" id="279" r:id="Rfe7191d554444ef1"/>
+    <p:sldId xmlns:r="http://schemas.openxmlformats.org/officeDocument/2006/relationships" id="280" r:id="R62a447633ce748b0"/>
+    <p:sldId xmlns:r="http://schemas.openxmlformats.org/officeDocument/2006/relationships" id="281" r:id="R34b72fb5474940dd"/>
+    <p:sldId xmlns:r="http://schemas.openxmlformats.org/officeDocument/2006/relationships" id="282" r:id="Rb1fc0de7e3b54ef8"/>
+    <p:sldId xmlns:r="http://schemas.openxmlformats.org/officeDocument/2006/relationships" id="283" r:id="Rc4fb2f7694754773"/>
+    <p:sldId xmlns:r="http://schemas.openxmlformats.org/officeDocument/2006/relationships" id="284" r:id="Rdc8419624a6145fb"/>
   </p:sldIdLst>
   <p:sldSz cx="9144000" cy="5143500"/>
   <p:notesSz cx="6858000" cy="9144000"/>
@@ -2783,7 +2783,7 @@
           </a:p>
           <a:p xmlns:a="http://schemas.openxmlformats.org/drawingml/2006/main">
             <a:r>
-              <a:t>First, the ground — Omnipresence. Formless, all-pervasive, transparent, permeating, non-transforming, immeasurable. Actionless energy: it acts not at all, yet every unit is energised and regulated in it. There is no place where it is absent. The same pervasive reality is also named jyoti, light; realisation in it is described as enduring prakash.</a:t>
+              <a:t>First, the ground — Omnipresence. Formless, all-pervasive, transparent, permeating, non-transforming, immeasurable. Actionless energy: it acts not at all, yet every unit is energised and regulated in it. There is no place where it is absent. The pervasive ground is prakash, light; realisation in it is described as enduring prakash.</a:t>
             </a:r>
           </a:p>
           <a:p xmlns:a="http://schemas.openxmlformats.org/drawingml/2006/main">
@@ -2893,7 +2893,7 @@
           </a:p>
           <a:p xmlns:a="http://schemas.openxmlformats.org/drawingml/2006/main">
             <a:r>
-              <a:t>These are connected aspects of one saturation. Energy becomes evident in activity, recognition in mutuality, and regulation in definite conduct. The ground is named jyoti, light; each unit saturated in it is prakashman, manifest. The texts explicitly connect this manifestness with satta permeating the unit and its being endowed with force. Manifestness belongs to all units, including sentient jeevan.</a:t>
+              <a:t>These are connected aspects of one saturation. Energy becomes evident in activity, recognition in mutuality, and regulation in definite conduct. The ground is prakash, light; each unit saturated in it is prakashman, manifest. The texts explicitly connect this manifestness with satta permeating the unit and its being endowed with force. Manifestness belongs to all units, including sentient jeevan.</a:t>
             </a:r>
           </a:p>
           <a:p xmlns:a="http://schemas.openxmlformats.org/drawingml/2006/main">
@@ -3268,7 +3268,7 @@
   </p:cSld>
   <p:clrMap bg1="lt1" tx1="dk1" bg2="dk2" tx2="lt2" accent1="accent1" accent2="accent2" accent3="accent3" accent4="accent4" accent5="accent5" accent6="accent6" hlink="hlink" folHlink="folHlink"/>
   <p:sldLayoutIdLst>
-    <p:sldLayoutId xmlns:r="http://schemas.openxmlformats.org/officeDocument/2006/relationships" id="2147483649" r:id="Rccf15baee49a48d0"/>
+    <p:sldLayoutId xmlns:r="http://schemas.openxmlformats.org/officeDocument/2006/relationships" id="2147483649" r:id="R648a55c00fc24910"/>
   </p:sldLayoutIdLst>
   <p:hf sldNum="0" hdr="0" ftr="0" dt="0"/>
   <p:txStyles>
@@ -27669,7 +27669,7 @@
       </p:sp>
       <p:cxnSp>
         <p:nvCxnSpPr>
-          <p:cNvPr id="1343" name="Google Shape;445;p18"/>
+          <p:cNvPr id="1380" name="Google Shape;445;p18"/>
           <p:cNvCxnSpPr/>
           <p:nvPr/>
         </p:nvCxnSpPr>
@@ -27750,7 +27750,7 @@
       </p:sp>
       <p:cxnSp>
         <p:nvCxnSpPr>
-          <p:cNvPr id="1345" name="Google Shape;447;p18"/>
+          <p:cNvPr id="1382" name="Google Shape;447;p18"/>
           <p:cNvCxnSpPr/>
           <p:nvPr/>
         </p:nvCxnSpPr>
@@ -29446,7 +29446,7 @@
           <p:nvPr/>
         </p:nvPicPr>
         <p:blipFill rotWithShape="1">
-          <a:blip xmlns:r="http://schemas.openxmlformats.org/officeDocument/2006/relationships" xmlns:a="http://schemas.openxmlformats.org/drawingml/2006/main" r:embed="Rbeef1ba50dab4717">
+          <a:blip xmlns:r="http://schemas.openxmlformats.org/officeDocument/2006/relationships" xmlns:a="http://schemas.openxmlformats.org/drawingml/2006/main" r:embed="R9455c43259144718">
             <a:alphaModFix/>
           </a:blip>
           <a:srcRect xmlns:a="http://schemas.openxmlformats.org/drawingml/2006/main" l="0" t="0" r="0" b="0"/>
@@ -29689,7 +29689,7 @@
           <p:nvPr/>
         </p:nvPicPr>
         <p:blipFill rotWithShape="1">
-          <a:blip xmlns:r="http://schemas.openxmlformats.org/officeDocument/2006/relationships" xmlns:a="http://schemas.openxmlformats.org/drawingml/2006/main" r:embed="Rac6e0b5be9014e0d">
+          <a:blip xmlns:r="http://schemas.openxmlformats.org/officeDocument/2006/relationships" xmlns:a="http://schemas.openxmlformats.org/drawingml/2006/main" r:embed="R3e519ae0af664ceb">
             <a:alphaModFix/>
           </a:blip>
           <a:srcRect xmlns:a="http://schemas.openxmlformats.org/drawingml/2006/main" l="0" t="0" r="0" b="0"/>
@@ -29932,7 +29932,7 @@
           <p:nvPr/>
         </p:nvPicPr>
         <p:blipFill rotWithShape="1">
-          <a:blip xmlns:r="http://schemas.openxmlformats.org/officeDocument/2006/relationships" xmlns:a="http://schemas.openxmlformats.org/drawingml/2006/main" r:embed="Re775de770ff140c8">
+          <a:blip xmlns:r="http://schemas.openxmlformats.org/officeDocument/2006/relationships" xmlns:a="http://schemas.openxmlformats.org/drawingml/2006/main" r:embed="R41428cec87e04a20">
             <a:alphaModFix/>
           </a:blip>
           <a:srcRect xmlns:a="http://schemas.openxmlformats.org/drawingml/2006/main" l="0" t="0" r="0" b="0"/>
@@ -34247,7 +34247,7 @@
           <p:nvPr/>
         </p:nvPicPr>
         <p:blipFill rotWithShape="1">
-          <a:blip xmlns:r="http://schemas.openxmlformats.org/officeDocument/2006/relationships" xmlns:a="http://schemas.openxmlformats.org/drawingml/2006/main" r:embed="Rab090c9d22c0488e">
+          <a:blip xmlns:r="http://schemas.openxmlformats.org/officeDocument/2006/relationships" xmlns:a="http://schemas.openxmlformats.org/drawingml/2006/main" r:embed="R7c93790924734689">
             <a:alphaModFix/>
           </a:blip>
           <a:srcRect xmlns:a="http://schemas.openxmlformats.org/drawingml/2006/main" l="0" t="0" r="0" b="0"/>
@@ -34389,7 +34389,7 @@
           <p:nvPr/>
         </p:nvPicPr>
         <p:blipFill rotWithShape="1">
-          <a:blip xmlns:r="http://schemas.openxmlformats.org/officeDocument/2006/relationships" xmlns:a="http://schemas.openxmlformats.org/drawingml/2006/main" r:embed="Rab090c9d22c0488e">
+          <a:blip xmlns:r="http://schemas.openxmlformats.org/officeDocument/2006/relationships" xmlns:a="http://schemas.openxmlformats.org/drawingml/2006/main" r:embed="R7c93790924734689">
             <a:alphaModFix/>
           </a:blip>
           <a:srcRect xmlns:a="http://schemas.openxmlformats.org/drawingml/2006/main" l="0" t="0" r="0" b="0"/>
@@ -34531,7 +34531,7 @@
           <p:nvPr/>
         </p:nvPicPr>
         <p:blipFill rotWithShape="1">
-          <a:blip xmlns:r="http://schemas.openxmlformats.org/officeDocument/2006/relationships" xmlns:a="http://schemas.openxmlformats.org/drawingml/2006/main" r:embed="Rab090c9d22c0488e">
+          <a:blip xmlns:r="http://schemas.openxmlformats.org/officeDocument/2006/relationships" xmlns:a="http://schemas.openxmlformats.org/drawingml/2006/main" r:embed="R7c93790924734689">
             <a:alphaModFix/>
           </a:blip>
           <a:srcRect xmlns:a="http://schemas.openxmlformats.org/drawingml/2006/main" l="0" t="0" r="0" b="0"/>
@@ -34673,7 +34673,7 @@
           <p:nvPr/>
         </p:nvPicPr>
         <p:blipFill rotWithShape="1">
-          <a:blip xmlns:r="http://schemas.openxmlformats.org/officeDocument/2006/relationships" xmlns:a="http://schemas.openxmlformats.org/drawingml/2006/main" r:embed="Rab090c9d22c0488e">
+          <a:blip xmlns:r="http://schemas.openxmlformats.org/officeDocument/2006/relationships" xmlns:a="http://schemas.openxmlformats.org/drawingml/2006/main" r:embed="R7c93790924734689">
             <a:alphaModFix/>
           </a:blip>
           <a:srcRect xmlns:a="http://schemas.openxmlformats.org/drawingml/2006/main" l="0" t="0" r="0" b="0"/>
@@ -34815,7 +34815,7 @@
           <p:nvPr/>
         </p:nvPicPr>
         <p:blipFill rotWithShape="1">
-          <a:blip xmlns:r="http://schemas.openxmlformats.org/officeDocument/2006/relationships" xmlns:a="http://schemas.openxmlformats.org/drawingml/2006/main" r:embed="Rab090c9d22c0488e">
+          <a:blip xmlns:r="http://schemas.openxmlformats.org/officeDocument/2006/relationships" xmlns:a="http://schemas.openxmlformats.org/drawingml/2006/main" r:embed="R7c93790924734689">
             <a:alphaModFix/>
           </a:blip>
           <a:srcRect xmlns:a="http://schemas.openxmlformats.org/drawingml/2006/main" l="0" t="0" r="0" b="0"/>
@@ -34957,7 +34957,7 @@
           <p:nvPr/>
         </p:nvPicPr>
         <p:blipFill rotWithShape="1">
-          <a:blip xmlns:r="http://schemas.openxmlformats.org/officeDocument/2006/relationships" xmlns:a="http://schemas.openxmlformats.org/drawingml/2006/main" r:embed="Rab090c9d22c0488e">
+          <a:blip xmlns:r="http://schemas.openxmlformats.org/officeDocument/2006/relationships" xmlns:a="http://schemas.openxmlformats.org/drawingml/2006/main" r:embed="R7c93790924734689">
             <a:alphaModFix/>
           </a:blip>
           <a:srcRect xmlns:a="http://schemas.openxmlformats.org/drawingml/2006/main" l="0" t="0" r="0" b="0"/>
@@ -35508,7 +35508,7 @@
           <p:nvPr/>
         </p:nvPicPr>
         <p:blipFill>
-          <a:blip xmlns:r="http://schemas.openxmlformats.org/officeDocument/2006/relationships" xmlns:a="http://schemas.openxmlformats.org/drawingml/2006/main" r:embed="R6f640c4b95674b2d"/>
+          <a:blip xmlns:r="http://schemas.openxmlformats.org/officeDocument/2006/relationships" xmlns:a="http://schemas.openxmlformats.org/drawingml/2006/main" r:embed="R3ec1ce94b8b44042"/>
           <a:stretch xmlns:a="http://schemas.openxmlformats.org/drawingml/2006/main"/>
         </p:blipFill>
         <p:spPr>
@@ -35882,7 +35882,29 @@
                 <a:ea typeface="Calibri"/>
                 <a:cs typeface="Calibri"/>
               </a:rPr>
-              <a:t>Formless, all-pervasive, non-transforming and actionless. Also named jyoti (light), it permeates every unit and is transparent in mutuality. Saturated units are active and manifest (prakashman). It has no absent place.</a:t>
+              <a:t>Formless, all-pervasive, non-transforming and actionless. </a:t>
+            </a:r>
+            <a:r>
+              <a:rPr sz="1250" b="0" i="0" u="none" cap="none">
+                <a:solidFill>
+                  <a:srgbClr val="5A6377"/>
+                </a:solidFill>
+                <a:latin typeface="Calibri"/>
+                <a:ea typeface="Calibri"/>
+                <a:cs typeface="Calibri"/>
+              </a:rPr>
+              <a:t>As prakash (light),</a:t>
+            </a:r>
+            <a:r>
+              <a:rPr sz="1250" b="0" i="0" u="none" cap="none">
+                <a:solidFill>
+                  <a:srgbClr val="5A6377"/>
+                </a:solidFill>
+                <a:latin typeface="Calibri"/>
+                <a:ea typeface="Calibri"/>
+                <a:cs typeface="Calibri"/>
+              </a:rPr>
+              <a:t> it permeates every unit and is transparent in mutuality. Saturated units are active and manifest (prakashman). It has no absent place.</a:t>
             </a:r>
           </a:p>
           <a:p xmlns:a="http://schemas.openxmlformats.org/drawingml/2006/main">
@@ -37445,7 +37467,7 @@
           <p:nvPr/>
         </p:nvPicPr>
         <p:blipFill rotWithShape="1">
-          <a:blip xmlns:r="http://schemas.openxmlformats.org/officeDocument/2006/relationships" xmlns:a="http://schemas.openxmlformats.org/drawingml/2006/main" r:embed="R60478028fed94430">
+          <a:blip xmlns:r="http://schemas.openxmlformats.org/officeDocument/2006/relationships" xmlns:a="http://schemas.openxmlformats.org/drawingml/2006/main" r:embed="R16092fe9cffc4f1b">
             <a:alphaModFix/>
           </a:blip>
           <a:srcRect xmlns:a="http://schemas.openxmlformats.org/drawingml/2006/main" l="0" t="0" r="0" b="0"/>
@@ -37688,7 +37710,7 @@
           <p:nvPr/>
         </p:nvPicPr>
         <p:blipFill rotWithShape="1">
-          <a:blip xmlns:r="http://schemas.openxmlformats.org/officeDocument/2006/relationships" xmlns:a="http://schemas.openxmlformats.org/drawingml/2006/main" r:embed="R77bb050624ca48bf">
+          <a:blip xmlns:r="http://schemas.openxmlformats.org/officeDocument/2006/relationships" xmlns:a="http://schemas.openxmlformats.org/drawingml/2006/main" r:embed="R5df44989debe4f9d">
             <a:alphaModFix/>
           </a:blip>
           <a:srcRect xmlns:a="http://schemas.openxmlformats.org/drawingml/2006/main" l="0" t="0" r="0" b="0"/>
@@ -37931,7 +37953,7 @@
           <p:nvPr/>
         </p:nvPicPr>
         <p:blipFill rotWithShape="1">
-          <a:blip xmlns:r="http://schemas.openxmlformats.org/officeDocument/2006/relationships" xmlns:a="http://schemas.openxmlformats.org/drawingml/2006/main" r:embed="R730f6d8c24c74730">
+          <a:blip xmlns:r="http://schemas.openxmlformats.org/officeDocument/2006/relationships" xmlns:a="http://schemas.openxmlformats.org/drawingml/2006/main" r:embed="R2d5403df97274114">
             <a:alphaModFix/>
           </a:blip>
           <a:srcRect xmlns:a="http://schemas.openxmlformats.org/drawingml/2006/main" l="0" t="0" r="0" b="0"/>
@@ -38607,7 +38629,7 @@
           <p:nvPr/>
         </p:nvPicPr>
         <p:blipFill rotWithShape="1">
-          <a:blip xmlns:r="http://schemas.openxmlformats.org/officeDocument/2006/relationships" xmlns:a="http://schemas.openxmlformats.org/drawingml/2006/main" r:embed="R83aca33a03a146e1">
+          <a:blip xmlns:r="http://schemas.openxmlformats.org/officeDocument/2006/relationships" xmlns:a="http://schemas.openxmlformats.org/drawingml/2006/main" r:embed="R36c3a7ddcc70466c">
             <a:alphaModFix/>
           </a:blip>
           <a:srcRect xmlns:a="http://schemas.openxmlformats.org/drawingml/2006/main" l="0" t="0" r="0" b="0"/>
@@ -38850,7 +38872,7 @@
           <p:nvPr/>
         </p:nvPicPr>
         <p:blipFill rotWithShape="1">
-          <a:blip xmlns:r="http://schemas.openxmlformats.org/officeDocument/2006/relationships" xmlns:a="http://schemas.openxmlformats.org/drawingml/2006/main" r:embed="R667e578a5fb349ff">
+          <a:blip xmlns:r="http://schemas.openxmlformats.org/officeDocument/2006/relationships" xmlns:a="http://schemas.openxmlformats.org/drawingml/2006/main" r:embed="R396e8f81bc8e4321">
             <a:alphaModFix/>
           </a:blip>
           <a:srcRect xmlns:a="http://schemas.openxmlformats.org/drawingml/2006/main" l="0" t="0" r="0" b="0"/>
@@ -39093,7 +39115,7 @@
           <p:nvPr/>
         </p:nvPicPr>
         <p:blipFill rotWithShape="1">
-          <a:blip xmlns:r="http://schemas.openxmlformats.org/officeDocument/2006/relationships" xmlns:a="http://schemas.openxmlformats.org/drawingml/2006/main" r:embed="R3af91f88232c4d55">
+          <a:blip xmlns:r="http://schemas.openxmlformats.org/officeDocument/2006/relationships" xmlns:a="http://schemas.openxmlformats.org/drawingml/2006/main" r:embed="R9277301ffa62439f">
             <a:alphaModFix/>
           </a:blip>
           <a:srcRect xmlns:a="http://schemas.openxmlformats.org/drawingml/2006/main" l="0" t="0" r="0" b="0"/>
@@ -41456,7 +41478,7 @@
           <p:nvPr/>
         </p:nvPicPr>
         <p:blipFill rotWithShape="1">
-          <a:blip xmlns:r="http://schemas.openxmlformats.org/officeDocument/2006/relationships" xmlns:a="http://schemas.openxmlformats.org/drawingml/2006/main" r:embed="R4309ea82831a4909">
+          <a:blip xmlns:r="http://schemas.openxmlformats.org/officeDocument/2006/relationships" xmlns:a="http://schemas.openxmlformats.org/drawingml/2006/main" r:embed="R38e062b78e5545fa">
             <a:alphaModFix/>
           </a:blip>
           <a:srcRect xmlns:a="http://schemas.openxmlformats.org/drawingml/2006/main" l="0" t="0" r="0" b="0"/>
@@ -41699,7 +41721,7 @@
           <p:nvPr/>
         </p:nvPicPr>
         <p:blipFill rotWithShape="1">
-          <a:blip xmlns:r="http://schemas.openxmlformats.org/officeDocument/2006/relationships" xmlns:a="http://schemas.openxmlformats.org/drawingml/2006/main" r:embed="R652459c6135e4133">
+          <a:blip xmlns:r="http://schemas.openxmlformats.org/officeDocument/2006/relationships" xmlns:a="http://schemas.openxmlformats.org/drawingml/2006/main" r:embed="Rb2d0b6b640b940e0">
             <a:alphaModFix/>
           </a:blip>
           <a:srcRect xmlns:a="http://schemas.openxmlformats.org/drawingml/2006/main" l="0" t="0" r="0" b="0"/>
@@ -41942,7 +41964,7 @@
           <p:nvPr/>
         </p:nvPicPr>
         <p:blipFill rotWithShape="1">
-          <a:blip xmlns:r="http://schemas.openxmlformats.org/officeDocument/2006/relationships" xmlns:a="http://schemas.openxmlformats.org/drawingml/2006/main" r:embed="R258b4be7ee2948e0">
+          <a:blip xmlns:r="http://schemas.openxmlformats.org/officeDocument/2006/relationships" xmlns:a="http://schemas.openxmlformats.org/drawingml/2006/main" r:embed="R3ae96e7dd6c44924">
             <a:alphaModFix/>
           </a:blip>
           <a:srcRect xmlns:a="http://schemas.openxmlformats.org/drawingml/2006/main" l="0" t="0" r="0" b="0"/>

</xml_diff>